<commit_message>
Align GFS lecture questions with slide text
</commit_message>
<xml_diff>
--- a/slides/fall26/4-gfs.pptx
+++ b/slides/fall26/4-gfs.pptx
@@ -28227,7 +28227,7 @@
         <p:spPr>
           <a:xfrm>
             <a:off x="88135" y="914401"/>
-            <a:ext cx="12191998" cy="3724096"/>
+            <a:ext cx="12191998" cy="3231654"/>
           </a:xfrm>
           <a:prstGeom prst="rect">
             <a:avLst/>
@@ -28290,7 +28290,15 @@
           <a:p>
             <a:r>
               <a:rPr lang="en-US" sz="3200" b="1" dirty="0"/>
-              <a:t>Get the storage interface right and the systems above it get simpler</a:t>
+              <a:t>Get the </a:t>
+            </a:r>
+            <a:r>
+              <a:rPr lang="en-US" sz="3200" b="1"/>
+              <a:t>storage right </a:t>
+            </a:r>
+            <a:r>
+              <a:rPr lang="en-US" sz="3200" b="1" dirty="0"/>
+              <a:t>and the systems above it get simpler</a:t>
             </a:r>
           </a:p>
           <a:p>
@@ -28307,10 +28315,10 @@
       </p:sp>
       <p:sp>
         <p:nvSpPr>
-          <p:cNvPr id="9" name="Lecture questions heading">
-            <a:extLst>
-              <a:ext uri="{FF2B5EF4-FFF2-40B4-BE49-F238E27FC236}">
-                <a16:creationId xmlns:a16="http://schemas.microsoft.com/office/drawing/2014/main" id="{0E7D93B9-70F2-44EF-B1AB-321BF93DACEB}"/>
+          <p:cNvPr id="12" name="Aligned lecture question 1">
+            <a:extLst>
+              <a:ext uri="{FF2B5EF4-FFF2-40B4-BE49-F238E27FC236}">
+                <a16:creationId xmlns:a16="http://schemas.microsoft.com/office/drawing/2014/main" id="{65C260B1-CF5C-4765-A4FA-8A06EC3F7E5E}"/>
               </a:ext>
             </a:extLst>
           </p:cNvPr>
@@ -28321,8 +28329,8 @@
         </p:nvSpPr>
         <p:spPr>
           <a:xfrm>
-            <a:off x="190500" y="5029200"/>
-            <a:ext cx="11811000" cy="266700"/>
+            <a:off x="552450" y="5029200"/>
+            <a:ext cx="11096625" cy="419100"/>
           </a:xfrm>
           <a:prstGeom prst="rect">
             <a:avLst/>
@@ -28334,40 +28342,40 @@
         </p:spPr>
         <p:txBody>
           <a:bodyPr>
-            <a:normAutofit fontScale="63889"/>
+            <a:normAutofit fontScale="76786"/>
           </a:bodyPr>
           <a:lstStyle/>
           <a:p>
             <a:pPr>
-              <a:defRPr sz="1800" b="1">
+              <a:defRPr sz="2800" b="0">
                 <a:solidFill>
-                  <a:srgbClr val="000000"/>
+                  <a:srgbClr val="A02B93"/>
                 </a:solidFill>
-                <a:latin typeface="Helvetica"/>
-                <a:ea typeface="Helvetica"/>
-                <a:cs typeface="Helvetica"/>
+                <a:latin typeface="Aptos"/>
+                <a:ea typeface="Aptos"/>
+                <a:cs typeface="Aptos"/>
               </a:defRPr>
             </a:pPr>
             <a:r>
-              <a:rPr sz="1800" b="1">
+              <a:rPr sz="2800" b="0">
                 <a:solidFill>
-                  <a:srgbClr val="000000"/>
+                  <a:srgbClr val="A02B93"/>
                 </a:solidFill>
-                <a:latin typeface="Helvetica"/>
-                <a:ea typeface="Helvetica"/>
-                <a:cs typeface="Helvetica"/>
+                <a:latin typeface="Aptos"/>
+                <a:ea typeface="Aptos"/>
+                <a:cs typeface="Aptos"/>
               </a:rPr>
-              <a:t>Two questions for this lecture</a:t>
-            </a:r>
-          </a:p>
-        </p:txBody>
-      </p:sp>
-      <p:sp>
-        <p:nvSpPr>
-          <p:cNvPr id="10" name="Lecture question 1">
-            <a:extLst>
-              <a:ext uri="{FF2B5EF4-FFF2-40B4-BE49-F238E27FC236}">
-                <a16:creationId xmlns:a16="http://schemas.microsoft.com/office/drawing/2014/main" id="{BC1B4C56-B947-4D5A-96BB-4AB4D6BC84A8}"/>
+              <a:t>•     What interface should a large distributed storage system expose?</a:t>
+            </a:r>
+          </a:p>
+        </p:txBody>
+      </p:sp>
+      <p:sp>
+        <p:nvSpPr>
+          <p:cNvPr id="13" name="Aligned lecture question 2">
+            <a:extLst>
+              <a:ext uri="{FF2B5EF4-FFF2-40B4-BE49-F238E27FC236}">
+                <a16:creationId xmlns:a16="http://schemas.microsoft.com/office/drawing/2014/main" id="{6603DCFD-0381-4AA0-9012-46F6D9960692}"/>
               </a:ext>
             </a:extLst>
           </p:cNvPr>
@@ -28378,8 +28386,8 @@
         </p:nvSpPr>
         <p:spPr>
           <a:xfrm>
-            <a:off x="323850" y="5295900"/>
-            <a:ext cx="11544300" cy="295275"/>
+            <a:off x="552450" y="5467350"/>
+            <a:ext cx="11096625" cy="419100"/>
           </a:xfrm>
           <a:prstGeom prst="rect">
             <a:avLst/>
@@ -28391,87 +28399,30 @@
         </p:spPr>
         <p:txBody>
           <a:bodyPr>
-            <a:normAutofit fontScale="77536"/>
+            <a:normAutofit fontScale="76786"/>
           </a:bodyPr>
           <a:lstStyle/>
           <a:p>
             <a:pPr>
-              <a:defRPr sz="1725" b="1">
+              <a:defRPr sz="2800" b="0">
                 <a:solidFill>
                   <a:srgbClr val="A02B93"/>
                 </a:solidFill>
-                <a:latin typeface="Helvetica"/>
-                <a:ea typeface="Helvetica"/>
-                <a:cs typeface="Helvetica"/>
+                <a:latin typeface="Aptos"/>
+                <a:ea typeface="Aptos"/>
+                <a:cs typeface="Aptos"/>
               </a:defRPr>
             </a:pPr>
             <a:r>
-              <a:rPr sz="1725" b="1">
+              <a:rPr sz="2800" b="0">
                 <a:solidFill>
                   <a:srgbClr val="A02B93"/>
                 </a:solidFill>
-                <a:latin typeface="Helvetica"/>
-                <a:ea typeface="Helvetica"/>
-                <a:cs typeface="Helvetica"/>
+                <a:latin typeface="Aptos"/>
+                <a:ea typeface="Aptos"/>
+                <a:cs typeface="Aptos"/>
               </a:rPr>
-              <a:t>1. What interface should a large distributed storage system expose?</a:t>
-            </a:r>
-          </a:p>
-        </p:txBody>
-      </p:sp>
-      <p:sp>
-        <p:nvSpPr>
-          <p:cNvPr id="11" name="Lecture question 2">
-            <a:extLst>
-              <a:ext uri="{FF2B5EF4-FFF2-40B4-BE49-F238E27FC236}">
-                <a16:creationId xmlns:a16="http://schemas.microsoft.com/office/drawing/2014/main" id="{2E3E5ABF-0571-40AA-89F5-E63855C61DEF}"/>
-              </a:ext>
-            </a:extLst>
-          </p:cNvPr>
-          <p:cNvSpPr>
-            <a:spLocks noGrp="1"/>
-          </p:cNvSpPr>
-          <p:nvPr/>
-        </p:nvSpPr>
-        <p:spPr>
-          <a:xfrm>
-            <a:off x="323850" y="5591175"/>
-            <a:ext cx="11544300" cy="590550"/>
-          </a:xfrm>
-          <a:prstGeom prst="rect">
-            <a:avLst/>
-          </a:prstGeom>
-          <a:noFill/>
-          <a:ln w="0">
-            <a:noFill/>
-          </a:ln>
-        </p:spPr>
-        <p:txBody>
-          <a:bodyPr>
-            <a:normAutofit fontScale="94927"/>
-          </a:bodyPr>
-          <a:lstStyle/>
-          <a:p>
-            <a:pPr>
-              <a:defRPr sz="1725" b="1">
-                <a:solidFill>
-                  <a:srgbClr val="A02B93"/>
-                </a:solidFill>
-                <a:latin typeface="Helvetica"/>
-                <a:ea typeface="Helvetica"/>
-                <a:cs typeface="Helvetica"/>
-              </a:defRPr>
-            </a:pPr>
-            <a:r>
-              <a:rPr sz="1725" b="1">
-                <a:solidFill>
-                  <a:srgbClr val="A02B93"/>
-                </a:solidFill>
-                <a:latin typeface="Helvetica"/>
-                <a:ea typeface="Helvetica"/>
-                <a:cs typeface="Helvetica"/>
-              </a:rPr>
-              <a:t>2. What must happen inside the system so that the interface remains useful when data spans many machines and those machines fail?</a:t>
+              <a:t>•     How can that interface remain useful as data spans machines that fail?</a:t>
             </a:r>
           </a:p>
         </p:txBody>

</xml_diff>

<commit_message>
Clarify GFS replication tradeoff questions
</commit_message>
<xml_diff>
--- a/slides/fall26/4-gfs.pptx
+++ b/slides/fall26/4-gfs.pptx
@@ -15,8 +15,8 @@
     <p:sldId id="477" r:id="rId6"/>
     <p:sldId id="478" r:id="rId7"/>
     <p:sldId id="479" r:id="rId8"/>
+    <p:sldId id="428" r:id="rId10"/>
     <p:sldId id="483" r:id="rId9"/>
-    <p:sldId id="428" r:id="rId10"/>
     <p:sldId id="443" r:id="rId11"/>
     <p:sldId id="444" r:id="rId12"/>
     <p:sldId id="445" r:id="rId13"/>
@@ -38,6 +38,7 @@
     <p:sldId id="442" r:id="rId29"/>
     <p:sldId id="446" r:id="rId30"/>
     <p:sldId id="447" r:id="rId31"/>
+    <p:sldId id="484" r:id="rId58"/>
     <p:sldId id="470" r:id="rId32"/>
     <p:sldId id="448" r:id="rId33"/>
     <p:sldId id="482" r:id="rId34"/>
@@ -1304,57 +1305,34 @@
 </file>
 
 <file path=ppt/notesSlides/notesSlide14.xml><?xml version="1.0" encoding="utf-8"?>
-<p:notes xmlns:a="http://schemas.openxmlformats.org/drawingml/2006/main" xmlns:r="http://schemas.openxmlformats.org/officeDocument/2006/relationships" xmlns:p="http://schemas.openxmlformats.org/presentationml/2006/main">
+<p:notes xmlns:p="http://schemas.openxmlformats.org/presentationml/2006/main">
   <p:cSld>
     <p:spTree>
       <p:nvGrpSpPr>
-        <p:cNvPr id="1" name="">
-          <a:extLst>
-            <a:ext uri="{FF2B5EF4-FFF2-40B4-BE49-F238E27FC236}">
-              <a16:creationId xmlns:a16="http://schemas.microsoft.com/office/drawing/2014/main" id="{96985D24-230C-6270-6214-3E867A2550BC}"/>
-            </a:ext>
-          </a:extLst>
-        </p:cNvPr>
+        <p:cNvPr id="1" name=""/>
         <p:cNvGrpSpPr/>
         <p:nvPr/>
       </p:nvGrpSpPr>
       <p:grpSpPr>
-        <a:xfrm>
-          <a:off x="0" y="0"/>
-          <a:ext cx="0" cy="0"/>
-          <a:chOff x="0" y="0"/>
-          <a:chExt cx="0" cy="0"/>
-        </a:xfrm>
+        <a:xfrm xmlns:a="http://schemas.openxmlformats.org/drawingml/2006/main"/>
       </p:grpSpPr>
       <p:sp>
         <p:nvSpPr>
-          <p:cNvPr id="2" name="Slide Image Placeholder 1">
-            <a:extLst>
-              <a:ext uri="{FF2B5EF4-FFF2-40B4-BE49-F238E27FC236}">
-                <a16:creationId xmlns:a16="http://schemas.microsoft.com/office/drawing/2014/main" id="{46553026-D75E-0E0C-F4A0-B2BFCACF2484}"/>
-              </a:ext>
-            </a:extLst>
-          </p:cNvPr>
+          <p:cNvPr id="2" name="Slide Image Placeholder 1"/>
           <p:cNvSpPr>
-            <a:spLocks noGrp="1" noRot="1" noChangeAspect="1"/>
+            <a:spLocks xmlns:a="http://schemas.openxmlformats.org/drawingml/2006/main" noGrp="1"/>
           </p:cNvSpPr>
           <p:nvPr>
-            <p:ph type="sldImg"/>
+            <p:ph type="sldImg" idx="0"/>
           </p:nvPr>
         </p:nvSpPr>
         <p:spPr/>
       </p:sp>
       <p:sp>
         <p:nvSpPr>
-          <p:cNvPr id="3" name="Notes Placeholder 2">
-            <a:extLst>
-              <a:ext uri="{FF2B5EF4-FFF2-40B4-BE49-F238E27FC236}">
-                <a16:creationId xmlns:a16="http://schemas.microsoft.com/office/drawing/2014/main" id="{81C0A957-8562-1954-5E3F-EBB74140409F}"/>
-              </a:ext>
-            </a:extLst>
-          </p:cNvPr>
+          <p:cNvPr id="3" name="Notes Placeholder 2"/>
           <p:cNvSpPr>
-            <a:spLocks noGrp="1"/>
+            <a:spLocks xmlns:a="http://schemas.openxmlformats.org/drawingml/2006/main" noGrp="1"/>
           </p:cNvSpPr>
           <p:nvPr>
             <p:ph type="body" idx="1"/>
@@ -1362,117 +1340,121 @@
         </p:nvSpPr>
         <p:spPr/>
         <p:txBody>
-          <a:bodyPr/>
-          <a:lstStyle/>
-          <a:p>
-            <a:r>
-              <a:t>We read GFS because distributed storage is one of the most useful abstractions in distributed systems. Applications can build on a file interface while the storage layer handles placement, replication, failures, and recovery.</a:t>
-            </a:r>
-            <a:endParaRPr lang="en-US" dirty="0"/>
-          </a:p>
-          <a:p>
-            <a:endParaRPr lang="en-US" dirty="0"/>
-          </a:p>
-          <a:p>
+          <a:bodyPr xmlns:a="http://schemas.openxmlformats.org/drawingml/2006/main"/>
+          <a:lstStyle xmlns:a="http://schemas.openxmlformats.org/drawingml/2006/main"/>
+          <a:p xmlns:a="http://schemas.openxmlformats.org/drawingml/2006/main">
+            <a:r>
+              <a:t>We read GFS because distributed storage is one of the most useful abstractions in distributed systems.</a:t>
+            </a:r>
+            <a:endParaRPr/>
+          </a:p>
+          <a:p xmlns:a="http://schemas.openxmlformats.org/drawingml/2006/main">
+            <a:r>
+              <a:t/>
+            </a:r>
+            <a:endParaRPr/>
+          </a:p>
+          <a:p xmlns:a="http://schemas.openxmlformats.org/drawingml/2006/main">
+            <a:r>
+              <a:t>This is where the interface question belongs: what should a large distributed storage system expose to applications? GFS presents a familiar file interface, but it adapts the operations and guarantees to Google's large, sequential, data-intensive workloads. A useful interface hides placement, replication, failures, and recovery without promising behavior the implementation cannot provide efficiently.</a:t>
+            </a:r>
+            <a:endParaRPr/>
+          </a:p>
+          <a:p xmlns:a="http://schemas.openxmlformats.org/drawingml/2006/main">
+            <a:r>
+              <a:t/>
+            </a:r>
+            <a:endParaRPr/>
+          </a:p>
+          <a:p xmlns:a="http://schemas.openxmlformats.org/drawingml/2006/main">
             <a:r>
               <a:t>The paper also connects several themes from this course. Sharding gives parallel performance. Replication gives fault tolerance, but it creates consistency problems. The designers then choose where to spend coordination cost and where to accept weaker behavior.</a:t>
             </a:r>
-            <a:endParaRPr lang="en-US" dirty="0"/>
-          </a:p>
-          <a:p>
-            <a:endParaRPr lang="en-US" dirty="0"/>
-          </a:p>
-          <a:p>
+            <a:endParaRPr/>
+          </a:p>
+          <a:p xmlns:a="http://schemas.openxmlformats.org/drawingml/2006/main">
+            <a:r>
+              <a:t/>
+            </a:r>
+            <a:endParaRPr/>
+          </a:p>
+          <a:p xmlns:a="http://schemas.openxmlformats.org/drawingml/2006/main">
             <a:r>
               <a:t>This is also a strong systems paper because it connects application workloads to machine-level details. The system succeeded in production, so we can judge the tradeoffs using real experience rather than only a conceptual design.</a:t>
             </a:r>
-            <a:endParaRPr lang="en-US" dirty="0"/>
-          </a:p>
-          <a:p>
-            <a:endParaRPr lang="en-US" dirty="0"/>
-          </a:p>
-          <a:p>
+            <a:endParaRPr/>
+          </a:p>
+          <a:p xmlns:a="http://schemas.openxmlformats.org/drawingml/2006/main">
+            <a:r>
+              <a:t/>
+            </a:r>
+            <a:endParaRPr/>
+          </a:p>
+          <a:p xmlns:a="http://schemas.openxmlformats.org/drawingml/2006/main">
             <a:r>
               <a:t>SOURCE</a:t>
             </a:r>
-            <a:endParaRPr lang="en-US" dirty="0"/>
-          </a:p>
-          <a:p>
+            <a:endParaRPr/>
+          </a:p>
+          <a:p xmlns:a="http://schemas.openxmlformats.org/drawingml/2006/main">
             <a:r>
               <a:t>MIT 6.824, Spring 2020, Lecture 3 video, 0:00-5:09.</a:t>
             </a:r>
-            <a:endParaRPr lang="en-US" dirty="0"/>
-          </a:p>
-          <a:p>
+            <a:endParaRPr/>
+          </a:p>
+          <a:p xmlns:a="http://schemas.openxmlformats.org/drawingml/2006/main">
             <a:r>
               <a:t>https://www.youtube.com/watch?v=EpIgvowZr00</a:t>
             </a:r>
-            <a:endParaRPr lang="en-US" dirty="0"/>
-          </a:p>
-          <a:p>
+            <a:endParaRPr/>
+          </a:p>
+          <a:p xmlns:a="http://schemas.openxmlformats.org/drawingml/2006/main">
             <a:r>
               <a:t>MIT 6.5840, GFS lecture notes.</a:t>
             </a:r>
-            <a:endParaRPr lang="en-US" dirty="0"/>
-          </a:p>
-          <a:p>
+            <a:endParaRPr/>
+          </a:p>
+          <a:p xmlns:a="http://schemas.openxmlformats.org/drawingml/2006/main">
             <a:r>
               <a:t>https://pdos.csail.mit.edu/6.824/notes/l-gfs.txt</a:t>
             </a:r>
-            <a:endParaRPr lang="en-US" dirty="0"/>
-          </a:p>
-          <a:p>
+            <a:endParaRPr/>
+          </a:p>
+          <a:p xmlns:a="http://schemas.openxmlformats.org/drawingml/2006/main">
             <a:r>
               <a:t>Ghemawat, Gobioff, and Leung, The Google File System, Sections 1, 2, and 6.</a:t>
             </a:r>
-            <a:endParaRPr lang="en-US" dirty="0"/>
-          </a:p>
-          <a:p>
+            <a:endParaRPr/>
+          </a:p>
+          <a:p xmlns:a="http://schemas.openxmlformats.org/drawingml/2006/main">
             <a:r>
               <a:t>https://pdos.csail.mit.edu/6.824/papers/gfs.pdf</a:t>
             </a:r>
-            <a:endParaRPr lang="en-US" dirty="0"/>
-          </a:p>
-        </p:txBody>
-      </p:sp>
-      <p:sp>
-        <p:nvSpPr>
-          <p:cNvPr id="4" name="Slide Number Placeholder 3">
-            <a:extLst>
-              <a:ext uri="{FF2B5EF4-FFF2-40B4-BE49-F238E27FC236}">
-                <a16:creationId xmlns:a16="http://schemas.microsoft.com/office/drawing/2014/main" id="{2069476A-DD91-FBC3-1B32-A751589B309A}"/>
-              </a:ext>
-            </a:extLst>
-          </p:cNvPr>
+            <a:endParaRPr/>
+          </a:p>
+        </p:txBody>
+      </p:sp>
+      <p:sp>
+        <p:nvSpPr>
+          <p:cNvPr id="4" name="Slide Number Placeholder 3"/>
           <p:cNvSpPr>
-            <a:spLocks noGrp="1"/>
+            <a:spLocks xmlns:a="http://schemas.openxmlformats.org/drawingml/2006/main" noGrp="1"/>
           </p:cNvSpPr>
           <p:nvPr>
-            <p:ph type="sldNum" sz="quarter" idx="5"/>
+            <p:ph type="sldNum" idx="5"/>
           </p:nvPr>
         </p:nvSpPr>
         <p:spPr/>
         <p:txBody>
-          <a:bodyPr/>
-          <a:lstStyle/>
-          <a:p>
-            <a:fld id="{1C9584DC-3658-4054-9DA4-7B68A1D8CC6D}" type="slidenum">
-              <a:rPr lang="zh-CN" altLang="en-US" smtClean="0"/>
-              <a:t>14</a:t>
-            </a:fld>
-            <a:endParaRPr lang="zh-CN" altLang="en-US"/>
-          </a:p>
+          <a:bodyPr xmlns:a="http://schemas.openxmlformats.org/drawingml/2006/main"/>
+          <a:lstStyle xmlns:a="http://schemas.openxmlformats.org/drawingml/2006/main"/>
+          <a:p xmlns:a="http://schemas.openxmlformats.org/drawingml/2006/main"/>
         </p:txBody>
       </p:sp>
     </p:spTree>
-    <p:extLst>
-      <p:ext uri="{BB962C8B-B14F-4D97-AF65-F5344CB8AC3E}">
-        <p14:creationId xmlns:p14="http://schemas.microsoft.com/office/powerpoint/2010/main" val="3265497464"/>
-      </p:ext>
-    </p:extLst>
   </p:cSld>
   <p:clrMapOvr>
-    <a:masterClrMapping/>
+    <a:masterClrMapping xmlns:a="http://schemas.openxmlformats.org/drawingml/2006/main"/>
   </p:clrMapOvr>
 </p:notes>
 </file>
@@ -8273,7 +8255,7 @@
 </file>
 
 <file path=ppt/notesSlides/notesSlide5.xml><?xml version="1.0" encoding="utf-8"?>
-<p:notes xmlns:p="http://schemas.openxmlformats.org/presentationml/2006/main">
+<p:notes xmlns:a="http://schemas.openxmlformats.org/drawingml/2006/main" xmlns:r="http://schemas.openxmlformats.org/officeDocument/2006/relationships" xmlns:p="http://schemas.openxmlformats.org/presentationml/2006/main">
   <p:cSld>
     <p:spTree>
       <p:nvGrpSpPr>
@@ -8282,16 +8264,21 @@
         <p:nvPr/>
       </p:nvGrpSpPr>
       <p:grpSpPr>
-        <a:xfrm xmlns:a="http://schemas.openxmlformats.org/drawingml/2006/main"/>
+        <a:xfrm>
+          <a:off x="0" y="0"/>
+          <a:ext cx="0" cy="0"/>
+          <a:chOff x="0" y="0"/>
+          <a:chExt cx="0" cy="0"/>
+        </a:xfrm>
       </p:grpSpPr>
       <p:sp>
         <p:nvSpPr>
           <p:cNvPr id="2" name="Slide Image Placeholder 1"/>
           <p:cNvSpPr>
-            <a:spLocks xmlns:a="http://schemas.openxmlformats.org/drawingml/2006/main" noGrp="1"/>
+            <a:spLocks noGrp="1" noRot="1" noChangeAspect="1"/>
           </p:cNvSpPr>
           <p:nvPr>
-            <p:ph type="sldImg" idx="0"/>
+            <p:ph type="sldImg"/>
           </p:nvPr>
         </p:nvSpPr>
         <p:spPr/>
@@ -8300,7 +8287,7 @@
         <p:nvSpPr>
           <p:cNvPr id="3" name="Notes Placeholder 2"/>
           <p:cNvSpPr>
-            <a:spLocks xmlns:a="http://schemas.openxmlformats.org/drawingml/2006/main" noGrp="1"/>
+            <a:spLocks noGrp="1"/>
           </p:cNvSpPr>
           <p:nvPr>
             <p:ph type="body" idx="1"/>
@@ -8308,37 +8295,39 @@
         </p:nvSpPr>
         <p:spPr/>
         <p:txBody>
-          <a:bodyPr xmlns:a="http://schemas.openxmlformats.org/drawingml/2006/main"/>
-          <a:lstStyle xmlns:a="http://schemas.openxmlformats.org/drawingml/2006/main"/>
-          <a:p xmlns:a="http://schemas.openxmlformats.org/drawingml/2006/main">
-            <a:r>
+          <a:bodyPr/>
+          <a:lstStyle/>
+          <a:p>
+            <a:r>
+              <a:rPr dirty="0"/>
               <a:t>Last time we focused on computation, but every map task had to read its input from somewhere, and every reducer had to write its output somewhere. At Google, that shared storage layer was GFS.</a:t>
             </a:r>
-            <a:endParaRPr/>
-          </a:p>
-          <a:p xmlns:a="http://schemas.openxmlformats.org/drawingml/2006/main">
-            <a:r>
-              <a:t/>
-            </a:r>
-            <a:endParaRPr/>
-          </a:p>
-          <a:p xmlns:a="http://schemas.openxmlformats.org/drawingml/2006/main">
-            <a:r>
-              <a:t>Storage became a key abstraction because a simple interface—name some data, read it, and write it—was general enough to support many different systems. MapReduce used GFS for input and output files. BigTable later stored its table data in GFS as well. If the storage layer handles scale and failures, every system above it becomes easier to build.</a:t>
-            </a:r>
-            <a:endParaRPr/>
-          </a:p>
-          <a:p xmlns:a="http://schemas.openxmlformats.org/drawingml/2006/main">
-            <a:r>
-              <a:t/>
-            </a:r>
-            <a:endParaRPr/>
-          </a:p>
-          <a:p xmlns:a="http://schemas.openxmlformats.org/drawingml/2006/main">
-            <a:r>
-              <a:t>That gives us two questions for today. What interface should this storage layer expose to applications? And what must happen behind that interface when the data is spread across many machines? Before we look at the GFS interface, we need to understand why the storage has to be distributed at all. Two pressures drive the design: one machine cannot provide enough capacity or throughput, and once data is spread across many machines, failures become routine.</a:t>
-            </a:r>
-            <a:endParaRPr/>
+          </a:p>
+          <a:p>
+            <a:endParaRPr dirty="0"/>
+          </a:p>
+          <a:p>
+            <a:r>
+              <a:rPr dirty="0"/>
+              <a:t>Storage became a key abstraction because a simple interface—name some data, read it, and write it—was general enough to support many different systems. MapReduce used GFS for input and output files. </a:t>
+            </a:r>
+            <a:r>
+              <a:rPr dirty="0" err="1"/>
+              <a:t>BigTable</a:t>
+            </a:r>
+            <a:r>
+              <a:rPr dirty="0"/>
+              <a:t> later stored its table data in GFS as well. If the storage layer handles scale and failures, every system above it becomes easier to build.</a:t>
+            </a:r>
+          </a:p>
+          <a:p>
+            <a:endParaRPr dirty="0"/>
+          </a:p>
+          <a:p>
+            <a:r>
+              <a:rPr dirty="0"/>
+              <a:t>Two pressures drive the design: one machine cannot provide enough capacity or throughput, and once data is spread across many machines, failures become routine.</a:t>
+            </a:r>
           </a:p>
         </p:txBody>
       </p:sp>
@@ -8346,7 +8335,7 @@
         <p:nvSpPr>
           <p:cNvPr id="4" name="Slide Number Placeholder 3"/>
           <p:cNvSpPr>
-            <a:spLocks xmlns:a="http://schemas.openxmlformats.org/drawingml/2006/main" noGrp="1"/>
+            <a:spLocks noGrp="1"/>
           </p:cNvSpPr>
           <p:nvPr>
             <p:ph type="sldNum" idx="5"/>
@@ -8354,15 +8343,17 @@
         </p:nvSpPr>
         <p:spPr/>
         <p:txBody>
-          <a:bodyPr xmlns:a="http://schemas.openxmlformats.org/drawingml/2006/main"/>
-          <a:lstStyle xmlns:a="http://schemas.openxmlformats.org/drawingml/2006/main"/>
-          <a:p xmlns:a="http://schemas.openxmlformats.org/drawingml/2006/main"/>
+          <a:bodyPr/>
+          <a:lstStyle/>
+          <a:p>
+            <a:endParaRPr/>
+          </a:p>
         </p:txBody>
       </p:sp>
     </p:spTree>
   </p:cSld>
   <p:clrMapOvr>
-    <a:masterClrMapping xmlns:a="http://schemas.openxmlformats.org/drawingml/2006/main"/>
+    <a:masterClrMapping/>
   </p:clrMapOvr>
 </p:notes>
 </file>
@@ -8484,269 +8475,7 @@
 </p:notes>
 </file>
 
-<file path=ppt/notesSlides/notesSlide6.xml><?xml version="1.0" encoding="utf-8"?>
-<p:notes xmlns:p="http://schemas.openxmlformats.org/presentationml/2006/main">
-  <p:cSld>
-    <p:spTree>
-      <p:nvGrpSpPr>
-        <p:cNvPr id="1" name=""/>
-        <p:cNvGrpSpPr/>
-        <p:nvPr/>
-      </p:nvGrpSpPr>
-      <p:grpSpPr>
-        <a:xfrm xmlns:a="http://schemas.openxmlformats.org/drawingml/2006/main"/>
-      </p:grpSpPr>
-      <p:sp>
-        <p:nvSpPr>
-          <p:cNvPr id="2" name="Slide Image Placeholder 1"/>
-          <p:cNvSpPr>
-            <a:spLocks xmlns:a="http://schemas.openxmlformats.org/drawingml/2006/main" noGrp="1"/>
-          </p:cNvSpPr>
-          <p:nvPr>
-            <p:ph type="sldImg" idx="0"/>
-          </p:nvPr>
-        </p:nvSpPr>
-        <p:spPr/>
-      </p:sp>
-      <p:sp>
-        <p:nvSpPr>
-          <p:cNvPr id="3" name="Notes Placeholder 2"/>
-          <p:cNvSpPr>
-            <a:spLocks xmlns:a="http://schemas.openxmlformats.org/drawingml/2006/main" noGrp="1"/>
-          </p:cNvSpPr>
-          <p:nvPr>
-            <p:ph type="body" idx="1"/>
-          </p:nvPr>
-        </p:nvSpPr>
-        <p:spPr/>
-        <p:txBody>
-          <a:bodyPr xmlns:a="http://schemas.openxmlformats.org/drawingml/2006/main"/>
-          <a:lstStyle xmlns:a="http://schemas.openxmlformats.org/drawingml/2006/main"/>
-          <a:p xmlns:a="http://schemas.openxmlformats.org/drawingml/2006/main">
-            <a:r>
-              <a:t>Start with the first pressure: one machine cannot provide enough capacity or throughput.</a:t>
-            </a:r>
-            <a:endParaRPr/>
-          </a:p>
-          <a:p xmlns:a="http://schemas.openxmlformats.org/drawingml/2006/main">
-            <a:r>
-              <a:t/>
-            </a:r>
-            <a:endParaRPr/>
-          </a:p>
-          <a:p xmlns:a="http://schemas.openxmlformats.org/drawingml/2006/main">
-            <a:r>
-              <a:t>Use the numbers on the slide as a scale estimate. A crawled copy of the web was on the order of hundreds of terabytes. At roughly 35 megabytes per second, one disk would take about four months just to scan 400 terabytes once. And the data would require roughly a thousand disks to store in the first place.</a:t>
-            </a:r>
-            <a:endParaRPr/>
-          </a:p>
-          <a:p xmlns:a="http://schemas.openxmlformats.org/drawingml/2006/main">
-            <a:r>
-              <a:t/>
-            </a:r>
-            <a:endParaRPr/>
-          </a:p>
-          <a:p xmlns:a="http://schemas.openxmlformats.org/drawingml/2006/main">
-            <a:r>
-              <a:t>So one machine is not merely inconvenient; it cannot hold the data or process it at the required rate. The natural solution is sharding: split each large file into pieces and place those pieces across many machines. Now one file can be larger than any single disk, and many clients can read different pieces in parallel. Aggregate throughput grows with the number of disks and servers.</a:t>
-            </a:r>
-            <a:endParaRPr/>
-          </a:p>
-          <a:p xmlns:a="http://schemas.openxmlformats.org/drawingml/2006/main">
-            <a:r>
-              <a:t/>
-            </a:r>
-            <a:endParaRPr/>
-          </a:p>
-          <a:p xmlns:a="http://schemas.openxmlformats.org/drawingml/2006/main">
-            <a:r>
-              <a:t>This decision solves the capacity and performance problem, but it creates the next problem. Once the system depends on hundreds or thousands of machines, some component will almost always be unavailable.</a:t>
-            </a:r>
-            <a:endParaRPr/>
-          </a:p>
-        </p:txBody>
-      </p:sp>
-      <p:sp>
-        <p:nvSpPr>
-          <p:cNvPr id="4" name="Slide Number Placeholder 3"/>
-          <p:cNvSpPr>
-            <a:spLocks xmlns:a="http://schemas.openxmlformats.org/drawingml/2006/main" noGrp="1"/>
-          </p:cNvSpPr>
-          <p:nvPr>
-            <p:ph type="sldNum" idx="5"/>
-          </p:nvPr>
-        </p:nvSpPr>
-        <p:spPr/>
-        <p:txBody>
-          <a:bodyPr xmlns:a="http://schemas.openxmlformats.org/drawingml/2006/main"/>
-          <a:lstStyle xmlns:a="http://schemas.openxmlformats.org/drawingml/2006/main"/>
-          <a:p xmlns:a="http://schemas.openxmlformats.org/drawingml/2006/main"/>
-        </p:txBody>
-      </p:sp>
-    </p:spTree>
-  </p:cSld>
-  <p:clrMapOvr>
-    <a:masterClrMapping xmlns:a="http://schemas.openxmlformats.org/drawingml/2006/main"/>
-  </p:clrMapOvr>
-</p:notes>
-</file>
-
-<file path=ppt/notesSlides/notesSlide7.xml><?xml version="1.0" encoding="utf-8"?>
-<p:notes xmlns:p="http://schemas.openxmlformats.org/presentationml/2006/main">
-  <p:cSld>
-    <p:spTree>
-      <p:nvGrpSpPr>
-        <p:cNvPr id="1" name=""/>
-        <p:cNvGrpSpPr/>
-        <p:nvPr/>
-      </p:nvGrpSpPr>
-      <p:grpSpPr>
-        <a:xfrm xmlns:a="http://schemas.openxmlformats.org/drawingml/2006/main"/>
-      </p:grpSpPr>
-      <p:sp>
-        <p:nvSpPr>
-          <p:cNvPr id="2" name="Slide Image Placeholder 1"/>
-          <p:cNvSpPr>
-            <a:spLocks xmlns:a="http://schemas.openxmlformats.org/drawingml/2006/main" noGrp="1"/>
-          </p:cNvSpPr>
-          <p:nvPr>
-            <p:ph type="sldImg" idx="0"/>
-          </p:nvPr>
-        </p:nvSpPr>
-        <p:spPr/>
-      </p:sp>
-      <p:sp>
-        <p:nvSpPr>
-          <p:cNvPr id="3" name="Notes Placeholder 2"/>
-          <p:cNvSpPr>
-            <a:spLocks xmlns:a="http://schemas.openxmlformats.org/drawingml/2006/main" noGrp="1"/>
-          </p:cNvSpPr>
-          <p:nvPr>
-            <p:ph type="body" idx="1"/>
-          </p:nvPr>
-        </p:nvSpPr>
-        <p:spPr/>
-        <p:txBody>
-          <a:bodyPr xmlns:a="http://schemas.openxmlformats.org/drawingml/2006/main"/>
-          <a:lstStyle xmlns:a="http://schemas.openxmlformats.org/drawingml/2006/main"/>
-          <a:p xmlns:a="http://schemas.openxmlformats.org/drawingml/2006/main">
-            <a:r>
-              <a:t>That brings us to the second pressure. Once storage depends on hundreds or thousands of machines, failure becomes the normal operating condition.</a:t>
-            </a:r>
-            <a:endParaRPr/>
-          </a:p>
-          <a:p xmlns:a="http://schemas.openxmlformats.org/drawingml/2006/main">
-            <a:r>
-              <a:t/>
-            </a:r>
-            <a:endParaRPr/>
-          </a:p>
-          <a:p xmlns:a="http://schemas.openxmlformats.org/drawingml/2006/main">
-            <a:r>
-              <a:t>Commodity machines provide much better performance per dollar, so Google built clusters from many ordinary servers and disks. More reliable hardware would reduce the failure rate, but it would not eliminate failures—and it would be far more expensive. Once the cluster contains a thousand machines and thousands of disks, even a small failure probability produces failures every day.</a:t>
-            </a:r>
-            <a:endParaRPr/>
-          </a:p>
-          <a:p xmlns:a="http://schemas.openxmlformats.org/drawingml/2006/main">
-            <a:r>
-              <a:t/>
-            </a:r>
-            <a:endParaRPr/>
-          </a:p>
-          <a:p xmlns:a="http://schemas.openxmlformats.org/drawingml/2006/main">
-            <a:r>
-              <a:t>The operational examples make this concrete: rack failures can remove dozens of machines at once; individual machines and disks fail repeatedly; network maintenance and transient communication failures also make healthy machines appear unavailable.</a:t>
-            </a:r>
-            <a:endParaRPr/>
-          </a:p>
-          <a:p xmlns:a="http://schemas.openxmlformats.org/drawingml/2006/main">
-            <a:r>
-              <a:t/>
-            </a:r>
-            <a:endParaRPr/>
-          </a:p>
-          <a:p xmlns:a="http://schemas.openxmlformats.org/drawingml/2006/main">
-            <a:r>
-              <a:t>Human repair cannot be part of the normal data-access path. The storage system must detect failures, keep serving data, and restore redundancy automatically. The standard technique is replication: keep several copies so that another copy remains available when one machine fails.</a:t>
-            </a:r>
-            <a:endParaRPr/>
-          </a:p>
-          <a:p xmlns:a="http://schemas.openxmlformats.org/drawingml/2006/main">
-            <a:r>
-              <a:t/>
-            </a:r>
-            <a:endParaRPr/>
-          </a:p>
-          <a:p xmlns:a="http://schemas.openxmlformats.org/drawingml/2006/main">
-            <a:r>
-              <a:t>Replication gives us fault tolerance, but it also creates a new question: how do we keep those copies from disagreeing?</a:t>
-            </a:r>
-            <a:endParaRPr/>
-          </a:p>
-          <a:p xmlns:a="http://schemas.openxmlformats.org/drawingml/2006/main">
-            <a:r>
-              <a:t/>
-            </a:r>
-            <a:endParaRPr/>
-          </a:p>
-          <a:p xmlns:a="http://schemas.openxmlformats.org/drawingml/2006/main">
-            <a:r>
-              <a:t>SOURCE</a:t>
-            </a:r>
-            <a:endParaRPr/>
-          </a:p>
-          <a:p xmlns:a="http://schemas.openxmlformats.org/drawingml/2006/main">
-            <a:r>
-              <a:t>MIT 6.824, Spring 2020, Lecture 3 transcript/video, 02:28–04:05 and 18:07–18:55.</a:t>
-            </a:r>
-            <a:endParaRPr/>
-          </a:p>
-          <a:p xmlns:a="http://schemas.openxmlformats.org/drawingml/2006/main">
-            <a:r>
-              <a:t>Local transcript: fall2026/lectures/references/mit-6824-2020-lecture3-gfs-transcript.txt</a:t>
-            </a:r>
-            <a:endParaRPr/>
-          </a:p>
-          <a:p xmlns:a="http://schemas.openxmlformats.org/drawingml/2006/main">
-            <a:r>
-              <a:t>EC528 Fall 2023 GFS lecture and Jeff Dean talks for the failure counts.</a:t>
-            </a:r>
-            <a:endParaRPr/>
-          </a:p>
-          <a:p xmlns:a="http://schemas.openxmlformats.org/drawingml/2006/main">
-            <a:r>
-              <a:t>https://www.youtube.com/watch?v=EpIgvowZr00</a:t>
-            </a:r>
-            <a:endParaRPr/>
-          </a:p>
-        </p:txBody>
-      </p:sp>
-      <p:sp>
-        <p:nvSpPr>
-          <p:cNvPr id="4" name="Slide Number Placeholder 3"/>
-          <p:cNvSpPr>
-            <a:spLocks xmlns:a="http://schemas.openxmlformats.org/drawingml/2006/main" noGrp="1"/>
-          </p:cNvSpPr>
-          <p:nvPr>
-            <p:ph type="sldNum" idx="5"/>
-          </p:nvPr>
-        </p:nvSpPr>
-        <p:spPr/>
-        <p:txBody>
-          <a:bodyPr xmlns:a="http://schemas.openxmlformats.org/drawingml/2006/main"/>
-          <a:lstStyle xmlns:a="http://schemas.openxmlformats.org/drawingml/2006/main"/>
-          <a:p xmlns:a="http://schemas.openxmlformats.org/drawingml/2006/main"/>
-        </p:txBody>
-      </p:sp>
-    </p:spTree>
-  </p:cSld>
-  <p:clrMapOvr>
-    <a:masterClrMapping xmlns:a="http://schemas.openxmlformats.org/drawingml/2006/main"/>
-  </p:clrMapOvr>
-</p:notes>
-</file>
-
-<file path=ppt/notesSlides/notesSlide8.xml><?xml version="1.0" encoding="utf-8"?>
+<file path=ppt/notesSlides/notesSlide51.xml><?xml version="1.0" encoding="utf-8"?>
 <p:notes xmlns:a="http://schemas.openxmlformats.org/drawingml/2006/main" xmlns:r="http://schemas.openxmlformats.org/officeDocument/2006/relationships" xmlns:p="http://schemas.openxmlformats.org/presentationml/2006/main">
   <p:cSld>
     <p:spTree>
@@ -8810,21 +8539,28 @@
           <a:p>
             <a:r>
               <a:rPr dirty="0"/>
-              <a:t>There are therefore two questions for this lecture. What interface should a large distributed storage system expose? And what must happen inside the system so that the interface remains useful when data spans many machines and those machines fail?</a:t>
+              <a:t>This is the write operation that matters for GFS, and the one the paper optimises. MIT makes the same choice in lecture: it starts to describe an ordinary offset write, then deliberately backs up and says it will only talk about record append.</a:t>
             </a:r>
             <a:endParaRPr lang="en-US" dirty="0"/>
           </a:p>
           <a:p>
             <a:r>
               <a:rPr dirty="0"/>
-              <a:t>PIVOT, about 20 seconds. The last three slides built the case: storage is the foundation, one machine cannot hold the data, and at that scale something is always broken. Stop here and name what the lecture has to answer.</a:t>
+              <a:t>Contrast it with the previous slide, where the client knew the offset. Here it does not, and that is the point: with many clients appending to one file, letting each pick its own offset would force them to coordinate, which is exactly what GFS wants to avoid. Think of a log that hundreds of web servers append to at once.</a:t>
             </a:r>
             <a:endParaRPr lang="en-US" dirty="0"/>
           </a:p>
           <a:p>
             <a:r>
               <a:rPr dirty="0"/>
-              <a:t>The first question is answered by the GFS API and its consistency guarantees; the second is what the next slide, and the rest of the lecture, is about.</a:t>
+              <a:t>The at-least-once promise is where the anomalies later in the lecture come from. A failed append is retried, so a record can land twice, and abandoned attempts leave padding behind. Point forward to "Why Are These Anomalies OK?".</a:t>
+            </a:r>
+            <a:endParaRPr lang="en-US" dirty="0"/>
+          </a:p>
+          <a:p>
+            <a:r>
+              <a:rPr dirty="0"/>
+              <a:t>This is also the honest answer to the first of the two questions: the interface is a file name plus a buffer, offered by a client library, not a POSIX file system.</a:t>
             </a:r>
             <a:endParaRPr lang="en-US" dirty="0"/>
           </a:p>
@@ -8838,14 +8574,28 @@
           <a:p>
             <a:r>
               <a:rPr dirty="0"/>
-              <a:t>MIT 6.5840, GFS lecture notes, "Why are we reading this paper?".</a:t>
+              <a:t>MIT 6.824, Spring 2020, Lecture 3 video, 40:04-43:00.</a:t>
             </a:r>
             <a:endParaRPr lang="en-US" dirty="0"/>
           </a:p>
           <a:p>
             <a:r>
               <a:rPr dirty="0"/>
-              <a:t>https://pdos.csail.mit.edu/6.824/notes/l-gfs.txt</a:t>
+              <a:t>https://www.youtube.com/watch?v=EpIgvowZr00</a:t>
+            </a:r>
+            <a:endParaRPr lang="en-US" dirty="0"/>
+          </a:p>
+          <a:p>
+            <a:r>
+              <a:rPr dirty="0"/>
+              <a:t>Ghemawat, Gobioff, and Leung, The Google File System, Sections 2.3 and 3.3.</a:t>
+            </a:r>
+            <a:endParaRPr lang="en-US" dirty="0"/>
+          </a:p>
+          <a:p>
+            <a:r>
+              <a:rPr dirty="0"/>
+              <a:t>https://pdos.csail.mit.edu/6.824/papers/gfs.pdf</a:t>
             </a:r>
             <a:endParaRPr lang="en-US" dirty="0"/>
           </a:p>
@@ -8874,7 +8624,7 @@
           <a:p>
             <a:fld id="{1C9584DC-3658-4054-9DA4-7B68A1D8CC6D}" type="slidenum">
               <a:rPr lang="zh-CN" altLang="en-US" smtClean="0"/>
-              <a:t>8</a:t>
+              <a:t>4</a:t>
             </a:fld>
             <a:endParaRPr lang="zh-CN" altLang="en-US"/>
           </a:p>
@@ -8893,18 +8643,12 @@
 </p:notes>
 </file>
 
-<file path=ppt/notesSlides/notesSlide9.xml><?xml version="1.0" encoding="utf-8"?>
+<file path=ppt/notesSlides/notesSlide6.xml><?xml version="1.0" encoding="utf-8"?>
 <p:notes xmlns:a="http://schemas.openxmlformats.org/drawingml/2006/main" xmlns:r="http://schemas.openxmlformats.org/officeDocument/2006/relationships" xmlns:p="http://schemas.openxmlformats.org/presentationml/2006/main">
   <p:cSld>
     <p:spTree>
       <p:nvGrpSpPr>
-        <p:cNvPr id="1" name="">
-          <a:extLst>
-            <a:ext uri="{FF2B5EF4-FFF2-40B4-BE49-F238E27FC236}">
-              <a16:creationId xmlns:a16="http://schemas.microsoft.com/office/drawing/2014/main" id="{4EC59D2F-F719-1204-3BE4-5648B3224DA8}"/>
-            </a:ext>
-          </a:extLst>
-        </p:cNvPr>
+        <p:cNvPr id="1" name=""/>
         <p:cNvGrpSpPr/>
         <p:nvPr/>
       </p:nvGrpSpPr>
@@ -8918,13 +8662,7 @@
       </p:grpSpPr>
       <p:sp>
         <p:nvSpPr>
-          <p:cNvPr id="2" name="Slide Image Placeholder 1">
-            <a:extLst>
-              <a:ext uri="{FF2B5EF4-FFF2-40B4-BE49-F238E27FC236}">
-                <a16:creationId xmlns:a16="http://schemas.microsoft.com/office/drawing/2014/main" id="{8AC7BD6E-9ED5-B0EB-2519-0B5A471E326C}"/>
-              </a:ext>
-            </a:extLst>
-          </p:cNvPr>
+          <p:cNvPr id="2" name="Slide Image Placeholder 1"/>
           <p:cNvSpPr>
             <a:spLocks noGrp="1" noRot="1" noChangeAspect="1"/>
           </p:cNvSpPr>
@@ -8936,13 +8674,7 @@
       </p:sp>
       <p:sp>
         <p:nvSpPr>
-          <p:cNvPr id="3" name="Notes Placeholder 2">
-            <a:extLst>
-              <a:ext uri="{FF2B5EF4-FFF2-40B4-BE49-F238E27FC236}">
-                <a16:creationId xmlns:a16="http://schemas.microsoft.com/office/drawing/2014/main" id="{A39AF431-6503-9F6E-44FB-746BDA533D73}"/>
-              </a:ext>
-            </a:extLst>
-          </p:cNvPr>
+          <p:cNvPr id="3" name="Notes Placeholder 2"/>
           <p:cNvSpPr>
             <a:spLocks noGrp="1"/>
           </p:cNvSpPr>
@@ -8956,89 +8688,47 @@
           <a:lstStyle/>
           <a:p>
             <a:r>
-              <a:rPr lang="en-US" dirty="0"/>
-              <a:t>This diagram summarizes the design pressure we have just built up.</a:t>
-            </a:r>
-          </a:p>
-          <a:p>
-            <a:endParaRPr lang="en-US" dirty="0"/>
-          </a:p>
-          <a:p>
-            <a:r>
-              <a:rPr lang="en-US" dirty="0"/>
-              <a:t>We begin with performance. To obtain high aggregate throughput and enough capacity, we shard data across many servers. With many servers, failures become routine, so the system must tolerate them automatically. Replication is the basic tool: keep multiple copies and use a surviving copy when another one fails.</a:t>
-            </a:r>
-          </a:p>
-          <a:p>
-            <a:endParaRPr lang="en-US" dirty="0"/>
-          </a:p>
-          <a:p>
-            <a:r>
-              <a:rPr lang="en-US" dirty="0"/>
-              <a:t>But replication changes the correctness problem. Two copies are useful only if they represent the same data. Concurrent writes, lost messages, or a server failure in the middle of an update can leave replicas in different states. Different readers may then observe different answers.</a:t>
-            </a:r>
-          </a:p>
-          <a:p>
-            <a:endParaRPr lang="en-US" dirty="0"/>
-          </a:p>
-          <a:p>
-            <a:r>
-              <a:rPr lang="en-US" dirty="0"/>
-              <a:t>We can coordinate the replicas more carefully and provide behavior closer to a single correct server, but that requires additional messages, waiting, and recovery logic. GFS deliberately chooses a point in this tradeoff space. It prioritizes high throughput and a relatively simple design for Google's batch workloads, while exposing weaker behavior in some failure cases.</a:t>
-            </a:r>
-          </a:p>
-          <a:p>
-            <a:endParaRPr lang="en-US" dirty="0"/>
-          </a:p>
-          <a:p>
-            <a:r>
-              <a:rPr lang="en-US" dirty="0"/>
-              <a:t>Before examining the GFS protocol, the next slide defines the single-server behavior we would ideally like to preserve.</a:t>
-            </a:r>
-          </a:p>
-          <a:p>
-            <a:endParaRPr lang="en-US" dirty="0"/>
-          </a:p>
-          <a:p>
-            <a:r>
-              <a:rPr lang="en-US" dirty="0"/>
-              <a:t>SOURCE</a:t>
-            </a:r>
-          </a:p>
-          <a:p>
-            <a:r>
-              <a:rPr lang="en-US" dirty="0"/>
-              <a:t>MIT 6.824, Spring 2020, Lecture 3 transcript/video, 02:28–05:42.</a:t>
-            </a:r>
-          </a:p>
-          <a:p>
-            <a:r>
-              <a:rPr lang="en-US" dirty="0"/>
-              <a:t>Local transcript: fall2026/lectures/references/mit-6824-2020-lecture3-gfs-transcript.txt</a:t>
-            </a:r>
-          </a:p>
-          <a:p>
-            <a:r>
-              <a:rPr lang="en-US" dirty="0"/>
-              <a:t>https://www.youtube.com/watch?v=EpIgvowZr00</a:t>
-            </a:r>
-          </a:p>
-        </p:txBody>
-      </p:sp>
-      <p:sp>
-        <p:nvSpPr>
-          <p:cNvPr id="4" name="Slide Number Placeholder 3">
-            <a:extLst>
-              <a:ext uri="{FF2B5EF4-FFF2-40B4-BE49-F238E27FC236}">
-                <a16:creationId xmlns:a16="http://schemas.microsoft.com/office/drawing/2014/main" id="{E8FE7602-B30B-17D7-6742-4BE51445636D}"/>
-              </a:ext>
-            </a:extLst>
-          </p:cNvPr>
+              <a:rPr dirty="0"/>
+              <a:t>Start with the first pressure: one machine cannot provide enough capacity or throughput.</a:t>
+            </a:r>
+          </a:p>
+          <a:p>
+            <a:endParaRPr dirty="0"/>
+          </a:p>
+          <a:p>
+            <a:r>
+              <a:rPr dirty="0"/>
+              <a:t>Use the numbers on the slide as a scale estimate. A crawled copy of the web was on the order of hundreds of terabytes. At roughly 35 megabytes per second, one disk would take about four months just to scan 400 terabytes once. And the data would require roughly a thousand disks to store in the first place.</a:t>
+            </a:r>
+          </a:p>
+          <a:p>
+            <a:endParaRPr dirty="0"/>
+          </a:p>
+          <a:p>
+            <a:r>
+              <a:rPr dirty="0"/>
+              <a:t>So one machine is not merely inconvenient; it cannot hold the data or process it at the required rate. The natural solution is sharding: split each large file into pieces and place those pieces across many machines. Now one file can be larger than any single disk, and many clients can read different pieces in parallel. Aggregate throughput grows with the number of disks and servers.</a:t>
+            </a:r>
+          </a:p>
+          <a:p>
+            <a:endParaRPr dirty="0"/>
+          </a:p>
+          <a:p>
+            <a:r>
+              <a:rPr dirty="0"/>
+              <a:t>This decision solves the capacity and performance problem, but it creates the next problem. Once the system depends on hundreds or thousands of machines, some component will almost always be unavailable.</a:t>
+            </a:r>
+          </a:p>
+        </p:txBody>
+      </p:sp>
+      <p:sp>
+        <p:nvSpPr>
+          <p:cNvPr id="4" name="Slide Number Placeholder 3"/>
           <p:cNvSpPr>
             <a:spLocks noGrp="1"/>
           </p:cNvSpPr>
           <p:nvPr>
-            <p:ph type="sldNum" sz="quarter" idx="5"/>
+            <p:ph type="sldNum" idx="5"/>
           </p:nvPr>
         </p:nvSpPr>
         <p:spPr/>
@@ -9046,23 +8736,415 @@
           <a:bodyPr/>
           <a:lstStyle/>
           <a:p>
-            <a:fld id="{1C9584DC-3658-4054-9DA4-7B68A1D8CC6D}" type="slidenum">
-              <a:rPr lang="zh-CN" altLang="en-US" smtClean="0"/>
-              <a:t>9</a:t>
-            </a:fld>
-            <a:endParaRPr lang="zh-CN" altLang="en-US"/>
+            <a:endParaRPr/>
           </a:p>
         </p:txBody>
       </p:sp>
     </p:spTree>
-    <p:extLst>
-      <p:ext uri="{BB962C8B-B14F-4D97-AF65-F5344CB8AC3E}">
-        <p14:creationId xmlns:p14="http://schemas.microsoft.com/office/powerpoint/2010/main" val="2775443294"/>
-      </p:ext>
-    </p:extLst>
   </p:cSld>
   <p:clrMapOvr>
     <a:masterClrMapping/>
+  </p:clrMapOvr>
+</p:notes>
+</file>
+
+<file path=ppt/notesSlides/notesSlide7.xml><?xml version="1.0" encoding="utf-8"?>
+<p:notes xmlns:a="http://schemas.openxmlformats.org/drawingml/2006/main" xmlns:r="http://schemas.openxmlformats.org/officeDocument/2006/relationships" xmlns:p="http://schemas.openxmlformats.org/presentationml/2006/main">
+  <p:cSld>
+    <p:spTree>
+      <p:nvGrpSpPr>
+        <p:cNvPr id="1" name=""/>
+        <p:cNvGrpSpPr/>
+        <p:nvPr/>
+      </p:nvGrpSpPr>
+      <p:grpSpPr>
+        <a:xfrm>
+          <a:off x="0" y="0"/>
+          <a:ext cx="0" cy="0"/>
+          <a:chOff x="0" y="0"/>
+          <a:chExt cx="0" cy="0"/>
+        </a:xfrm>
+      </p:grpSpPr>
+      <p:sp>
+        <p:nvSpPr>
+          <p:cNvPr id="2" name="Slide Image Placeholder 1"/>
+          <p:cNvSpPr>
+            <a:spLocks noGrp="1" noRot="1" noChangeAspect="1"/>
+          </p:cNvSpPr>
+          <p:nvPr>
+            <p:ph type="sldImg"/>
+          </p:nvPr>
+        </p:nvSpPr>
+        <p:spPr/>
+      </p:sp>
+      <p:sp>
+        <p:nvSpPr>
+          <p:cNvPr id="3" name="Notes Placeholder 2"/>
+          <p:cNvSpPr>
+            <a:spLocks noGrp="1"/>
+          </p:cNvSpPr>
+          <p:nvPr>
+            <p:ph type="body" idx="1"/>
+          </p:nvPr>
+        </p:nvSpPr>
+        <p:spPr/>
+        <p:txBody>
+          <a:bodyPr/>
+          <a:lstStyle/>
+          <a:p>
+            <a:endParaRPr lang="en-US" dirty="0"/>
+          </a:p>
+          <a:p>
+            <a:r>
+              <a:rPr dirty="0"/>
+              <a:t>That brings us to the second pressure. Once storage depends on hundreds or thousands of machines, failure becomes the normal operating condition.</a:t>
+            </a:r>
+          </a:p>
+          <a:p>
+            <a:endParaRPr dirty="0"/>
+          </a:p>
+          <a:p>
+            <a:r>
+              <a:rPr dirty="0"/>
+              <a:t>Commodity machines provide much better performance per dollar, so Google built clusters from many ordinary servers and disks. More reliable hardware would reduce the failure rate, but it would not eliminate failures—and it would be far more expensive. Once the cluster contains a thousand machines and thousands of disks, even a small failure probability produces failures every day.</a:t>
+            </a:r>
+          </a:p>
+          <a:p>
+            <a:endParaRPr dirty="0"/>
+          </a:p>
+          <a:p>
+            <a:r>
+              <a:rPr dirty="0"/>
+              <a:t>The operational examples make this concrete: rack failures can remove dozens of machines at once; individual machines and disks fail repeatedly; network maintenance and transient communication failures also make healthy machines appear unavailable.</a:t>
+            </a:r>
+          </a:p>
+          <a:p>
+            <a:endParaRPr dirty="0"/>
+          </a:p>
+          <a:p>
+            <a:r>
+              <a:rPr dirty="0"/>
+              <a:t>Human repair cannot be part of the normal data-access path. The storage system must detect failures, keep serving data, and restore redundancy automatically. The standard technique is replication: keep several copies so that another copy remains available when one machine fails.</a:t>
+            </a:r>
+          </a:p>
+          <a:p>
+            <a:endParaRPr dirty="0"/>
+          </a:p>
+          <a:p>
+            <a:r>
+              <a:rPr dirty="0"/>
+              <a:t>Replication gives us fault tolerance, but it also creates a new question: how do we keep those copies from disagreeing</a:t>
+            </a:r>
+            <a:r>
+              <a:rPr lang="en-US" dirty="0"/>
+              <a:t>?</a:t>
+            </a:r>
+          </a:p>
+        </p:txBody>
+      </p:sp>
+      <p:sp>
+        <p:nvSpPr>
+          <p:cNvPr id="4" name="Slide Number Placeholder 3"/>
+          <p:cNvSpPr>
+            <a:spLocks noGrp="1"/>
+          </p:cNvSpPr>
+          <p:nvPr>
+            <p:ph type="sldNum" idx="5"/>
+          </p:nvPr>
+        </p:nvSpPr>
+        <p:spPr/>
+        <p:txBody>
+          <a:bodyPr/>
+          <a:lstStyle/>
+          <a:p>
+            <a:endParaRPr/>
+          </a:p>
+        </p:txBody>
+      </p:sp>
+    </p:spTree>
+  </p:cSld>
+  <p:clrMapOvr>
+    <a:masterClrMapping/>
+  </p:clrMapOvr>
+</p:notes>
+</file>
+
+<file path=ppt/notesSlides/notesSlide8.xml><?xml version="1.0" encoding="utf-8"?>
+<p:notes xmlns:p="http://schemas.openxmlformats.org/presentationml/2006/main">
+  <p:cSld>
+    <p:spTree>
+      <p:nvGrpSpPr>
+        <p:cNvPr id="1" name=""/>
+        <p:cNvGrpSpPr/>
+        <p:nvPr/>
+      </p:nvGrpSpPr>
+      <p:grpSpPr>
+        <a:xfrm xmlns:a="http://schemas.openxmlformats.org/drawingml/2006/main"/>
+      </p:grpSpPr>
+      <p:sp>
+        <p:nvSpPr>
+          <p:cNvPr id="2" name="Slide Image Placeholder 1"/>
+          <p:cNvSpPr>
+            <a:spLocks xmlns:a="http://schemas.openxmlformats.org/drawingml/2006/main" noGrp="1"/>
+          </p:cNvSpPr>
+          <p:nvPr>
+            <p:ph type="sldImg" idx="0"/>
+          </p:nvPr>
+        </p:nvSpPr>
+        <p:spPr/>
+      </p:sp>
+      <p:sp>
+        <p:nvSpPr>
+          <p:cNvPr id="3" name="Notes Placeholder 2"/>
+          <p:cNvSpPr>
+            <a:spLocks xmlns:a="http://schemas.openxmlformats.org/drawingml/2006/main" noGrp="1"/>
+          </p:cNvSpPr>
+          <p:nvPr>
+            <p:ph type="body" idx="1"/>
+          </p:nvPr>
+        </p:nvSpPr>
+        <p:spPr/>
+        <p:txBody>
+          <a:bodyPr xmlns:a="http://schemas.openxmlformats.org/drawingml/2006/main"/>
+          <a:lstStyle xmlns:a="http://schemas.openxmlformats.org/drawingml/2006/main"/>
+          <a:p xmlns:a="http://schemas.openxmlformats.org/drawingml/2006/main">
+            <a:pPr marL="0" marR="0" lvl="0" indent="0" algn="l" defTabSz="914400">
+              <a:lnSpc>
+                <a:spcPct val="100000"/>
+              </a:lnSpc>
+              <a:spcBef>
+                <a:spcPts val="0"/>
+              </a:spcBef>
+              <a:spcAft>
+                <a:spcPts val="0"/>
+              </a:spcAft>
+              <a:buClrTx/>
+              <a:buSzTx/>
+              <a:buFontTx/>
+              <a:buNone/>
+            </a:pPr>
+            <a:r>
+              <a:t>The chain on the previous slide leaves us with two questions.</a:t>
+            </a:r>
+          </a:p>
+          <a:p xmlns:a="http://schemas.openxmlformats.org/drawingml/2006/main">
+            <a:r>
+              <a:t/>
+            </a:r>
+            <a:endParaRPr/>
+          </a:p>
+          <a:p xmlns:a="http://schemas.openxmlformats.org/drawingml/2006/main">
+            <a:r>
+              <a:t>First, when data is spread and replicated across machines that fail, how can the system keep the data correct? The next slide states the behavior we would ideally like, and the following slides show why naive replication cannot provide it.</a:t>
+            </a:r>
+            <a:endParaRPr/>
+          </a:p>
+          <a:p xmlns:a="http://schemas.openxmlformats.org/drawingml/2006/main">
+            <a:pPr marL="0" marR="0" lvl="0" indent="0" algn="l" defTabSz="914400">
+              <a:lnSpc>
+                <a:spcPct val="100000"/>
+              </a:lnSpc>
+              <a:spcBef>
+                <a:spcPts val="0"/>
+              </a:spcBef>
+              <a:spcAft>
+                <a:spcPts val="0"/>
+              </a:spcAft>
+              <a:buClrTx/>
+              <a:buSzTx/>
+              <a:buFontTx/>
+              <a:buNone/>
+            </a:pPr>
+            <a:r>
+              <a:t/>
+            </a:r>
+          </a:p>
+          <a:p xmlns:a="http://schemas.openxmlformats.org/drawingml/2006/main">
+            <a:pPr marL="0" marR="0" lvl="0" indent="0" algn="l" defTabSz="914400">
+              <a:lnSpc>
+                <a:spcPct val="100000"/>
+              </a:lnSpc>
+              <a:spcBef>
+                <a:spcPts val="0"/>
+              </a:spcBef>
+              <a:spcAft>
+                <a:spcPts val="0"/>
+              </a:spcAft>
+              <a:buClrTx/>
+              <a:buSzTx/>
+              <a:buFontTx/>
+              <a:buNone/>
+            </a:pPr>
+            <a:r>
+              <a:t>Second, what performance cost must we pay to obtain that correctness? Coordinating replicas can preserve the illusion of one correct server, but the extra messages and waiting increase latency and can reduce throughput.</a:t>
+            </a:r>
+          </a:p>
+          <a:p xmlns:a="http://schemas.openxmlformats.org/drawingml/2006/main">
+            <a:pPr marL="0" marR="0" lvl="0" indent="0" algn="l" defTabSz="914400">
+              <a:lnSpc>
+                <a:spcPct val="100000"/>
+              </a:lnSpc>
+              <a:spcBef>
+                <a:spcPts val="0"/>
+              </a:spcBef>
+              <a:spcAft>
+                <a:spcPts val="0"/>
+              </a:spcAft>
+              <a:buClrTx/>
+              <a:buSzTx/>
+              <a:buFontTx/>
+              <a:buNone/>
+            </a:pPr>
+            <a:r>
+              <a:t/>
+            </a:r>
+          </a:p>
+          <a:p xmlns:a="http://schemas.openxmlformats.org/drawingml/2006/main">
+            <a:pPr marL="0" marR="0" lvl="0" indent="0" algn="l" defTabSz="914400">
+              <a:lnSpc>
+                <a:spcPct val="100000"/>
+              </a:lnSpc>
+              <a:spcBef>
+                <a:spcPts val="0"/>
+              </a:spcBef>
+              <a:spcAft>
+                <a:spcPts val="0"/>
+              </a:spcAft>
+              <a:buClrTx/>
+              <a:buSzTx/>
+              <a:buFontTx/>
+              <a:buNone/>
+            </a:pPr>
+            <a:r>
+              <a:t>GFS answers both questions by choosing consistency guarantees and protocols that fit Google's workloads.</a:t>
+            </a:r>
+          </a:p>
+        </p:txBody>
+      </p:sp>
+      <p:sp>
+        <p:nvSpPr>
+          <p:cNvPr id="4" name="Slide Number Placeholder 3"/>
+          <p:cNvSpPr>
+            <a:spLocks xmlns:a="http://schemas.openxmlformats.org/drawingml/2006/main" noGrp="1"/>
+          </p:cNvSpPr>
+          <p:nvPr>
+            <p:ph type="sldNum" idx="5"/>
+          </p:nvPr>
+        </p:nvSpPr>
+        <p:spPr/>
+        <p:txBody>
+          <a:bodyPr xmlns:a="http://schemas.openxmlformats.org/drawingml/2006/main"/>
+          <a:lstStyle xmlns:a="http://schemas.openxmlformats.org/drawingml/2006/main"/>
+          <a:p xmlns:a="http://schemas.openxmlformats.org/drawingml/2006/main"/>
+        </p:txBody>
+      </p:sp>
+    </p:spTree>
+  </p:cSld>
+  <p:clrMapOvr>
+    <a:masterClrMapping xmlns:a="http://schemas.openxmlformats.org/drawingml/2006/main"/>
+  </p:clrMapOvr>
+</p:notes>
+</file>
+
+<file path=ppt/notesSlides/notesSlide9.xml><?xml version="1.0" encoding="utf-8"?>
+<p:notes xmlns:p="http://schemas.openxmlformats.org/presentationml/2006/main">
+  <p:cSld>
+    <p:spTree>
+      <p:nvGrpSpPr>
+        <p:cNvPr id="1" name=""/>
+        <p:cNvGrpSpPr/>
+        <p:nvPr/>
+      </p:nvGrpSpPr>
+      <p:grpSpPr>
+        <a:xfrm xmlns:a="http://schemas.openxmlformats.org/drawingml/2006/main"/>
+      </p:grpSpPr>
+      <p:sp>
+        <p:nvSpPr>
+          <p:cNvPr id="2" name="Slide Image Placeholder 1"/>
+          <p:cNvSpPr>
+            <a:spLocks xmlns:a="http://schemas.openxmlformats.org/drawingml/2006/main" noGrp="1"/>
+          </p:cNvSpPr>
+          <p:nvPr>
+            <p:ph type="sldImg" idx="0"/>
+          </p:nvPr>
+        </p:nvSpPr>
+        <p:spPr/>
+      </p:sp>
+      <p:sp>
+        <p:nvSpPr>
+          <p:cNvPr id="3" name="Notes Placeholder 2"/>
+          <p:cNvSpPr>
+            <a:spLocks xmlns:a="http://schemas.openxmlformats.org/drawingml/2006/main" noGrp="1"/>
+          </p:cNvSpPr>
+          <p:nvPr>
+            <p:ph type="body" idx="1"/>
+          </p:nvPr>
+        </p:nvSpPr>
+        <p:spPr/>
+        <p:txBody>
+          <a:bodyPr xmlns:a="http://schemas.openxmlformats.org/drawingml/2006/main"/>
+          <a:lstStyle xmlns:a="http://schemas.openxmlformats.org/drawingml/2006/main"/>
+          <a:p xmlns:a="http://schemas.openxmlformats.org/drawingml/2006/main">
+            <a:r>
+              <a:t>This slide makes the chain explicit. We need fault tolerance because machines fail. Fault tolerance requires replication: keep multiple copies and use a surviving copy when another one fails.</a:t>
+            </a:r>
+          </a:p>
+          <a:p xmlns:a="http://schemas.openxmlformats.org/drawingml/2006/main">
+            <a:r>
+              <a:t/>
+            </a:r>
+            <a:endParaRPr/>
+          </a:p>
+          <a:p xmlns:a="http://schemas.openxmlformats.org/drawingml/2006/main">
+            <a:r>
+              <a:t>But replication changes the correctness problem. Writes can reach the copies in different orders, or a server can fail partway through an update. The replicas may then contain different data.</a:t>
+            </a:r>
+          </a:p>
+          <a:p xmlns:a="http://schemas.openxmlformats.org/drawingml/2006/main">
+            <a:r>
+              <a:t/>
+            </a:r>
+            <a:endParaRPr/>
+          </a:p>
+          <a:p xmlns:a="http://schemas.openxmlformats.org/drawingml/2006/main">
+            <a:r>
+              <a:t>Stronger consistency requires the replicas to coordinate on an order and wait for enough copies. That coordination adds messages and waiting, so it increases latency and can reduce throughput.</a:t>
+            </a:r>
+          </a:p>
+          <a:p xmlns:a="http://schemas.openxmlformats.org/drawingml/2006/main">
+            <a:r>
+              <a:t/>
+            </a:r>
+            <a:endParaRPr/>
+          </a:p>
+          <a:p xmlns:a="http://schemas.openxmlformats.org/drawingml/2006/main">
+            <a:r>
+              <a:t>This is the tradeoff that motivates the rest of the lecture: how do we keep replicated data correct, and how much performance are we willing to pay for that correctness?</a:t>
+            </a:r>
+          </a:p>
+        </p:txBody>
+      </p:sp>
+      <p:sp>
+        <p:nvSpPr>
+          <p:cNvPr id="4" name="Slide Number Placeholder 3"/>
+          <p:cNvSpPr>
+            <a:spLocks xmlns:a="http://schemas.openxmlformats.org/drawingml/2006/main" noGrp="1"/>
+          </p:cNvSpPr>
+          <p:nvPr>
+            <p:ph type="sldNum" idx="5"/>
+          </p:nvPr>
+        </p:nvSpPr>
+        <p:spPr/>
+        <p:txBody>
+          <a:bodyPr xmlns:a="http://schemas.openxmlformats.org/drawingml/2006/main"/>
+          <a:lstStyle xmlns:a="http://schemas.openxmlformats.org/drawingml/2006/main"/>
+          <a:p xmlns:a="http://schemas.openxmlformats.org/drawingml/2006/main"/>
+        </p:txBody>
+      </p:sp>
+    </p:spTree>
+  </p:cSld>
+  <p:clrMapOvr>
+    <a:masterClrMapping xmlns:a="http://schemas.openxmlformats.org/drawingml/2006/main"/>
   </p:clrMapOvr>
 </p:notes>
 </file>
@@ -15202,6 +15284,63 @@
             <a:endParaRPr lang="en-US" sz="2800" dirty="0">
               <a:effectLst/>
             </a:endParaRPr>
+          </a:p>
+        </p:txBody>
+      </p:sp>
+      <p:sp>
+        <p:nvSpPr>
+          <p:cNvPr id="9" name="Interface question">
+            <a:extLst>
+              <a:ext uri="{FF2B5EF4-FFF2-40B4-BE49-F238E27FC236}">
+                <a16:creationId xmlns:a16="http://schemas.microsoft.com/office/drawing/2014/main" id="{32AA9800-7FDB-4DEB-80B5-FE9FA5B76952}"/>
+              </a:ext>
+            </a:extLst>
+          </p:cNvPr>
+          <p:cNvSpPr>
+            <a:spLocks noGrp="1"/>
+          </p:cNvSpPr>
+          <p:nvPr/>
+        </p:nvSpPr>
+        <p:spPr>
+          <a:xfrm>
+            <a:off x="164402" y="1600200"/>
+            <a:ext cx="11191875" cy="419100"/>
+          </a:xfrm>
+          <a:prstGeom prst="rect">
+            <a:avLst/>
+          </a:prstGeom>
+          <a:noFill/>
+          <a:ln w="0">
+            <a:noFill/>
+          </a:ln>
+        </p:spPr>
+        <p:txBody>
+          <a:bodyPr>
+            <a:normAutofit fontScale="76786"/>
+          </a:bodyPr>
+          <a:lstStyle/>
+          <a:p>
+            <a:pPr>
+              <a:defRPr sz="2800" b="1">
+                <a:solidFill>
+                  <a:srgbClr val="A02B93"/>
+                </a:solidFill>
+                <a:latin typeface="Aptos"/>
+                <a:ea typeface="Aptos"/>
+                <a:cs typeface="Aptos"/>
+              </a:defRPr>
+            </a:pPr>
+            <a:r>
+              <a:rPr sz="2800" b="1">
+                <a:solidFill>
+                  <a:srgbClr val="A02B93"/>
+                </a:solidFill>
+                <a:latin typeface="Aptos"/>
+                <a:ea typeface="Aptos"/>
+                <a:cs typeface="Aptos"/>
+              </a:rPr>
+              <a:t>What interface should GFS expose to applications?</a:t>
+            </a:r>
           </a:p>
         </p:txBody>
       </p:sp>
@@ -28598,6 +28737,203 @@
 </p:sld>
 </file>
 
+<file path=ppt/slides/slide51.xml><?xml version="1.0" encoding="utf-8"?>
+<p:sld xmlns:a="http://schemas.openxmlformats.org/drawingml/2006/main" xmlns:r="http://schemas.openxmlformats.org/officeDocument/2006/relationships" xmlns:p="http://schemas.openxmlformats.org/presentationml/2006/main">
+  <p:cSld>
+    <p:spTree>
+      <p:nvGrpSpPr>
+        <p:cNvPr id="1" name="">
+          <a:extLst>
+            <a:ext uri="{FF2B5EF4-FFF2-40B4-BE49-F238E27FC236}">
+              <a16:creationId xmlns:a16="http://schemas.microsoft.com/office/drawing/2014/main" id="{872729AB-5EBB-FD20-43DD-D6E0374E6833}"/>
+            </a:ext>
+          </a:extLst>
+        </p:cNvPr>
+        <p:cNvGrpSpPr/>
+        <p:nvPr/>
+      </p:nvGrpSpPr>
+      <p:grpSpPr>
+        <a:xfrm>
+          <a:off x="0" y="0"/>
+          <a:ext cx="0" cy="0"/>
+          <a:chOff x="0" y="0"/>
+          <a:chExt cx="0" cy="0"/>
+        </a:xfrm>
+      </p:grpSpPr>
+      <p:sp>
+        <p:nvSpPr>
+          <p:cNvPr id="7" name="Title 1">
+            <a:extLst>
+              <a:ext uri="{FF2B5EF4-FFF2-40B4-BE49-F238E27FC236}">
+                <a16:creationId xmlns:a16="http://schemas.microsoft.com/office/drawing/2014/main" id="{2ED557C7-2CDD-8C0B-07A1-1DABA8EF652A}"/>
+              </a:ext>
+            </a:extLst>
+          </p:cNvPr>
+          <p:cNvSpPr>
+            <a:spLocks noGrp="1"/>
+          </p:cNvSpPr>
+          <p:nvPr>
+            <p:ph type="title"/>
+          </p:nvPr>
+        </p:nvSpPr>
+        <p:spPr>
+          <a:xfrm>
+            <a:off x="0" y="1"/>
+            <a:ext cx="12191999" cy="914400"/>
+          </a:xfrm>
+        </p:spPr>
+        <p:txBody>
+          <a:bodyPr>
+            <a:normAutofit/>
+          </a:bodyPr>
+          <a:lstStyle/>
+          <a:p>
+            <a:pPr algn="ctr"/>
+            <a:r>
+              <a:rPr lang="en-US" b="1" dirty="0">
+                <a:latin typeface="Helvetica" panose="020B0604020202020204" pitchFamily="34" charset="0"/>
+                <a:cs typeface="Helvetica" panose="020B0604020202020204" pitchFamily="34" charset="0"/>
+              </a:rPr>
+              <a:t>Record Append</a:t>
+            </a:r>
+          </a:p>
+        </p:txBody>
+      </p:sp>
+      <p:sp>
+        <p:nvSpPr>
+          <p:cNvPr id="8" name="Slide Number Placeholder 4">
+            <a:extLst>
+              <a:ext uri="{FF2B5EF4-FFF2-40B4-BE49-F238E27FC236}">
+                <a16:creationId xmlns:a16="http://schemas.microsoft.com/office/drawing/2014/main" id="{25E098EE-1299-32C0-2821-1DB599BAC8E9}"/>
+              </a:ext>
+            </a:extLst>
+          </p:cNvPr>
+          <p:cNvSpPr>
+            <a:spLocks noGrp="1"/>
+          </p:cNvSpPr>
+          <p:nvPr>
+            <p:ph type="sldNum" sz="quarter" idx="12"/>
+          </p:nvPr>
+        </p:nvSpPr>
+        <p:spPr>
+          <a:xfrm>
+            <a:off x="8610600" y="6356350"/>
+            <a:ext cx="2743200" cy="365125"/>
+          </a:xfrm>
+        </p:spPr>
+        <p:txBody>
+          <a:bodyPr/>
+          <a:lstStyle/>
+          <a:p>
+            <a:fld id="{212DA15D-5F50-8B40-811F-34F736B90848}" type="slidenum">
+              <a:rPr lang="en-US" smtClean="0"/>
+              <a:t>4</a:t>
+            </a:fld>
+            <a:endParaRPr lang="en-US"/>
+          </a:p>
+        </p:txBody>
+      </p:sp>
+      <p:sp>
+        <p:nvSpPr>
+          <p:cNvPr id="3" name="TextBox 2">
+            <a:extLst>
+              <a:ext uri="{FF2B5EF4-FFF2-40B4-BE49-F238E27FC236}">
+                <a16:creationId xmlns:a16="http://schemas.microsoft.com/office/drawing/2014/main" id="{857EC8A2-DB9F-8BB1-7445-FE716E76BAC5}"/>
+              </a:ext>
+            </a:extLst>
+          </p:cNvPr>
+          <p:cNvSpPr txBox="1"/>
+          <p:nvPr/>
+        </p:nvSpPr>
+        <p:spPr>
+          <a:xfrm>
+            <a:off x="88135" y="914401"/>
+            <a:ext cx="11265665" cy="5016758"/>
+          </a:xfrm>
+          <a:prstGeom prst="rect">
+            <a:avLst/>
+          </a:prstGeom>
+          <a:noFill/>
+        </p:spPr>
+        <p:txBody>
+          <a:bodyPr wrap="square" rtlCol="0">
+            <a:spAutoFit/>
+          </a:bodyPr>
+          <a:lstStyle/>
+          <a:p>
+            <a:r>
+              <a:rPr lang="en-US" sz="3200" b="1" dirty="0"/>
+              <a:t>An ordinary write names a file, an offset and a buffer</a:t>
+            </a:r>
+          </a:p>
+          <a:p>
+            <a:pPr marL="457200"/>
+            <a:r>
+              <a:rPr lang="en-US" sz="2800" b="0" dirty="0"/>
+              <a:t>Concurrent writes to the same range interleave, so clients must coordinate</a:t>
+            </a:r>
+          </a:p>
+          <a:p>
+            <a:r>
+              <a:rPr lang="en-US" sz="3200" b="1" dirty="0"/>
+              <a:t>A record append names a file and a buffer, but no offset</a:t>
+            </a:r>
+          </a:p>
+          <a:p>
+            <a:pPr marL="457200"/>
+            <a:r>
+              <a:rPr lang="en-US" sz="2800" b="0" dirty="0"/>
+              <a:t>The primary picks the offset at the end of the chunk and tells every replica to use it</a:t>
+            </a:r>
+          </a:p>
+          <a:p>
+            <a:pPr marL="457200"/>
+            <a:r>
+              <a:rPr lang="en-US" sz="2800" b="0" dirty="0"/>
+              <a:t>Many clients can append to one file at once without coordinating with each other</a:t>
+            </a:r>
+          </a:p>
+          <a:p>
+            <a:r>
+              <a:rPr lang="en-US" sz="3200" b="1" dirty="0"/>
+              <a:t>What the client is promised</a:t>
+            </a:r>
+          </a:p>
+          <a:p>
+            <a:pPr marL="457200"/>
+            <a:r>
+              <a:rPr lang="en-US" sz="2800" b="0" dirty="0"/>
+              <a:t>On success: the record is in every replica, at the same offset, at least once</a:t>
+            </a:r>
+          </a:p>
+          <a:p>
+            <a:pPr marL="457200"/>
+            <a:r>
+              <a:rPr lang="en-US" sz="2800" b="0" dirty="0"/>
+              <a:t>On failure: the client retries the whole append, which can leave duplicates and padding</a:t>
+            </a:r>
+          </a:p>
+          <a:p>
+            <a:r>
+              <a:rPr lang="en-US" sz="3200" b="1" dirty="0"/>
+              <a:t>The operation GFS was built for: many producers, one log</a:t>
+            </a:r>
+          </a:p>
+        </p:txBody>
+      </p:sp>
+    </p:spTree>
+    <p:extLst>
+      <p:ext uri="{BB962C8B-B14F-4D97-AF65-F5344CB8AC3E}">
+        <p14:creationId xmlns:p14="http://schemas.microsoft.com/office/powerpoint/2010/main" val="1720670694"/>
+      </p:ext>
+    </p:extLst>
+  </p:cSld>
+  <p:clrMapOvr>
+    <a:masterClrMapping/>
+  </p:clrMapOvr>
+</p:sld>
+</file>
+
 <file path=ppt/slides/slide6.xml><?xml version="1.0" encoding="utf-8"?>
 <p:sld xmlns:a="http://schemas.openxmlformats.org/drawingml/2006/main" xmlns:r="http://schemas.openxmlformats.org/officeDocument/2006/relationships" xmlns:p="http://schemas.openxmlformats.org/presentationml/2006/main">
   <p:cSld>
@@ -28799,6 +29135,269 @@
   <p:clrMapOvr>
     <a:masterClrMapping/>
   </p:clrMapOvr>
+  <p:timing>
+    <p:tnLst>
+      <p:par>
+        <p:cTn id="1" dur="indefinite" restart="never" nodeType="tmRoot">
+          <p:childTnLst>
+            <p:seq concurrent="1" nextAc="seek">
+              <p:cTn id="2" dur="indefinite" nodeType="mainSeq">
+                <p:childTnLst>
+                  <p:par>
+                    <p:cTn id="3" fill="hold">
+                      <p:stCondLst>
+                        <p:cond delay="indefinite"/>
+                      </p:stCondLst>
+                      <p:childTnLst>
+                        <p:par>
+                          <p:cTn id="4" fill="hold">
+                            <p:stCondLst>
+                              <p:cond delay="0"/>
+                            </p:stCondLst>
+                            <p:childTnLst>
+                              <p:par>
+                                <p:cTn id="5" presetID="9" presetClass="entr" presetSubtype="0" fill="hold" nodeType="clickEffect">
+                                  <p:stCondLst>
+                                    <p:cond delay="0"/>
+                                  </p:stCondLst>
+                                  <p:childTnLst>
+                                    <p:set>
+                                      <p:cBhvr>
+                                        <p:cTn id="6" dur="1" fill="hold">
+                                          <p:stCondLst>
+                                            <p:cond delay="0"/>
+                                          </p:stCondLst>
+                                        </p:cTn>
+                                        <p:tgtEl>
+                                          <p:spTgt spid="3">
+                                            <p:txEl>
+                                              <p:pRg st="3" end="3"/>
+                                            </p:txEl>
+                                          </p:spTgt>
+                                        </p:tgtEl>
+                                        <p:attrNameLst>
+                                          <p:attrName>style.visibility</p:attrName>
+                                        </p:attrNameLst>
+                                      </p:cBhvr>
+                                      <p:to>
+                                        <p:strVal val="visible"/>
+                                      </p:to>
+                                    </p:set>
+                                    <p:animEffect transition="in" filter="dissolve">
+                                      <p:cBhvr>
+                                        <p:cTn id="7" dur="500"/>
+                                        <p:tgtEl>
+                                          <p:spTgt spid="3">
+                                            <p:txEl>
+                                              <p:pRg st="3" end="3"/>
+                                            </p:txEl>
+                                          </p:spTgt>
+                                        </p:tgtEl>
+                                      </p:cBhvr>
+                                    </p:animEffect>
+                                  </p:childTnLst>
+                                </p:cTn>
+                              </p:par>
+                              <p:par>
+                                <p:cTn id="8" presetID="9" presetClass="entr" presetSubtype="0" fill="hold" nodeType="withEffect">
+                                  <p:stCondLst>
+                                    <p:cond delay="0"/>
+                                  </p:stCondLst>
+                                  <p:childTnLst>
+                                    <p:set>
+                                      <p:cBhvr>
+                                        <p:cTn id="9" dur="1" fill="hold">
+                                          <p:stCondLst>
+                                            <p:cond delay="0"/>
+                                          </p:stCondLst>
+                                        </p:cTn>
+                                        <p:tgtEl>
+                                          <p:spTgt spid="3">
+                                            <p:txEl>
+                                              <p:pRg st="4" end="4"/>
+                                            </p:txEl>
+                                          </p:spTgt>
+                                        </p:tgtEl>
+                                        <p:attrNameLst>
+                                          <p:attrName>style.visibility</p:attrName>
+                                        </p:attrNameLst>
+                                      </p:cBhvr>
+                                      <p:to>
+                                        <p:strVal val="visible"/>
+                                      </p:to>
+                                    </p:set>
+                                    <p:animEffect transition="in" filter="dissolve">
+                                      <p:cBhvr>
+                                        <p:cTn id="10" dur="500"/>
+                                        <p:tgtEl>
+                                          <p:spTgt spid="3">
+                                            <p:txEl>
+                                              <p:pRg st="4" end="4"/>
+                                            </p:txEl>
+                                          </p:spTgt>
+                                        </p:tgtEl>
+                                      </p:cBhvr>
+                                    </p:animEffect>
+                                  </p:childTnLst>
+                                </p:cTn>
+                              </p:par>
+                              <p:par>
+                                <p:cTn id="11" presetID="9" presetClass="entr" presetSubtype="0" fill="hold" nodeType="withEffect">
+                                  <p:stCondLst>
+                                    <p:cond delay="0"/>
+                                  </p:stCondLst>
+                                  <p:childTnLst>
+                                    <p:set>
+                                      <p:cBhvr>
+                                        <p:cTn id="12" dur="1" fill="hold">
+                                          <p:stCondLst>
+                                            <p:cond delay="0"/>
+                                          </p:stCondLst>
+                                        </p:cTn>
+                                        <p:tgtEl>
+                                          <p:spTgt spid="3">
+                                            <p:txEl>
+                                              <p:pRg st="5" end="5"/>
+                                            </p:txEl>
+                                          </p:spTgt>
+                                        </p:tgtEl>
+                                        <p:attrNameLst>
+                                          <p:attrName>style.visibility</p:attrName>
+                                        </p:attrNameLst>
+                                      </p:cBhvr>
+                                      <p:to>
+                                        <p:strVal val="visible"/>
+                                      </p:to>
+                                    </p:set>
+                                    <p:animEffect transition="in" filter="dissolve">
+                                      <p:cBhvr>
+                                        <p:cTn id="13" dur="500"/>
+                                        <p:tgtEl>
+                                          <p:spTgt spid="3">
+                                            <p:txEl>
+                                              <p:pRg st="5" end="5"/>
+                                            </p:txEl>
+                                          </p:spTgt>
+                                        </p:tgtEl>
+                                      </p:cBhvr>
+                                    </p:animEffect>
+                                  </p:childTnLst>
+                                </p:cTn>
+                              </p:par>
+                              <p:par>
+                                <p:cTn id="14" presetID="9" presetClass="entr" presetSubtype="0" fill="hold" nodeType="withEffect">
+                                  <p:stCondLst>
+                                    <p:cond delay="0"/>
+                                  </p:stCondLst>
+                                  <p:childTnLst>
+                                    <p:set>
+                                      <p:cBhvr>
+                                        <p:cTn id="15" dur="1" fill="hold">
+                                          <p:stCondLst>
+                                            <p:cond delay="0"/>
+                                          </p:stCondLst>
+                                        </p:cTn>
+                                        <p:tgtEl>
+                                          <p:spTgt spid="3">
+                                            <p:txEl>
+                                              <p:pRg st="7" end="7"/>
+                                            </p:txEl>
+                                          </p:spTgt>
+                                        </p:tgtEl>
+                                        <p:attrNameLst>
+                                          <p:attrName>style.visibility</p:attrName>
+                                        </p:attrNameLst>
+                                      </p:cBhvr>
+                                      <p:to>
+                                        <p:strVal val="visible"/>
+                                      </p:to>
+                                    </p:set>
+                                    <p:animEffect transition="in" filter="dissolve">
+                                      <p:cBhvr>
+                                        <p:cTn id="16" dur="500"/>
+                                        <p:tgtEl>
+                                          <p:spTgt spid="3">
+                                            <p:txEl>
+                                              <p:pRg st="7" end="7"/>
+                                            </p:txEl>
+                                          </p:spTgt>
+                                        </p:tgtEl>
+                                      </p:cBhvr>
+                                    </p:animEffect>
+                                  </p:childTnLst>
+                                </p:cTn>
+                              </p:par>
+                              <p:par>
+                                <p:cTn id="17" presetID="9" presetClass="entr" presetSubtype="0" fill="hold" nodeType="withEffect">
+                                  <p:stCondLst>
+                                    <p:cond delay="0"/>
+                                  </p:stCondLst>
+                                  <p:childTnLst>
+                                    <p:set>
+                                      <p:cBhvr>
+                                        <p:cTn id="18" dur="1" fill="hold">
+                                          <p:stCondLst>
+                                            <p:cond delay="0"/>
+                                          </p:stCondLst>
+                                        </p:cTn>
+                                        <p:tgtEl>
+                                          <p:spTgt spid="3">
+                                            <p:txEl>
+                                              <p:pRg st="8" end="8"/>
+                                            </p:txEl>
+                                          </p:spTgt>
+                                        </p:tgtEl>
+                                        <p:attrNameLst>
+                                          <p:attrName>style.visibility</p:attrName>
+                                        </p:attrNameLst>
+                                      </p:cBhvr>
+                                      <p:to>
+                                        <p:strVal val="visible"/>
+                                      </p:to>
+                                    </p:set>
+                                    <p:animEffect transition="in" filter="dissolve">
+                                      <p:cBhvr>
+                                        <p:cTn id="19" dur="500"/>
+                                        <p:tgtEl>
+                                          <p:spTgt spid="3">
+                                            <p:txEl>
+                                              <p:pRg st="8" end="8"/>
+                                            </p:txEl>
+                                          </p:spTgt>
+                                        </p:tgtEl>
+                                      </p:cBhvr>
+                                    </p:animEffect>
+                                  </p:childTnLst>
+                                </p:cTn>
+                              </p:par>
+                            </p:childTnLst>
+                          </p:cTn>
+                        </p:par>
+                      </p:childTnLst>
+                    </p:cTn>
+                  </p:par>
+                </p:childTnLst>
+              </p:cTn>
+              <p:prevCondLst>
+                <p:cond evt="onPrev" delay="0">
+                  <p:tgtEl>
+                    <p:sldTgt/>
+                  </p:tgtEl>
+                </p:cond>
+              </p:prevCondLst>
+              <p:nextCondLst>
+                <p:cond evt="onNext" delay="0">
+                  <p:tgtEl>
+                    <p:sldTgt/>
+                  </p:tgtEl>
+                </p:cond>
+              </p:nextCondLst>
+            </p:seq>
+          </p:childTnLst>
+        </p:cTn>
+      </p:par>
+    </p:tnLst>
+  </p:timing>
 </p:sld>
 </file>
 
@@ -28913,7 +29512,7 @@
         <p:spPr>
           <a:xfrm>
             <a:off x="88135" y="914401"/>
-            <a:ext cx="11414752" cy="5078313"/>
+            <a:ext cx="12191998" cy="4585871"/>
           </a:xfrm>
           <a:prstGeom prst="rect">
             <a:avLst/>
@@ -28932,14 +29531,20 @@
             </a:r>
           </a:p>
           <a:p>
-            <a:pPr marL="457200"/>
+            <a:pPr marL="914400" indent="-457200">
+              <a:buFont typeface="Arial" panose="020B0604020202020204" pitchFamily="34" charset="0"/>
+              <a:buChar char="•"/>
+            </a:pPr>
             <a:r>
               <a:rPr lang="en-US" sz="2800" b="0" dirty="0"/>
               <a:t>Far better performance per dollar than reliable, expensive hardware</a:t>
             </a:r>
           </a:p>
           <a:p>
-            <a:pPr marL="457200"/>
+            <a:pPr marL="914400" indent="-457200">
+              <a:buFont typeface="Arial" panose="020B0604020202020204" pitchFamily="34" charset="0"/>
+              <a:buChar char="•"/>
+            </a:pPr>
             <a:r>
               <a:rPr lang="en-US" sz="2800" b="0" dirty="0"/>
               <a:t>Expensive hardware fails less often, but it still fails</a:t>
@@ -28956,21 +29561,30 @@
             </a:r>
           </a:p>
           <a:p>
-            <a:pPr marL="457200"/>
+            <a:pPr marL="914400" indent="-457200">
+              <a:buFont typeface="Arial" panose="020B0604020202020204" pitchFamily="34" charset="0"/>
+              <a:buChar char="•"/>
+            </a:pPr>
             <a:r>
               <a:rPr lang="en-US" sz="2800" b="0" dirty="0"/>
               <a:t>Around 20 rack failures, each taking 40-80 machines away for hours</a:t>
             </a:r>
           </a:p>
           <a:p>
-            <a:pPr marL="457200"/>
+            <a:pPr marL="914400" indent="-457200">
+              <a:buFont typeface="Arial" panose="020B0604020202020204" pitchFamily="34" charset="0"/>
+              <a:buChar char="•"/>
+            </a:pPr>
             <a:r>
               <a:rPr lang="en-US" sz="2800" b="0" dirty="0"/>
               <a:t>About a thousand machine failures and thousands of disk failures</a:t>
             </a:r>
           </a:p>
           <a:p>
-            <a:pPr marL="457200"/>
+            <a:pPr marL="914400" indent="-457200">
+              <a:buFont typeface="Arial" panose="020B0604020202020204" pitchFamily="34" charset="0"/>
+              <a:buChar char="•"/>
+            </a:pPr>
             <a:r>
               <a:rPr lang="en-US" sz="2800" b="0" dirty="0"/>
               <a:t>Plus rewiring, router reloads and network blips</a:t>
@@ -29099,44 +29713,85 @@
       </p:sp>
       <p:sp>
         <p:nvSpPr>
-          <p:cNvPr id="3" name="TextBox 2">
-            <a:extLst>
-              <a:ext uri="{FF2B5EF4-FFF2-40B4-BE49-F238E27FC236}">
-                <a16:creationId xmlns:a16="http://schemas.microsoft.com/office/drawing/2014/main" id="{857EC8A2-DB9F-8BB1-7445-FE716E76BAC5}"/>
-              </a:ext>
-            </a:extLst>
-          </p:cNvPr>
-          <p:cNvSpPr txBox="1"/>
+          <p:cNvPr id="9" name="Tradeoff lecture questions">
+            <a:extLst>
+              <a:ext uri="{FF2B5EF4-FFF2-40B4-BE49-F238E27FC236}">
+                <a16:creationId xmlns:a16="http://schemas.microsoft.com/office/drawing/2014/main" id="{1C6172CA-3D22-4927-B780-D9FCE0B7AE19}"/>
+              </a:ext>
+            </a:extLst>
+          </p:cNvPr>
+          <p:cNvSpPr>
+            <a:spLocks noGrp="1"/>
+          </p:cNvSpPr>
           <p:nvPr/>
         </p:nvSpPr>
         <p:spPr>
           <a:xfrm>
-            <a:off x="88135" y="914401"/>
-            <a:ext cx="11265665" cy="5016758"/>
+            <a:off x="88106" y="914400"/>
+            <a:ext cx="11265694" cy="5016722"/>
           </a:xfrm>
           <a:prstGeom prst="rect">
             <a:avLst/>
           </a:prstGeom>
           <a:noFill/>
+          <a:ln w="0">
+            <a:noFill/>
+          </a:ln>
         </p:spPr>
         <p:txBody>
-          <a:bodyPr wrap="square" rtlCol="0">
-            <a:spAutoFit/>
+          <a:bodyPr>
+            <a:normAutofit fontScale="100000"/>
           </a:bodyPr>
           <a:lstStyle/>
           <a:p>
-            <a:r>
-              <a:rPr lang="en-US" sz="3200" b="1" dirty="0"/>
-              <a:t>What interface should a large distributed storage system expose?</a:t>
-            </a:r>
-          </a:p>
-          <a:p>
-            <a:endParaRPr lang="en-US" sz="3200" b="1" dirty="0"/>
-          </a:p>
-          <a:p>
-            <a:r>
-              <a:rPr lang="en-US" sz="3200" b="1" dirty="0"/>
-              <a:t>How can that interface remain useful as data spans machines that fail?</a:t>
+            <a:pPr>
+              <a:defRPr sz="3200" b="1">
+                <a:solidFill>
+                  <a:srgbClr val="000000"/>
+                </a:solidFill>
+                <a:latin typeface="Aptos"/>
+                <a:ea typeface="Aptos"/>
+                <a:cs typeface="Aptos"/>
+              </a:defRPr>
+            </a:pPr>
+            <a:r>
+              <a:rPr sz="3200" b="1">
+                <a:solidFill>
+                  <a:srgbClr val="000000"/>
+                </a:solidFill>
+                <a:latin typeface="Aptos"/>
+                <a:ea typeface="Aptos"/>
+                <a:cs typeface="Aptos"/>
+              </a:rPr>
+              <a:t>How can data remain correct when it is spread across machines that fail?</a:t>
+            </a:r>
+          </a:p>
+          <a:p>
+            <a:r>
+              <a:t/>
+            </a:r>
+          </a:p>
+          <a:p>
+            <a:pPr>
+              <a:defRPr sz="3200" b="1">
+                <a:solidFill>
+                  <a:srgbClr val="000000"/>
+                </a:solidFill>
+                <a:latin typeface="Aptos"/>
+                <a:ea typeface="Aptos"/>
+                <a:cs typeface="Aptos"/>
+              </a:defRPr>
+            </a:pPr>
+            <a:r>
+              <a:rPr sz="3200" b="1">
+                <a:solidFill>
+                  <a:srgbClr val="000000"/>
+                </a:solidFill>
+                <a:latin typeface="Aptos"/>
+                <a:ea typeface="Aptos"/>
+                <a:cs typeface="Aptos"/>
+              </a:rPr>
+              <a:t>What performance cost must we pay to make that happen?</a:t>
             </a:r>
           </a:p>
         </p:txBody>
@@ -29190,7 +29845,7 @@
             <a:spLocks noGrp="1"/>
           </p:cNvSpPr>
           <p:nvPr>
-            <p:ph type="title"/>
+            <p:ph type="title" idx="0"/>
           </p:nvPr>
         </p:nvSpPr>
         <p:spPr>
@@ -29201,17 +29856,20 @@
         </p:spPr>
         <p:txBody>
           <a:bodyPr>
-            <a:normAutofit/>
+            <a:normAutofit fontScale="100000"/>
           </a:bodyPr>
           <a:lstStyle/>
           <a:p>
-            <a:pPr algn="ctr"/>
-            <a:r>
-              <a:rPr lang="en-US" b="1" dirty="0">
-                <a:latin typeface="Helvetica" panose="020B0604020202020204" pitchFamily="34" charset="0"/>
-                <a:cs typeface="Helvetica" panose="020B0604020202020204" pitchFamily="34" charset="0"/>
+            <a:pPr algn="ctr">
+              <a:buNone/>
+            </a:pPr>
+            <a:r>
+              <a:rPr b="1">
+                <a:latin typeface="Helvetica"/>
+                <a:ea typeface="Helvetica"/>
+                <a:cs typeface="Helvetica"/>
               </a:rPr>
-              <a:t>Why Is Distributed Storage Hard?</a:t>
+              <a:t>Fault Tolerance Comes with a Cost</a:t>
             </a:r>
           </a:p>
         </p:txBody>
@@ -31107,120 +31765,141 @@
       </p:grpSp>
       <p:sp>
         <p:nvSpPr>
-          <p:cNvPr id="48" name="TextBox 47">
-            <a:extLst>
-              <a:ext uri="{FF2B5EF4-FFF2-40B4-BE49-F238E27FC236}">
-                <a16:creationId xmlns:a16="http://schemas.microsoft.com/office/drawing/2014/main" id="{51F35555-7DB3-0E9F-0CC1-8DCCA40D364A}"/>
-              </a:ext>
-            </a:extLst>
-          </p:cNvPr>
-          <p:cNvSpPr txBox="1"/>
+          <p:cNvPr id="61" name="Tradeoff chain bullets">
+            <a:extLst>
+              <a:ext uri="{FF2B5EF4-FFF2-40B4-BE49-F238E27FC236}">
+                <a16:creationId xmlns:a16="http://schemas.microsoft.com/office/drawing/2014/main" id="{349D2510-06A7-443F-BD28-77CA7DFA9405}"/>
+              </a:ext>
+            </a:extLst>
+          </p:cNvPr>
+          <p:cNvSpPr>
+            <a:spLocks noGrp="1"/>
+          </p:cNvSpPr>
           <p:nvPr/>
         </p:nvSpPr>
         <p:spPr>
           <a:xfrm>
-            <a:off x="7325250" y="1373218"/>
-            <a:ext cx="4706595" cy="4154984"/>
+            <a:off x="7325296" y="1373219"/>
+            <a:ext cx="4706588" cy="4154996"/>
           </a:xfrm>
           <a:prstGeom prst="rect">
             <a:avLst/>
           </a:prstGeom>
           <a:noFill/>
+          <a:ln w="0">
+            <a:noFill/>
+          </a:ln>
         </p:spPr>
         <p:txBody>
-          <a:bodyPr wrap="square">
-            <a:spAutoFit/>
+          <a:bodyPr>
+            <a:normAutofit fontScale="100000"/>
           </a:bodyPr>
           <a:lstStyle/>
           <a:p>
-            <a:pPr marL="342900" indent="-342900">
-              <a:buFont typeface="Arial" panose="020B0604020202020204" pitchFamily="34" charset="0"/>
-              <a:buChar char="•"/>
+            <a:pPr>
+              <a:defRPr sz="2400">
+                <a:solidFill>
+                  <a:srgbClr val="000000"/>
+                </a:solidFill>
+                <a:latin typeface="Aptos"/>
+                <a:ea typeface="Aptos"/>
+                <a:cs typeface="Aptos"/>
+              </a:defRPr>
             </a:pPr>
             <a:r>
-              <a:rPr lang="en-US" sz="3200" dirty="0">
-                <a:effectLst/>
+              <a:rPr sz="2400">
+                <a:solidFill>
+                  <a:srgbClr val="000000"/>
+                </a:solidFill>
+                <a:latin typeface="Aptos"/>
+                <a:ea typeface="Aptos"/>
+                <a:cs typeface="Aptos"/>
               </a:rPr>
-              <a:t>Performance</a:t>
-            </a:r>
-          </a:p>
-          <a:p>
-            <a:pPr marL="342900" indent="-342900">
-              <a:buFont typeface="Arial" panose="020B0604020202020204" pitchFamily="34" charset="0"/>
-              <a:buChar char="•"/>
+              <a:t>• Fault tolerance requires replication</a:t>
+            </a:r>
+          </a:p>
+          <a:p>
+            <a:r>
+              <a:t/>
+            </a:r>
+          </a:p>
+          <a:p>
+            <a:pPr>
+              <a:defRPr sz="2400">
+                <a:solidFill>
+                  <a:srgbClr val="000000"/>
+                </a:solidFill>
+                <a:latin typeface="Aptos"/>
+                <a:ea typeface="Aptos"/>
+                <a:cs typeface="Aptos"/>
+              </a:defRPr>
             </a:pPr>
-            <a:endParaRPr lang="en-US" sz="2400" dirty="0"/>
-          </a:p>
-          <a:p>
-            <a:pPr marL="342900" indent="-342900">
-              <a:buFont typeface="Arial" panose="020B0604020202020204" pitchFamily="34" charset="0"/>
-              <a:buChar char="•"/>
+            <a:r>
+              <a:rPr sz="2400">
+                <a:solidFill>
+                  <a:srgbClr val="000000"/>
+                </a:solidFill>
+                <a:latin typeface="Aptos"/>
+                <a:ea typeface="Aptos"/>
+                <a:cs typeface="Aptos"/>
+              </a:rPr>
+              <a:t>• Replication risks inconsistency</a:t>
+            </a:r>
+          </a:p>
+          <a:p>
+            <a:r>
+              <a:t/>
+            </a:r>
+          </a:p>
+          <a:p>
+            <a:pPr>
+              <a:defRPr sz="2400">
+                <a:solidFill>
+                  <a:srgbClr val="000000"/>
+                </a:solidFill>
+                <a:latin typeface="Aptos"/>
+                <a:ea typeface="Aptos"/>
+                <a:cs typeface="Aptos"/>
+              </a:defRPr>
             </a:pPr>
             <a:r>
-              <a:rPr lang="en-US" sz="3200" dirty="0"/>
-              <a:t>Many servers</a:t>
-            </a:r>
-            <a:endParaRPr lang="en-US" sz="3200" dirty="0">
-              <a:effectLst/>
-            </a:endParaRPr>
-          </a:p>
-          <a:p>
-            <a:pPr marL="342900" indent="-342900">
-              <a:buFont typeface="Arial" panose="020B0604020202020204" pitchFamily="34" charset="0"/>
-              <a:buChar char="•"/>
+              <a:rPr sz="2400">
+                <a:solidFill>
+                  <a:srgbClr val="000000"/>
+                </a:solidFill>
+                <a:latin typeface="Aptos"/>
+                <a:ea typeface="Aptos"/>
+                <a:cs typeface="Aptos"/>
+              </a:rPr>
+              <a:t>• Consistency requires coordination</a:t>
+            </a:r>
+          </a:p>
+          <a:p>
+            <a:r>
+              <a:t/>
+            </a:r>
+          </a:p>
+          <a:p>
+            <a:pPr>
+              <a:defRPr sz="2400">
+                <a:solidFill>
+                  <a:srgbClr val="000000"/>
+                </a:solidFill>
+                <a:latin typeface="Aptos"/>
+                <a:ea typeface="Aptos"/>
+                <a:cs typeface="Aptos"/>
+              </a:defRPr>
             </a:pPr>
-            <a:endParaRPr lang="en-US" sz="2400" dirty="0">
-              <a:effectLst/>
-            </a:endParaRPr>
-          </a:p>
-          <a:p>
-            <a:pPr marL="342900" indent="-342900">
-              <a:buFont typeface="Arial" panose="020B0604020202020204" pitchFamily="34" charset="0"/>
-              <a:buChar char="•"/>
-            </a:pPr>
-            <a:r>
-              <a:rPr lang="en-US" sz="3200" dirty="0">
-                <a:effectLst/>
+            <a:r>
+              <a:rPr sz="2400">
+                <a:solidFill>
+                  <a:srgbClr val="000000"/>
+                </a:solidFill>
+                <a:latin typeface="Aptos"/>
+                <a:ea typeface="Aptos"/>
+                <a:cs typeface="Aptos"/>
               </a:rPr>
-              <a:t>Fault tolerance</a:t>
-            </a:r>
-          </a:p>
-          <a:p>
-            <a:pPr marL="342900" indent="-342900">
-              <a:buFont typeface="Arial" panose="020B0604020202020204" pitchFamily="34" charset="0"/>
-              <a:buChar char="•"/>
-            </a:pPr>
-            <a:endParaRPr lang="en-US" sz="2400" dirty="0"/>
-          </a:p>
-          <a:p>
-            <a:pPr marL="342900" indent="-342900">
-              <a:buFont typeface="Arial" panose="020B0604020202020204" pitchFamily="34" charset="0"/>
-              <a:buChar char="•"/>
-            </a:pPr>
-            <a:r>
-              <a:rPr lang="en-US" sz="3200" dirty="0"/>
-              <a:t>Replication</a:t>
-            </a:r>
-          </a:p>
-          <a:p>
-            <a:pPr marL="342900" indent="-342900">
-              <a:buFont typeface="Arial" panose="020B0604020202020204" pitchFamily="34" charset="0"/>
-              <a:buChar char="•"/>
-            </a:pPr>
-            <a:endParaRPr lang="en-US" sz="2400" dirty="0">
-              <a:effectLst/>
-            </a:endParaRPr>
-          </a:p>
-          <a:p>
-            <a:pPr marL="342900" indent="-342900">
-              <a:buFont typeface="Arial" panose="020B0604020202020204" pitchFamily="34" charset="0"/>
-              <a:buChar char="•"/>
-            </a:pPr>
-            <a:r>
-              <a:rPr lang="en-US" sz="3200" dirty="0">
-                <a:effectLst/>
-              </a:rPr>
-              <a:t>Better Consistency</a:t>
+              <a:t>• Coordination lowers performance</a:t>
             </a:r>
           </a:p>
         </p:txBody>

</xml_diff>

<commit_message>
Rebuild GFS slide edits for PowerPoint compatibility
</commit_message>
<xml_diff>
--- a/slides/fall26/4-gfs.pptx
+++ b/slides/fall26/4-gfs.pptx
@@ -1305,34 +1305,57 @@
 </file>
 
 <file path=ppt/notesSlides/notesSlide14.xml><?xml version="1.0" encoding="utf-8"?>
-<p:notes xmlns:p="http://schemas.openxmlformats.org/presentationml/2006/main">
+<p:notes xmlns:a="http://schemas.openxmlformats.org/drawingml/2006/main" xmlns:r="http://schemas.openxmlformats.org/officeDocument/2006/relationships" xmlns:p="http://schemas.openxmlformats.org/presentationml/2006/main">
   <p:cSld>
     <p:spTree>
       <p:nvGrpSpPr>
-        <p:cNvPr id="1" name=""/>
+        <p:cNvPr id="1" name="">
+          <a:extLst>
+            <a:ext uri="{FF2B5EF4-FFF2-40B4-BE49-F238E27FC236}">
+              <a16:creationId xmlns:a16="http://schemas.microsoft.com/office/drawing/2014/main" id="{96985D24-230C-6270-6214-3E867A2550BC}"/>
+            </a:ext>
+          </a:extLst>
+        </p:cNvPr>
         <p:cNvGrpSpPr/>
         <p:nvPr/>
       </p:nvGrpSpPr>
       <p:grpSpPr>
-        <a:xfrm xmlns:a="http://schemas.openxmlformats.org/drawingml/2006/main"/>
+        <a:xfrm>
+          <a:off x="0" y="0"/>
+          <a:ext cx="0" cy="0"/>
+          <a:chOff x="0" y="0"/>
+          <a:chExt cx="0" cy="0"/>
+        </a:xfrm>
       </p:grpSpPr>
       <p:sp>
         <p:nvSpPr>
-          <p:cNvPr id="2" name="Slide Image Placeholder 1"/>
+          <p:cNvPr id="2" name="Slide Image Placeholder 1">
+            <a:extLst>
+              <a:ext uri="{FF2B5EF4-FFF2-40B4-BE49-F238E27FC236}">
+                <a16:creationId xmlns:a16="http://schemas.microsoft.com/office/drawing/2014/main" id="{46553026-D75E-0E0C-F4A0-B2BFCACF2484}"/>
+              </a:ext>
+            </a:extLst>
+          </p:cNvPr>
           <p:cNvSpPr>
-            <a:spLocks xmlns:a="http://schemas.openxmlformats.org/drawingml/2006/main" noGrp="1"/>
+            <a:spLocks noGrp="1" noRot="1" noChangeAspect="1"/>
           </p:cNvSpPr>
           <p:nvPr>
-            <p:ph type="sldImg" idx="0"/>
+            <p:ph type="sldImg"/>
           </p:nvPr>
         </p:nvSpPr>
         <p:spPr/>
       </p:sp>
       <p:sp>
         <p:nvSpPr>
-          <p:cNvPr id="3" name="Notes Placeholder 2"/>
+          <p:cNvPr id="3" name="Notes Placeholder 2">
+            <a:extLst>
+              <a:ext uri="{FF2B5EF4-FFF2-40B4-BE49-F238E27FC236}">
+                <a16:creationId xmlns:a16="http://schemas.microsoft.com/office/drawing/2014/main" id="{81C0A957-8562-1954-5E3F-EBB74140409F}"/>
+              </a:ext>
+            </a:extLst>
+          </p:cNvPr>
           <p:cNvSpPr>
-            <a:spLocks xmlns:a="http://schemas.openxmlformats.org/drawingml/2006/main" noGrp="1"/>
+            <a:spLocks noGrp="1"/>
           </p:cNvSpPr>
           <p:nvPr>
             <p:ph type="body" idx="1"/>
@@ -1340,121 +1363,96 @@
         </p:nvSpPr>
         <p:spPr/>
         <p:txBody>
-          <a:bodyPr xmlns:a="http://schemas.openxmlformats.org/drawingml/2006/main"/>
-          <a:lstStyle xmlns:a="http://schemas.openxmlformats.org/drawingml/2006/main"/>
-          <a:p xmlns:a="http://schemas.openxmlformats.org/drawingml/2006/main">
-            <a:r>
+          <a:bodyPr/>
+          <a:lstStyle/>
+          <a:p>
+            <a:r>
+              <a:rPr lang="en-US" dirty="0"/>
               <a:t>We read GFS because distributed storage is one of the most useful abstractions in distributed systems.</a:t>
             </a:r>
-            <a:endParaRPr/>
-          </a:p>
-          <a:p xmlns:a="http://schemas.openxmlformats.org/drawingml/2006/main">
-            <a:r>
-              <a:t/>
-            </a:r>
-            <a:endParaRPr/>
-          </a:p>
-          <a:p xmlns:a="http://schemas.openxmlformats.org/drawingml/2006/main">
-            <a:r>
+          </a:p>
+          <a:p>
+            <a:endParaRPr lang="en-US" dirty="0"/>
+          </a:p>
+          <a:p>
+            <a:r>
+              <a:rPr lang="en-US" dirty="0"/>
               <a:t>This is where the interface question belongs: what should a large distributed storage system expose to applications? GFS presents a familiar file interface, but it adapts the operations and guarantees to Google's large, sequential, data-intensive workloads. A useful interface hides placement, replication, failures, and recovery without promising behavior the implementation cannot provide efficiently.</a:t>
             </a:r>
-            <a:endParaRPr/>
-          </a:p>
-          <a:p xmlns:a="http://schemas.openxmlformats.org/drawingml/2006/main">
-            <a:r>
-              <a:t/>
-            </a:r>
-            <a:endParaRPr/>
-          </a:p>
-          <a:p xmlns:a="http://schemas.openxmlformats.org/drawingml/2006/main">
-            <a:r>
+          </a:p>
+          <a:p>
+            <a:endParaRPr lang="en-US" dirty="0"/>
+          </a:p>
+          <a:p>
+            <a:r>
+              <a:rPr lang="en-US" dirty="0"/>
               <a:t>The paper also connects several themes from this course. Sharding gives parallel performance. Replication gives fault tolerance, but it creates consistency problems. The designers then choose where to spend coordination cost and where to accept weaker behavior.</a:t>
             </a:r>
-            <a:endParaRPr/>
-          </a:p>
-          <a:p xmlns:a="http://schemas.openxmlformats.org/drawingml/2006/main">
-            <a:r>
-              <a:t/>
-            </a:r>
-            <a:endParaRPr/>
-          </a:p>
-          <a:p xmlns:a="http://schemas.openxmlformats.org/drawingml/2006/main">
-            <a:r>
+          </a:p>
+          <a:p>
+            <a:endParaRPr lang="en-US" dirty="0"/>
+          </a:p>
+          <a:p>
+            <a:r>
+              <a:rPr lang="en-US" dirty="0"/>
               <a:t>This is also a strong systems paper because it connects application workloads to machine-level details. The system succeeded in production, so we can judge the tradeoffs using real experience rather than only a conceptual design.</a:t>
             </a:r>
-            <a:endParaRPr/>
-          </a:p>
-          <a:p xmlns:a="http://schemas.openxmlformats.org/drawingml/2006/main">
-            <a:r>
-              <a:t/>
-            </a:r>
-            <a:endParaRPr/>
-          </a:p>
-          <a:p xmlns:a="http://schemas.openxmlformats.org/drawingml/2006/main">
-            <a:r>
-              <a:t>SOURCE</a:t>
-            </a:r>
-            <a:endParaRPr/>
-          </a:p>
-          <a:p xmlns:a="http://schemas.openxmlformats.org/drawingml/2006/main">
-            <a:r>
-              <a:t>MIT 6.824, Spring 2020, Lecture 3 video, 0:00-5:09.</a:t>
-            </a:r>
-            <a:endParaRPr/>
-          </a:p>
-          <a:p xmlns:a="http://schemas.openxmlformats.org/drawingml/2006/main">
-            <a:r>
-              <a:t>https://www.youtube.com/watch?v=EpIgvowZr00</a:t>
-            </a:r>
-            <a:endParaRPr/>
-          </a:p>
-          <a:p xmlns:a="http://schemas.openxmlformats.org/drawingml/2006/main">
-            <a:r>
-              <a:t>MIT 6.5840, GFS lecture notes.</a:t>
-            </a:r>
-            <a:endParaRPr/>
-          </a:p>
-          <a:p xmlns:a="http://schemas.openxmlformats.org/drawingml/2006/main">
-            <a:r>
-              <a:t>https://pdos.csail.mit.edu/6.824/notes/l-gfs.txt</a:t>
-            </a:r>
-            <a:endParaRPr/>
-          </a:p>
-          <a:p xmlns:a="http://schemas.openxmlformats.org/drawingml/2006/main">
-            <a:r>
-              <a:t>Ghemawat, Gobioff, and Leung, The Google File System, Sections 1, 2, and 6.</a:t>
-            </a:r>
-            <a:endParaRPr/>
-          </a:p>
-          <a:p xmlns:a="http://schemas.openxmlformats.org/drawingml/2006/main">
-            <a:r>
-              <a:t>https://pdos.csail.mit.edu/6.824/papers/gfs.pdf</a:t>
-            </a:r>
-            <a:endParaRPr/>
-          </a:p>
-        </p:txBody>
-      </p:sp>
-      <p:sp>
-        <p:nvSpPr>
-          <p:cNvPr id="4" name="Slide Number Placeholder 3"/>
+          </a:p>
+          <a:p>
+            <a:endParaRPr lang="en-US" dirty="0"/>
+          </a:p>
+          <a:p>
+            <a:r>
+              <a:rPr lang="en-US" dirty="0"/>
+              <a:t>SOURCE
+MIT 6.824, Spring 2020, Lecture 3 video, 0:00-5:09.
+https://www.youtube.com/watch?v=EpIgvowZr00
+MIT 6.5840, GFS lecture notes.
+https://pdos.csail.mit.edu/6.824/notes/l-gfs.txt
+Ghemawat, Gobioff, and Leung, The Google File System, Sections 1, 2, and 6.
+https://pdos.csail.mit.edu/6.824/papers/gfs.pdf</a:t>
+            </a:r>
+          </a:p>
+        </p:txBody>
+      </p:sp>
+      <p:sp>
+        <p:nvSpPr>
+          <p:cNvPr id="4" name="Slide Number Placeholder 3">
+            <a:extLst>
+              <a:ext uri="{FF2B5EF4-FFF2-40B4-BE49-F238E27FC236}">
+                <a16:creationId xmlns:a16="http://schemas.microsoft.com/office/drawing/2014/main" id="{2069476A-DD91-FBC3-1B32-A751589B309A}"/>
+              </a:ext>
+            </a:extLst>
+          </p:cNvPr>
           <p:cNvSpPr>
-            <a:spLocks xmlns:a="http://schemas.openxmlformats.org/drawingml/2006/main" noGrp="1"/>
+            <a:spLocks noGrp="1"/>
           </p:cNvSpPr>
           <p:nvPr>
-            <p:ph type="sldNum" idx="5"/>
+            <p:ph type="sldNum" sz="quarter" idx="5"/>
           </p:nvPr>
         </p:nvSpPr>
         <p:spPr/>
         <p:txBody>
-          <a:bodyPr xmlns:a="http://schemas.openxmlformats.org/drawingml/2006/main"/>
-          <a:lstStyle xmlns:a="http://schemas.openxmlformats.org/drawingml/2006/main"/>
-          <a:p xmlns:a="http://schemas.openxmlformats.org/drawingml/2006/main"/>
+          <a:bodyPr/>
+          <a:lstStyle/>
+          <a:p>
+            <a:fld id="{1C9584DC-3658-4054-9DA4-7B68A1D8CC6D}" type="slidenum">
+              <a:rPr lang="zh-CN" altLang="en-US" smtClean="0"/>
+              <a:t>14</a:t>
+            </a:fld>
+            <a:endParaRPr lang="zh-CN" altLang="en-US"/>
+          </a:p>
         </p:txBody>
       </p:sp>
     </p:spTree>
+    <p:extLst>
+      <p:ext uri="{BB962C8B-B14F-4D97-AF65-F5344CB8AC3E}">
+        <p14:creationId xmlns:p14="http://schemas.microsoft.com/office/powerpoint/2010/main" val="3265497464"/>
+      </p:ext>
+    </p:extLst>
   </p:cSld>
   <p:clrMapOvr>
-    <a:masterClrMapping xmlns:a="http://schemas.openxmlformats.org/drawingml/2006/main"/>
+    <a:masterClrMapping/>
   </p:clrMapOvr>
 </p:notes>
 </file>
@@ -8870,34 +8868,57 @@
 </file>
 
 <file path=ppt/notesSlides/notesSlide8.xml><?xml version="1.0" encoding="utf-8"?>
-<p:notes xmlns:p="http://schemas.openxmlformats.org/presentationml/2006/main">
+<p:notes xmlns:a="http://schemas.openxmlformats.org/drawingml/2006/main" xmlns:r="http://schemas.openxmlformats.org/officeDocument/2006/relationships" xmlns:p="http://schemas.openxmlformats.org/presentationml/2006/main">
   <p:cSld>
     <p:spTree>
       <p:nvGrpSpPr>
-        <p:cNvPr id="1" name=""/>
+        <p:cNvPr id="1" name="">
+          <a:extLst>
+            <a:ext uri="{FF2B5EF4-FFF2-40B4-BE49-F238E27FC236}">
+              <a16:creationId xmlns:a16="http://schemas.microsoft.com/office/drawing/2014/main" id="{B2FBB8B7-6C3A-826B-BEDC-11B455E4E59E}"/>
+            </a:ext>
+          </a:extLst>
+        </p:cNvPr>
         <p:cNvGrpSpPr/>
         <p:nvPr/>
       </p:nvGrpSpPr>
       <p:grpSpPr>
-        <a:xfrm xmlns:a="http://schemas.openxmlformats.org/drawingml/2006/main"/>
+        <a:xfrm>
+          <a:off x="0" y="0"/>
+          <a:ext cx="0" cy="0"/>
+          <a:chOff x="0" y="0"/>
+          <a:chExt cx="0" cy="0"/>
+        </a:xfrm>
       </p:grpSpPr>
       <p:sp>
         <p:nvSpPr>
-          <p:cNvPr id="2" name="Slide Image Placeholder 1"/>
+          <p:cNvPr id="2" name="Slide Image Placeholder 1">
+            <a:extLst>
+              <a:ext uri="{FF2B5EF4-FFF2-40B4-BE49-F238E27FC236}">
+                <a16:creationId xmlns:a16="http://schemas.microsoft.com/office/drawing/2014/main" id="{0059D6B3-B338-2117-3D33-BCA332753A2A}"/>
+              </a:ext>
+            </a:extLst>
+          </p:cNvPr>
           <p:cNvSpPr>
-            <a:spLocks xmlns:a="http://schemas.openxmlformats.org/drawingml/2006/main" noGrp="1"/>
+            <a:spLocks noGrp="1" noRot="1" noChangeAspect="1"/>
           </p:cNvSpPr>
           <p:nvPr>
-            <p:ph type="sldImg" idx="0"/>
+            <p:ph type="sldImg"/>
           </p:nvPr>
         </p:nvSpPr>
         <p:spPr/>
       </p:sp>
       <p:sp>
         <p:nvSpPr>
-          <p:cNvPr id="3" name="Notes Placeholder 2"/>
+          <p:cNvPr id="3" name="Notes Placeholder 2">
+            <a:extLst>
+              <a:ext uri="{FF2B5EF4-FFF2-40B4-BE49-F238E27FC236}">
+                <a16:creationId xmlns:a16="http://schemas.microsoft.com/office/drawing/2014/main" id="{FF01A163-C2DA-77C8-7422-DB4C8C9F21C5}"/>
+              </a:ext>
+            </a:extLst>
+          </p:cNvPr>
           <p:cNvSpPr>
-            <a:spLocks xmlns:a="http://schemas.openxmlformats.org/drawingml/2006/main" noGrp="1"/>
+            <a:spLocks noGrp="1"/>
           </p:cNvSpPr>
           <p:nvPr>
             <p:ph type="body" idx="1"/>
@@ -8905,117 +8926,38 @@
         </p:nvSpPr>
         <p:spPr/>
         <p:txBody>
-          <a:bodyPr xmlns:a="http://schemas.openxmlformats.org/drawingml/2006/main"/>
-          <a:lstStyle xmlns:a="http://schemas.openxmlformats.org/drawingml/2006/main"/>
-          <a:p xmlns:a="http://schemas.openxmlformats.org/drawingml/2006/main">
-            <a:pPr marL="0" marR="0" lvl="0" indent="0" algn="l" defTabSz="914400">
-              <a:lnSpc>
-                <a:spcPct val="100000"/>
-              </a:lnSpc>
-              <a:spcBef>
-                <a:spcPts val="0"/>
-              </a:spcBef>
-              <a:spcAft>
-                <a:spcPts val="0"/>
-              </a:spcAft>
-              <a:buClrTx/>
-              <a:buSzTx/>
-              <a:buFontTx/>
-              <a:buNone/>
-            </a:pPr>
-            <a:r>
+          <a:bodyPr/>
+          <a:lstStyle/>
+          <a:p>
+            <a:r>
+              <a:rPr lang="en-US" dirty="0"/>
               <a:t>The chain on the previous slide leaves us with two questions.</a:t>
             </a:r>
           </a:p>
-          <a:p xmlns:a="http://schemas.openxmlformats.org/drawingml/2006/main">
-            <a:r>
-              <a:t/>
-            </a:r>
-            <a:endParaRPr/>
-          </a:p>
-          <a:p xmlns:a="http://schemas.openxmlformats.org/drawingml/2006/main">
-            <a:r>
+          <a:p>
+            <a:endParaRPr lang="en-US" dirty="0"/>
+          </a:p>
+          <a:p>
+            <a:r>
+              <a:rPr lang="en-US" dirty="0"/>
               <a:t>First, when data is spread and replicated across machines that fail, how can the system keep the data correct? The next slide states the behavior we would ideally like, and the following slides show why naive replication cannot provide it.</a:t>
             </a:r>
-            <a:endParaRPr/>
-          </a:p>
-          <a:p xmlns:a="http://schemas.openxmlformats.org/drawingml/2006/main">
-            <a:pPr marL="0" marR="0" lvl="0" indent="0" algn="l" defTabSz="914400">
-              <a:lnSpc>
-                <a:spcPct val="100000"/>
-              </a:lnSpc>
-              <a:spcBef>
-                <a:spcPts val="0"/>
-              </a:spcBef>
-              <a:spcAft>
-                <a:spcPts val="0"/>
-              </a:spcAft>
-              <a:buClrTx/>
-              <a:buSzTx/>
-              <a:buFontTx/>
-              <a:buNone/>
-            </a:pPr>
-            <a:r>
-              <a:t/>
-            </a:r>
-          </a:p>
-          <a:p xmlns:a="http://schemas.openxmlformats.org/drawingml/2006/main">
-            <a:pPr marL="0" marR="0" lvl="0" indent="0" algn="l" defTabSz="914400">
-              <a:lnSpc>
-                <a:spcPct val="100000"/>
-              </a:lnSpc>
-              <a:spcBef>
-                <a:spcPts val="0"/>
-              </a:spcBef>
-              <a:spcAft>
-                <a:spcPts val="0"/>
-              </a:spcAft>
-              <a:buClrTx/>
-              <a:buSzTx/>
-              <a:buFontTx/>
-              <a:buNone/>
-            </a:pPr>
-            <a:r>
+          </a:p>
+          <a:p>
+            <a:endParaRPr lang="en-US" dirty="0"/>
+          </a:p>
+          <a:p>
+            <a:r>
+              <a:rPr lang="en-US" dirty="0"/>
               <a:t>Second, what performance cost must we pay to obtain that correctness? Coordinating replicas can preserve the illusion of one correct server, but the extra messages and waiting increase latency and can reduce throughput.</a:t>
             </a:r>
           </a:p>
-          <a:p xmlns:a="http://schemas.openxmlformats.org/drawingml/2006/main">
-            <a:pPr marL="0" marR="0" lvl="0" indent="0" algn="l" defTabSz="914400">
-              <a:lnSpc>
-                <a:spcPct val="100000"/>
-              </a:lnSpc>
-              <a:spcBef>
-                <a:spcPts val="0"/>
-              </a:spcBef>
-              <a:spcAft>
-                <a:spcPts val="0"/>
-              </a:spcAft>
-              <a:buClrTx/>
-              <a:buSzTx/>
-              <a:buFontTx/>
-              <a:buNone/>
-            </a:pPr>
-            <a:r>
-              <a:t/>
-            </a:r>
-          </a:p>
-          <a:p xmlns:a="http://schemas.openxmlformats.org/drawingml/2006/main">
-            <a:pPr marL="0" marR="0" lvl="0" indent="0" algn="l" defTabSz="914400">
-              <a:lnSpc>
-                <a:spcPct val="100000"/>
-              </a:lnSpc>
-              <a:spcBef>
-                <a:spcPts val="0"/>
-              </a:spcBef>
-              <a:spcAft>
-                <a:spcPts val="0"/>
-              </a:spcAft>
-              <a:buClrTx/>
-              <a:buSzTx/>
-              <a:buFontTx/>
-              <a:buNone/>
-            </a:pPr>
-            <a:r>
+          <a:p>
+            <a:endParaRPr lang="en-US" dirty="0"/>
+          </a:p>
+          <a:p>
+            <a:r>
+              <a:rPr lang="en-US" dirty="0"/>
               <a:t>GFS answers both questions by choosing consistency guarantees and protocols that fit Google's workloads.</a:t>
             </a:r>
           </a:p>
@@ -9023,58 +8965,98 @@
       </p:sp>
       <p:sp>
         <p:nvSpPr>
-          <p:cNvPr id="4" name="Slide Number Placeholder 3"/>
+          <p:cNvPr id="4" name="Slide Number Placeholder 3">
+            <a:extLst>
+              <a:ext uri="{FF2B5EF4-FFF2-40B4-BE49-F238E27FC236}">
+                <a16:creationId xmlns:a16="http://schemas.microsoft.com/office/drawing/2014/main" id="{09D73A9A-D881-2613-9D53-6BBD01037D23}"/>
+              </a:ext>
+            </a:extLst>
+          </p:cNvPr>
           <p:cNvSpPr>
-            <a:spLocks xmlns:a="http://schemas.openxmlformats.org/drawingml/2006/main" noGrp="1"/>
+            <a:spLocks noGrp="1"/>
           </p:cNvSpPr>
           <p:nvPr>
-            <p:ph type="sldNum" idx="5"/>
+            <p:ph type="sldNum" sz="quarter" idx="5"/>
           </p:nvPr>
         </p:nvSpPr>
         <p:spPr/>
         <p:txBody>
-          <a:bodyPr xmlns:a="http://schemas.openxmlformats.org/drawingml/2006/main"/>
-          <a:lstStyle xmlns:a="http://schemas.openxmlformats.org/drawingml/2006/main"/>
-          <a:p xmlns:a="http://schemas.openxmlformats.org/drawingml/2006/main"/>
+          <a:bodyPr/>
+          <a:lstStyle/>
+          <a:p>
+            <a:fld id="{1C9584DC-3658-4054-9DA4-7B68A1D8CC6D}" type="slidenum">
+              <a:rPr lang="zh-CN" altLang="en-US" smtClean="0"/>
+              <a:t>8</a:t>
+            </a:fld>
+            <a:endParaRPr lang="zh-CN" altLang="en-US"/>
+          </a:p>
         </p:txBody>
       </p:sp>
     </p:spTree>
+    <p:extLst>
+      <p:ext uri="{BB962C8B-B14F-4D97-AF65-F5344CB8AC3E}">
+        <p14:creationId xmlns:p14="http://schemas.microsoft.com/office/powerpoint/2010/main" val="3354523721"/>
+      </p:ext>
+    </p:extLst>
   </p:cSld>
   <p:clrMapOvr>
-    <a:masterClrMapping xmlns:a="http://schemas.openxmlformats.org/drawingml/2006/main"/>
+    <a:masterClrMapping/>
   </p:clrMapOvr>
 </p:notes>
 </file>
 
 <file path=ppt/notesSlides/notesSlide9.xml><?xml version="1.0" encoding="utf-8"?>
-<p:notes xmlns:p="http://schemas.openxmlformats.org/presentationml/2006/main">
+<p:notes xmlns:a="http://schemas.openxmlformats.org/drawingml/2006/main" xmlns:r="http://schemas.openxmlformats.org/officeDocument/2006/relationships" xmlns:p="http://schemas.openxmlformats.org/presentationml/2006/main">
   <p:cSld>
     <p:spTree>
       <p:nvGrpSpPr>
-        <p:cNvPr id="1" name=""/>
+        <p:cNvPr id="1" name="">
+          <a:extLst>
+            <a:ext uri="{FF2B5EF4-FFF2-40B4-BE49-F238E27FC236}">
+              <a16:creationId xmlns:a16="http://schemas.microsoft.com/office/drawing/2014/main" id="{4EC59D2F-F719-1204-3BE4-5648B3224DA8}"/>
+            </a:ext>
+          </a:extLst>
+        </p:cNvPr>
         <p:cNvGrpSpPr/>
         <p:nvPr/>
       </p:nvGrpSpPr>
       <p:grpSpPr>
-        <a:xfrm xmlns:a="http://schemas.openxmlformats.org/drawingml/2006/main"/>
+        <a:xfrm>
+          <a:off x="0" y="0"/>
+          <a:ext cx="0" cy="0"/>
+          <a:chOff x="0" y="0"/>
+          <a:chExt cx="0" cy="0"/>
+        </a:xfrm>
       </p:grpSpPr>
       <p:sp>
         <p:nvSpPr>
-          <p:cNvPr id="2" name="Slide Image Placeholder 1"/>
+          <p:cNvPr id="2" name="Slide Image Placeholder 1">
+            <a:extLst>
+              <a:ext uri="{FF2B5EF4-FFF2-40B4-BE49-F238E27FC236}">
+                <a16:creationId xmlns:a16="http://schemas.microsoft.com/office/drawing/2014/main" id="{8AC7BD6E-9ED5-B0EB-2519-0B5A471E326C}"/>
+              </a:ext>
+            </a:extLst>
+          </p:cNvPr>
           <p:cNvSpPr>
-            <a:spLocks xmlns:a="http://schemas.openxmlformats.org/drawingml/2006/main" noGrp="1"/>
+            <a:spLocks noGrp="1" noRot="1" noChangeAspect="1"/>
           </p:cNvSpPr>
           <p:nvPr>
-            <p:ph type="sldImg" idx="0"/>
+            <p:ph type="sldImg"/>
           </p:nvPr>
         </p:nvSpPr>
         <p:spPr/>
       </p:sp>
       <p:sp>
         <p:nvSpPr>
-          <p:cNvPr id="3" name="Notes Placeholder 2"/>
+          <p:cNvPr id="3" name="Notes Placeholder 2">
+            <a:extLst>
+              <a:ext uri="{FF2B5EF4-FFF2-40B4-BE49-F238E27FC236}">
+                <a16:creationId xmlns:a16="http://schemas.microsoft.com/office/drawing/2014/main" id="{A39AF431-6503-9F6E-44FB-746BDA533D73}"/>
+              </a:ext>
+            </a:extLst>
+          </p:cNvPr>
           <p:cNvSpPr>
-            <a:spLocks xmlns:a="http://schemas.openxmlformats.org/drawingml/2006/main" noGrp="1"/>
+            <a:spLocks noGrp="1"/>
           </p:cNvSpPr>
           <p:nvPr>
             <p:ph type="body" idx="1"/>
@@ -9082,43 +9064,38 @@
         </p:nvSpPr>
         <p:spPr/>
         <p:txBody>
-          <a:bodyPr xmlns:a="http://schemas.openxmlformats.org/drawingml/2006/main"/>
-          <a:lstStyle xmlns:a="http://schemas.openxmlformats.org/drawingml/2006/main"/>
-          <a:p xmlns:a="http://schemas.openxmlformats.org/drawingml/2006/main">
-            <a:r>
+          <a:bodyPr/>
+          <a:lstStyle/>
+          <a:p>
+            <a:r>
+              <a:rPr lang="en-US" dirty="0"/>
               <a:t>This slide makes the chain explicit. We need fault tolerance because machines fail. Fault tolerance requires replication: keep multiple copies and use a surviving copy when another one fails.</a:t>
             </a:r>
           </a:p>
-          <a:p xmlns:a="http://schemas.openxmlformats.org/drawingml/2006/main">
-            <a:r>
-              <a:t/>
-            </a:r>
-            <a:endParaRPr/>
-          </a:p>
-          <a:p xmlns:a="http://schemas.openxmlformats.org/drawingml/2006/main">
-            <a:r>
+          <a:p>
+            <a:endParaRPr lang="en-US" dirty="0"/>
+          </a:p>
+          <a:p>
+            <a:r>
+              <a:rPr lang="en-US" dirty="0"/>
               <a:t>But replication changes the correctness problem. Writes can reach the copies in different orders, or a server can fail partway through an update. The replicas may then contain different data.</a:t>
             </a:r>
           </a:p>
-          <a:p xmlns:a="http://schemas.openxmlformats.org/drawingml/2006/main">
-            <a:r>
-              <a:t/>
-            </a:r>
-            <a:endParaRPr/>
-          </a:p>
-          <a:p xmlns:a="http://schemas.openxmlformats.org/drawingml/2006/main">
-            <a:r>
+          <a:p>
+            <a:endParaRPr lang="en-US" dirty="0"/>
+          </a:p>
+          <a:p>
+            <a:r>
+              <a:rPr lang="en-US" dirty="0"/>
               <a:t>Stronger consistency requires the replicas to coordinate on an order and wait for enough copies. That coordination adds messages and waiting, so it increases latency and can reduce throughput.</a:t>
             </a:r>
           </a:p>
-          <a:p xmlns:a="http://schemas.openxmlformats.org/drawingml/2006/main">
-            <a:r>
-              <a:t/>
-            </a:r>
-            <a:endParaRPr/>
-          </a:p>
-          <a:p xmlns:a="http://schemas.openxmlformats.org/drawingml/2006/main">
-            <a:r>
+          <a:p>
+            <a:endParaRPr lang="en-US" dirty="0"/>
+          </a:p>
+          <a:p>
+            <a:r>
+              <a:rPr lang="en-US" dirty="0"/>
               <a:t>This is the tradeoff that motivates the rest of the lecture: how do we keep replicated data correct, and how much performance are we willing to pay for that correctness?</a:t>
             </a:r>
           </a:p>
@@ -9126,25 +9103,42 @@
       </p:sp>
       <p:sp>
         <p:nvSpPr>
-          <p:cNvPr id="4" name="Slide Number Placeholder 3"/>
+          <p:cNvPr id="4" name="Slide Number Placeholder 3">
+            <a:extLst>
+              <a:ext uri="{FF2B5EF4-FFF2-40B4-BE49-F238E27FC236}">
+                <a16:creationId xmlns:a16="http://schemas.microsoft.com/office/drawing/2014/main" id="{E8FE7602-B30B-17D7-6742-4BE51445636D}"/>
+              </a:ext>
+            </a:extLst>
+          </p:cNvPr>
           <p:cNvSpPr>
-            <a:spLocks xmlns:a="http://schemas.openxmlformats.org/drawingml/2006/main" noGrp="1"/>
+            <a:spLocks noGrp="1"/>
           </p:cNvSpPr>
           <p:nvPr>
-            <p:ph type="sldNum" idx="5"/>
+            <p:ph type="sldNum" sz="quarter" idx="5"/>
           </p:nvPr>
         </p:nvSpPr>
         <p:spPr/>
         <p:txBody>
-          <a:bodyPr xmlns:a="http://schemas.openxmlformats.org/drawingml/2006/main"/>
-          <a:lstStyle xmlns:a="http://schemas.openxmlformats.org/drawingml/2006/main"/>
-          <a:p xmlns:a="http://schemas.openxmlformats.org/drawingml/2006/main"/>
+          <a:bodyPr/>
+          <a:lstStyle/>
+          <a:p>
+            <a:fld id="{1C9584DC-3658-4054-9DA4-7B68A1D8CC6D}" type="slidenum">
+              <a:rPr lang="zh-CN" altLang="en-US" smtClean="0"/>
+              <a:t>9</a:t>
+            </a:fld>
+            <a:endParaRPr lang="zh-CN" altLang="en-US"/>
+          </a:p>
         </p:txBody>
       </p:sp>
     </p:spTree>
+    <p:extLst>
+      <p:ext uri="{BB962C8B-B14F-4D97-AF65-F5344CB8AC3E}">
+        <p14:creationId xmlns:p14="http://schemas.microsoft.com/office/powerpoint/2010/main" val="2775443294"/>
+      </p:ext>
+    </p:extLst>
   </p:cSld>
   <p:clrMapOvr>
-    <a:masterClrMapping xmlns:a="http://schemas.openxmlformats.org/drawingml/2006/main"/>
+    <a:masterClrMapping/>
   </p:clrMapOvr>
 </p:notes>
 </file>
@@ -15210,9 +15204,14 @@
             </a:r>
           </a:p>
           <a:p>
-            <a:endParaRPr lang="en-US" sz="2800" dirty="0">
-              <a:effectLst/>
-            </a:endParaRPr>
+            <a:r>
+              <a:rPr lang="en-US" sz="2800" dirty="0" b="1">
+                <a:solidFill>
+                  <a:srgbClr val="A02B93"/>
+                </a:solidFill>
+              </a:rPr>
+              <a:t>What interface should GFS expose to applications?</a:t>
+            </a:r>
           </a:p>
           <a:p>
             <a:r>
@@ -15284,63 +15283,6 @@
             <a:endParaRPr lang="en-US" sz="2800" dirty="0">
               <a:effectLst/>
             </a:endParaRPr>
-          </a:p>
-        </p:txBody>
-      </p:sp>
-      <p:sp>
-        <p:nvSpPr>
-          <p:cNvPr id="9" name="Interface question">
-            <a:extLst>
-              <a:ext uri="{FF2B5EF4-FFF2-40B4-BE49-F238E27FC236}">
-                <a16:creationId xmlns:a16="http://schemas.microsoft.com/office/drawing/2014/main" id="{32AA9800-7FDB-4DEB-80B5-FE9FA5B76952}"/>
-              </a:ext>
-            </a:extLst>
-          </p:cNvPr>
-          <p:cNvSpPr>
-            <a:spLocks noGrp="1"/>
-          </p:cNvSpPr>
-          <p:nvPr/>
-        </p:nvSpPr>
-        <p:spPr>
-          <a:xfrm>
-            <a:off x="164402" y="1600200"/>
-            <a:ext cx="11191875" cy="419100"/>
-          </a:xfrm>
-          <a:prstGeom prst="rect">
-            <a:avLst/>
-          </a:prstGeom>
-          <a:noFill/>
-          <a:ln w="0">
-            <a:noFill/>
-          </a:ln>
-        </p:spPr>
-        <p:txBody>
-          <a:bodyPr>
-            <a:normAutofit fontScale="76786"/>
-          </a:bodyPr>
-          <a:lstStyle/>
-          <a:p>
-            <a:pPr>
-              <a:defRPr sz="2800" b="1">
-                <a:solidFill>
-                  <a:srgbClr val="A02B93"/>
-                </a:solidFill>
-                <a:latin typeface="Aptos"/>
-                <a:ea typeface="Aptos"/>
-                <a:cs typeface="Aptos"/>
-              </a:defRPr>
-            </a:pPr>
-            <a:r>
-              <a:rPr sz="2800" b="1">
-                <a:solidFill>
-                  <a:srgbClr val="A02B93"/>
-                </a:solidFill>
-                <a:latin typeface="Aptos"/>
-                <a:ea typeface="Aptos"/>
-                <a:cs typeface="Aptos"/>
-              </a:rPr>
-              <a:t>What interface should GFS expose to applications?</a:t>
-            </a:r>
           </a:p>
         </p:txBody>
       </p:sp>
@@ -29713,84 +29655,43 @@
       </p:sp>
       <p:sp>
         <p:nvSpPr>
-          <p:cNvPr id="9" name="Tradeoff lecture questions">
-            <a:extLst>
-              <a:ext uri="{FF2B5EF4-FFF2-40B4-BE49-F238E27FC236}">
-                <a16:creationId xmlns:a16="http://schemas.microsoft.com/office/drawing/2014/main" id="{1C6172CA-3D22-4927-B780-D9FCE0B7AE19}"/>
-              </a:ext>
-            </a:extLst>
-          </p:cNvPr>
-          <p:cNvSpPr>
-            <a:spLocks noGrp="1"/>
-          </p:cNvSpPr>
+          <p:cNvPr id="3" name="TextBox 2">
+            <a:extLst>
+              <a:ext uri="{FF2B5EF4-FFF2-40B4-BE49-F238E27FC236}">
+                <a16:creationId xmlns:a16="http://schemas.microsoft.com/office/drawing/2014/main" id="{857EC8A2-DB9F-8BB1-7445-FE716E76BAC5}"/>
+              </a:ext>
+            </a:extLst>
+          </p:cNvPr>
+          <p:cNvSpPr txBox="1"/>
           <p:nvPr/>
         </p:nvSpPr>
         <p:spPr>
           <a:xfrm>
-            <a:off x="88106" y="914400"/>
-            <a:ext cx="11265694" cy="5016722"/>
+            <a:off x="88135" y="914401"/>
+            <a:ext cx="11265665" cy="5016758"/>
           </a:xfrm>
           <a:prstGeom prst="rect">
             <a:avLst/>
           </a:prstGeom>
           <a:noFill/>
-          <a:ln w="0">
-            <a:noFill/>
-          </a:ln>
         </p:spPr>
         <p:txBody>
-          <a:bodyPr>
-            <a:normAutofit fontScale="100000"/>
+          <a:bodyPr wrap="square" rtlCol="0">
+            <a:spAutoFit/>
           </a:bodyPr>
           <a:lstStyle/>
           <a:p>
-            <a:pPr>
-              <a:defRPr sz="3200" b="1">
-                <a:solidFill>
-                  <a:srgbClr val="000000"/>
-                </a:solidFill>
-                <a:latin typeface="Aptos"/>
-                <a:ea typeface="Aptos"/>
-                <a:cs typeface="Aptos"/>
-              </a:defRPr>
-            </a:pPr>
-            <a:r>
-              <a:rPr sz="3200" b="1">
-                <a:solidFill>
-                  <a:srgbClr val="000000"/>
-                </a:solidFill>
-                <a:latin typeface="Aptos"/>
-                <a:ea typeface="Aptos"/>
-                <a:cs typeface="Aptos"/>
-              </a:rPr>
+            <a:r>
+              <a:rPr lang="en-US" sz="3200" dirty="0" b="1"/>
               <a:t>How can data remain correct when it is spread across machines that fail?</a:t>
             </a:r>
           </a:p>
           <a:p>
-            <a:r>
-              <a:t/>
-            </a:r>
-          </a:p>
-          <a:p>
-            <a:pPr>
-              <a:defRPr sz="3200" b="1">
-                <a:solidFill>
-                  <a:srgbClr val="000000"/>
-                </a:solidFill>
-                <a:latin typeface="Aptos"/>
-                <a:ea typeface="Aptos"/>
-                <a:cs typeface="Aptos"/>
-              </a:defRPr>
-            </a:pPr>
-            <a:r>
-              <a:rPr sz="3200" b="1">
-                <a:solidFill>
-                  <a:srgbClr val="000000"/>
-                </a:solidFill>
-                <a:latin typeface="Aptos"/>
-                <a:ea typeface="Aptos"/>
-                <a:cs typeface="Aptos"/>
-              </a:rPr>
+            <a:endParaRPr lang="en-US" sz="3200" dirty="0"/>
+          </a:p>
+          <a:p>
+            <a:r>
+              <a:rPr lang="en-US" sz="3200" dirty="0" b="1"/>
               <a:t>What performance cost must we pay to make that happen?</a:t>
             </a:r>
           </a:p>
@@ -29845,7 +29746,7 @@
             <a:spLocks noGrp="1"/>
           </p:cNvSpPr>
           <p:nvPr>
-            <p:ph type="title" idx="0"/>
+            <p:ph type="title"/>
           </p:nvPr>
         </p:nvSpPr>
         <p:spPr>
@@ -29856,18 +29757,15 @@
         </p:spPr>
         <p:txBody>
           <a:bodyPr>
-            <a:normAutofit fontScale="100000"/>
+            <a:normAutofit/>
           </a:bodyPr>
           <a:lstStyle/>
           <a:p>
-            <a:pPr algn="ctr">
-              <a:buNone/>
-            </a:pPr>
-            <a:r>
-              <a:rPr b="1">
-                <a:latin typeface="Helvetica"/>
-                <a:ea typeface="Helvetica"/>
-                <a:cs typeface="Helvetica"/>
+            <a:pPr algn="ctr"/>
+            <a:r>
+              <a:rPr lang="en-US" b="1" dirty="0">
+                <a:latin typeface="Helvetica" panose="020B0604020202020204" pitchFamily="34" charset="0"/>
+                <a:cs typeface="Helvetica" panose="020B0604020202020204" pitchFamily="34" charset="0"/>
               </a:rPr>
               <a:t>Fault Tolerance Comes with a Cost</a:t>
             </a:r>
@@ -31765,141 +31663,90 @@
       </p:grpSp>
       <p:sp>
         <p:nvSpPr>
-          <p:cNvPr id="61" name="Tradeoff chain bullets">
-            <a:extLst>
-              <a:ext uri="{FF2B5EF4-FFF2-40B4-BE49-F238E27FC236}">
-                <a16:creationId xmlns:a16="http://schemas.microsoft.com/office/drawing/2014/main" id="{349D2510-06A7-443F-BD28-77CA7DFA9405}"/>
-              </a:ext>
-            </a:extLst>
-          </p:cNvPr>
-          <p:cNvSpPr>
-            <a:spLocks noGrp="1"/>
-          </p:cNvSpPr>
+          <p:cNvPr id="48" name="TextBox 47">
+            <a:extLst>
+              <a:ext uri="{FF2B5EF4-FFF2-40B4-BE49-F238E27FC236}">
+                <a16:creationId xmlns:a16="http://schemas.microsoft.com/office/drawing/2014/main" id="{51F35555-7DB3-0E9F-0CC1-8DCCA40D364A}"/>
+              </a:ext>
+            </a:extLst>
+          </p:cNvPr>
+          <p:cNvSpPr txBox="1"/>
           <p:nvPr/>
         </p:nvSpPr>
         <p:spPr>
           <a:xfrm>
-            <a:off x="7325296" y="1373219"/>
-            <a:ext cx="4706588" cy="4154996"/>
+            <a:off x="7325250" y="1373218"/>
+            <a:ext cx="4706595" cy="4154984"/>
           </a:xfrm>
           <a:prstGeom prst="rect">
             <a:avLst/>
           </a:prstGeom>
           <a:noFill/>
-          <a:ln w="0">
-            <a:noFill/>
-          </a:ln>
         </p:spPr>
         <p:txBody>
-          <a:bodyPr>
-            <a:normAutofit fontScale="100000"/>
+          <a:bodyPr wrap="square">
+            <a:spAutoFit/>
           </a:bodyPr>
           <a:lstStyle/>
           <a:p>
-            <a:pPr>
-              <a:defRPr sz="2400">
-                <a:solidFill>
-                  <a:srgbClr val="000000"/>
-                </a:solidFill>
-                <a:latin typeface="Aptos"/>
-                <a:ea typeface="Aptos"/>
-                <a:cs typeface="Aptos"/>
-              </a:defRPr>
+            <a:pPr marL="342900" indent="-342900">
+              <a:buFont typeface="Arial" panose="020B0604020202020204" pitchFamily="34" charset="0"/>
+              <a:buChar char="•"/>
             </a:pPr>
             <a:r>
-              <a:rPr sz="2400">
-                <a:solidFill>
-                  <a:srgbClr val="000000"/>
-                </a:solidFill>
-                <a:latin typeface="Aptos"/>
-                <a:ea typeface="Aptos"/>
-                <a:cs typeface="Aptos"/>
-              </a:rPr>
-              <a:t>• Fault tolerance requires replication</a:t>
-            </a:r>
-          </a:p>
-          <a:p>
-            <a:r>
-              <a:t/>
-            </a:r>
-          </a:p>
-          <a:p>
-            <a:pPr>
-              <a:defRPr sz="2400">
-                <a:solidFill>
-                  <a:srgbClr val="000000"/>
-                </a:solidFill>
-                <a:latin typeface="Aptos"/>
-                <a:ea typeface="Aptos"/>
-                <a:cs typeface="Aptos"/>
-              </a:defRPr>
+              <a:rPr lang="en-US" sz="2400" dirty="0"/>
+              <a:t>Fault tolerance requires replication</a:t>
+            </a:r>
+          </a:p>
+          <a:p>
+            <a:pPr marL="342900" indent="-342900">
+              <a:buFont typeface="Arial" panose="020B0604020202020204" pitchFamily="34" charset="0"/>
+              <a:buChar char="•"/>
             </a:pPr>
-            <a:r>
-              <a:rPr sz="2400">
-                <a:solidFill>
-                  <a:srgbClr val="000000"/>
-                </a:solidFill>
-                <a:latin typeface="Aptos"/>
-                <a:ea typeface="Aptos"/>
-                <a:cs typeface="Aptos"/>
-              </a:rPr>
-              <a:t>• Replication risks inconsistency</a:t>
-            </a:r>
-          </a:p>
-          <a:p>
-            <a:r>
-              <a:t/>
-            </a:r>
-          </a:p>
-          <a:p>
-            <a:pPr>
-              <a:defRPr sz="2400">
-                <a:solidFill>
-                  <a:srgbClr val="000000"/>
-                </a:solidFill>
-                <a:latin typeface="Aptos"/>
-                <a:ea typeface="Aptos"/>
-                <a:cs typeface="Aptos"/>
-              </a:defRPr>
+            <a:endParaRPr lang="en-US" sz="1200" dirty="0"/>
+          </a:p>
+          <a:p>
+            <a:pPr marL="342900" indent="-342900">
+              <a:buFont typeface="Arial" panose="020B0604020202020204" pitchFamily="34" charset="0"/>
+              <a:buChar char="•"/>
             </a:pPr>
             <a:r>
-              <a:rPr sz="2400">
-                <a:solidFill>
-                  <a:srgbClr val="000000"/>
-                </a:solidFill>
-                <a:latin typeface="Aptos"/>
-                <a:ea typeface="Aptos"/>
-                <a:cs typeface="Aptos"/>
-              </a:rPr>
-              <a:t>• Consistency requires coordination</a:t>
-            </a:r>
-          </a:p>
-          <a:p>
-            <a:r>
-              <a:t/>
-            </a:r>
-          </a:p>
-          <a:p>
-            <a:pPr>
-              <a:defRPr sz="2400">
-                <a:solidFill>
-                  <a:srgbClr val="000000"/>
-                </a:solidFill>
-                <a:latin typeface="Aptos"/>
-                <a:ea typeface="Aptos"/>
-                <a:cs typeface="Aptos"/>
-              </a:defRPr>
+              <a:rPr lang="en-US" sz="2400" dirty="0"/>
+              <a:t>Replication risks inconsistency</a:t>
+            </a:r>
+          </a:p>
+          <a:p>
+            <a:pPr marL="342900" indent="-342900">
+              <a:buFont typeface="Arial" panose="020B0604020202020204" pitchFamily="34" charset="0"/>
+              <a:buChar char="•"/>
             </a:pPr>
-            <a:r>
-              <a:rPr sz="2400">
-                <a:solidFill>
-                  <a:srgbClr val="000000"/>
-                </a:solidFill>
-                <a:latin typeface="Aptos"/>
-                <a:ea typeface="Aptos"/>
-                <a:cs typeface="Aptos"/>
-              </a:rPr>
-              <a:t>• Coordination lowers performance</a:t>
+            <a:endParaRPr lang="en-US" sz="1200" dirty="0"/>
+          </a:p>
+          <a:p>
+            <a:pPr marL="342900" indent="-342900">
+              <a:buFont typeface="Arial" panose="020B0604020202020204" pitchFamily="34" charset="0"/>
+              <a:buChar char="•"/>
+            </a:pPr>
+            <a:r>
+              <a:rPr lang="en-US" sz="2400" dirty="0"/>
+              <a:t>Consistency requires coordination</a:t>
+            </a:r>
+          </a:p>
+          <a:p>
+            <a:pPr marL="342900" indent="-342900">
+              <a:buFont typeface="Arial" panose="020B0604020202020204" pitchFamily="34" charset="0"/>
+              <a:buChar char="•"/>
+            </a:pPr>
+            <a:endParaRPr lang="en-US" sz="1200" dirty="0"/>
+          </a:p>
+          <a:p>
+            <a:pPr marL="342900" indent="-342900">
+              <a:buFont typeface="Arial" panose="020B0604020202020204" pitchFamily="34" charset="0"/>
+              <a:buChar char="•"/>
+            </a:pPr>
+            <a:r>
+              <a:rPr lang="en-US" sz="2400" dirty="0"/>
+              <a:t>Coordination lowers performance</a:t>
             </a:r>
           </a:p>
         </p:txBody>

</xml_diff>

<commit_message>
Rewrite GFS tradeoff notes from MIT lecture
</commit_message>
<xml_diff>
--- a/slides/fall26/4-gfs.pptx
+++ b/slides/fall26/4-gfs.pptx
@@ -9069,7 +9069,7 @@
           <a:p>
             <a:r>
               <a:rPr lang="en-US" dirty="0"/>
-              <a:t>This slide makes the chain explicit. We need fault tolerance because machines fail. Fault tolerance requires replication: keep multiple copies and use a surviving copy when another one fails.</a:t>
+              <a:t>The starting point is performance. To get huge aggregate throughput, we split the data across many servers and read from many of them in parallel. But once the system has hundreds or thousands of servers, failures are no longer exceptional. Some machine is always down, so fault tolerance has to be automatic.</a:t>
             </a:r>
           </a:p>
           <a:p>
@@ -9078,7 +9078,7 @@
           <a:p>
             <a:r>
               <a:rPr lang="en-US" dirty="0"/>
-              <a:t>But replication changes the correctness problem. Writes can reach the copies in different orders, or a server can fail partway through an update. The replicas may then contain different data.</a:t>
+              <a:t>The standard way to get fault tolerance is replication. Keep two or three copies of each piece of data, and if one server fails, use another copy.</a:t>
             </a:r>
           </a:p>
           <a:p>
@@ -9087,7 +9087,7 @@
           <a:p>
             <a:r>
               <a:rPr lang="en-US" dirty="0"/>
-              <a:t>Stronger consistency requires the replicas to coordinate on an order and wait for enough copies. That coordination adds messages and waiting, so it increases latency and can reduce throughput.</a:t>
+              <a:t>But now we have a new problem. If we are not careful, those replicas get out of sync. What looked like interchangeable copies becomes two almost identical copies, and the value a client reads depends on which server it contacts.</a:t>
             </a:r>
           </a:p>
           <a:p>
@@ -9096,7 +9096,19 @@
           <a:p>
             <a:r>
               <a:rPr lang="en-US" dirty="0"/>
-              <a:t>This is the tradeoff that motivates the rest of the lecture: how do we keep replicated data correct, and how much performance are we willing to pay for that correctness?</a:t>
+              <a:t>We can eliminate those inconsistencies with more careful coordination, but coordination means more work, more messages, and more waiting. That reduces performance. So the design comes back to a tension: we started with performance, but stronger consistency costs performance. GFS chooses a point in that tradeoff instead of paying the full cost of strict consistency.</a:t>
+            </a:r>
+          </a:p>
+          <a:p>
+            <a:endParaRPr lang="en-US" dirty="0"/>
+          </a:p>
+          <a:p>
+            <a:r>
+              <a:rPr lang="en-US" dirty="0"/>
+              <a:t>SOURCE
+MIT 6.824, Spring 2020, Lecture 3 transcript/video, 02:28–05:42.
+Local transcript: fall2026/lectures/references/mit-6824-2020-lecture3-gfs-transcript.txt
+https://www.youtube.com/watch?v=EpIgvowZr00</a:t>
             </a:r>
           </a:p>
         </p:txBody>

</xml_diff>

<commit_message>
Continue GFS tradeoff narrative across slides
</commit_message>
<xml_diff>
--- a/slides/fall26/4-gfs.pptx
+++ b/slides/fall26/4-gfs.pptx
@@ -9069,7 +9069,7 @@
           <a:p>
             <a:r>
               <a:rPr lang="en-US" dirty="0"/>
-              <a:t>The starting point is performance. To get huge aggregate throughput, we split the data across many servers and read from many of them in parallel. But once the system has hundreds or thousands of servers, failures are no longer exceptional. Some machine is always down, so fault tolerance has to be automatic.</a:t>
+              <a:t>Up to this point, performance has pushed us to spread the data across many servers, and failures have pushed us to replicate it. Now replication creates a new problem.</a:t>
             </a:r>
           </a:p>
           <a:p>
@@ -9078,7 +9078,7 @@
           <a:p>
             <a:r>
               <a:rPr lang="en-US" dirty="0"/>
-              <a:t>The standard way to get fault tolerance is replication. Keep two or three copies of each piece of data, and if one server fails, use another copy.</a:t>
+              <a:t>If we are not careful, the replicas get out of sync. What were supposed to be interchangeable copies become two almost identical copies, and the value a client reads depends on which server it contacts.</a:t>
             </a:r>
           </a:p>
           <a:p>
@@ -9087,7 +9087,7 @@
           <a:p>
             <a:r>
               <a:rPr lang="en-US" dirty="0"/>
-              <a:t>But now we have a new problem. If we are not careful, those replicas get out of sync. What looked like interchangeable copies becomes two almost identical copies, and the value a client reads depends on which server it contacts.</a:t>
+              <a:t>We can eliminate those inconsistencies with more careful coordination, but coordination requires extra work and extra communication among the servers and clients. That adds waiting and reduces performance.</a:t>
             </a:r>
           </a:p>
           <a:p>
@@ -9096,7 +9096,7 @@
           <a:p>
             <a:r>
               <a:rPr lang="en-US" dirty="0"/>
-              <a:t>We can eliminate those inconsistencies with more careful coordination, but coordination means more work, more messages, and more waiting. That reduces performance. So the design comes back to a tension: we started with performance, but stronger consistency costs performance. GFS chooses a point in that tradeoff instead of paying the full cost of strict consistency.</a:t>
+              <a:t>So the argument comes full circle. We started by distributing the data to gain performance, but stronger consistency makes us give some of that performance back. GFS chooses a point in this tradeoff rather than paying the full cost of strict consistency.</a:t>
             </a:r>
           </a:p>
           <a:p>
@@ -9106,7 +9106,7 @@
             <a:r>
               <a:rPr lang="en-US" dirty="0"/>
               <a:t>SOURCE
-MIT 6.824, Spring 2020, Lecture 3 transcript/video, 02:28–05:42.
+MIT 6.824, Spring 2020, Lecture 3 transcript/video, 04:05–05:42.
 Local transcript: fall2026/lectures/references/mit-6824-2020-lecture3-gfs-transcript.txt
 https://www.youtube.com/watch?v=EpIgvowZr00</a:t>
             </a:r>

</xml_diff>

<commit_message>
Clarify GFS replication tradeoff diagram
</commit_message>
<xml_diff>
--- a/slides/fall26/4-gfs.pptx
+++ b/slides/fall26/4-gfs.pptx
@@ -29723,61 +29723,53 @@
 </file>
 
 <file path=ppt/slides/slide9.xml><?xml version="1.0" encoding="utf-8"?>
-<p:sld xmlns:a="http://schemas.openxmlformats.org/drawingml/2006/main" xmlns:r="http://schemas.openxmlformats.org/officeDocument/2006/relationships" xmlns:p="http://schemas.openxmlformats.org/presentationml/2006/main">
+<p:sld xmlns:p="http://schemas.openxmlformats.org/presentationml/2006/main">
   <p:cSld>
     <p:spTree>
       <p:nvGrpSpPr>
-        <p:cNvPr id="1" name="">
-          <a:extLst>
-            <a:ext uri="{FF2B5EF4-FFF2-40B4-BE49-F238E27FC236}">
-              <a16:creationId xmlns:a16="http://schemas.microsoft.com/office/drawing/2014/main" id="{8D3006AC-979F-0806-0955-EC68D0D83E2B}"/>
-            </a:ext>
-          </a:extLst>
-        </p:cNvPr>
+        <p:cNvPr id="1" name=""/>
         <p:cNvGrpSpPr/>
         <p:nvPr/>
       </p:nvGrpSpPr>
       <p:grpSpPr>
-        <a:xfrm>
-          <a:off x="0" y="0"/>
-          <a:ext cx="0" cy="0"/>
-          <a:chOff x="0" y="0"/>
-          <a:chExt cx="0" cy="0"/>
-        </a:xfrm>
+        <a:xfrm xmlns:a="http://schemas.openxmlformats.org/drawingml/2006/main"/>
       </p:grpSpPr>
       <p:sp>
         <p:nvSpPr>
           <p:cNvPr id="7" name="Title 1">
-            <a:extLst>
+            <a:extLst xmlns:a="http://schemas.openxmlformats.org/drawingml/2006/main">
               <a:ext uri="{FF2B5EF4-FFF2-40B4-BE49-F238E27FC236}">
                 <a16:creationId xmlns:a16="http://schemas.microsoft.com/office/drawing/2014/main" id="{9452C5CF-C823-F93B-EC88-BA4478E024CE}"/>
               </a:ext>
             </a:extLst>
           </p:cNvPr>
           <p:cNvSpPr>
-            <a:spLocks noGrp="1"/>
-          </p:cNvSpPr>
-          <p:nvPr>
-            <p:ph type="title"/>
+            <a:spLocks xmlns:a="http://schemas.openxmlformats.org/drawingml/2006/main" noGrp="1"/>
+          </p:cNvSpPr>
+          <p:nvPr>
+            <p:ph type="title" idx="0"/>
           </p:nvPr>
         </p:nvSpPr>
         <p:spPr>
-          <a:xfrm>
+          <a:xfrm xmlns:a="http://schemas.openxmlformats.org/drawingml/2006/main">
             <a:off x="0" y="1"/>
             <a:ext cx="12191999" cy="914400"/>
           </a:xfrm>
         </p:spPr>
         <p:txBody>
-          <a:bodyPr>
+          <a:bodyPr xmlns:a="http://schemas.openxmlformats.org/drawingml/2006/main">
             <a:normAutofit/>
           </a:bodyPr>
-          <a:lstStyle/>
-          <a:p>
-            <a:pPr algn="ctr"/>
-            <a:r>
-              <a:rPr lang="en-US" b="1" dirty="0">
-                <a:latin typeface="Helvetica" panose="020B0604020202020204" pitchFamily="34" charset="0"/>
-                <a:cs typeface="Helvetica" panose="020B0604020202020204" pitchFamily="34" charset="0"/>
+          <a:lstStyle xmlns:a="http://schemas.openxmlformats.org/drawingml/2006/main"/>
+          <a:p xmlns:a="http://schemas.openxmlformats.org/drawingml/2006/main">
+            <a:pPr algn="ctr">
+              <a:buNone/>
+            </a:pPr>
+            <a:r>
+              <a:rPr b="1">
+                <a:latin typeface="Helvetica"/>
+                <a:ea typeface="Helvetica"/>
+                <a:cs typeface="Helvetica"/>
               </a:rPr>
               <a:t>Fault Tolerance Comes with a Cost</a:t>
             </a:r>
@@ -29787,1978 +29779,1237 @@
       <p:sp>
         <p:nvSpPr>
           <p:cNvPr id="8" name="Slide Number Placeholder 4">
-            <a:extLst>
+            <a:extLst xmlns:a="http://schemas.openxmlformats.org/drawingml/2006/main">
               <a:ext uri="{FF2B5EF4-FFF2-40B4-BE49-F238E27FC236}">
                 <a16:creationId xmlns:a16="http://schemas.microsoft.com/office/drawing/2014/main" id="{16D0A24B-6300-8D05-5AB9-F3998A2F3009}"/>
               </a:ext>
             </a:extLst>
           </p:cNvPr>
           <p:cNvSpPr>
-            <a:spLocks noGrp="1"/>
-          </p:cNvSpPr>
-          <p:nvPr>
-            <p:ph type="sldNum" sz="quarter" idx="12"/>
+            <a:spLocks xmlns:a="http://schemas.openxmlformats.org/drawingml/2006/main" noGrp="1"/>
+          </p:cNvSpPr>
+          <p:nvPr>
+            <p:ph type="sldNum" idx="12"/>
           </p:nvPr>
         </p:nvSpPr>
         <p:spPr>
-          <a:xfrm>
+          <a:xfrm xmlns:a="http://schemas.openxmlformats.org/drawingml/2006/main">
             <a:off x="8610600" y="6356350"/>
             <a:ext cx="2743200" cy="365125"/>
           </a:xfrm>
         </p:spPr>
         <p:txBody>
-          <a:bodyPr/>
-          <a:lstStyle/>
-          <a:p>
+          <a:bodyPr xmlns:a="http://schemas.openxmlformats.org/drawingml/2006/main"/>
+          <a:lstStyle xmlns:a="http://schemas.openxmlformats.org/drawingml/2006/main"/>
+          <a:p xmlns:a="http://schemas.openxmlformats.org/drawingml/2006/main">
             <a:fld id="{212DA15D-5F50-8B40-811F-34F736B90848}" type="slidenum">
-              <a:rPr lang="en-US" smtClean="0"/>
               <a:t>9</a:t>
             </a:fld>
-            <a:endParaRPr lang="en-US"/>
-          </a:p>
-        </p:txBody>
-      </p:sp>
-      <p:grpSp>
-        <p:nvGrpSpPr>
-          <p:cNvPr id="46" name="Group 45">
-            <a:extLst>
-              <a:ext uri="{FF2B5EF4-FFF2-40B4-BE49-F238E27FC236}">
-                <a16:creationId xmlns:a16="http://schemas.microsoft.com/office/drawing/2014/main" id="{1B5B40A3-42ED-D7FD-CD41-D3E850056927}"/>
-              </a:ext>
-            </a:extLst>
-          </p:cNvPr>
-          <p:cNvGrpSpPr/>
+            <a:endParaRPr/>
+          </a:p>
+        </p:txBody>
+      </p:sp>
+      <p:sp>
+        <p:nvSpPr>
+          <p:cNvPr id="48" name="TextBox 47">
+            <a:extLst xmlns:a="http://schemas.openxmlformats.org/drawingml/2006/main">
+              <a:ext uri="{FF2B5EF4-FFF2-40B4-BE49-F238E27FC236}">
+                <a16:creationId xmlns:a16="http://schemas.microsoft.com/office/drawing/2014/main" id="{51F35555-7DB3-0E9F-0CC1-8DCCA40D364A}"/>
+              </a:ext>
+            </a:extLst>
+          </p:cNvPr>
+          <p:cNvSpPr>
+            <a:spLocks xmlns:a="http://schemas.openxmlformats.org/drawingml/2006/main" noGrp="1"/>
+          </p:cNvSpPr>
           <p:nvPr/>
-        </p:nvGrpSpPr>
-        <p:grpSpPr>
-          <a:xfrm>
-            <a:off x="331574" y="1589379"/>
-            <a:ext cx="6761205" cy="3896732"/>
-            <a:chOff x="838200" y="1097281"/>
-            <a:chExt cx="10136302" cy="6086348"/>
-          </a:xfrm>
-        </p:grpSpPr>
-        <p:pic>
-          <p:nvPicPr>
-            <p:cNvPr id="2" name="object 3">
-              <a:extLst>
-                <a:ext uri="{FF2B5EF4-FFF2-40B4-BE49-F238E27FC236}">
-                  <a16:creationId xmlns:a16="http://schemas.microsoft.com/office/drawing/2014/main" id="{142A3B20-70B3-1E06-BF84-CC4A6EFF3338}"/>
-                </a:ext>
-              </a:extLst>
-            </p:cNvPr>
-            <p:cNvPicPr/>
-            <p:nvPr/>
-          </p:nvPicPr>
-          <p:blipFill>
-            <a:blip r:embed="rId3" cstate="print"/>
-            <a:stretch>
-              <a:fillRect/>
-            </a:stretch>
-          </p:blipFill>
-          <p:spPr>
-            <a:xfrm>
-              <a:off x="9175601" y="1097281"/>
-              <a:ext cx="1094207" cy="1094207"/>
-            </a:xfrm>
-            <a:prstGeom prst="rect">
-              <a:avLst/>
-            </a:prstGeom>
-          </p:spPr>
-        </p:pic>
-        <p:pic>
-          <p:nvPicPr>
-            <p:cNvPr id="3" name="object 4">
-              <a:extLst>
-                <a:ext uri="{FF2B5EF4-FFF2-40B4-BE49-F238E27FC236}">
-                  <a16:creationId xmlns:a16="http://schemas.microsoft.com/office/drawing/2014/main" id="{A43C5B78-A690-FD29-E1D9-CF937AFDC2FD}"/>
-                </a:ext>
-              </a:extLst>
-            </p:cNvPr>
-            <p:cNvPicPr/>
-            <p:nvPr/>
-          </p:nvPicPr>
-          <p:blipFill>
-            <a:blip r:embed="rId4" cstate="print"/>
-            <a:stretch>
-              <a:fillRect/>
-            </a:stretch>
-          </p:blipFill>
-          <p:spPr>
-            <a:xfrm>
-              <a:off x="838200" y="5263070"/>
-              <a:ext cx="1011177" cy="1920559"/>
-            </a:xfrm>
-            <a:prstGeom prst="rect">
-              <a:avLst/>
-            </a:prstGeom>
-          </p:spPr>
-        </p:pic>
-        <p:pic>
-          <p:nvPicPr>
-            <p:cNvPr id="4" name="object 5">
-              <a:extLst>
-                <a:ext uri="{FF2B5EF4-FFF2-40B4-BE49-F238E27FC236}">
-                  <a16:creationId xmlns:a16="http://schemas.microsoft.com/office/drawing/2014/main" id="{988263FD-6D57-7E2C-6E25-F9F04101C121}"/>
-                </a:ext>
-              </a:extLst>
-            </p:cNvPr>
-            <p:cNvPicPr/>
-            <p:nvPr/>
-          </p:nvPicPr>
-          <p:blipFill>
-            <a:blip r:embed="rId3" cstate="print"/>
-            <a:stretch>
-              <a:fillRect/>
-            </a:stretch>
-          </p:blipFill>
-          <p:spPr>
-            <a:xfrm>
-              <a:off x="3772917" y="1097281"/>
-              <a:ext cx="1094207" cy="1094207"/>
-            </a:xfrm>
-            <a:prstGeom prst="rect">
-              <a:avLst/>
-            </a:prstGeom>
-          </p:spPr>
-        </p:pic>
-        <p:pic>
-          <p:nvPicPr>
-            <p:cNvPr id="5" name="object 6">
-              <a:extLst>
-                <a:ext uri="{FF2B5EF4-FFF2-40B4-BE49-F238E27FC236}">
-                  <a16:creationId xmlns:a16="http://schemas.microsoft.com/office/drawing/2014/main" id="{4B80EA4D-0E16-09E4-6100-7886C10ECDBC}"/>
-                </a:ext>
-              </a:extLst>
-            </p:cNvPr>
-            <p:cNvPicPr/>
-            <p:nvPr/>
-          </p:nvPicPr>
-          <p:blipFill>
-            <a:blip r:embed="rId3" cstate="print"/>
-            <a:stretch>
-              <a:fillRect/>
-            </a:stretch>
-          </p:blipFill>
-          <p:spPr>
-            <a:xfrm>
-              <a:off x="6474280" y="1097281"/>
-              <a:ext cx="1094207" cy="1094207"/>
-            </a:xfrm>
-            <a:prstGeom prst="rect">
-              <a:avLst/>
-            </a:prstGeom>
-          </p:spPr>
-        </p:pic>
-        <p:pic>
-          <p:nvPicPr>
-            <p:cNvPr id="6" name="object 7">
-              <a:extLst>
-                <a:ext uri="{FF2B5EF4-FFF2-40B4-BE49-F238E27FC236}">
-                  <a16:creationId xmlns:a16="http://schemas.microsoft.com/office/drawing/2014/main" id="{3BF40DD3-A61E-7FB7-A78A-48BF2D45AE28}"/>
-                </a:ext>
-              </a:extLst>
-            </p:cNvPr>
-            <p:cNvPicPr/>
-            <p:nvPr/>
-          </p:nvPicPr>
-          <p:blipFill>
-            <a:blip r:embed="rId3" cstate="print"/>
-            <a:stretch>
-              <a:fillRect/>
-            </a:stretch>
-          </p:blipFill>
-          <p:spPr>
-            <a:xfrm>
-              <a:off x="1239999" y="1097281"/>
-              <a:ext cx="1094207" cy="1094207"/>
-            </a:xfrm>
-            <a:prstGeom prst="rect">
-              <a:avLst/>
-            </a:prstGeom>
-          </p:spPr>
-        </p:pic>
-        <p:pic>
-          <p:nvPicPr>
-            <p:cNvPr id="9" name="object 8">
-              <a:extLst>
-                <a:ext uri="{FF2B5EF4-FFF2-40B4-BE49-F238E27FC236}">
-                  <a16:creationId xmlns:a16="http://schemas.microsoft.com/office/drawing/2014/main" id="{A8C8909B-0E1D-4340-C78B-70444DFEB365}"/>
-                </a:ext>
-              </a:extLst>
-            </p:cNvPr>
-            <p:cNvPicPr/>
-            <p:nvPr/>
-          </p:nvPicPr>
-          <p:blipFill>
-            <a:blip r:embed="rId4" cstate="print"/>
-            <a:stretch>
-              <a:fillRect/>
-            </a:stretch>
-          </p:blipFill>
-          <p:spPr>
-            <a:xfrm>
-              <a:off x="2141794" y="5263070"/>
-              <a:ext cx="1011177" cy="1920559"/>
-            </a:xfrm>
-            <a:prstGeom prst="rect">
-              <a:avLst/>
-            </a:prstGeom>
-          </p:spPr>
-        </p:pic>
-        <p:pic>
-          <p:nvPicPr>
-            <p:cNvPr id="10" name="object 9">
-              <a:extLst>
-                <a:ext uri="{FF2B5EF4-FFF2-40B4-BE49-F238E27FC236}">
-                  <a16:creationId xmlns:a16="http://schemas.microsoft.com/office/drawing/2014/main" id="{0C15F954-7353-9107-9F6F-197173DC5DF6}"/>
-                </a:ext>
-              </a:extLst>
-            </p:cNvPr>
-            <p:cNvPicPr/>
-            <p:nvPr/>
-          </p:nvPicPr>
-          <p:blipFill>
-            <a:blip r:embed="rId4" cstate="print"/>
-            <a:stretch>
-              <a:fillRect/>
-            </a:stretch>
-          </p:blipFill>
-          <p:spPr>
-            <a:xfrm>
-              <a:off x="3445377" y="5263070"/>
-              <a:ext cx="1011177" cy="1920559"/>
-            </a:xfrm>
-            <a:prstGeom prst="rect">
-              <a:avLst/>
-            </a:prstGeom>
-          </p:spPr>
-        </p:pic>
-        <p:pic>
-          <p:nvPicPr>
-            <p:cNvPr id="11" name="object 10">
-              <a:extLst>
-                <a:ext uri="{FF2B5EF4-FFF2-40B4-BE49-F238E27FC236}">
-                  <a16:creationId xmlns:a16="http://schemas.microsoft.com/office/drawing/2014/main" id="{E284F254-DCE1-F957-AE7D-035ACCA2693D}"/>
-                </a:ext>
-              </a:extLst>
-            </p:cNvPr>
-            <p:cNvPicPr/>
-            <p:nvPr/>
-          </p:nvPicPr>
-          <p:blipFill>
-            <a:blip r:embed="rId4" cstate="print"/>
-            <a:stretch>
-              <a:fillRect/>
-            </a:stretch>
-          </p:blipFill>
-          <p:spPr>
-            <a:xfrm>
-              <a:off x="4748960" y="5263070"/>
-              <a:ext cx="1011177" cy="1920559"/>
-            </a:xfrm>
-            <a:prstGeom prst="rect">
-              <a:avLst/>
-            </a:prstGeom>
-          </p:spPr>
-        </p:pic>
-        <p:pic>
-          <p:nvPicPr>
-            <p:cNvPr id="12" name="object 11">
-              <a:extLst>
-                <a:ext uri="{FF2B5EF4-FFF2-40B4-BE49-F238E27FC236}">
-                  <a16:creationId xmlns:a16="http://schemas.microsoft.com/office/drawing/2014/main" id="{916F235B-72F2-0D11-4184-B4BE532F30C1}"/>
-                </a:ext>
-              </a:extLst>
-            </p:cNvPr>
-            <p:cNvPicPr/>
-            <p:nvPr/>
-          </p:nvPicPr>
-          <p:blipFill>
-            <a:blip r:embed="rId4" cstate="print"/>
-            <a:stretch>
-              <a:fillRect/>
-            </a:stretch>
-          </p:blipFill>
-          <p:spPr>
-            <a:xfrm>
-              <a:off x="6052544" y="5263070"/>
-              <a:ext cx="1011177" cy="1920559"/>
-            </a:xfrm>
-            <a:prstGeom prst="rect">
-              <a:avLst/>
-            </a:prstGeom>
-          </p:spPr>
-        </p:pic>
-        <p:pic>
-          <p:nvPicPr>
-            <p:cNvPr id="13" name="object 12">
-              <a:extLst>
-                <a:ext uri="{FF2B5EF4-FFF2-40B4-BE49-F238E27FC236}">
-                  <a16:creationId xmlns:a16="http://schemas.microsoft.com/office/drawing/2014/main" id="{FA4C07D9-F95A-74C1-F922-EC4A4F0806B6}"/>
-                </a:ext>
-              </a:extLst>
-            </p:cNvPr>
-            <p:cNvPicPr/>
-            <p:nvPr/>
-          </p:nvPicPr>
-          <p:blipFill>
-            <a:blip r:embed="rId4" cstate="print"/>
-            <a:stretch>
-              <a:fillRect/>
-            </a:stretch>
-          </p:blipFill>
-          <p:spPr>
-            <a:xfrm>
-              <a:off x="7356138" y="5263070"/>
-              <a:ext cx="1011177" cy="1920559"/>
-            </a:xfrm>
-            <a:prstGeom prst="rect">
-              <a:avLst/>
-            </a:prstGeom>
-          </p:spPr>
-        </p:pic>
-        <p:pic>
-          <p:nvPicPr>
-            <p:cNvPr id="14" name="object 13">
-              <a:extLst>
-                <a:ext uri="{FF2B5EF4-FFF2-40B4-BE49-F238E27FC236}">
-                  <a16:creationId xmlns:a16="http://schemas.microsoft.com/office/drawing/2014/main" id="{6C144F63-4F0C-DD47-9329-4A3D7C0A95C4}"/>
-                </a:ext>
-              </a:extLst>
-            </p:cNvPr>
-            <p:cNvPicPr/>
-            <p:nvPr/>
-          </p:nvPicPr>
-          <p:blipFill>
-            <a:blip r:embed="rId4" cstate="print"/>
-            <a:stretch>
-              <a:fillRect/>
-            </a:stretch>
-          </p:blipFill>
-          <p:spPr>
-            <a:xfrm>
-              <a:off x="8659721" y="5263070"/>
-              <a:ext cx="1011177" cy="1920559"/>
-            </a:xfrm>
-            <a:prstGeom prst="rect">
-              <a:avLst/>
-            </a:prstGeom>
-          </p:spPr>
-        </p:pic>
-        <p:pic>
-          <p:nvPicPr>
-            <p:cNvPr id="15" name="object 14">
-              <a:extLst>
-                <a:ext uri="{FF2B5EF4-FFF2-40B4-BE49-F238E27FC236}">
-                  <a16:creationId xmlns:a16="http://schemas.microsoft.com/office/drawing/2014/main" id="{570B2A07-5EF0-D692-D983-34F16576A58D}"/>
-                </a:ext>
-              </a:extLst>
-            </p:cNvPr>
-            <p:cNvPicPr/>
-            <p:nvPr/>
-          </p:nvPicPr>
-          <p:blipFill>
-            <a:blip r:embed="rId4" cstate="print"/>
-            <a:stretch>
-              <a:fillRect/>
-            </a:stretch>
-          </p:blipFill>
-          <p:spPr>
-            <a:xfrm>
-              <a:off x="9963325" y="5263070"/>
-              <a:ext cx="1011177" cy="1920559"/>
-            </a:xfrm>
-            <a:prstGeom prst="rect">
-              <a:avLst/>
-            </a:prstGeom>
-          </p:spPr>
-        </p:pic>
-        <p:grpSp>
-          <p:nvGrpSpPr>
-            <p:cNvPr id="16" name="object 15">
-              <a:extLst>
-                <a:ext uri="{FF2B5EF4-FFF2-40B4-BE49-F238E27FC236}">
-                  <a16:creationId xmlns:a16="http://schemas.microsoft.com/office/drawing/2014/main" id="{407F9748-BEE0-E2B9-4986-74FD8E36EFE4}"/>
-                </a:ext>
-              </a:extLst>
-            </p:cNvPr>
-            <p:cNvGrpSpPr/>
-            <p:nvPr/>
-          </p:nvGrpSpPr>
-          <p:grpSpPr>
-            <a:xfrm>
-              <a:off x="1295767" y="2581707"/>
-              <a:ext cx="551180" cy="2283460"/>
-              <a:chOff x="2729581" y="5036569"/>
-              <a:chExt cx="551180" cy="2283460"/>
-            </a:xfrm>
-          </p:grpSpPr>
-          <p:sp>
-            <p:nvSpPr>
-              <p:cNvPr id="17" name="object 16">
-                <a:extLst>
-                  <a:ext uri="{FF2B5EF4-FFF2-40B4-BE49-F238E27FC236}">
-                    <a16:creationId xmlns:a16="http://schemas.microsoft.com/office/drawing/2014/main" id="{3A487CDD-75B6-283D-4D7E-FC532C2BE8A0}"/>
-                  </a:ext>
-                </a:extLst>
-              </p:cNvPr>
-              <p:cNvSpPr/>
-              <p:nvPr/>
-            </p:nvSpPr>
-            <p:spPr>
-              <a:xfrm>
-                <a:off x="2776296" y="5047040"/>
-                <a:ext cx="494030" cy="2185035"/>
-              </a:xfrm>
-              <a:custGeom>
-                <a:avLst/>
-                <a:gdLst/>
-                <a:ahLst/>
-                <a:cxnLst/>
-                <a:rect l="l" t="t" r="r" b="b"/>
-                <a:pathLst>
-                  <a:path w="494029" h="2185034">
-                    <a:moveTo>
-                      <a:pt x="493540" y="0"/>
-                    </a:moveTo>
-                    <a:lnTo>
-                      <a:pt x="2307" y="2174444"/>
-                    </a:lnTo>
-                    <a:lnTo>
-                      <a:pt x="0" y="2184657"/>
-                    </a:lnTo>
-                  </a:path>
-                </a:pathLst>
-              </a:custGeom>
-              <a:ln w="20941">
-                <a:solidFill>
-                  <a:srgbClr val="222C4A"/>
-                </a:solidFill>
-              </a:ln>
-            </p:spPr>
-            <p:txBody>
-              <a:bodyPr wrap="square" lIns="0" tIns="0" rIns="0" bIns="0" rtlCol="0"/>
-              <a:lstStyle/>
-              <a:p>
-                <a:endParaRPr/>
-              </a:p>
-            </p:txBody>
-          </p:sp>
-          <p:sp>
-            <p:nvSpPr>
-              <p:cNvPr id="18" name="object 17">
-                <a:extLst>
-                  <a:ext uri="{FF2B5EF4-FFF2-40B4-BE49-F238E27FC236}">
-                    <a16:creationId xmlns:a16="http://schemas.microsoft.com/office/drawing/2014/main" id="{09CC7B15-56C1-9430-708E-7CBE073CB618}"/>
-                  </a:ext>
-                </a:extLst>
-              </p:cNvPr>
-              <p:cNvSpPr/>
-              <p:nvPr/>
-            </p:nvSpPr>
-            <p:spPr>
-              <a:xfrm>
-                <a:off x="2729581" y="7210419"/>
-                <a:ext cx="98425" cy="109220"/>
-              </a:xfrm>
-              <a:custGeom>
-                <a:avLst/>
-                <a:gdLst/>
-                <a:ahLst/>
-                <a:cxnLst/>
-                <a:rect l="l" t="t" r="r" b="b"/>
-                <a:pathLst>
-                  <a:path w="98425" h="109220">
-                    <a:moveTo>
-                      <a:pt x="0" y="0"/>
-                    </a:moveTo>
-                    <a:lnTo>
-                      <a:pt x="26868" y="109117"/>
-                    </a:lnTo>
-                    <a:lnTo>
-                      <a:pt x="98049" y="22145"/>
-                    </a:lnTo>
-                    <a:lnTo>
-                      <a:pt x="0" y="0"/>
-                    </a:lnTo>
-                    <a:close/>
-                  </a:path>
-                </a:pathLst>
-              </a:custGeom>
-              <a:solidFill>
-                <a:srgbClr val="222C4A"/>
-              </a:solidFill>
-            </p:spPr>
-            <p:txBody>
-              <a:bodyPr wrap="square" lIns="0" tIns="0" rIns="0" bIns="0" rtlCol="0"/>
-              <a:lstStyle/>
-              <a:p>
-                <a:endParaRPr/>
-              </a:p>
-            </p:txBody>
-          </p:sp>
-        </p:grpSp>
-        <p:grpSp>
-          <p:nvGrpSpPr>
-            <p:cNvPr id="19" name="object 18">
-              <a:extLst>
-                <a:ext uri="{FF2B5EF4-FFF2-40B4-BE49-F238E27FC236}">
-                  <a16:creationId xmlns:a16="http://schemas.microsoft.com/office/drawing/2014/main" id="{982CE0AE-1548-C8A5-FBCA-EE20BDF6A3F7}"/>
-                </a:ext>
-              </a:extLst>
-            </p:cNvPr>
-            <p:cNvGrpSpPr/>
-            <p:nvPr/>
-          </p:nvGrpSpPr>
-          <p:grpSpPr>
-            <a:xfrm>
-              <a:off x="2034970" y="2263905"/>
-              <a:ext cx="8624570" cy="2872740"/>
-              <a:chOff x="3468784" y="4718767"/>
-              <a:chExt cx="8624570" cy="2872740"/>
-            </a:xfrm>
-          </p:grpSpPr>
-          <p:sp>
-            <p:nvSpPr>
-              <p:cNvPr id="20" name="object 19">
-                <a:extLst>
-                  <a:ext uri="{FF2B5EF4-FFF2-40B4-BE49-F238E27FC236}">
-                    <a16:creationId xmlns:a16="http://schemas.microsoft.com/office/drawing/2014/main" id="{4BB2EDFC-6C22-7FFF-7345-BB7BD06A1231}"/>
-                  </a:ext>
-                </a:extLst>
-              </p:cNvPr>
-              <p:cNvSpPr/>
-              <p:nvPr/>
-            </p:nvSpPr>
-            <p:spPr>
-              <a:xfrm>
-                <a:off x="3597576" y="4904698"/>
-                <a:ext cx="2782570" cy="2502535"/>
-              </a:xfrm>
-              <a:custGeom>
-                <a:avLst/>
-                <a:gdLst/>
-                <a:ahLst/>
-                <a:cxnLst/>
-                <a:rect l="l" t="t" r="r" b="b"/>
-                <a:pathLst>
-                  <a:path w="2782570" h="2502534">
-                    <a:moveTo>
-                      <a:pt x="0" y="0"/>
-                    </a:moveTo>
-                    <a:lnTo>
-                      <a:pt x="2774486" y="2495492"/>
-                    </a:lnTo>
-                    <a:lnTo>
-                      <a:pt x="2782271" y="2502494"/>
-                    </a:lnTo>
-                  </a:path>
-                </a:pathLst>
-              </a:custGeom>
-              <a:ln w="20941">
-                <a:solidFill>
-                  <a:srgbClr val="222C4A"/>
-                </a:solidFill>
-              </a:ln>
-            </p:spPr>
-            <p:txBody>
-              <a:bodyPr wrap="square" lIns="0" tIns="0" rIns="0" bIns="0" rtlCol="0"/>
-              <a:lstStyle/>
-              <a:p>
-                <a:endParaRPr/>
-              </a:p>
-            </p:txBody>
-          </p:sp>
-          <p:sp>
-            <p:nvSpPr>
-              <p:cNvPr id="21" name="object 20">
-                <a:extLst>
-                  <a:ext uri="{FF2B5EF4-FFF2-40B4-BE49-F238E27FC236}">
-                    <a16:creationId xmlns:a16="http://schemas.microsoft.com/office/drawing/2014/main" id="{FF5BBBEA-1890-6199-DB62-8F14CFA53BE1}"/>
-                  </a:ext>
-                </a:extLst>
-              </p:cNvPr>
-              <p:cNvSpPr/>
-              <p:nvPr/>
-            </p:nvSpPr>
-            <p:spPr>
-              <a:xfrm>
-                <a:off x="6338445" y="7362833"/>
-                <a:ext cx="108585" cy="104775"/>
-              </a:xfrm>
-              <a:custGeom>
-                <a:avLst/>
-                <a:gdLst/>
-                <a:ahLst/>
-                <a:cxnLst/>
-                <a:rect l="l" t="t" r="r" b="b"/>
-                <a:pathLst>
-                  <a:path w="108585" h="104775">
-                    <a:moveTo>
-                      <a:pt x="67223" y="0"/>
-                    </a:moveTo>
-                    <a:lnTo>
-                      <a:pt x="0" y="74730"/>
-                    </a:lnTo>
-                    <a:lnTo>
-                      <a:pt x="108352" y="104583"/>
-                    </a:lnTo>
-                    <a:lnTo>
-                      <a:pt x="67223" y="0"/>
-                    </a:lnTo>
-                    <a:close/>
-                  </a:path>
-                </a:pathLst>
-              </a:custGeom>
-              <a:solidFill>
-                <a:srgbClr val="222C4A"/>
-              </a:solidFill>
-            </p:spPr>
-            <p:txBody>
-              <a:bodyPr wrap="square" lIns="0" tIns="0" rIns="0" bIns="0" rtlCol="0"/>
-              <a:lstStyle/>
-              <a:p>
-                <a:endParaRPr/>
-              </a:p>
-            </p:txBody>
-          </p:sp>
-          <p:sp>
-            <p:nvSpPr>
-              <p:cNvPr id="22" name="object 21">
-                <a:extLst>
-                  <a:ext uri="{FF2B5EF4-FFF2-40B4-BE49-F238E27FC236}">
-                    <a16:creationId xmlns:a16="http://schemas.microsoft.com/office/drawing/2014/main" id="{5962EC71-5C93-76DF-2F38-DC1621878E9D}"/>
-                  </a:ext>
-                </a:extLst>
-              </p:cNvPr>
-              <p:cNvSpPr/>
-              <p:nvPr/>
-            </p:nvSpPr>
-            <p:spPr>
-              <a:xfrm>
-                <a:off x="8601790" y="4904583"/>
-                <a:ext cx="3162300" cy="2463165"/>
-              </a:xfrm>
-              <a:custGeom>
-                <a:avLst/>
-                <a:gdLst/>
-                <a:ahLst/>
-                <a:cxnLst/>
-                <a:rect l="l" t="t" r="r" b="b"/>
-                <a:pathLst>
-                  <a:path w="3162300" h="2463165">
-                    <a:moveTo>
-                      <a:pt x="0" y="0"/>
-                    </a:moveTo>
-                    <a:lnTo>
-                      <a:pt x="3153677" y="2456279"/>
-                    </a:lnTo>
-                    <a:lnTo>
-                      <a:pt x="3161938" y="2462713"/>
-                    </a:lnTo>
-                  </a:path>
-                </a:pathLst>
-              </a:custGeom>
-              <a:ln w="20941">
-                <a:solidFill>
-                  <a:srgbClr val="222C4A"/>
-                </a:solidFill>
-              </a:ln>
-            </p:spPr>
-            <p:txBody>
-              <a:bodyPr wrap="square" lIns="0" tIns="0" rIns="0" bIns="0" rtlCol="0"/>
-              <a:lstStyle/>
-              <a:p>
-                <a:endParaRPr/>
-              </a:p>
-            </p:txBody>
-          </p:sp>
-          <p:sp>
-            <p:nvSpPr>
-              <p:cNvPr id="23" name="object 22">
-                <a:extLst>
-                  <a:ext uri="{FF2B5EF4-FFF2-40B4-BE49-F238E27FC236}">
-                    <a16:creationId xmlns:a16="http://schemas.microsoft.com/office/drawing/2014/main" id="{2815727C-608A-0549-638D-10099A59125C}"/>
-                  </a:ext>
-                </a:extLst>
-              </p:cNvPr>
-              <p:cNvSpPr/>
-              <p:nvPr/>
-            </p:nvSpPr>
-            <p:spPr>
-              <a:xfrm>
-                <a:off x="11724564" y="7321211"/>
-                <a:ext cx="110489" cy="101600"/>
-              </a:xfrm>
-              <a:custGeom>
-                <a:avLst/>
-                <a:gdLst/>
-                <a:ahLst/>
-                <a:cxnLst/>
-                <a:rect l="l" t="t" r="r" b="b"/>
-                <a:pathLst>
-                  <a:path w="110490" h="101600">
-                    <a:moveTo>
-                      <a:pt x="61778" y="0"/>
-                    </a:moveTo>
-                    <a:lnTo>
-                      <a:pt x="0" y="79306"/>
-                    </a:lnTo>
-                    <a:lnTo>
-                      <a:pt x="110258" y="101420"/>
-                    </a:lnTo>
-                    <a:lnTo>
-                      <a:pt x="61778" y="0"/>
-                    </a:lnTo>
-                    <a:close/>
-                  </a:path>
-                </a:pathLst>
-              </a:custGeom>
-              <a:solidFill>
-                <a:srgbClr val="222C4A"/>
-              </a:solidFill>
-            </p:spPr>
-            <p:txBody>
-              <a:bodyPr wrap="square" lIns="0" tIns="0" rIns="0" bIns="0" rtlCol="0"/>
-              <a:lstStyle/>
-              <a:p>
-                <a:endParaRPr/>
-              </a:p>
-            </p:txBody>
-          </p:sp>
-          <p:sp>
-            <p:nvSpPr>
-              <p:cNvPr id="24" name="object 23">
-                <a:extLst>
-                  <a:ext uri="{FF2B5EF4-FFF2-40B4-BE49-F238E27FC236}">
-                    <a16:creationId xmlns:a16="http://schemas.microsoft.com/office/drawing/2014/main" id="{C855B784-A6EA-76E4-D9DD-D160CC1A8424}"/>
-                  </a:ext>
-                </a:extLst>
-              </p:cNvPr>
-              <p:cNvSpPr/>
-              <p:nvPr/>
-            </p:nvSpPr>
-            <p:spPr>
-              <a:xfrm>
-                <a:off x="3479255" y="5256457"/>
-                <a:ext cx="1777364" cy="2236470"/>
-              </a:xfrm>
-              <a:custGeom>
-                <a:avLst/>
-                <a:gdLst/>
-                <a:ahLst/>
-                <a:cxnLst/>
-                <a:rect l="l" t="t" r="r" b="b"/>
-                <a:pathLst>
-                  <a:path w="1777364" h="2236470">
-                    <a:moveTo>
-                      <a:pt x="0" y="0"/>
-                    </a:moveTo>
-                    <a:lnTo>
-                      <a:pt x="1770745" y="2227906"/>
-                    </a:lnTo>
-                    <a:lnTo>
-                      <a:pt x="1777260" y="2236103"/>
-                    </a:lnTo>
-                  </a:path>
-                </a:pathLst>
-              </a:custGeom>
-              <a:ln w="20941">
-                <a:solidFill>
-                  <a:srgbClr val="222C4A"/>
-                </a:solidFill>
-              </a:ln>
-            </p:spPr>
-            <p:txBody>
-              <a:bodyPr wrap="square" lIns="0" tIns="0" rIns="0" bIns="0" rtlCol="0"/>
-              <a:lstStyle/>
-              <a:p>
-                <a:endParaRPr/>
-              </a:p>
-            </p:txBody>
-          </p:sp>
-          <p:sp>
-            <p:nvSpPr>
-              <p:cNvPr id="25" name="object 24">
-                <a:extLst>
-                  <a:ext uri="{FF2B5EF4-FFF2-40B4-BE49-F238E27FC236}">
-                    <a16:creationId xmlns:a16="http://schemas.microsoft.com/office/drawing/2014/main" id="{C797F35C-90CA-AA91-9C89-B32C150C3835}"/>
-                  </a:ext>
-                </a:extLst>
-              </p:cNvPr>
-              <p:cNvSpPr/>
-              <p:nvPr/>
-            </p:nvSpPr>
-            <p:spPr>
-              <a:xfrm>
-                <a:off x="5210658" y="7453092"/>
-                <a:ext cx="102235" cy="110489"/>
-              </a:xfrm>
-              <a:custGeom>
-                <a:avLst/>
-                <a:gdLst/>
-                <a:ahLst/>
-                <a:cxnLst/>
-                <a:rect l="l" t="t" r="r" b="b"/>
-                <a:pathLst>
-                  <a:path w="102235" h="110490">
-                    <a:moveTo>
-                      <a:pt x="78688" y="0"/>
-                    </a:moveTo>
-                    <a:lnTo>
-                      <a:pt x="0" y="62542"/>
-                    </a:lnTo>
-                    <a:lnTo>
-                      <a:pt x="101892" y="109965"/>
-                    </a:lnTo>
-                    <a:lnTo>
-                      <a:pt x="78688" y="0"/>
-                    </a:lnTo>
-                    <a:close/>
-                  </a:path>
-                </a:pathLst>
-              </a:custGeom>
-              <a:solidFill>
-                <a:srgbClr val="222C4A"/>
-              </a:solidFill>
-            </p:spPr>
-            <p:txBody>
-              <a:bodyPr wrap="square" lIns="0" tIns="0" rIns="0" bIns="0" rtlCol="0"/>
-              <a:lstStyle/>
-              <a:p>
-                <a:endParaRPr/>
-              </a:p>
-            </p:txBody>
-          </p:sp>
-          <p:sp>
-            <p:nvSpPr>
-              <p:cNvPr id="26" name="object 25">
-                <a:extLst>
-                  <a:ext uri="{FF2B5EF4-FFF2-40B4-BE49-F238E27FC236}">
-                    <a16:creationId xmlns:a16="http://schemas.microsoft.com/office/drawing/2014/main" id="{4B257583-0E05-7F18-6DF3-095E8F2AD887}"/>
-                  </a:ext>
-                </a:extLst>
-              </p:cNvPr>
-              <p:cNvSpPr/>
-              <p:nvPr/>
-            </p:nvSpPr>
-            <p:spPr>
-              <a:xfrm>
-                <a:off x="5225790" y="5132335"/>
-                <a:ext cx="355600" cy="2012950"/>
-              </a:xfrm>
-              <a:custGeom>
-                <a:avLst/>
-                <a:gdLst/>
-                <a:ahLst/>
-                <a:cxnLst/>
-                <a:rect l="l" t="t" r="r" b="b"/>
-                <a:pathLst>
-                  <a:path w="355600" h="2012950">
-                    <a:moveTo>
-                      <a:pt x="355264" y="0"/>
-                    </a:moveTo>
-                    <a:lnTo>
-                      <a:pt x="1820" y="2002439"/>
-                    </a:lnTo>
-                    <a:lnTo>
-                      <a:pt x="0" y="2012750"/>
-                    </a:lnTo>
-                  </a:path>
-                </a:pathLst>
-              </a:custGeom>
-              <a:ln w="20941">
-                <a:solidFill>
-                  <a:srgbClr val="222C4A"/>
-                </a:solidFill>
-              </a:ln>
-            </p:spPr>
-            <p:txBody>
-              <a:bodyPr wrap="square" lIns="0" tIns="0" rIns="0" bIns="0" rtlCol="0"/>
-              <a:lstStyle/>
-              <a:p>
-                <a:endParaRPr/>
-              </a:p>
-            </p:txBody>
-          </p:sp>
-          <p:sp>
-            <p:nvSpPr>
-              <p:cNvPr id="27" name="object 26">
-                <a:extLst>
-                  <a:ext uri="{FF2B5EF4-FFF2-40B4-BE49-F238E27FC236}">
-                    <a16:creationId xmlns:a16="http://schemas.microsoft.com/office/drawing/2014/main" id="{0E5617FF-8F24-A389-CFD9-0FF600A56ABA}"/>
-                  </a:ext>
-                </a:extLst>
-              </p:cNvPr>
-              <p:cNvSpPr/>
-              <p:nvPr/>
-            </p:nvSpPr>
-            <p:spPr>
-              <a:xfrm>
-                <a:off x="5178114" y="7126034"/>
-                <a:ext cx="99060" cy="107950"/>
-              </a:xfrm>
-              <a:custGeom>
-                <a:avLst/>
-                <a:gdLst/>
-                <a:ahLst/>
-                <a:cxnLst/>
-                <a:rect l="l" t="t" r="r" b="b"/>
-                <a:pathLst>
-                  <a:path w="99060" h="107950">
-                    <a:moveTo>
-                      <a:pt x="0" y="0"/>
-                    </a:moveTo>
-                    <a:lnTo>
-                      <a:pt x="32019" y="107724"/>
-                    </a:lnTo>
-                    <a:lnTo>
-                      <a:pt x="98991" y="17475"/>
-                    </a:lnTo>
-                    <a:lnTo>
-                      <a:pt x="0" y="0"/>
-                    </a:lnTo>
-                    <a:close/>
-                  </a:path>
-                </a:pathLst>
-              </a:custGeom>
-              <a:solidFill>
-                <a:srgbClr val="222C4A"/>
-              </a:solidFill>
-            </p:spPr>
-            <p:txBody>
-              <a:bodyPr wrap="square" lIns="0" tIns="0" rIns="0" bIns="0" rtlCol="0"/>
-              <a:lstStyle/>
-              <a:p>
-                <a:endParaRPr/>
-              </a:p>
-            </p:txBody>
-          </p:sp>
-          <p:sp>
-            <p:nvSpPr>
-              <p:cNvPr id="28" name="object 27">
-                <a:extLst>
-                  <a:ext uri="{FF2B5EF4-FFF2-40B4-BE49-F238E27FC236}">
-                    <a16:creationId xmlns:a16="http://schemas.microsoft.com/office/drawing/2014/main" id="{9164E05E-445F-2AB1-8A40-9123E7CEED47}"/>
-                  </a:ext>
-                </a:extLst>
-              </p:cNvPr>
-              <p:cNvSpPr/>
-              <p:nvPr/>
-            </p:nvSpPr>
-            <p:spPr>
-              <a:xfrm>
-                <a:off x="11289394" y="4930562"/>
-                <a:ext cx="759460" cy="2221230"/>
-              </a:xfrm>
-              <a:custGeom>
-                <a:avLst/>
-                <a:gdLst/>
-                <a:ahLst/>
-                <a:cxnLst/>
-                <a:rect l="l" t="t" r="r" b="b"/>
-                <a:pathLst>
-                  <a:path w="759459" h="2221229">
-                    <a:moveTo>
-                      <a:pt x="0" y="0"/>
-                    </a:moveTo>
-                    <a:lnTo>
-                      <a:pt x="755898" y="2210753"/>
-                    </a:lnTo>
-                    <a:lnTo>
-                      <a:pt x="759286" y="2220661"/>
-                    </a:lnTo>
-                  </a:path>
-                </a:pathLst>
-              </a:custGeom>
-              <a:ln w="20941">
-                <a:solidFill>
-                  <a:srgbClr val="222C4A"/>
-                </a:solidFill>
-              </a:ln>
-            </p:spPr>
-            <p:txBody>
-              <a:bodyPr wrap="square" lIns="0" tIns="0" rIns="0" bIns="0" rtlCol="0"/>
-              <a:lstStyle/>
-              <a:p>
-                <a:endParaRPr/>
-              </a:p>
-            </p:txBody>
-          </p:sp>
-          <p:sp>
-            <p:nvSpPr>
-              <p:cNvPr id="29" name="object 28">
-                <a:extLst>
-                  <a:ext uri="{FF2B5EF4-FFF2-40B4-BE49-F238E27FC236}">
-                    <a16:creationId xmlns:a16="http://schemas.microsoft.com/office/drawing/2014/main" id="{7D9F10B6-ADE9-B413-0228-E8C9A51E4406}"/>
-                  </a:ext>
-                </a:extLst>
-              </p:cNvPr>
-              <p:cNvSpPr/>
-              <p:nvPr/>
-            </p:nvSpPr>
-            <p:spPr>
-              <a:xfrm>
-                <a:off x="11997749" y="7125060"/>
-                <a:ext cx="95250" cy="111760"/>
-              </a:xfrm>
-              <a:custGeom>
-                <a:avLst/>
-                <a:gdLst/>
-                <a:ahLst/>
-                <a:cxnLst/>
-                <a:rect l="l" t="t" r="r" b="b"/>
-                <a:pathLst>
-                  <a:path w="95250" h="111759">
-                    <a:moveTo>
-                      <a:pt x="95075" y="0"/>
-                    </a:moveTo>
-                    <a:lnTo>
-                      <a:pt x="0" y="32522"/>
-                    </a:lnTo>
-                    <a:lnTo>
-                      <a:pt x="79997" y="111378"/>
-                    </a:lnTo>
-                    <a:lnTo>
-                      <a:pt x="95075" y="0"/>
-                    </a:lnTo>
-                    <a:close/>
-                  </a:path>
-                </a:pathLst>
-              </a:custGeom>
-              <a:solidFill>
-                <a:srgbClr val="222C4A"/>
-              </a:solidFill>
-            </p:spPr>
-            <p:txBody>
-              <a:bodyPr wrap="square" lIns="0" tIns="0" rIns="0" bIns="0" rtlCol="0"/>
-              <a:lstStyle/>
-              <a:p>
-                <a:endParaRPr/>
-              </a:p>
-            </p:txBody>
-          </p:sp>
-          <p:sp>
-            <p:nvSpPr>
-              <p:cNvPr id="30" name="object 29">
-                <a:extLst>
-                  <a:ext uri="{FF2B5EF4-FFF2-40B4-BE49-F238E27FC236}">
-                    <a16:creationId xmlns:a16="http://schemas.microsoft.com/office/drawing/2014/main" id="{163B4B47-50D4-5C0C-70F4-EBE69D032EA4}"/>
-                  </a:ext>
-                </a:extLst>
-              </p:cNvPr>
-              <p:cNvSpPr/>
-              <p:nvPr/>
-            </p:nvSpPr>
-            <p:spPr>
-              <a:xfrm>
-                <a:off x="4394008" y="4969341"/>
-                <a:ext cx="4673600" cy="2477135"/>
-              </a:xfrm>
-              <a:custGeom>
-                <a:avLst/>
-                <a:gdLst/>
-                <a:ahLst/>
-                <a:cxnLst/>
-                <a:rect l="l" t="t" r="r" b="b"/>
-                <a:pathLst>
-                  <a:path w="4673600" h="2477134">
-                    <a:moveTo>
-                      <a:pt x="0" y="0"/>
-                    </a:moveTo>
-                    <a:lnTo>
-                      <a:pt x="9251" y="4903"/>
-                    </a:lnTo>
-                    <a:lnTo>
-                      <a:pt x="4673196" y="2476959"/>
-                    </a:lnTo>
-                  </a:path>
-                </a:pathLst>
-              </a:custGeom>
-              <a:ln w="20941">
-                <a:solidFill>
-                  <a:srgbClr val="222C4A"/>
-                </a:solidFill>
-              </a:ln>
-            </p:spPr>
-            <p:txBody>
-              <a:bodyPr wrap="square" lIns="0" tIns="0" rIns="0" bIns="0" rtlCol="0"/>
-              <a:lstStyle/>
-              <a:p>
-                <a:endParaRPr/>
-              </a:p>
-            </p:txBody>
-          </p:sp>
-          <p:sp>
-            <p:nvSpPr>
-              <p:cNvPr id="31" name="object 30">
-                <a:extLst>
-                  <a:ext uri="{FF2B5EF4-FFF2-40B4-BE49-F238E27FC236}">
-                    <a16:creationId xmlns:a16="http://schemas.microsoft.com/office/drawing/2014/main" id="{DF0D2854-E1C9-B36F-1406-D641A6A301C0}"/>
-                  </a:ext>
-                </a:extLst>
-              </p:cNvPr>
-              <p:cNvSpPr/>
-              <p:nvPr/>
-            </p:nvSpPr>
-            <p:spPr>
-              <a:xfrm>
-                <a:off x="4314444" y="4927169"/>
-                <a:ext cx="112395" cy="92075"/>
-              </a:xfrm>
-              <a:custGeom>
-                <a:avLst/>
-                <a:gdLst/>
-                <a:ahLst/>
-                <a:cxnLst/>
-                <a:rect l="l" t="t" r="r" b="b"/>
-                <a:pathLst>
-                  <a:path w="112395" h="92075">
-                    <a:moveTo>
-                      <a:pt x="0" y="0"/>
-                    </a:moveTo>
-                    <a:lnTo>
-                      <a:pt x="65275" y="91484"/>
-                    </a:lnTo>
-                    <a:lnTo>
-                      <a:pt x="112352" y="2670"/>
-                    </a:lnTo>
-                    <a:lnTo>
-                      <a:pt x="0" y="0"/>
-                    </a:lnTo>
-                    <a:close/>
-                  </a:path>
-                </a:pathLst>
-              </a:custGeom>
-              <a:solidFill>
-                <a:srgbClr val="222C4A"/>
-              </a:solidFill>
-            </p:spPr>
-            <p:txBody>
-              <a:bodyPr wrap="square" lIns="0" tIns="0" rIns="0" bIns="0" rtlCol="0"/>
-              <a:lstStyle/>
-              <a:p>
-                <a:endParaRPr/>
-              </a:p>
-            </p:txBody>
-          </p:sp>
-          <p:sp>
-            <p:nvSpPr>
-              <p:cNvPr id="32" name="object 31">
-                <a:extLst>
-                  <a:ext uri="{FF2B5EF4-FFF2-40B4-BE49-F238E27FC236}">
-                    <a16:creationId xmlns:a16="http://schemas.microsoft.com/office/drawing/2014/main" id="{F6E536FC-F39F-621F-B0B0-4142232ECD96}"/>
-                  </a:ext>
-                </a:extLst>
-              </p:cNvPr>
-              <p:cNvSpPr/>
-              <p:nvPr/>
-            </p:nvSpPr>
-            <p:spPr>
-              <a:xfrm>
-                <a:off x="6230951" y="5009365"/>
-                <a:ext cx="3922395" cy="2264410"/>
-              </a:xfrm>
-              <a:custGeom>
-                <a:avLst/>
-                <a:gdLst/>
-                <a:ahLst/>
-                <a:cxnLst/>
-                <a:rect l="l" t="t" r="r" b="b"/>
-                <a:pathLst>
-                  <a:path w="3922395" h="2264409">
-                    <a:moveTo>
-                      <a:pt x="0" y="0"/>
-                    </a:moveTo>
-                    <a:lnTo>
-                      <a:pt x="3912763" y="2258993"/>
-                    </a:lnTo>
-                    <a:lnTo>
-                      <a:pt x="3921831" y="2264229"/>
-                    </a:lnTo>
-                  </a:path>
-                </a:pathLst>
-              </a:custGeom>
-              <a:ln w="20941">
-                <a:solidFill>
-                  <a:srgbClr val="222C4A"/>
-                </a:solidFill>
-              </a:ln>
-            </p:spPr>
-            <p:txBody>
-              <a:bodyPr wrap="square" lIns="0" tIns="0" rIns="0" bIns="0" rtlCol="0"/>
-              <a:lstStyle/>
-              <a:p>
-                <a:endParaRPr/>
-              </a:p>
-            </p:txBody>
-          </p:sp>
-          <p:sp>
-            <p:nvSpPr>
-              <p:cNvPr id="33" name="object 32">
-                <a:extLst>
-                  <a:ext uri="{FF2B5EF4-FFF2-40B4-BE49-F238E27FC236}">
-                    <a16:creationId xmlns:a16="http://schemas.microsoft.com/office/drawing/2014/main" id="{7C17965E-EE18-01CB-909E-3DDD2DA6A86D}"/>
-                  </a:ext>
-                </a:extLst>
-              </p:cNvPr>
-              <p:cNvSpPr/>
-              <p:nvPr/>
-            </p:nvSpPr>
-            <p:spPr>
-              <a:xfrm>
-                <a:off x="10118592" y="7224827"/>
-                <a:ext cx="112395" cy="93980"/>
-              </a:xfrm>
-              <a:custGeom>
-                <a:avLst/>
-                <a:gdLst/>
-                <a:ahLst/>
-                <a:cxnLst/>
-                <a:rect l="l" t="t" r="r" b="b"/>
-                <a:pathLst>
-                  <a:path w="112395" h="93979">
-                    <a:moveTo>
-                      <a:pt x="50260" y="0"/>
-                    </a:moveTo>
-                    <a:lnTo>
-                      <a:pt x="0" y="87054"/>
-                    </a:lnTo>
-                    <a:lnTo>
-                      <a:pt x="112185" y="93787"/>
-                    </a:lnTo>
-                    <a:lnTo>
-                      <a:pt x="50260" y="0"/>
-                    </a:lnTo>
-                    <a:close/>
-                  </a:path>
-                </a:pathLst>
-              </a:custGeom>
-              <a:solidFill>
-                <a:srgbClr val="222C4A"/>
-              </a:solidFill>
-            </p:spPr>
-            <p:txBody>
-              <a:bodyPr wrap="square" lIns="0" tIns="0" rIns="0" bIns="0" rtlCol="0"/>
-              <a:lstStyle/>
-              <a:p>
-                <a:endParaRPr/>
-              </a:p>
-            </p:txBody>
-          </p:sp>
-          <p:sp>
-            <p:nvSpPr>
-              <p:cNvPr id="34" name="object 33">
-                <a:extLst>
-                  <a:ext uri="{FF2B5EF4-FFF2-40B4-BE49-F238E27FC236}">
-                    <a16:creationId xmlns:a16="http://schemas.microsoft.com/office/drawing/2014/main" id="{13A17944-DDD2-6E24-0A96-F6742E028C75}"/>
-                  </a:ext>
-                </a:extLst>
-              </p:cNvPr>
-              <p:cNvSpPr/>
-              <p:nvPr/>
-            </p:nvSpPr>
-            <p:spPr>
-              <a:xfrm>
-                <a:off x="8050286" y="4904583"/>
-                <a:ext cx="3099435" cy="2524760"/>
-              </a:xfrm>
-              <a:custGeom>
-                <a:avLst/>
-                <a:gdLst/>
-                <a:ahLst/>
-                <a:cxnLst/>
-                <a:rect l="l" t="t" r="r" b="b"/>
-                <a:pathLst>
-                  <a:path w="3099434" h="2524759">
-                    <a:moveTo>
-                      <a:pt x="3098903" y="0"/>
-                    </a:moveTo>
-                    <a:lnTo>
-                      <a:pt x="8117" y="2518140"/>
-                    </a:lnTo>
-                    <a:lnTo>
-                      <a:pt x="0" y="2524754"/>
-                    </a:lnTo>
-                  </a:path>
-                </a:pathLst>
-              </a:custGeom>
-              <a:ln w="20941">
-                <a:solidFill>
-                  <a:srgbClr val="222C4A"/>
-                </a:solidFill>
-              </a:ln>
-            </p:spPr>
-            <p:txBody>
-              <a:bodyPr wrap="square" lIns="0" tIns="0" rIns="0" bIns="0" rtlCol="0"/>
-              <a:lstStyle/>
-              <a:p>
-                <a:endParaRPr/>
-              </a:p>
-            </p:txBody>
-          </p:sp>
-          <p:sp>
-            <p:nvSpPr>
-              <p:cNvPr id="35" name="object 34">
-                <a:extLst>
-                  <a:ext uri="{FF2B5EF4-FFF2-40B4-BE49-F238E27FC236}">
-                    <a16:creationId xmlns:a16="http://schemas.microsoft.com/office/drawing/2014/main" id="{38109B22-D6E8-A30B-6917-F3F48D414AB8}"/>
-                  </a:ext>
-                </a:extLst>
-              </p:cNvPr>
-              <p:cNvSpPr/>
-              <p:nvPr/>
-            </p:nvSpPr>
-            <p:spPr>
-              <a:xfrm>
-                <a:off x="7980458" y="7383754"/>
-                <a:ext cx="109855" cy="102870"/>
-              </a:xfrm>
-              <a:custGeom>
-                <a:avLst/>
-                <a:gdLst/>
-                <a:ahLst/>
-                <a:cxnLst/>
-                <a:rect l="l" t="t" r="r" b="b"/>
-                <a:pathLst>
-                  <a:path w="109854" h="102870">
-                    <a:moveTo>
-                      <a:pt x="46187" y="0"/>
-                    </a:moveTo>
-                    <a:lnTo>
-                      <a:pt x="0" y="102457"/>
-                    </a:lnTo>
-                    <a:lnTo>
-                      <a:pt x="109682" y="77934"/>
-                    </a:lnTo>
-                    <a:lnTo>
-                      <a:pt x="46187" y="0"/>
-                    </a:lnTo>
-                    <a:close/>
-                  </a:path>
-                </a:pathLst>
-              </a:custGeom>
-              <a:solidFill>
-                <a:srgbClr val="222C4A"/>
-              </a:solidFill>
-            </p:spPr>
-            <p:txBody>
-              <a:bodyPr wrap="square" lIns="0" tIns="0" rIns="0" bIns="0" rtlCol="0"/>
-              <a:lstStyle/>
-              <a:p>
-                <a:endParaRPr/>
-              </a:p>
-            </p:txBody>
-          </p:sp>
-          <p:sp>
-            <p:nvSpPr>
-              <p:cNvPr id="36" name="object 35">
-                <a:extLst>
-                  <a:ext uri="{FF2B5EF4-FFF2-40B4-BE49-F238E27FC236}">
-                    <a16:creationId xmlns:a16="http://schemas.microsoft.com/office/drawing/2014/main" id="{5A409ED8-3203-B3CF-8350-32D13E0ADE24}"/>
-                  </a:ext>
-                </a:extLst>
-              </p:cNvPr>
-              <p:cNvSpPr/>
-              <p:nvPr/>
-            </p:nvSpPr>
-            <p:spPr>
-              <a:xfrm>
-                <a:off x="8094993" y="4729238"/>
-                <a:ext cx="304800" cy="2772410"/>
-              </a:xfrm>
-              <a:custGeom>
-                <a:avLst/>
-                <a:gdLst/>
-                <a:ahLst/>
-                <a:cxnLst/>
-                <a:rect l="l" t="t" r="r" b="b"/>
-                <a:pathLst>
-                  <a:path w="304800" h="2772409">
-                    <a:moveTo>
-                      <a:pt x="304311" y="0"/>
-                    </a:moveTo>
-                    <a:lnTo>
-                      <a:pt x="1142" y="2761765"/>
-                    </a:lnTo>
-                    <a:lnTo>
-                      <a:pt x="0" y="2772173"/>
-                    </a:lnTo>
-                  </a:path>
-                </a:pathLst>
-              </a:custGeom>
-              <a:ln w="20941">
-                <a:solidFill>
-                  <a:srgbClr val="222C4A"/>
-                </a:solidFill>
-              </a:ln>
-            </p:spPr>
-            <p:txBody>
-              <a:bodyPr wrap="square" lIns="0" tIns="0" rIns="0" bIns="0" rtlCol="0"/>
-              <a:lstStyle/>
-              <a:p>
-                <a:endParaRPr/>
-              </a:p>
-            </p:txBody>
-          </p:sp>
-          <p:sp>
-            <p:nvSpPr>
-              <p:cNvPr id="37" name="object 36">
-                <a:extLst>
-                  <a:ext uri="{FF2B5EF4-FFF2-40B4-BE49-F238E27FC236}">
-                    <a16:creationId xmlns:a16="http://schemas.microsoft.com/office/drawing/2014/main" id="{96B4602E-7883-69E3-6CB8-58AB2DD435DB}"/>
-                  </a:ext>
-                </a:extLst>
-              </p:cNvPr>
-              <p:cNvSpPr/>
-              <p:nvPr/>
-            </p:nvSpPr>
-            <p:spPr>
-              <a:xfrm>
-                <a:off x="8046184" y="7485520"/>
-                <a:ext cx="100330" cy="105410"/>
-              </a:xfrm>
-              <a:custGeom>
-                <a:avLst/>
-                <a:gdLst/>
-                <a:ahLst/>
-                <a:cxnLst/>
-                <a:rect l="l" t="t" r="r" b="b"/>
-                <a:pathLst>
-                  <a:path w="100329" h="105409">
-                    <a:moveTo>
-                      <a:pt x="0" y="0"/>
-                    </a:moveTo>
-                    <a:lnTo>
-                      <a:pt x="38983" y="105399"/>
-                    </a:lnTo>
-                    <a:lnTo>
-                      <a:pt x="99913" y="10963"/>
-                    </a:lnTo>
-                    <a:lnTo>
-                      <a:pt x="0" y="0"/>
-                    </a:lnTo>
-                    <a:close/>
-                  </a:path>
-                </a:pathLst>
-              </a:custGeom>
-              <a:solidFill>
-                <a:srgbClr val="222C4A"/>
-              </a:solidFill>
-            </p:spPr>
-            <p:txBody>
-              <a:bodyPr wrap="square" lIns="0" tIns="0" rIns="0" bIns="0" rtlCol="0"/>
-              <a:lstStyle/>
-              <a:p>
-                <a:endParaRPr/>
-              </a:p>
-            </p:txBody>
-          </p:sp>
-          <p:sp>
-            <p:nvSpPr>
-              <p:cNvPr id="38" name="object 37">
-                <a:extLst>
-                  <a:ext uri="{FF2B5EF4-FFF2-40B4-BE49-F238E27FC236}">
-                    <a16:creationId xmlns:a16="http://schemas.microsoft.com/office/drawing/2014/main" id="{29F812BA-CF38-0F98-2ADF-B0AAC2C04311}"/>
-                  </a:ext>
-                </a:extLst>
-              </p:cNvPr>
-              <p:cNvSpPr/>
-              <p:nvPr/>
-            </p:nvSpPr>
-            <p:spPr>
-              <a:xfrm>
-                <a:off x="6129943" y="4932090"/>
-                <a:ext cx="627380" cy="2545080"/>
-              </a:xfrm>
-              <a:custGeom>
-                <a:avLst/>
-                <a:gdLst/>
-                <a:ahLst/>
-                <a:cxnLst/>
-                <a:rect l="l" t="t" r="r" b="b"/>
-                <a:pathLst>
-                  <a:path w="627379" h="2545079">
-                    <a:moveTo>
-                      <a:pt x="0" y="0"/>
-                    </a:moveTo>
-                    <a:lnTo>
-                      <a:pt x="2506" y="10166"/>
-                    </a:lnTo>
-                    <a:lnTo>
-                      <a:pt x="627376" y="2544923"/>
-                    </a:lnTo>
-                  </a:path>
-                </a:pathLst>
-              </a:custGeom>
-              <a:ln w="20941">
-                <a:solidFill>
-                  <a:srgbClr val="222C4A"/>
-                </a:solidFill>
-              </a:ln>
-            </p:spPr>
-            <p:txBody>
-              <a:bodyPr wrap="square" lIns="0" tIns="0" rIns="0" bIns="0" rtlCol="0"/>
-              <a:lstStyle/>
-              <a:p>
-                <a:endParaRPr/>
-              </a:p>
-            </p:txBody>
-          </p:sp>
-          <p:sp>
-            <p:nvSpPr>
-              <p:cNvPr id="39" name="object 38">
-                <a:extLst>
-                  <a:ext uri="{FF2B5EF4-FFF2-40B4-BE49-F238E27FC236}">
-                    <a16:creationId xmlns:a16="http://schemas.microsoft.com/office/drawing/2014/main" id="{EB55ACEB-88E3-35C5-9EC9-078E4FE29E48}"/>
-                  </a:ext>
-                </a:extLst>
-              </p:cNvPr>
-              <p:cNvSpPr/>
-              <p:nvPr/>
-            </p:nvSpPr>
-            <p:spPr>
-              <a:xfrm>
-                <a:off x="6083647" y="4844658"/>
-                <a:ext cx="97790" cy="109855"/>
-              </a:xfrm>
-              <a:custGeom>
-                <a:avLst/>
-                <a:gdLst/>
-                <a:ahLst/>
-                <a:cxnLst/>
-                <a:rect l="l" t="t" r="r" b="b"/>
-                <a:pathLst>
-                  <a:path w="97789" h="109854">
-                    <a:moveTo>
-                      <a:pt x="24742" y="0"/>
-                    </a:moveTo>
-                    <a:lnTo>
-                      <a:pt x="0" y="109630"/>
-                    </a:lnTo>
-                    <a:lnTo>
-                      <a:pt x="97599" y="85568"/>
-                    </a:lnTo>
-                    <a:lnTo>
-                      <a:pt x="24742" y="0"/>
-                    </a:lnTo>
-                    <a:close/>
-                  </a:path>
-                </a:pathLst>
-              </a:custGeom>
-              <a:solidFill>
-                <a:srgbClr val="222C4A"/>
-              </a:solidFill>
-            </p:spPr>
-            <p:txBody>
-              <a:bodyPr wrap="square" lIns="0" tIns="0" rIns="0" bIns="0" rtlCol="0"/>
-              <a:lstStyle/>
-              <a:p>
-                <a:endParaRPr/>
-              </a:p>
-            </p:txBody>
-          </p:sp>
-          <p:sp>
-            <p:nvSpPr>
-              <p:cNvPr id="40" name="object 39">
-                <a:extLst>
-                  <a:ext uri="{FF2B5EF4-FFF2-40B4-BE49-F238E27FC236}">
-                    <a16:creationId xmlns:a16="http://schemas.microsoft.com/office/drawing/2014/main" id="{1D4B686D-B7E3-EBE5-21C3-9450F6BDE937}"/>
-                  </a:ext>
-                </a:extLst>
-              </p:cNvPr>
-              <p:cNvSpPr/>
-              <p:nvPr/>
-            </p:nvSpPr>
-            <p:spPr>
-              <a:xfrm>
-                <a:off x="6262686" y="5024534"/>
-                <a:ext cx="1585595" cy="2403475"/>
-              </a:xfrm>
-              <a:custGeom>
-                <a:avLst/>
-                <a:gdLst/>
-                <a:ahLst/>
-                <a:cxnLst/>
-                <a:rect l="l" t="t" r="r" b="b"/>
-                <a:pathLst>
-                  <a:path w="1585595" h="2403475">
-                    <a:moveTo>
-                      <a:pt x="0" y="0"/>
-                    </a:moveTo>
-                    <a:lnTo>
-                      <a:pt x="5766" y="8740"/>
-                    </a:lnTo>
-                    <a:lnTo>
-                      <a:pt x="1585388" y="2403174"/>
-                    </a:lnTo>
-                  </a:path>
-                </a:pathLst>
-              </a:custGeom>
-              <a:ln w="20941">
-                <a:solidFill>
-                  <a:srgbClr val="222C4A"/>
-                </a:solidFill>
-              </a:ln>
-            </p:spPr>
-            <p:txBody>
-              <a:bodyPr wrap="square" lIns="0" tIns="0" rIns="0" bIns="0" rtlCol="0"/>
-              <a:lstStyle/>
-              <a:p>
-                <a:endParaRPr/>
-              </a:p>
-            </p:txBody>
-          </p:sp>
-          <p:sp>
-            <p:nvSpPr>
-              <p:cNvPr id="41" name="object 40">
-                <a:extLst>
-                  <a:ext uri="{FF2B5EF4-FFF2-40B4-BE49-F238E27FC236}">
-                    <a16:creationId xmlns:a16="http://schemas.microsoft.com/office/drawing/2014/main" id="{434FAC37-491C-6A05-8097-0026B6E46178}"/>
-                  </a:ext>
-                </a:extLst>
-              </p:cNvPr>
-              <p:cNvSpPr/>
-              <p:nvPr/>
-            </p:nvSpPr>
-            <p:spPr>
-              <a:xfrm>
-                <a:off x="6213098" y="4949367"/>
-                <a:ext cx="97790" cy="111760"/>
-              </a:xfrm>
-              <a:custGeom>
-                <a:avLst/>
-                <a:gdLst/>
-                <a:ahLst/>
-                <a:cxnLst/>
-                <a:rect l="l" t="t" r="r" b="b"/>
-                <a:pathLst>
-                  <a:path w="97789" h="111760">
-                    <a:moveTo>
-                      <a:pt x="0" y="0"/>
-                    </a:moveTo>
-                    <a:lnTo>
-                      <a:pt x="13392" y="111577"/>
-                    </a:lnTo>
-                    <a:lnTo>
-                      <a:pt x="97305" y="56228"/>
-                    </a:lnTo>
-                    <a:lnTo>
-                      <a:pt x="0" y="0"/>
-                    </a:lnTo>
-                    <a:close/>
-                  </a:path>
-                </a:pathLst>
-              </a:custGeom>
-              <a:solidFill>
-                <a:srgbClr val="222C4A"/>
-              </a:solidFill>
-            </p:spPr>
-            <p:txBody>
-              <a:bodyPr wrap="square" lIns="0" tIns="0" rIns="0" bIns="0" rtlCol="0"/>
-              <a:lstStyle/>
-              <a:p>
-                <a:endParaRPr/>
-              </a:p>
-            </p:txBody>
-          </p:sp>
-          <p:sp>
-            <p:nvSpPr>
-              <p:cNvPr id="42" name="object 41">
-                <a:extLst>
-                  <a:ext uri="{FF2B5EF4-FFF2-40B4-BE49-F238E27FC236}">
-                    <a16:creationId xmlns:a16="http://schemas.microsoft.com/office/drawing/2014/main" id="{BF89AE6F-999E-9F8F-0E41-1485253A2280}"/>
-                  </a:ext>
-                </a:extLst>
-              </p:cNvPr>
-              <p:cNvSpPr/>
-              <p:nvPr/>
-            </p:nvSpPr>
-            <p:spPr>
-              <a:xfrm>
-                <a:off x="8614705" y="4952142"/>
-                <a:ext cx="627380" cy="2545080"/>
-              </a:xfrm>
-              <a:custGeom>
-                <a:avLst/>
-                <a:gdLst/>
-                <a:ahLst/>
-                <a:cxnLst/>
-                <a:rect l="l" t="t" r="r" b="b"/>
-                <a:pathLst>
-                  <a:path w="627379" h="2545079">
-                    <a:moveTo>
-                      <a:pt x="0" y="0"/>
-                    </a:moveTo>
-                    <a:lnTo>
-                      <a:pt x="2506" y="10166"/>
-                    </a:lnTo>
-                    <a:lnTo>
-                      <a:pt x="627376" y="2544923"/>
-                    </a:lnTo>
-                  </a:path>
-                </a:pathLst>
-              </a:custGeom>
-              <a:ln w="20941">
-                <a:solidFill>
-                  <a:srgbClr val="222C4A"/>
-                </a:solidFill>
-              </a:ln>
-            </p:spPr>
-            <p:txBody>
-              <a:bodyPr wrap="square" lIns="0" tIns="0" rIns="0" bIns="0" rtlCol="0"/>
-              <a:lstStyle/>
-              <a:p>
-                <a:endParaRPr/>
-              </a:p>
-            </p:txBody>
-          </p:sp>
-          <p:sp>
-            <p:nvSpPr>
-              <p:cNvPr id="43" name="object 42">
-                <a:extLst>
-                  <a:ext uri="{FF2B5EF4-FFF2-40B4-BE49-F238E27FC236}">
-                    <a16:creationId xmlns:a16="http://schemas.microsoft.com/office/drawing/2014/main" id="{BA741C6A-C4DA-0BC3-5A32-D720E1567895}"/>
-                  </a:ext>
-                </a:extLst>
-              </p:cNvPr>
-              <p:cNvSpPr/>
-              <p:nvPr/>
-            </p:nvSpPr>
-            <p:spPr>
-              <a:xfrm>
-                <a:off x="8568409" y="4864710"/>
-                <a:ext cx="97790" cy="109855"/>
-              </a:xfrm>
-              <a:custGeom>
-                <a:avLst/>
-                <a:gdLst/>
-                <a:ahLst/>
-                <a:cxnLst/>
-                <a:rect l="l" t="t" r="r" b="b"/>
-                <a:pathLst>
-                  <a:path w="97790" h="109854">
-                    <a:moveTo>
-                      <a:pt x="24742" y="0"/>
-                    </a:moveTo>
-                    <a:lnTo>
-                      <a:pt x="0" y="109630"/>
-                    </a:lnTo>
-                    <a:lnTo>
-                      <a:pt x="97599" y="85568"/>
-                    </a:lnTo>
-                    <a:lnTo>
-                      <a:pt x="24742" y="0"/>
-                    </a:lnTo>
-                    <a:close/>
-                  </a:path>
-                </a:pathLst>
-              </a:custGeom>
-              <a:solidFill>
-                <a:srgbClr val="222C4A"/>
-              </a:solidFill>
-            </p:spPr>
-            <p:txBody>
-              <a:bodyPr wrap="square" lIns="0" tIns="0" rIns="0" bIns="0" rtlCol="0"/>
-              <a:lstStyle/>
-              <a:p>
-                <a:endParaRPr/>
-              </a:p>
-            </p:txBody>
-          </p:sp>
-          <p:sp>
-            <p:nvSpPr>
-              <p:cNvPr id="44" name="object 43">
-                <a:extLst>
-                  <a:ext uri="{FF2B5EF4-FFF2-40B4-BE49-F238E27FC236}">
-                    <a16:creationId xmlns:a16="http://schemas.microsoft.com/office/drawing/2014/main" id="{DF00236A-3795-47D7-F8EB-8CCB572603D4}"/>
-                  </a:ext>
-                </a:extLst>
-              </p:cNvPr>
-              <p:cNvSpPr/>
-              <p:nvPr/>
-            </p:nvSpPr>
-            <p:spPr>
-              <a:xfrm>
-                <a:off x="3583964" y="5008140"/>
-                <a:ext cx="759460" cy="2221230"/>
-              </a:xfrm>
-              <a:custGeom>
-                <a:avLst/>
-                <a:gdLst/>
-                <a:ahLst/>
-                <a:cxnLst/>
-                <a:rect l="l" t="t" r="r" b="b"/>
-                <a:pathLst>
-                  <a:path w="759460" h="2221229">
-                    <a:moveTo>
-                      <a:pt x="0" y="0"/>
-                    </a:moveTo>
-                    <a:lnTo>
-                      <a:pt x="755898" y="2210753"/>
-                    </a:lnTo>
-                    <a:lnTo>
-                      <a:pt x="759286" y="2220661"/>
-                    </a:lnTo>
-                  </a:path>
-                </a:pathLst>
-              </a:custGeom>
-              <a:ln w="20941">
-                <a:solidFill>
-                  <a:srgbClr val="222C4A"/>
-                </a:solidFill>
-              </a:ln>
-            </p:spPr>
-            <p:txBody>
-              <a:bodyPr wrap="square" lIns="0" tIns="0" rIns="0" bIns="0" rtlCol="0"/>
-              <a:lstStyle/>
-              <a:p>
-                <a:endParaRPr/>
-              </a:p>
-            </p:txBody>
-          </p:sp>
-          <p:sp>
-            <p:nvSpPr>
-              <p:cNvPr id="45" name="object 44">
-                <a:extLst>
-                  <a:ext uri="{FF2B5EF4-FFF2-40B4-BE49-F238E27FC236}">
-                    <a16:creationId xmlns:a16="http://schemas.microsoft.com/office/drawing/2014/main" id="{C89D064C-E7E5-AF52-D2DD-043FD848D60B}"/>
-                  </a:ext>
-                </a:extLst>
-              </p:cNvPr>
-              <p:cNvSpPr/>
-              <p:nvPr/>
-            </p:nvSpPr>
-            <p:spPr>
-              <a:xfrm>
-                <a:off x="4292309" y="7202639"/>
-                <a:ext cx="95250" cy="111760"/>
-              </a:xfrm>
-              <a:custGeom>
-                <a:avLst/>
-                <a:gdLst/>
-                <a:ahLst/>
-                <a:cxnLst/>
-                <a:rect l="l" t="t" r="r" b="b"/>
-                <a:pathLst>
-                  <a:path w="95250" h="111759">
-                    <a:moveTo>
-                      <a:pt x="95117" y="0"/>
-                    </a:moveTo>
-                    <a:lnTo>
-                      <a:pt x="0" y="32522"/>
-                    </a:lnTo>
-                    <a:lnTo>
-                      <a:pt x="80081" y="111378"/>
-                    </a:lnTo>
-                    <a:lnTo>
-                      <a:pt x="95117" y="0"/>
-                    </a:lnTo>
-                    <a:close/>
-                  </a:path>
-                </a:pathLst>
-              </a:custGeom>
-              <a:solidFill>
-                <a:srgbClr val="222C4A"/>
-              </a:solidFill>
-            </p:spPr>
-            <p:txBody>
-              <a:bodyPr wrap="square" lIns="0" tIns="0" rIns="0" bIns="0" rtlCol="0"/>
-              <a:lstStyle/>
-              <a:p>
-                <a:endParaRPr/>
-              </a:p>
-            </p:txBody>
-          </p:sp>
-        </p:grpSp>
-      </p:grpSp>
-      <p:sp>
-        <p:nvSpPr>
-          <p:cNvPr id="48" name="TextBox 47">
-            <a:extLst>
-              <a:ext uri="{FF2B5EF4-FFF2-40B4-BE49-F238E27FC236}">
-                <a16:creationId xmlns:a16="http://schemas.microsoft.com/office/drawing/2014/main" id="{51F35555-7DB3-0E9F-0CC1-8DCCA40D364A}"/>
-              </a:ext>
-            </a:extLst>
-          </p:cNvPr>
-          <p:cNvSpPr txBox="1"/>
-          <p:nvPr/>
         </p:nvSpPr>
         <p:spPr>
-          <a:xfrm>
+          <a:xfrm xmlns:a="http://schemas.openxmlformats.org/drawingml/2006/main">
             <a:off x="7325250" y="1373218"/>
             <a:ext cx="4706595" cy="4154984"/>
           </a:xfrm>
-          <a:prstGeom prst="rect">
+          <a:prstGeom xmlns:a="http://schemas.openxmlformats.org/drawingml/2006/main" prst="rect">
             <a:avLst/>
           </a:prstGeom>
-          <a:noFill/>
+          <a:noFill xmlns:a="http://schemas.openxmlformats.org/drawingml/2006/main"/>
         </p:spPr>
         <p:txBody>
-          <a:bodyPr wrap="square">
+          <a:bodyPr xmlns:a="http://schemas.openxmlformats.org/drawingml/2006/main" wrap="square">
             <a:spAutoFit/>
           </a:bodyPr>
-          <a:lstStyle/>
-          <a:p>
+          <a:lstStyle xmlns:a="http://schemas.openxmlformats.org/drawingml/2006/main"/>
+          <a:p xmlns:a="http://schemas.openxmlformats.org/drawingml/2006/main">
             <a:pPr marL="342900" indent="-342900">
-              <a:buFont typeface="Arial" panose="020B0604020202020204" pitchFamily="34" charset="0"/>
+              <a:buFont typeface="Arial"/>
               <a:buChar char="•"/>
             </a:pPr>
             <a:r>
-              <a:rPr lang="en-US" sz="2400" dirty="0"/>
+              <a:rPr sz="2400"/>
               <a:t>Fault tolerance requires replication</a:t>
             </a:r>
           </a:p>
-          <a:p>
+          <a:p xmlns:a="http://schemas.openxmlformats.org/drawingml/2006/main">
             <a:pPr marL="342900" indent="-342900">
-              <a:buFont typeface="Arial" panose="020B0604020202020204" pitchFamily="34" charset="0"/>
+              <a:buFont typeface="Arial"/>
               <a:buChar char="•"/>
             </a:pPr>
-            <a:endParaRPr lang="en-US" sz="1200" dirty="0"/>
-          </a:p>
-          <a:p>
+            <a:endParaRPr sz="1200"/>
+          </a:p>
+          <a:p xmlns:a="http://schemas.openxmlformats.org/drawingml/2006/main">
             <a:pPr marL="342900" indent="-342900">
-              <a:buFont typeface="Arial" panose="020B0604020202020204" pitchFamily="34" charset="0"/>
+              <a:buFont typeface="Arial"/>
               <a:buChar char="•"/>
             </a:pPr>
             <a:r>
-              <a:rPr lang="en-US" sz="2400" dirty="0"/>
+              <a:rPr sz="2400"/>
               <a:t>Replication risks inconsistency</a:t>
             </a:r>
           </a:p>
-          <a:p>
+          <a:p xmlns:a="http://schemas.openxmlformats.org/drawingml/2006/main">
             <a:pPr marL="342900" indent="-342900">
-              <a:buFont typeface="Arial" panose="020B0604020202020204" pitchFamily="34" charset="0"/>
+              <a:buFont typeface="Arial"/>
               <a:buChar char="•"/>
             </a:pPr>
-            <a:endParaRPr lang="en-US" sz="1200" dirty="0"/>
-          </a:p>
-          <a:p>
+            <a:endParaRPr sz="1200"/>
+          </a:p>
+          <a:p xmlns:a="http://schemas.openxmlformats.org/drawingml/2006/main">
             <a:pPr marL="342900" indent="-342900">
-              <a:buFont typeface="Arial" panose="020B0604020202020204" pitchFamily="34" charset="0"/>
+              <a:buFont typeface="Arial"/>
               <a:buChar char="•"/>
             </a:pPr>
             <a:r>
-              <a:rPr lang="en-US" sz="2400" dirty="0"/>
+              <a:rPr sz="2400"/>
               <a:t>Consistency requires coordination</a:t>
             </a:r>
           </a:p>
-          <a:p>
+          <a:p xmlns:a="http://schemas.openxmlformats.org/drawingml/2006/main">
             <a:pPr marL="342900" indent="-342900">
-              <a:buFont typeface="Arial" panose="020B0604020202020204" pitchFamily="34" charset="0"/>
+              <a:buFont typeface="Arial"/>
               <a:buChar char="•"/>
             </a:pPr>
-            <a:endParaRPr lang="en-US" sz="1200" dirty="0"/>
-          </a:p>
-          <a:p>
+            <a:endParaRPr sz="1200"/>
+          </a:p>
+          <a:p xmlns:a="http://schemas.openxmlformats.org/drawingml/2006/main">
             <a:pPr marL="342900" indent="-342900">
-              <a:buFont typeface="Arial" panose="020B0604020202020204" pitchFamily="34" charset="0"/>
+              <a:buFont typeface="Arial"/>
               <a:buChar char="•"/>
             </a:pPr>
             <a:r>
-              <a:rPr lang="en-US" sz="2400" dirty="0"/>
+              <a:rPr sz="2400"/>
               <a:t>Coordination lowers performance</a:t>
+            </a:r>
+          </a:p>
+        </p:txBody>
+      </p:sp>
+      <p:sp>
+        <p:nvSpPr>
+          <p:cNvPr id="49" name="Partial write heading">
+            <a:extLst xmlns:a="http://schemas.openxmlformats.org/drawingml/2006/main">
+              <a:ext uri="{FF2B5EF4-FFF2-40B4-BE49-F238E27FC236}">
+                <a16:creationId xmlns:a16="http://schemas.microsoft.com/office/drawing/2014/main" id="{661EE3E6-4BC3-4749-8762-CC8F835B020D}"/>
+              </a:ext>
+            </a:extLst>
+          </p:cNvPr>
+          <p:cNvSpPr>
+            <a:spLocks xmlns:a="http://schemas.openxmlformats.org/drawingml/2006/main" noGrp="1"/>
+          </p:cNvSpPr>
+          <p:nvPr/>
+        </p:nvSpPr>
+        <p:spPr>
+          <a:xfrm xmlns:a="http://schemas.openxmlformats.org/drawingml/2006/main">
+            <a:off x="409575" y="1057275"/>
+            <a:ext cx="6429375" cy="323850"/>
+          </a:xfrm>
+          <a:prstGeom xmlns:a="http://schemas.openxmlformats.org/drawingml/2006/main" prst="rect">
+            <a:avLst/>
+          </a:prstGeom>
+          <a:noFill xmlns:a="http://schemas.openxmlformats.org/drawingml/2006/main"/>
+          <a:ln xmlns:a="http://schemas.openxmlformats.org/drawingml/2006/main" w="0">
+            <a:noFill/>
+          </a:ln>
+        </p:spPr>
+        <p:txBody>
+          <a:bodyPr xmlns:a="http://schemas.openxmlformats.org/drawingml/2006/main">
+            <a:normAutofit fontScale="88406"/>
+          </a:bodyPr>
+          <a:lstStyle xmlns:a="http://schemas.openxmlformats.org/drawingml/2006/main"/>
+          <a:p xmlns:a="http://schemas.openxmlformats.org/drawingml/2006/main">
+            <a:pPr>
+              <a:defRPr sz="1725" b="1">
+                <a:solidFill>
+                  <a:srgbClr val="0E2841"/>
+                </a:solidFill>
+                <a:latin typeface="Aptos"/>
+                <a:ea typeface="Aptos"/>
+                <a:cs typeface="Aptos"/>
+              </a:defRPr>
+            </a:pPr>
+            <a:r>
+              <a:rPr sz="1725" b="1">
+                <a:solidFill>
+                  <a:srgbClr val="0E2841"/>
+                </a:solidFill>
+                <a:latin typeface="Aptos"/>
+                <a:ea typeface="Aptos"/>
+                <a:cs typeface="Aptos"/>
+              </a:rPr>
+              <a:t>A partial write can make replicas disagree</a:t>
+            </a:r>
+          </a:p>
+        </p:txBody>
+      </p:sp>
+      <p:sp>
+        <p:nvSpPr>
+          <p:cNvPr id="50" name="Write request">
+            <a:extLst xmlns:a="http://schemas.openxmlformats.org/drawingml/2006/main">
+              <a:ext uri="{FF2B5EF4-FFF2-40B4-BE49-F238E27FC236}">
+                <a16:creationId xmlns:a16="http://schemas.microsoft.com/office/drawing/2014/main" id="{75D3A3DE-8E0D-482B-BCFD-2AD2458A4DA5}"/>
+              </a:ext>
+            </a:extLst>
+          </p:cNvPr>
+          <p:cNvSpPr>
+            <a:spLocks xmlns:a="http://schemas.openxmlformats.org/drawingml/2006/main" noGrp="1"/>
+          </p:cNvSpPr>
+          <p:nvPr/>
+        </p:nvSpPr>
+        <p:spPr>
+          <a:xfrm xmlns:a="http://schemas.openxmlformats.org/drawingml/2006/main">
+            <a:off x="2838450" y="1438275"/>
+            <a:ext cx="1219200" cy="590550"/>
+          </a:xfrm>
+          <a:prstGeom xmlns:a="http://schemas.openxmlformats.org/drawingml/2006/main" prst="roundRect">
+            <a:avLst>
+              <a:gd name="adj" fmla="val 16129"/>
+            </a:avLst>
+          </a:prstGeom>
+          <a:solidFill xmlns:a="http://schemas.openxmlformats.org/drawingml/2006/main">
+            <a:srgbClr val="A02B93"/>
+          </a:solidFill>
+          <a:ln xmlns:a="http://schemas.openxmlformats.org/drawingml/2006/main" w="19050">
+            <a:solidFill>
+              <a:srgbClr val="A02B93"/>
+            </a:solidFill>
+            <a:prstDash val="solid"/>
+          </a:ln>
+        </p:spPr>
+        <p:txBody>
+          <a:bodyPr xmlns:a="http://schemas.openxmlformats.org/drawingml/2006/main" lIns="47625" tIns="47625" rIns="47625" bIns="47625" anchor="ctr">
+            <a:normAutofit fontScale="100000"/>
+          </a:bodyPr>
+          <a:lstStyle xmlns:a="http://schemas.openxmlformats.org/drawingml/2006/main"/>
+          <a:p xmlns:a="http://schemas.openxmlformats.org/drawingml/2006/main">
+            <a:pPr algn="ctr">
+              <a:defRPr sz="1425" b="1">
+                <a:solidFill>
+                  <a:srgbClr val="FFFFFF"/>
+                </a:solidFill>
+                <a:latin typeface="Aptos"/>
+                <a:ea typeface="Aptos"/>
+                <a:cs typeface="Aptos"/>
+              </a:defRPr>
+            </a:pPr>
+            <a:r>
+              <a:rPr sz="1425" b="1">
+                <a:solidFill>
+                  <a:srgbClr val="FFFFFF"/>
+                </a:solidFill>
+                <a:latin typeface="Aptos"/>
+                <a:ea typeface="Aptos"/>
+                <a:cs typeface="Aptos"/>
+              </a:rPr>
+              <a:t>WRITE</a:t>
+            </a:r>
+          </a:p>
+          <a:p xmlns:a="http://schemas.openxmlformats.org/drawingml/2006/main">
+            <a:pPr algn="ctr">
+              <a:defRPr sz="1425" b="1">
+                <a:solidFill>
+                  <a:srgbClr val="FFFFFF"/>
+                </a:solidFill>
+                <a:latin typeface="Aptos"/>
+                <a:ea typeface="Aptos"/>
+                <a:cs typeface="Aptos"/>
+              </a:defRPr>
+            </a:pPr>
+            <a:r>
+              <a:rPr sz="1425" b="1">
+                <a:solidFill>
+                  <a:srgbClr val="FFFFFF"/>
+                </a:solidFill>
+                <a:latin typeface="Aptos"/>
+                <a:ea typeface="Aptos"/>
+                <a:cs typeface="Aptos"/>
+              </a:rPr>
+              <a:t>x = B</a:t>
+            </a:r>
+          </a:p>
+        </p:txBody>
+      </p:sp>
+      <p:sp>
+        <p:nvSpPr>
+          <p:cNvPr id="51" name="Top replica 1">
+            <a:extLst xmlns:a="http://schemas.openxmlformats.org/drawingml/2006/main">
+              <a:ext uri="{FF2B5EF4-FFF2-40B4-BE49-F238E27FC236}">
+                <a16:creationId xmlns:a16="http://schemas.microsoft.com/office/drawing/2014/main" id="{C047F16D-4224-436C-BA2F-7F4F14E7970E}"/>
+              </a:ext>
+            </a:extLst>
+          </p:cNvPr>
+          <p:cNvSpPr>
+            <a:spLocks xmlns:a="http://schemas.openxmlformats.org/drawingml/2006/main" noGrp="1"/>
+          </p:cNvSpPr>
+          <p:nvPr/>
+        </p:nvSpPr>
+        <p:spPr>
+          <a:xfrm xmlns:a="http://schemas.openxmlformats.org/drawingml/2006/main">
+            <a:off x="581025" y="2266950"/>
+            <a:ext cx="1333500" cy="685800"/>
+          </a:xfrm>
+          <a:prstGeom xmlns:a="http://schemas.openxmlformats.org/drawingml/2006/main" prst="roundRect">
+            <a:avLst>
+              <a:gd name="adj" fmla="val 13889"/>
+            </a:avLst>
+          </a:prstGeom>
+          <a:solidFill xmlns:a="http://schemas.openxmlformats.org/drawingml/2006/main">
+            <a:srgbClr val="E8F0F5"/>
+          </a:solidFill>
+          <a:ln xmlns:a="http://schemas.openxmlformats.org/drawingml/2006/main" w="19050">
+            <a:solidFill>
+              <a:srgbClr val="0E2841"/>
+            </a:solidFill>
+            <a:prstDash val="solid"/>
+          </a:ln>
+        </p:spPr>
+        <p:txBody>
+          <a:bodyPr xmlns:a="http://schemas.openxmlformats.org/drawingml/2006/main" lIns="47625" tIns="47625" rIns="47625" bIns="47625" anchor="ctr">
+            <a:normAutofit fontScale="100000"/>
+          </a:bodyPr>
+          <a:lstStyle xmlns:a="http://schemas.openxmlformats.org/drawingml/2006/main"/>
+          <a:p xmlns:a="http://schemas.openxmlformats.org/drawingml/2006/main">
+            <a:pPr algn="ctr">
+              <a:defRPr sz="1350" b="1">
+                <a:solidFill>
+                  <a:srgbClr val="0E2841"/>
+                </a:solidFill>
+                <a:latin typeface="Aptos"/>
+                <a:ea typeface="Aptos"/>
+                <a:cs typeface="Aptos"/>
+              </a:defRPr>
+            </a:pPr>
+            <a:r>
+              <a:rPr sz="1350" b="1">
+                <a:solidFill>
+                  <a:srgbClr val="0E2841"/>
+                </a:solidFill>
+                <a:latin typeface="Aptos"/>
+                <a:ea typeface="Aptos"/>
+                <a:cs typeface="Aptos"/>
+              </a:rPr>
+              <a:t>Replica 1</a:t>
+            </a:r>
+          </a:p>
+          <a:p xmlns:a="http://schemas.openxmlformats.org/drawingml/2006/main">
+            <a:pPr algn="ctr">
+              <a:defRPr sz="1350" b="1">
+                <a:solidFill>
+                  <a:srgbClr val="0E2841"/>
+                </a:solidFill>
+                <a:latin typeface="Aptos"/>
+                <a:ea typeface="Aptos"/>
+                <a:cs typeface="Aptos"/>
+              </a:defRPr>
+            </a:pPr>
+            <a:r>
+              <a:rPr sz="1350" b="1">
+                <a:solidFill>
+                  <a:srgbClr val="0E2841"/>
+                </a:solidFill>
+                <a:latin typeface="Aptos"/>
+                <a:ea typeface="Aptos"/>
+                <a:cs typeface="Aptos"/>
+              </a:rPr>
+              <a:t>x = B</a:t>
+            </a:r>
+          </a:p>
+        </p:txBody>
+      </p:sp>
+      <p:sp>
+        <p:nvSpPr>
+          <p:cNvPr id="52" name="Top replica 2">
+            <a:extLst xmlns:a="http://schemas.openxmlformats.org/drawingml/2006/main">
+              <a:ext uri="{FF2B5EF4-FFF2-40B4-BE49-F238E27FC236}">
+                <a16:creationId xmlns:a16="http://schemas.microsoft.com/office/drawing/2014/main" id="{B89A6385-D3E5-42F1-8972-B1EBFAE8F87F}"/>
+              </a:ext>
+            </a:extLst>
+          </p:cNvPr>
+          <p:cNvSpPr>
+            <a:spLocks xmlns:a="http://schemas.openxmlformats.org/drawingml/2006/main" noGrp="1"/>
+          </p:cNvSpPr>
+          <p:nvPr/>
+        </p:nvSpPr>
+        <p:spPr>
+          <a:xfrm xmlns:a="http://schemas.openxmlformats.org/drawingml/2006/main">
+            <a:off x="2781300" y="2266950"/>
+            <a:ext cx="1333500" cy="685800"/>
+          </a:xfrm>
+          <a:prstGeom xmlns:a="http://schemas.openxmlformats.org/drawingml/2006/main" prst="roundRect">
+            <a:avLst>
+              <a:gd name="adj" fmla="val 13889"/>
+            </a:avLst>
+          </a:prstGeom>
+          <a:solidFill xmlns:a="http://schemas.openxmlformats.org/drawingml/2006/main">
+            <a:srgbClr val="E8F0F5"/>
+          </a:solidFill>
+          <a:ln xmlns:a="http://schemas.openxmlformats.org/drawingml/2006/main" w="19050">
+            <a:solidFill>
+              <a:srgbClr val="0E2841"/>
+            </a:solidFill>
+            <a:prstDash val="solid"/>
+          </a:ln>
+        </p:spPr>
+        <p:txBody>
+          <a:bodyPr xmlns:a="http://schemas.openxmlformats.org/drawingml/2006/main" lIns="47625" tIns="47625" rIns="47625" bIns="47625" anchor="ctr">
+            <a:normAutofit fontScale="100000"/>
+          </a:bodyPr>
+          <a:lstStyle xmlns:a="http://schemas.openxmlformats.org/drawingml/2006/main"/>
+          <a:p xmlns:a="http://schemas.openxmlformats.org/drawingml/2006/main">
+            <a:pPr algn="ctr">
+              <a:defRPr sz="1350" b="1">
+                <a:solidFill>
+                  <a:srgbClr val="0E2841"/>
+                </a:solidFill>
+                <a:latin typeface="Aptos"/>
+                <a:ea typeface="Aptos"/>
+                <a:cs typeface="Aptos"/>
+              </a:defRPr>
+            </a:pPr>
+            <a:r>
+              <a:rPr sz="1350" b="1">
+                <a:solidFill>
+                  <a:srgbClr val="0E2841"/>
+                </a:solidFill>
+                <a:latin typeface="Aptos"/>
+                <a:ea typeface="Aptos"/>
+                <a:cs typeface="Aptos"/>
+              </a:rPr>
+              <a:t>Replica 2</a:t>
+            </a:r>
+          </a:p>
+          <a:p xmlns:a="http://schemas.openxmlformats.org/drawingml/2006/main">
+            <a:pPr algn="ctr">
+              <a:defRPr sz="1350" b="1">
+                <a:solidFill>
+                  <a:srgbClr val="0E2841"/>
+                </a:solidFill>
+                <a:latin typeface="Aptos"/>
+                <a:ea typeface="Aptos"/>
+                <a:cs typeface="Aptos"/>
+              </a:defRPr>
+            </a:pPr>
+            <a:r>
+              <a:rPr sz="1350" b="1">
+                <a:solidFill>
+                  <a:srgbClr val="0E2841"/>
+                </a:solidFill>
+                <a:latin typeface="Aptos"/>
+                <a:ea typeface="Aptos"/>
+                <a:cs typeface="Aptos"/>
+              </a:rPr>
+              <a:t>x = B</a:t>
+            </a:r>
+          </a:p>
+        </p:txBody>
+      </p:sp>
+      <p:sp>
+        <p:nvSpPr>
+          <p:cNvPr id="53" name="Stale replica">
+            <a:extLst xmlns:a="http://schemas.openxmlformats.org/drawingml/2006/main">
+              <a:ext uri="{FF2B5EF4-FFF2-40B4-BE49-F238E27FC236}">
+                <a16:creationId xmlns:a16="http://schemas.microsoft.com/office/drawing/2014/main" id="{14E7EFFC-DB2B-4ECF-A2D6-8B87D9C1B16D}"/>
+              </a:ext>
+            </a:extLst>
+          </p:cNvPr>
+          <p:cNvSpPr>
+            <a:spLocks xmlns:a="http://schemas.openxmlformats.org/drawingml/2006/main" noGrp="1"/>
+          </p:cNvSpPr>
+          <p:nvPr/>
+        </p:nvSpPr>
+        <p:spPr>
+          <a:xfrm xmlns:a="http://schemas.openxmlformats.org/drawingml/2006/main">
+            <a:off x="4981575" y="2266950"/>
+            <a:ext cx="1333500" cy="685800"/>
+          </a:xfrm>
+          <a:prstGeom xmlns:a="http://schemas.openxmlformats.org/drawingml/2006/main" prst="roundRect">
+            <a:avLst>
+              <a:gd name="adj" fmla="val 13889"/>
+            </a:avLst>
+          </a:prstGeom>
+          <a:solidFill xmlns:a="http://schemas.openxmlformats.org/drawingml/2006/main">
+            <a:srgbClr val="F7E8F5"/>
+          </a:solidFill>
+          <a:ln xmlns:a="http://schemas.openxmlformats.org/drawingml/2006/main" w="28575">
+            <a:solidFill>
+              <a:srgbClr val="A02B93"/>
+            </a:solidFill>
+            <a:prstDash val="solid"/>
+          </a:ln>
+        </p:spPr>
+        <p:txBody>
+          <a:bodyPr xmlns:a="http://schemas.openxmlformats.org/drawingml/2006/main" lIns="47625" tIns="47625" rIns="47625" bIns="47625" anchor="ctr">
+            <a:normAutofit fontScale="100000"/>
+          </a:bodyPr>
+          <a:lstStyle xmlns:a="http://schemas.openxmlformats.org/drawingml/2006/main"/>
+          <a:p xmlns:a="http://schemas.openxmlformats.org/drawingml/2006/main">
+            <a:pPr algn="ctr">
+              <a:defRPr sz="1350" b="1">
+                <a:solidFill>
+                  <a:srgbClr val="A02B93"/>
+                </a:solidFill>
+                <a:latin typeface="Aptos"/>
+                <a:ea typeface="Aptos"/>
+                <a:cs typeface="Aptos"/>
+              </a:defRPr>
+            </a:pPr>
+            <a:r>
+              <a:rPr sz="1350" b="1">
+                <a:solidFill>
+                  <a:srgbClr val="A02B93"/>
+                </a:solidFill>
+                <a:latin typeface="Aptos"/>
+                <a:ea typeface="Aptos"/>
+                <a:cs typeface="Aptos"/>
+              </a:rPr>
+              <a:t>Replica 3</a:t>
+            </a:r>
+          </a:p>
+          <a:p xmlns:a="http://schemas.openxmlformats.org/drawingml/2006/main">
+            <a:pPr algn="ctr">
+              <a:defRPr sz="1350" b="1">
+                <a:solidFill>
+                  <a:srgbClr val="A02B93"/>
+                </a:solidFill>
+                <a:latin typeface="Aptos"/>
+                <a:ea typeface="Aptos"/>
+                <a:cs typeface="Aptos"/>
+              </a:defRPr>
+            </a:pPr>
+            <a:r>
+              <a:rPr sz="1350" b="1">
+                <a:solidFill>
+                  <a:srgbClr val="A02B93"/>
+                </a:solidFill>
+                <a:latin typeface="Aptos"/>
+                <a:ea typeface="Aptos"/>
+                <a:cs typeface="Aptos"/>
+              </a:rPr>
+              <a:t>x = A</a:t>
+            </a:r>
+          </a:p>
+        </p:txBody>
+      </p:sp>
+      <p:cxnSp>
+        <p:nvCxnSpPr>
+          <p:cNvPr id="76" name=""/>
+          <p:cNvCxnSpPr>
+            <a:stCxn xmlns:a="http://schemas.openxmlformats.org/drawingml/2006/main" id="50" idx="2"/>
+            <a:endCxn xmlns:a="http://schemas.openxmlformats.org/drawingml/2006/main" id="51" idx="0"/>
+          </p:cNvCxnSpPr>
+          <p:nvPr/>
+        </p:nvCxnSpPr>
+        <p:spPr>
+          <a:xfrm xmlns:a="http://schemas.openxmlformats.org/drawingml/2006/main" flipH="1">
+            <a:off x="1247775" y="2028825"/>
+            <a:ext cx="2200275" cy="238125"/>
+          </a:xfrm>
+          <a:prstGeom xmlns:a="http://schemas.openxmlformats.org/drawingml/2006/main" prst="straightConnector1">
+            <a:avLst/>
+          </a:prstGeom>
+          <a:ln xmlns:a="http://schemas.openxmlformats.org/drawingml/2006/main" w="19050">
+            <a:solidFill>
+              <a:srgbClr val="5B6573"/>
+            </a:solidFill>
+            <a:prstDash val="solid"/>
+            <a:tailEnd type="triangle" w="sm" len="sm"/>
+          </a:ln>
+        </p:spPr>
+      </p:cxnSp>
+      <p:cxnSp>
+        <p:nvCxnSpPr>
+          <p:cNvPr id="77" name=""/>
+          <p:cNvCxnSpPr>
+            <a:stCxn xmlns:a="http://schemas.openxmlformats.org/drawingml/2006/main" id="50" idx="2"/>
+            <a:endCxn xmlns:a="http://schemas.openxmlformats.org/drawingml/2006/main" id="52" idx="0"/>
+          </p:cNvCxnSpPr>
+          <p:nvPr/>
+        </p:nvCxnSpPr>
+        <p:spPr>
+          <a:xfrm xmlns:a="http://schemas.openxmlformats.org/drawingml/2006/main">
+            <a:off x="3448050" y="2028825"/>
+            <a:ext cx="0" cy="238125"/>
+          </a:xfrm>
+          <a:prstGeom xmlns:a="http://schemas.openxmlformats.org/drawingml/2006/main" prst="straightConnector1">
+            <a:avLst/>
+          </a:prstGeom>
+          <a:ln xmlns:a="http://schemas.openxmlformats.org/drawingml/2006/main" w="19050">
+            <a:solidFill>
+              <a:srgbClr val="5B6573"/>
+            </a:solidFill>
+            <a:prstDash val="solid"/>
+            <a:tailEnd type="triangle" w="sm" len="sm"/>
+          </a:ln>
+        </p:spPr>
+      </p:cxnSp>
+      <p:cxnSp>
+        <p:nvCxnSpPr>
+          <p:cNvPr id="78" name=""/>
+          <p:cNvCxnSpPr>
+            <a:stCxn xmlns:a="http://schemas.openxmlformats.org/drawingml/2006/main" id="50" idx="2"/>
+            <a:endCxn xmlns:a="http://schemas.openxmlformats.org/drawingml/2006/main" id="53" idx="0"/>
+          </p:cNvCxnSpPr>
+          <p:nvPr/>
+        </p:nvCxnSpPr>
+        <p:spPr>
+          <a:xfrm xmlns:a="http://schemas.openxmlformats.org/drawingml/2006/main">
+            <a:off x="3448050" y="2028825"/>
+            <a:ext cx="2200275" cy="238125"/>
+          </a:xfrm>
+          <a:prstGeom xmlns:a="http://schemas.openxmlformats.org/drawingml/2006/main" prst="straightConnector1">
+            <a:avLst/>
+          </a:prstGeom>
+          <a:ln xmlns:a="http://schemas.openxmlformats.org/drawingml/2006/main" w="19050">
+            <a:solidFill>
+              <a:srgbClr val="A02B93"/>
+            </a:solidFill>
+            <a:prstDash val="dash"/>
+            <a:tailEnd type="triangle" w="sm" len="sm"/>
+          </a:ln>
+        </p:spPr>
+      </p:cxnSp>
+      <p:sp>
+        <p:nvSpPr>
+          <p:cNvPr id="57" name="Stale copy label">
+            <a:extLst xmlns:a="http://schemas.openxmlformats.org/drawingml/2006/main">
+              <a:ext uri="{FF2B5EF4-FFF2-40B4-BE49-F238E27FC236}">
+                <a16:creationId xmlns:a16="http://schemas.microsoft.com/office/drawing/2014/main" id="{8E2343DF-2BB9-401F-B950-594DD72F33BC}"/>
+              </a:ext>
+            </a:extLst>
+          </p:cNvPr>
+          <p:cNvSpPr>
+            <a:spLocks xmlns:a="http://schemas.openxmlformats.org/drawingml/2006/main" noGrp="1"/>
+          </p:cNvSpPr>
+          <p:nvPr/>
+        </p:nvSpPr>
+        <p:spPr>
+          <a:xfrm xmlns:a="http://schemas.openxmlformats.org/drawingml/2006/main">
+            <a:off x="5000625" y="2971800"/>
+            <a:ext cx="1295400" cy="257175"/>
+          </a:xfrm>
+          <a:prstGeom xmlns:a="http://schemas.openxmlformats.org/drawingml/2006/main" prst="rect">
+            <a:avLst/>
+          </a:prstGeom>
+          <a:noFill xmlns:a="http://schemas.openxmlformats.org/drawingml/2006/main"/>
+          <a:ln xmlns:a="http://schemas.openxmlformats.org/drawingml/2006/main" w="0">
+            <a:noFill/>
+          </a:ln>
+        </p:spPr>
+        <p:txBody>
+          <a:bodyPr xmlns:a="http://schemas.openxmlformats.org/drawingml/2006/main">
+            <a:normAutofit fontScale="76316"/>
+          </a:bodyPr>
+          <a:lstStyle xmlns:a="http://schemas.openxmlformats.org/drawingml/2006/main"/>
+          <a:p xmlns:a="http://schemas.openxmlformats.org/drawingml/2006/main">
+            <a:pPr algn="ctr">
+              <a:defRPr sz="1425" b="1">
+                <a:solidFill>
+                  <a:srgbClr val="A02B93"/>
+                </a:solidFill>
+                <a:latin typeface="Aptos"/>
+                <a:ea typeface="Aptos"/>
+                <a:cs typeface="Aptos"/>
+              </a:defRPr>
+            </a:pPr>
+            <a:r>
+              <a:rPr sz="1425" b="1">
+                <a:solidFill>
+                  <a:srgbClr val="A02B93"/>
+                </a:solidFill>
+                <a:latin typeface="Aptos"/>
+                <a:ea typeface="Aptos"/>
+                <a:cs typeface="Aptos"/>
+              </a:rPr>
+              <a:t>stale copy</a:t>
+            </a:r>
+          </a:p>
+        </p:txBody>
+      </p:sp>
+      <p:sp>
+        <p:nvSpPr>
+          <p:cNvPr id="58" name="Diagram divider">
+            <a:extLst xmlns:a="http://schemas.openxmlformats.org/drawingml/2006/main">
+              <a:ext uri="{FF2B5EF4-FFF2-40B4-BE49-F238E27FC236}">
+                <a16:creationId xmlns:a16="http://schemas.microsoft.com/office/drawing/2014/main" id="{F5D6858F-3BE5-4C9A-98FD-301B4CE6E4D8}"/>
+              </a:ext>
+            </a:extLst>
+          </p:cNvPr>
+          <p:cNvSpPr>
+            <a:spLocks xmlns:a="http://schemas.openxmlformats.org/drawingml/2006/main" noGrp="1"/>
+          </p:cNvSpPr>
+          <p:nvPr/>
+        </p:nvSpPr>
+        <p:spPr>
+          <a:xfrm xmlns:a="http://schemas.openxmlformats.org/drawingml/2006/main">
+            <a:off x="409575" y="3352800"/>
+            <a:ext cx="6334125" cy="0"/>
+          </a:xfrm>
+          <a:prstGeom xmlns:a="http://schemas.openxmlformats.org/drawingml/2006/main" prst="line">
+            <a:avLst/>
+          </a:prstGeom>
+          <a:noFill xmlns:a="http://schemas.openxmlformats.org/drawingml/2006/main"/>
+          <a:ln xmlns:a="http://schemas.openxmlformats.org/drawingml/2006/main" w="9525">
+            <a:solidFill>
+              <a:srgbClr val="C9D1D9"/>
+            </a:solidFill>
+            <a:prstDash val="solid"/>
+          </a:ln>
+        </p:spPr>
+      </p:sp>
+      <p:sp>
+        <p:nvSpPr>
+          <p:cNvPr id="59" name="Coordination heading">
+            <a:extLst xmlns:a="http://schemas.openxmlformats.org/drawingml/2006/main">
+              <a:ext uri="{FF2B5EF4-FFF2-40B4-BE49-F238E27FC236}">
+                <a16:creationId xmlns:a16="http://schemas.microsoft.com/office/drawing/2014/main" id="{A3E49605-0D7A-41CB-AFA0-72806CB22D49}"/>
+              </a:ext>
+            </a:extLst>
+          </p:cNvPr>
+          <p:cNvSpPr>
+            <a:spLocks xmlns:a="http://schemas.openxmlformats.org/drawingml/2006/main" noGrp="1"/>
+          </p:cNvSpPr>
+          <p:nvPr/>
+        </p:nvSpPr>
+        <p:spPr>
+          <a:xfrm xmlns:a="http://schemas.openxmlformats.org/drawingml/2006/main">
+            <a:off x="409575" y="3514725"/>
+            <a:ext cx="6429375" cy="323850"/>
+          </a:xfrm>
+          <a:prstGeom xmlns:a="http://schemas.openxmlformats.org/drawingml/2006/main" prst="rect">
+            <a:avLst/>
+          </a:prstGeom>
+          <a:noFill xmlns:a="http://schemas.openxmlformats.org/drawingml/2006/main"/>
+          <a:ln xmlns:a="http://schemas.openxmlformats.org/drawingml/2006/main" w="0">
+            <a:noFill/>
+          </a:ln>
+        </p:spPr>
+        <p:txBody>
+          <a:bodyPr xmlns:a="http://schemas.openxmlformats.org/drawingml/2006/main">
+            <a:normAutofit fontScale="88406"/>
+          </a:bodyPr>
+          <a:lstStyle xmlns:a="http://schemas.openxmlformats.org/drawingml/2006/main"/>
+          <a:p xmlns:a="http://schemas.openxmlformats.org/drawingml/2006/main">
+            <a:pPr>
+              <a:defRPr sz="1725" b="1">
+                <a:solidFill>
+                  <a:srgbClr val="0E2841"/>
+                </a:solidFill>
+                <a:latin typeface="Aptos"/>
+                <a:ea typeface="Aptos"/>
+                <a:cs typeface="Aptos"/>
+              </a:defRPr>
+            </a:pPr>
+            <a:r>
+              <a:rPr sz="1725" b="1">
+                <a:solidFill>
+                  <a:srgbClr val="0E2841"/>
+                </a:solidFill>
+                <a:latin typeface="Aptos"/>
+                <a:ea typeface="Aptos"/>
+                <a:cs typeface="Aptos"/>
+              </a:rPr>
+              <a:t>Stronger consistency makes replicas coordinate</a:t>
+            </a:r>
+          </a:p>
+        </p:txBody>
+      </p:sp>
+      <p:sp>
+        <p:nvSpPr>
+          <p:cNvPr id="60" name="Consistent replica 1">
+            <a:extLst xmlns:a="http://schemas.openxmlformats.org/drawingml/2006/main">
+              <a:ext uri="{FF2B5EF4-FFF2-40B4-BE49-F238E27FC236}">
+                <a16:creationId xmlns:a16="http://schemas.microsoft.com/office/drawing/2014/main" id="{038D7E5E-8B95-4F93-B217-322D71EE6C6C}"/>
+              </a:ext>
+            </a:extLst>
+          </p:cNvPr>
+          <p:cNvSpPr>
+            <a:spLocks xmlns:a="http://schemas.openxmlformats.org/drawingml/2006/main" noGrp="1"/>
+          </p:cNvSpPr>
+          <p:nvPr/>
+        </p:nvSpPr>
+        <p:spPr>
+          <a:xfrm xmlns:a="http://schemas.openxmlformats.org/drawingml/2006/main">
+            <a:off x="523875" y="4095750"/>
+            <a:ext cx="1257300" cy="723900"/>
+          </a:xfrm>
+          <a:prstGeom xmlns:a="http://schemas.openxmlformats.org/drawingml/2006/main" prst="roundRect">
+            <a:avLst>
+              <a:gd name="adj" fmla="val 13158"/>
+            </a:avLst>
+          </a:prstGeom>
+          <a:solidFill xmlns:a="http://schemas.openxmlformats.org/drawingml/2006/main">
+            <a:srgbClr val="E8F0F5"/>
+          </a:solidFill>
+          <a:ln xmlns:a="http://schemas.openxmlformats.org/drawingml/2006/main" w="19050">
+            <a:solidFill>
+              <a:srgbClr val="0E2841"/>
+            </a:solidFill>
+            <a:prstDash val="solid"/>
+          </a:ln>
+        </p:spPr>
+        <p:txBody>
+          <a:bodyPr xmlns:a="http://schemas.openxmlformats.org/drawingml/2006/main" lIns="47625" tIns="47625" rIns="47625" bIns="47625" anchor="ctr">
+            <a:normAutofit fontScale="100000"/>
+          </a:bodyPr>
+          <a:lstStyle xmlns:a="http://schemas.openxmlformats.org/drawingml/2006/main"/>
+          <a:p xmlns:a="http://schemas.openxmlformats.org/drawingml/2006/main">
+            <a:pPr algn="ctr">
+              <a:defRPr sz="1350" b="1">
+                <a:solidFill>
+                  <a:srgbClr val="0E2841"/>
+                </a:solidFill>
+                <a:latin typeface="Aptos"/>
+                <a:ea typeface="Aptos"/>
+                <a:cs typeface="Aptos"/>
+              </a:defRPr>
+            </a:pPr>
+            <a:r>
+              <a:rPr sz="1350" b="1">
+                <a:solidFill>
+                  <a:srgbClr val="0E2841"/>
+                </a:solidFill>
+                <a:latin typeface="Aptos"/>
+                <a:ea typeface="Aptos"/>
+                <a:cs typeface="Aptos"/>
+              </a:rPr>
+              <a:t>Replica 1</a:t>
+            </a:r>
+          </a:p>
+          <a:p xmlns:a="http://schemas.openxmlformats.org/drawingml/2006/main">
+            <a:pPr algn="ctr">
+              <a:defRPr sz="1350" b="1">
+                <a:solidFill>
+                  <a:srgbClr val="0E2841"/>
+                </a:solidFill>
+                <a:latin typeface="Aptos"/>
+                <a:ea typeface="Aptos"/>
+                <a:cs typeface="Aptos"/>
+              </a:defRPr>
+            </a:pPr>
+            <a:r>
+              <a:rPr sz="1350" b="1">
+                <a:solidFill>
+                  <a:srgbClr val="0E2841"/>
+                </a:solidFill>
+                <a:latin typeface="Aptos"/>
+                <a:ea typeface="Aptos"/>
+                <a:cs typeface="Aptos"/>
+              </a:rPr>
+              <a:t>x = B</a:t>
+            </a:r>
+          </a:p>
+        </p:txBody>
+      </p:sp>
+      <p:sp>
+        <p:nvSpPr>
+          <p:cNvPr id="61" name="Consistent replica 2">
+            <a:extLst xmlns:a="http://schemas.openxmlformats.org/drawingml/2006/main">
+              <a:ext uri="{FF2B5EF4-FFF2-40B4-BE49-F238E27FC236}">
+                <a16:creationId xmlns:a16="http://schemas.microsoft.com/office/drawing/2014/main" id="{E7B20FF7-ACB2-41C6-84C8-20B1208AB980}"/>
+              </a:ext>
+            </a:extLst>
+          </p:cNvPr>
+          <p:cNvSpPr>
+            <a:spLocks xmlns:a="http://schemas.openxmlformats.org/drawingml/2006/main" noGrp="1"/>
+          </p:cNvSpPr>
+          <p:nvPr/>
+        </p:nvSpPr>
+        <p:spPr>
+          <a:xfrm xmlns:a="http://schemas.openxmlformats.org/drawingml/2006/main">
+            <a:off x="2352675" y="4095750"/>
+            <a:ext cx="1257300" cy="723900"/>
+          </a:xfrm>
+          <a:prstGeom xmlns:a="http://schemas.openxmlformats.org/drawingml/2006/main" prst="roundRect">
+            <a:avLst>
+              <a:gd name="adj" fmla="val 13158"/>
+            </a:avLst>
+          </a:prstGeom>
+          <a:solidFill xmlns:a="http://schemas.openxmlformats.org/drawingml/2006/main">
+            <a:srgbClr val="E8F0F5"/>
+          </a:solidFill>
+          <a:ln xmlns:a="http://schemas.openxmlformats.org/drawingml/2006/main" w="19050">
+            <a:solidFill>
+              <a:srgbClr val="0E2841"/>
+            </a:solidFill>
+            <a:prstDash val="solid"/>
+          </a:ln>
+        </p:spPr>
+        <p:txBody>
+          <a:bodyPr xmlns:a="http://schemas.openxmlformats.org/drawingml/2006/main" lIns="47625" tIns="47625" rIns="47625" bIns="47625" anchor="ctr">
+            <a:normAutofit fontScale="100000"/>
+          </a:bodyPr>
+          <a:lstStyle xmlns:a="http://schemas.openxmlformats.org/drawingml/2006/main"/>
+          <a:p xmlns:a="http://schemas.openxmlformats.org/drawingml/2006/main">
+            <a:pPr algn="ctr">
+              <a:defRPr sz="1350" b="1">
+                <a:solidFill>
+                  <a:srgbClr val="0E2841"/>
+                </a:solidFill>
+                <a:latin typeface="Aptos"/>
+                <a:ea typeface="Aptos"/>
+                <a:cs typeface="Aptos"/>
+              </a:defRPr>
+            </a:pPr>
+            <a:r>
+              <a:rPr sz="1350" b="1">
+                <a:solidFill>
+                  <a:srgbClr val="0E2841"/>
+                </a:solidFill>
+                <a:latin typeface="Aptos"/>
+                <a:ea typeface="Aptos"/>
+                <a:cs typeface="Aptos"/>
+              </a:rPr>
+              <a:t>Replica 2</a:t>
+            </a:r>
+          </a:p>
+          <a:p xmlns:a="http://schemas.openxmlformats.org/drawingml/2006/main">
+            <a:pPr algn="ctr">
+              <a:defRPr sz="1350" b="1">
+                <a:solidFill>
+                  <a:srgbClr val="0E2841"/>
+                </a:solidFill>
+                <a:latin typeface="Aptos"/>
+                <a:ea typeface="Aptos"/>
+                <a:cs typeface="Aptos"/>
+              </a:defRPr>
+            </a:pPr>
+            <a:r>
+              <a:rPr sz="1350" b="1">
+                <a:solidFill>
+                  <a:srgbClr val="0E2841"/>
+                </a:solidFill>
+                <a:latin typeface="Aptos"/>
+                <a:ea typeface="Aptos"/>
+                <a:cs typeface="Aptos"/>
+              </a:rPr>
+              <a:t>x = B</a:t>
+            </a:r>
+          </a:p>
+        </p:txBody>
+      </p:sp>
+      <p:sp>
+        <p:nvSpPr>
+          <p:cNvPr id="62" name="Consistent replica 3">
+            <a:extLst xmlns:a="http://schemas.openxmlformats.org/drawingml/2006/main">
+              <a:ext uri="{FF2B5EF4-FFF2-40B4-BE49-F238E27FC236}">
+                <a16:creationId xmlns:a16="http://schemas.microsoft.com/office/drawing/2014/main" id="{87044477-B397-489B-940A-AABA6864C522}"/>
+              </a:ext>
+            </a:extLst>
+          </p:cNvPr>
+          <p:cNvSpPr>
+            <a:spLocks xmlns:a="http://schemas.openxmlformats.org/drawingml/2006/main" noGrp="1"/>
+          </p:cNvSpPr>
+          <p:nvPr/>
+        </p:nvSpPr>
+        <p:spPr>
+          <a:xfrm xmlns:a="http://schemas.openxmlformats.org/drawingml/2006/main">
+            <a:off x="4181475" y="4095750"/>
+            <a:ext cx="1257300" cy="723900"/>
+          </a:xfrm>
+          <a:prstGeom xmlns:a="http://schemas.openxmlformats.org/drawingml/2006/main" prst="roundRect">
+            <a:avLst>
+              <a:gd name="adj" fmla="val 13158"/>
+            </a:avLst>
+          </a:prstGeom>
+          <a:solidFill xmlns:a="http://schemas.openxmlformats.org/drawingml/2006/main">
+            <a:srgbClr val="E8F0F5"/>
+          </a:solidFill>
+          <a:ln xmlns:a="http://schemas.openxmlformats.org/drawingml/2006/main" w="19050">
+            <a:solidFill>
+              <a:srgbClr val="0E2841"/>
+            </a:solidFill>
+            <a:prstDash val="solid"/>
+          </a:ln>
+        </p:spPr>
+        <p:txBody>
+          <a:bodyPr xmlns:a="http://schemas.openxmlformats.org/drawingml/2006/main" lIns="47625" tIns="47625" rIns="47625" bIns="47625" anchor="ctr">
+            <a:normAutofit fontScale="100000"/>
+          </a:bodyPr>
+          <a:lstStyle xmlns:a="http://schemas.openxmlformats.org/drawingml/2006/main"/>
+          <a:p xmlns:a="http://schemas.openxmlformats.org/drawingml/2006/main">
+            <a:pPr algn="ctr">
+              <a:defRPr sz="1350" b="1">
+                <a:solidFill>
+                  <a:srgbClr val="0E2841"/>
+                </a:solidFill>
+                <a:latin typeface="Aptos"/>
+                <a:ea typeface="Aptos"/>
+                <a:cs typeface="Aptos"/>
+              </a:defRPr>
+            </a:pPr>
+            <a:r>
+              <a:rPr sz="1350" b="1">
+                <a:solidFill>
+                  <a:srgbClr val="0E2841"/>
+                </a:solidFill>
+                <a:latin typeface="Aptos"/>
+                <a:ea typeface="Aptos"/>
+                <a:cs typeface="Aptos"/>
+              </a:rPr>
+              <a:t>Replica 3</a:t>
+            </a:r>
+          </a:p>
+          <a:p xmlns:a="http://schemas.openxmlformats.org/drawingml/2006/main">
+            <a:pPr algn="ctr">
+              <a:defRPr sz="1350" b="1">
+                <a:solidFill>
+                  <a:srgbClr val="0E2841"/>
+                </a:solidFill>
+                <a:latin typeface="Aptos"/>
+                <a:ea typeface="Aptos"/>
+                <a:cs typeface="Aptos"/>
+              </a:defRPr>
+            </a:pPr>
+            <a:r>
+              <a:rPr sz="1350" b="1">
+                <a:solidFill>
+                  <a:srgbClr val="0E2841"/>
+                </a:solidFill>
+                <a:latin typeface="Aptos"/>
+                <a:ea typeface="Aptos"/>
+                <a:cs typeface="Aptos"/>
+              </a:rPr>
+              <a:t>x = B</a:t>
+            </a:r>
+          </a:p>
+        </p:txBody>
+      </p:sp>
+      <p:sp>
+        <p:nvSpPr>
+          <p:cNvPr id="63" name="Wait before reply">
+            <a:extLst xmlns:a="http://schemas.openxmlformats.org/drawingml/2006/main">
+              <a:ext uri="{FF2B5EF4-FFF2-40B4-BE49-F238E27FC236}">
+                <a16:creationId xmlns:a16="http://schemas.microsoft.com/office/drawing/2014/main" id="{B0C8692A-27AE-4FA6-8FCE-A48108951AB8}"/>
+              </a:ext>
+            </a:extLst>
+          </p:cNvPr>
+          <p:cNvSpPr>
+            <a:spLocks xmlns:a="http://schemas.openxmlformats.org/drawingml/2006/main" noGrp="1"/>
+          </p:cNvSpPr>
+          <p:nvPr/>
+        </p:nvSpPr>
+        <p:spPr>
+          <a:xfrm xmlns:a="http://schemas.openxmlformats.org/drawingml/2006/main">
+            <a:off x="5915025" y="4076700"/>
+            <a:ext cx="838200" cy="762000"/>
+          </a:xfrm>
+          <a:prstGeom xmlns:a="http://schemas.openxmlformats.org/drawingml/2006/main" prst="roundRect">
+            <a:avLst>
+              <a:gd name="adj" fmla="val 12500"/>
+            </a:avLst>
+          </a:prstGeom>
+          <a:solidFill xmlns:a="http://schemas.openxmlformats.org/drawingml/2006/main">
+            <a:srgbClr val="FFFFFF"/>
+          </a:solidFill>
+          <a:ln xmlns:a="http://schemas.openxmlformats.org/drawingml/2006/main" w="28575">
+            <a:solidFill>
+              <a:srgbClr val="A02B93"/>
+            </a:solidFill>
+            <a:prstDash val="solid"/>
+          </a:ln>
+        </p:spPr>
+        <p:txBody>
+          <a:bodyPr xmlns:a="http://schemas.openxmlformats.org/drawingml/2006/main" lIns="47625" tIns="47625" rIns="47625" bIns="47625" anchor="ctr">
+            <a:normAutofit fontScale="100000"/>
+          </a:bodyPr>
+          <a:lstStyle xmlns:a="http://schemas.openxmlformats.org/drawingml/2006/main"/>
+          <a:p xmlns:a="http://schemas.openxmlformats.org/drawingml/2006/main">
+            <a:pPr algn="ctr">
+              <a:defRPr sz="1200" b="1">
+                <a:solidFill>
+                  <a:srgbClr val="A02B93"/>
+                </a:solidFill>
+                <a:latin typeface="Aptos"/>
+                <a:ea typeface="Aptos"/>
+                <a:cs typeface="Aptos"/>
+              </a:defRPr>
+            </a:pPr>
+            <a:r>
+              <a:rPr sz="1200" b="1">
+                <a:solidFill>
+                  <a:srgbClr val="A02B93"/>
+                </a:solidFill>
+                <a:latin typeface="Aptos"/>
+                <a:ea typeface="Aptos"/>
+                <a:cs typeface="Aptos"/>
+              </a:rPr>
+              <a:t>WAIT</a:t>
+            </a:r>
+          </a:p>
+          <a:p xmlns:a="http://schemas.openxmlformats.org/drawingml/2006/main">
+            <a:pPr algn="ctr">
+              <a:defRPr sz="1200" b="1">
+                <a:solidFill>
+                  <a:srgbClr val="A02B93"/>
+                </a:solidFill>
+                <a:latin typeface="Aptos"/>
+                <a:ea typeface="Aptos"/>
+                <a:cs typeface="Aptos"/>
+              </a:defRPr>
+            </a:pPr>
+            <a:r>
+              <a:rPr sz="1200" b="1">
+                <a:solidFill>
+                  <a:srgbClr val="A02B93"/>
+                </a:solidFill>
+                <a:latin typeface="Aptos"/>
+                <a:ea typeface="Aptos"/>
+                <a:cs typeface="Aptos"/>
+              </a:rPr>
+              <a:t>before reply</a:t>
+            </a:r>
+          </a:p>
+        </p:txBody>
+      </p:sp>
+      <p:cxnSp>
+        <p:nvCxnSpPr>
+          <p:cNvPr id="86" name=""/>
+          <p:cNvCxnSpPr>
+            <a:stCxn xmlns:a="http://schemas.openxmlformats.org/drawingml/2006/main" id="60" idx="3"/>
+            <a:endCxn xmlns:a="http://schemas.openxmlformats.org/drawingml/2006/main" id="61" idx="1"/>
+          </p:cNvCxnSpPr>
+          <p:nvPr/>
+        </p:nvCxnSpPr>
+        <p:spPr>
+          <a:xfrm xmlns:a="http://schemas.openxmlformats.org/drawingml/2006/main">
+            <a:off x="1781175" y="4457700"/>
+            <a:ext cx="571500" cy="0"/>
+          </a:xfrm>
+          <a:prstGeom xmlns:a="http://schemas.openxmlformats.org/drawingml/2006/main" prst="straightConnector1">
+            <a:avLst/>
+          </a:prstGeom>
+          <a:ln xmlns:a="http://schemas.openxmlformats.org/drawingml/2006/main" w="19050">
+            <a:solidFill>
+              <a:srgbClr val="5B6573"/>
+            </a:solidFill>
+            <a:prstDash val="solid"/>
+            <a:headEnd type="triangle" w="sm" len="sm"/>
+            <a:tailEnd type="triangle" w="sm" len="sm"/>
+          </a:ln>
+        </p:spPr>
+      </p:cxnSp>
+      <p:cxnSp>
+        <p:nvCxnSpPr>
+          <p:cNvPr id="87" name=""/>
+          <p:cNvCxnSpPr>
+            <a:stCxn xmlns:a="http://schemas.openxmlformats.org/drawingml/2006/main" id="61" idx="3"/>
+            <a:endCxn xmlns:a="http://schemas.openxmlformats.org/drawingml/2006/main" id="62" idx="1"/>
+          </p:cNvCxnSpPr>
+          <p:nvPr/>
+        </p:nvCxnSpPr>
+        <p:spPr>
+          <a:xfrm xmlns:a="http://schemas.openxmlformats.org/drawingml/2006/main">
+            <a:off x="3609975" y="4457700"/>
+            <a:ext cx="571500" cy="0"/>
+          </a:xfrm>
+          <a:prstGeom xmlns:a="http://schemas.openxmlformats.org/drawingml/2006/main" prst="straightConnector1">
+            <a:avLst/>
+          </a:prstGeom>
+          <a:ln xmlns:a="http://schemas.openxmlformats.org/drawingml/2006/main" w="19050">
+            <a:solidFill>
+              <a:srgbClr val="5B6573"/>
+            </a:solidFill>
+            <a:prstDash val="solid"/>
+            <a:headEnd type="triangle" w="sm" len="sm"/>
+            <a:tailEnd type="triangle" w="sm" len="sm"/>
+          </a:ln>
+        </p:spPr>
+      </p:cxnSp>
+      <p:cxnSp>
+        <p:nvCxnSpPr>
+          <p:cNvPr id="88" name=""/>
+          <p:cNvCxnSpPr>
+            <a:stCxn xmlns:a="http://schemas.openxmlformats.org/drawingml/2006/main" id="62" idx="3"/>
+            <a:endCxn xmlns:a="http://schemas.openxmlformats.org/drawingml/2006/main" id="63" idx="1"/>
+          </p:cNvCxnSpPr>
+          <p:nvPr/>
+        </p:nvCxnSpPr>
+        <p:spPr>
+          <a:xfrm xmlns:a="http://schemas.openxmlformats.org/drawingml/2006/main">
+            <a:off x="5438775" y="4457700"/>
+            <a:ext cx="476250" cy="0"/>
+          </a:xfrm>
+          <a:prstGeom xmlns:a="http://schemas.openxmlformats.org/drawingml/2006/main" prst="straightConnector1">
+            <a:avLst/>
+          </a:prstGeom>
+          <a:ln xmlns:a="http://schemas.openxmlformats.org/drawingml/2006/main" w="19050">
+            <a:solidFill>
+              <a:srgbClr val="A02B93"/>
+            </a:solidFill>
+            <a:prstDash val="solid"/>
+            <a:tailEnd type="triangle" w="sm" len="sm"/>
+          </a:ln>
+        </p:spPr>
+      </p:cxnSp>
+      <p:sp>
+        <p:nvSpPr>
+          <p:cNvPr id="67" name="Coordination cost">
+            <a:extLst xmlns:a="http://schemas.openxmlformats.org/drawingml/2006/main">
+              <a:ext uri="{FF2B5EF4-FFF2-40B4-BE49-F238E27FC236}">
+                <a16:creationId xmlns:a16="http://schemas.microsoft.com/office/drawing/2014/main" id="{F52DF72F-2902-473C-9FF3-D23AA5738F62}"/>
+              </a:ext>
+            </a:extLst>
+          </p:cNvPr>
+          <p:cNvSpPr>
+            <a:spLocks xmlns:a="http://schemas.openxmlformats.org/drawingml/2006/main" noGrp="1"/>
+          </p:cNvSpPr>
+          <p:nvPr/>
+        </p:nvSpPr>
+        <p:spPr>
+          <a:xfrm xmlns:a="http://schemas.openxmlformats.org/drawingml/2006/main">
+            <a:off x="533400" y="5105400"/>
+            <a:ext cx="6191250" cy="352425"/>
+          </a:xfrm>
+          <a:prstGeom xmlns:a="http://schemas.openxmlformats.org/drawingml/2006/main" prst="rect">
+            <a:avLst/>
+          </a:prstGeom>
+          <a:noFill xmlns:a="http://schemas.openxmlformats.org/drawingml/2006/main"/>
+          <a:ln xmlns:a="http://schemas.openxmlformats.org/drawingml/2006/main" w="0">
+            <a:noFill/>
+          </a:ln>
+        </p:spPr>
+        <p:txBody>
+          <a:bodyPr xmlns:a="http://schemas.openxmlformats.org/drawingml/2006/main">
+            <a:normAutofit fontScale="100000"/>
+          </a:bodyPr>
+          <a:lstStyle xmlns:a="http://schemas.openxmlformats.org/drawingml/2006/main"/>
+          <a:p xmlns:a="http://schemas.openxmlformats.org/drawingml/2006/main">
+            <a:pPr algn="ctr">
+              <a:defRPr sz="1650" b="1">
+                <a:solidFill>
+                  <a:srgbClr val="A02B93"/>
+                </a:solidFill>
+                <a:latin typeface="Aptos"/>
+                <a:ea typeface="Aptos"/>
+                <a:cs typeface="Aptos"/>
+              </a:defRPr>
+            </a:pPr>
+            <a:r>
+              <a:rPr sz="1650" b="1">
+                <a:solidFill>
+                  <a:srgbClr val="A02B93"/>
+                </a:solidFill>
+                <a:latin typeface="Aptos"/>
+                <a:ea typeface="Aptos"/>
+                <a:cs typeface="Aptos"/>
+              </a:rPr>
+              <a:t>extra messages + waiting  →  lower performance</a:t>
             </a:r>
           </a:p>
         </p:txBody>
@@ -31770,283 +31021,6 @@
       </p:ext>
     </p:extLst>
   </p:cSld>
-  <p:clrMapOvr>
-    <a:masterClrMapping/>
-  </p:clrMapOvr>
-  <p:timing>
-    <p:tnLst>
-      <p:par>
-        <p:cTn id="1" dur="indefinite" restart="never" nodeType="tmRoot">
-          <p:childTnLst>
-            <p:seq concurrent="1" nextAc="seek">
-              <p:cTn id="2" dur="indefinite" nodeType="mainSeq">
-                <p:childTnLst>
-                  <p:par>
-                    <p:cTn id="3" fill="hold">
-                      <p:stCondLst>
-                        <p:cond delay="indefinite"/>
-                      </p:stCondLst>
-                      <p:childTnLst>
-                        <p:par>
-                          <p:cTn id="4" fill="hold">
-                            <p:stCondLst>
-                              <p:cond delay="0"/>
-                            </p:stCondLst>
-                            <p:childTnLst>
-                              <p:par>
-                                <p:cTn id="5" presetID="9" presetClass="entr" presetSubtype="0" fill="hold" nodeType="clickEffect">
-                                  <p:stCondLst>
-                                    <p:cond delay="0"/>
-                                  </p:stCondLst>
-                                  <p:childTnLst>
-                                    <p:set>
-                                      <p:cBhvr>
-                                        <p:cTn id="6" dur="1" fill="hold">
-                                          <p:stCondLst>
-                                            <p:cond delay="0"/>
-                                          </p:stCondLst>
-                                        </p:cTn>
-                                        <p:tgtEl>
-                                          <p:spTgt spid="48">
-                                            <p:txEl>
-                                              <p:pRg st="2" end="2"/>
-                                            </p:txEl>
-                                          </p:spTgt>
-                                        </p:tgtEl>
-                                        <p:attrNameLst>
-                                          <p:attrName>style.visibility</p:attrName>
-                                        </p:attrNameLst>
-                                      </p:cBhvr>
-                                      <p:to>
-                                        <p:strVal val="visible"/>
-                                      </p:to>
-                                    </p:set>
-                                    <p:animEffect transition="in" filter="dissolve">
-                                      <p:cBhvr>
-                                        <p:cTn id="7" dur="500"/>
-                                        <p:tgtEl>
-                                          <p:spTgt spid="48">
-                                            <p:txEl>
-                                              <p:pRg st="2" end="2"/>
-                                            </p:txEl>
-                                          </p:spTgt>
-                                        </p:tgtEl>
-                                      </p:cBhvr>
-                                    </p:animEffect>
-                                  </p:childTnLst>
-                                </p:cTn>
-                              </p:par>
-                            </p:childTnLst>
-                          </p:cTn>
-                        </p:par>
-                      </p:childTnLst>
-                    </p:cTn>
-                  </p:par>
-                  <p:par>
-                    <p:cTn id="8" fill="hold">
-                      <p:stCondLst>
-                        <p:cond delay="indefinite"/>
-                      </p:stCondLst>
-                      <p:childTnLst>
-                        <p:par>
-                          <p:cTn id="9" fill="hold">
-                            <p:stCondLst>
-                              <p:cond delay="0"/>
-                            </p:stCondLst>
-                            <p:childTnLst>
-                              <p:par>
-                                <p:cTn id="10" presetID="9" presetClass="entr" presetSubtype="0" fill="hold" nodeType="clickEffect">
-                                  <p:stCondLst>
-                                    <p:cond delay="0"/>
-                                  </p:stCondLst>
-                                  <p:childTnLst>
-                                    <p:set>
-                                      <p:cBhvr>
-                                        <p:cTn id="11" dur="1" fill="hold">
-                                          <p:stCondLst>
-                                            <p:cond delay="0"/>
-                                          </p:stCondLst>
-                                        </p:cTn>
-                                        <p:tgtEl>
-                                          <p:spTgt spid="48">
-                                            <p:txEl>
-                                              <p:pRg st="4" end="4"/>
-                                            </p:txEl>
-                                          </p:spTgt>
-                                        </p:tgtEl>
-                                        <p:attrNameLst>
-                                          <p:attrName>style.visibility</p:attrName>
-                                        </p:attrNameLst>
-                                      </p:cBhvr>
-                                      <p:to>
-                                        <p:strVal val="visible"/>
-                                      </p:to>
-                                    </p:set>
-                                    <p:animEffect transition="in" filter="dissolve">
-                                      <p:cBhvr>
-                                        <p:cTn id="12" dur="500"/>
-                                        <p:tgtEl>
-                                          <p:spTgt spid="48">
-                                            <p:txEl>
-                                              <p:pRg st="4" end="4"/>
-                                            </p:txEl>
-                                          </p:spTgt>
-                                        </p:tgtEl>
-                                      </p:cBhvr>
-                                    </p:animEffect>
-                                  </p:childTnLst>
-                                </p:cTn>
-                              </p:par>
-                            </p:childTnLst>
-                          </p:cTn>
-                        </p:par>
-                      </p:childTnLst>
-                    </p:cTn>
-                  </p:par>
-                  <p:par>
-                    <p:cTn id="13" fill="hold">
-                      <p:stCondLst>
-                        <p:cond delay="indefinite"/>
-                      </p:stCondLst>
-                      <p:childTnLst>
-                        <p:par>
-                          <p:cTn id="14" fill="hold">
-                            <p:stCondLst>
-                              <p:cond delay="0"/>
-                            </p:stCondLst>
-                            <p:childTnLst>
-                              <p:par>
-                                <p:cTn id="15" presetID="9" presetClass="entr" presetSubtype="0" fill="hold" nodeType="clickEffect">
-                                  <p:stCondLst>
-                                    <p:cond delay="0"/>
-                                  </p:stCondLst>
-                                  <p:childTnLst>
-                                    <p:set>
-                                      <p:cBhvr>
-                                        <p:cTn id="16" dur="1" fill="hold">
-                                          <p:stCondLst>
-                                            <p:cond delay="0"/>
-                                          </p:stCondLst>
-                                        </p:cTn>
-                                        <p:tgtEl>
-                                          <p:spTgt spid="48">
-                                            <p:txEl>
-                                              <p:pRg st="6" end="6"/>
-                                            </p:txEl>
-                                          </p:spTgt>
-                                        </p:tgtEl>
-                                        <p:attrNameLst>
-                                          <p:attrName>style.visibility</p:attrName>
-                                        </p:attrNameLst>
-                                      </p:cBhvr>
-                                      <p:to>
-                                        <p:strVal val="visible"/>
-                                      </p:to>
-                                    </p:set>
-                                    <p:animEffect transition="in" filter="dissolve">
-                                      <p:cBhvr>
-                                        <p:cTn id="17" dur="500"/>
-                                        <p:tgtEl>
-                                          <p:spTgt spid="48">
-                                            <p:txEl>
-                                              <p:pRg st="6" end="6"/>
-                                            </p:txEl>
-                                          </p:spTgt>
-                                        </p:tgtEl>
-                                      </p:cBhvr>
-                                    </p:animEffect>
-                                  </p:childTnLst>
-                                </p:cTn>
-                              </p:par>
-                            </p:childTnLst>
-                          </p:cTn>
-                        </p:par>
-                      </p:childTnLst>
-                    </p:cTn>
-                  </p:par>
-                  <p:par>
-                    <p:cTn id="18" fill="hold">
-                      <p:stCondLst>
-                        <p:cond delay="indefinite"/>
-                      </p:stCondLst>
-                      <p:childTnLst>
-                        <p:par>
-                          <p:cTn id="19" fill="hold">
-                            <p:stCondLst>
-                              <p:cond delay="0"/>
-                            </p:stCondLst>
-                            <p:childTnLst>
-                              <p:par>
-                                <p:cTn id="20" presetID="9" presetClass="entr" presetSubtype="0" fill="hold" nodeType="clickEffect">
-                                  <p:stCondLst>
-                                    <p:cond delay="0"/>
-                                  </p:stCondLst>
-                                  <p:childTnLst>
-                                    <p:set>
-                                      <p:cBhvr>
-                                        <p:cTn id="21" dur="1" fill="hold">
-                                          <p:stCondLst>
-                                            <p:cond delay="0"/>
-                                          </p:stCondLst>
-                                        </p:cTn>
-                                        <p:tgtEl>
-                                          <p:spTgt spid="48">
-                                            <p:txEl>
-                                              <p:pRg st="8" end="8"/>
-                                            </p:txEl>
-                                          </p:spTgt>
-                                        </p:tgtEl>
-                                        <p:attrNameLst>
-                                          <p:attrName>style.visibility</p:attrName>
-                                        </p:attrNameLst>
-                                      </p:cBhvr>
-                                      <p:to>
-                                        <p:strVal val="visible"/>
-                                      </p:to>
-                                    </p:set>
-                                    <p:animEffect transition="in" filter="dissolve">
-                                      <p:cBhvr>
-                                        <p:cTn id="22" dur="500"/>
-                                        <p:tgtEl>
-                                          <p:spTgt spid="48">
-                                            <p:txEl>
-                                              <p:pRg st="8" end="8"/>
-                                            </p:txEl>
-                                          </p:spTgt>
-                                        </p:tgtEl>
-                                      </p:cBhvr>
-                                    </p:animEffect>
-                                  </p:childTnLst>
-                                </p:cTn>
-                              </p:par>
-                            </p:childTnLst>
-                          </p:cTn>
-                        </p:par>
-                      </p:childTnLst>
-                    </p:cTn>
-                  </p:par>
-                </p:childTnLst>
-              </p:cTn>
-              <p:prevCondLst>
-                <p:cond evt="onPrev" delay="0">
-                  <p:tgtEl>
-                    <p:sldTgt/>
-                  </p:tgtEl>
-                </p:cond>
-              </p:prevCondLst>
-              <p:nextCondLst>
-                <p:cond evt="onNext" delay="0">
-                  <p:tgtEl>
-                    <p:sldTgt/>
-                  </p:tgtEl>
-                </p:cond>
-              </p:nextCondLst>
-            </p:seq>
-          </p:childTnLst>
-        </p:cTn>
-      </p:par>
-    </p:tnLst>
-  </p:timing>
 </p:sld>
 </file>
 

</xml_diff>

<commit_message>
Add MIT storage themes to GFS introduction
</commit_message>
<xml_diff>
--- a/slides/fall26/4-gfs.pptx
+++ b/slides/fall26/4-gfs.pptx
@@ -18,8 +18,10 @@
     <p:sldId id="428" r:id="rId9"/>
     <p:sldId id="483" r:id="rId10"/>
     <p:sldId id="443" r:id="rId11"/>
+    <p:sldId id="486" r:id="rId60"/>
     <p:sldId id="444" r:id="rId12"/>
     <p:sldId id="445" r:id="rId13"/>
+    <p:sldId id="485" r:id="rId59"/>
     <p:sldId id="262" r:id="rId14"/>
     <p:sldId id="430" r:id="rId15"/>
     <p:sldId id="435" r:id="rId16"/>
@@ -8325,33 +8327,25 @@
           <a:lstStyle/>
           <a:p>
             <a:r>
-              <a:rPr dirty="0"/>
+              <a:rPr lang="en-US" dirty="0"/>
               <a:t>Last time we focused on computation, but every map task had to read its input from somewhere, and every reducer had to write its output somewhere. At Google, that shared storage layer was GFS.</a:t>
             </a:r>
           </a:p>
           <a:p>
-            <a:endParaRPr dirty="0"/>
-          </a:p>
-          <a:p>
-            <a:r>
-              <a:rPr dirty="0"/>
-              <a:t>Storage became a key abstraction because a simple interface—name some data, read it, and write it—was general enough to support many different systems. MapReduce used GFS for input and output files. </a:t>
-            </a:r>
-            <a:r>
-              <a:rPr dirty="0" err="1"/>
-              <a:t>BigTable</a:t>
-            </a:r>
-            <a:r>
-              <a:rPr dirty="0"/>
-              <a:t> later stored its table data in GFS as well. If the storage layer handles scale and failures, every system above it becomes easier to build.</a:t>
-            </a:r>
-          </a:p>
-          <a:p>
-            <a:endParaRPr dirty="0"/>
-          </a:p>
-          <a:p>
-            <a:r>
-              <a:rPr dirty="0"/>
+            <a:endParaRPr lang="en-US" dirty="0"/>
+          </a:p>
+          <a:p>
+            <a:r>
+              <a:rPr lang="en-US" dirty="0"/>
+              <a:t>Storage became a key abstraction because a simple interface—name some data, read it, and write it—was useful across many different systems. A large part of distributed-systems work therefore either builds storage systems or builds on top of a well-behaved distributed store. At Google, MapReduce used GFS for input and output, and BigTable later stored its files in GFS. GFS is also a useful first case study because it brings together four themes we will see repeatedly: parallel performance, fault tolerance, replication, and consistency.</a:t>
+            </a:r>
+          </a:p>
+          <a:p>
+            <a:endParaRPr lang="en-US" dirty="0"/>
+          </a:p>
+          <a:p>
+            <a:r>
+              <a:rPr lang="en-US" dirty="0"/>
               <a:t>Two pressures drive the design: one machine cannot provide enough capacity or throughput, and once data is spread across many machines, failures become routine.</a:t>
             </a:r>
           </a:p>
@@ -8633,6 +8627,330 @@
     <p:extLst>
       <p:ext uri="{BB962C8B-B14F-4D97-AF65-F5344CB8AC3E}">
         <p14:creationId xmlns:p14="http://schemas.microsoft.com/office/powerpoint/2010/main" val="3000447971"/>
+      </p:ext>
+    </p:extLst>
+  </p:cSld>
+  <p:clrMapOvr>
+    <a:masterClrMapping/>
+  </p:clrMapOvr>
+</p:notes>
+</file>
+
+<file path=ppt/notesSlides/notesSlide52.xml><?xml version="1.0" encoding="utf-8"?>
+<p:notes xmlns:a="http://schemas.openxmlformats.org/drawingml/2006/main" xmlns:r="http://schemas.openxmlformats.org/officeDocument/2006/relationships" xmlns:p="http://schemas.openxmlformats.org/presentationml/2006/main">
+  <p:cSld>
+    <p:spTree>
+      <p:nvGrpSpPr>
+        <p:cNvPr id="1" name="">
+          <a:extLst>
+            <a:ext uri="{FF2B5EF4-FFF2-40B4-BE49-F238E27FC236}">
+              <a16:creationId xmlns:a16="http://schemas.microsoft.com/office/drawing/2014/main" id="{4FD57F6F-974F-F53C-ED3C-4EABC142FAE9}"/>
+            </a:ext>
+          </a:extLst>
+        </p:cNvPr>
+        <p:cNvGrpSpPr/>
+        <p:nvPr/>
+      </p:nvGrpSpPr>
+      <p:grpSpPr>
+        <a:xfrm>
+          <a:off x="0" y="0"/>
+          <a:ext cx="0" cy="0"/>
+          <a:chOff x="0" y="0"/>
+          <a:chExt cx="0" cy="0"/>
+        </a:xfrm>
+      </p:grpSpPr>
+      <p:sp>
+        <p:nvSpPr>
+          <p:cNvPr id="2" name="Slide Image Placeholder 1">
+            <a:extLst>
+              <a:ext uri="{FF2B5EF4-FFF2-40B4-BE49-F238E27FC236}">
+                <a16:creationId xmlns:a16="http://schemas.microsoft.com/office/drawing/2014/main" id="{D27769DE-EE2B-CDF0-B3A8-4860B154D68E}"/>
+              </a:ext>
+            </a:extLst>
+          </p:cNvPr>
+          <p:cNvSpPr>
+            <a:spLocks noGrp="1" noRot="1" noChangeAspect="1"/>
+          </p:cNvSpPr>
+          <p:nvPr>
+            <p:ph type="sldImg"/>
+          </p:nvPr>
+        </p:nvSpPr>
+        <p:spPr/>
+      </p:sp>
+      <p:sp>
+        <p:nvSpPr>
+          <p:cNvPr id="3" name="Notes Placeholder 2">
+            <a:extLst>
+              <a:ext uri="{FF2B5EF4-FFF2-40B4-BE49-F238E27FC236}">
+                <a16:creationId xmlns:a16="http://schemas.microsoft.com/office/drawing/2014/main" id="{DCB13888-86BD-70E9-CE9B-FF85C31CFD9A}"/>
+              </a:ext>
+            </a:extLst>
+          </p:cNvPr>
+          <p:cNvSpPr>
+            <a:spLocks noGrp="1"/>
+          </p:cNvSpPr>
+          <p:nvPr>
+            <p:ph type="body" idx="1"/>
+          </p:nvPr>
+        </p:nvSpPr>
+        <p:spPr/>
+        <p:txBody>
+          <a:bodyPr/>
+          <a:lstStyle/>
+          <a:p>
+            <a:r>
+              <a:rPr lang="en-US" dirty="0"/>
+              <a:t>This slide is the bridge from the broken design to the paper.</a:t>
+            </a:r>
+          </a:p>
+          <a:p>
+            <a:r>
+              <a:rPr lang="en-US" dirty="0"/>
+              <a:t>The design on the previous slides failed for one reason: no component decided the order in which the replicas applied the writes. Every possible repair has to supply that missing decision.</a:t>
+            </a:r>
+          </a:p>
+          <a:p>
+            <a:r>
+              <a:rPr lang="en-US" dirty="0"/>
+              <a:t>Supplying it costs something. The servers have to exchange more messages, the protocol becomes more complicated, and a write cannot be reported as finished until the replicas have agreed. That waiting is the performance price, and it is the answer to the second question on the Two Questions slide.</a:t>
+            </a:r>
+          </a:p>
+          <a:p>
+            <a:r>
+              <a:rPr lang="en-US" dirty="0"/>
+              <a:t>Because the price is real, there is no single answer. There is a range of designs offering different strengths of guarantee, and a matching range of anomalies that people are willing to live with.</a:t>
+            </a:r>
+          </a:p>
+          <a:p>
+            <a:r>
+              <a:rPr lang="en-US" dirty="0"/>
+              <a:t>GFS sits at a deliberate point on that range: much better than the design we just took apart, and knowingly not perfect. Where exactly it sits, and why Google was willing to accept that, is the rest of the lecture.</a:t>
+            </a:r>
+          </a:p>
+          <a:p>
+            <a:r>
+              <a:rPr lang="en-US" dirty="0"/>
+              <a:t>Do not give the mechanism here. Leases, a primary, and how the primary orders mutations come later; at this point the class only needs to know that a fix exists and that it is paid for.</a:t>
+            </a:r>
+          </a:p>
+          <a:p>
+            <a:r>
+              <a:rPr lang="en-US" dirty="0"/>
+              <a:t>SOURCE</a:t>
+            </a:r>
+          </a:p>
+          <a:p>
+            <a:r>
+              <a:rPr lang="en-US" dirty="0"/>
+              <a:t>MIT 6.824, Spring 2020, Lecture 3 video, 14:07-15:00.</a:t>
+            </a:r>
+          </a:p>
+          <a:p>
+            <a:r>
+              <a:rPr lang="en-US" dirty="0"/>
+              <a:t>https://www.youtube.com/watch?v=EpIgvowZr00</a:t>
+            </a:r>
+          </a:p>
+          <a:p>
+            <a:r>
+              <a:rPr lang="en-US" dirty="0"/>
+              <a:t>Local transcript: fall2026/lectures/references/mit-6824-2020-lecture3-gfs-transcript.txt</a:t>
+            </a:r>
+          </a:p>
+        </p:txBody>
+      </p:sp>
+      <p:sp>
+        <p:nvSpPr>
+          <p:cNvPr id="4" name="Slide Number Placeholder 3">
+            <a:extLst>
+              <a:ext uri="{FF2B5EF4-FFF2-40B4-BE49-F238E27FC236}">
+                <a16:creationId xmlns:a16="http://schemas.microsoft.com/office/drawing/2014/main" id="{B1960F15-BADC-8306-DE62-2CD20BDF9BC7}"/>
+              </a:ext>
+            </a:extLst>
+          </p:cNvPr>
+          <p:cNvSpPr>
+            <a:spLocks noGrp="1"/>
+          </p:cNvSpPr>
+          <p:nvPr>
+            <p:ph type="sldNum" sz="quarter" idx="5"/>
+          </p:nvPr>
+        </p:nvSpPr>
+        <p:spPr/>
+        <p:txBody>
+          <a:bodyPr/>
+          <a:lstStyle/>
+          <a:p>
+            <a:fld id="{1C9584DC-3658-4054-9DA4-7B68A1D8CC6D}" type="slidenum">
+              <a:rPr lang="zh-CN" altLang="en-US" smtClean="0"/>
+              <a:t>12</a:t>
+            </a:fld>
+            <a:endParaRPr lang="zh-CN" altLang="en-US"/>
+          </a:p>
+        </p:txBody>
+      </p:sp>
+    </p:spTree>
+    <p:extLst>
+      <p:ext uri="{BB962C8B-B14F-4D97-AF65-F5344CB8AC3E}">
+        <p14:creationId xmlns:p14="http://schemas.microsoft.com/office/powerpoint/2010/main" val="2004993241"/>
+      </p:ext>
+    </p:extLst>
+  </p:cSld>
+  <p:clrMapOvr>
+    <a:masterClrMapping/>
+  </p:clrMapOvr>
+</p:notes>
+</file>
+
+<file path=ppt/notesSlides/notesSlide53.xml><?xml version="1.0" encoding="utf-8"?>
+<p:notes xmlns:a="http://schemas.openxmlformats.org/drawingml/2006/main" xmlns:r="http://schemas.openxmlformats.org/officeDocument/2006/relationships" xmlns:p="http://schemas.openxmlformats.org/presentationml/2006/main">
+  <p:cSld>
+    <p:spTree>
+      <p:nvGrpSpPr>
+        <p:cNvPr id="1" name="">
+          <a:extLst>
+            <a:ext uri="{FF2B5EF4-FFF2-40B4-BE49-F238E27FC236}">
+              <a16:creationId xmlns:a16="http://schemas.microsoft.com/office/drawing/2014/main" id="{4FD57F6F-974F-F53C-ED3C-4EABC142FAE9}"/>
+            </a:ext>
+          </a:extLst>
+        </p:cNvPr>
+        <p:cNvGrpSpPr/>
+        <p:nvPr/>
+      </p:nvGrpSpPr>
+      <p:grpSpPr>
+        <a:xfrm>
+          <a:off x="0" y="0"/>
+          <a:ext cx="0" cy="0"/>
+          <a:chOff x="0" y="0"/>
+          <a:chExt cx="0" cy="0"/>
+        </a:xfrm>
+      </p:grpSpPr>
+      <p:sp>
+        <p:nvSpPr>
+          <p:cNvPr id="2" name="Slide Image Placeholder 1">
+            <a:extLst>
+              <a:ext uri="{FF2B5EF4-FFF2-40B4-BE49-F238E27FC236}">
+                <a16:creationId xmlns:a16="http://schemas.microsoft.com/office/drawing/2014/main" id="{D27769DE-EE2B-CDF0-B3A8-4860B154D68E}"/>
+              </a:ext>
+            </a:extLst>
+          </p:cNvPr>
+          <p:cNvSpPr>
+            <a:spLocks noGrp="1" noRot="1" noChangeAspect="1"/>
+          </p:cNvSpPr>
+          <p:nvPr>
+            <p:ph type="sldImg"/>
+          </p:nvPr>
+        </p:nvSpPr>
+        <p:spPr/>
+      </p:sp>
+      <p:sp>
+        <p:nvSpPr>
+          <p:cNvPr id="3" name="Notes Placeholder 2">
+            <a:extLst>
+              <a:ext uri="{FF2B5EF4-FFF2-40B4-BE49-F238E27FC236}">
+                <a16:creationId xmlns:a16="http://schemas.microsoft.com/office/drawing/2014/main" id="{DCB13888-86BD-70E9-CE9B-FF85C31CFD9A}"/>
+              </a:ext>
+            </a:extLst>
+          </p:cNvPr>
+          <p:cNvSpPr>
+            <a:spLocks noGrp="1"/>
+          </p:cNvSpPr>
+          <p:nvPr>
+            <p:ph type="body" idx="1"/>
+          </p:nvPr>
+        </p:nvSpPr>
+        <p:spPr/>
+        <p:txBody>
+          <a:bodyPr/>
+          <a:lstStyle/>
+          <a:p>
+            <a:r>
+              <a:rPr lang="en-US" dirty="0"/>
+              <a:t>Do this one as a question to the class before clicking.</a:t>
+            </a:r>
+          </a:p>
+          <a:p>
+            <a:r>
+              <a:rPr lang="en-US" dirty="0"/>
+              <a:t>Set up the top half: C1 and C2 write the same key at the same time, and afterwards C3 and C4 each read it. Ask what the two readers can see.</a:t>
+            </a:r>
+          </a:p>
+          <a:p>
+            <a:r>
+              <a:rPr lang="en-US" dirty="0"/>
+              <a:t>Then click. Both readers seeing 1 is correct, and both seeing 2 is correct: the writes were concurrent, so either one could have gone first, and we do not get to insist on which. What is ruled out is the third card, where the readers disagree, because no single machine running one request at a time could have produced that.</a:t>
+            </a:r>
+          </a:p>
+          <a:p>
+            <a:r>
+              <a:rPr lang="en-US" dirty="0"/>
+              <a:t>The sentence to leave them with: consistency is not a claim about which value you get back. It is a claim that everything the clients saw can be explained by one order.</a:t>
+            </a:r>
+          </a:p>
+          <a:p>
+            <a:r>
+              <a:rPr lang="en-US" dirty="0"/>
+              <a:t>This is the last slide on which the ideal is free. One correct machine gives all of it at no cost, but the earlier slides ruled out running on one machine, so from here on we replicate, and the next two slides are where that goes wrong.</a:t>
+            </a:r>
+          </a:p>
+          <a:p>
+            <a:r>
+              <a:rPr lang="en-US" dirty="0"/>
+              <a:t>SOURCE</a:t>
+            </a:r>
+          </a:p>
+          <a:p>
+            <a:r>
+              <a:rPr lang="en-US" dirty="0"/>
+              <a:t>MIT 6.824, Spring 2020, Lecture 3 video, 08:11-10:47.</a:t>
+            </a:r>
+          </a:p>
+          <a:p>
+            <a:r>
+              <a:rPr lang="en-US" dirty="0"/>
+              <a:t>https://www.youtube.com/watch?v=EpIgvowZr00</a:t>
+            </a:r>
+          </a:p>
+          <a:p>
+            <a:r>
+              <a:rPr lang="en-US" dirty="0"/>
+              <a:t>Local transcript: fall2026/lectures/references/mit-6824-2020-lecture3-gfs-transcript.txt</a:t>
+            </a:r>
+          </a:p>
+        </p:txBody>
+      </p:sp>
+      <p:sp>
+        <p:nvSpPr>
+          <p:cNvPr id="4" name="Slide Number Placeholder 3">
+            <a:extLst>
+              <a:ext uri="{FF2B5EF4-FFF2-40B4-BE49-F238E27FC236}">
+                <a16:creationId xmlns:a16="http://schemas.microsoft.com/office/drawing/2014/main" id="{B1960F15-BADC-8306-DE62-2CD20BDF9BC7}"/>
+              </a:ext>
+            </a:extLst>
+          </p:cNvPr>
+          <p:cNvSpPr>
+            <a:spLocks noGrp="1"/>
+          </p:cNvSpPr>
+          <p:nvPr>
+            <p:ph type="sldNum" sz="quarter" idx="5"/>
+          </p:nvPr>
+        </p:nvSpPr>
+        <p:spPr/>
+        <p:txBody>
+          <a:bodyPr/>
+          <a:lstStyle/>
+          <a:p>
+            <a:fld id="{1C9584DC-3658-4054-9DA4-7B68A1D8CC6D}" type="slidenum">
+              <a:rPr lang="zh-CN" altLang="en-US" smtClean="0"/>
+              <a:t>12</a:t>
+            </a:fld>
+            <a:endParaRPr lang="zh-CN" altLang="en-US"/>
+          </a:p>
+        </p:txBody>
+      </p:sp>
+    </p:spTree>
+    <p:extLst>
+      <p:ext uri="{BB962C8B-B14F-4D97-AF65-F5344CB8AC3E}">
+        <p14:creationId xmlns:p14="http://schemas.microsoft.com/office/powerpoint/2010/main" val="2004993241"/>
       </p:ext>
     </p:extLst>
   </p:cSld>
@@ -12767,15 +13085,48 @@
             <a:endParaRPr lang="en-US" sz="3200" b="1" dirty="0"/>
           </a:p>
           <a:p>
+            <a:r>
+              <a:rPr lang="en-US" sz="3200" b="1" dirty="0"/>
+              <a:t>That one machine does one thing at a time</a:t>
+            </a:r>
+          </a:p>
+          <a:p>
+            <a:pPr marL="914400" indent="-457200">
+              <a:buFont typeface="Arial" panose="020B0604020202020204" pitchFamily="34" charset="0"/>
+              <a:buChar char="•"/>
+            </a:pPr>
+            <a:r>
+              <a:rPr lang="en-US" sz="2800" b="0" dirty="0"/>
+              <a:t>Concurrent requests are put in some order, and the machine picks the order</a:t>
+            </a:r>
+          </a:p>
+          <a:p>
+            <a:pPr marL="914400" indent="-457200">
+              <a:buFont typeface="Arial" panose="020B0604020202020204" pitchFamily="34" charset="0"/>
+              <a:buChar char="•"/>
+            </a:pPr>
+            <a:r>
+              <a:rPr lang="en-US" sz="2800" b="0" dirty="0"/>
+              <a:t>Each request finishes before the next one starts</a:t>
+            </a:r>
+          </a:p>
+          <a:p>
             <a:endParaRPr lang="en-US" sz="3200" b="1" dirty="0"/>
           </a:p>
           <a:p>
-            <a:endParaRPr lang="en-US" sz="3200" b="1" dirty="0"/>
-          </a:p>
-          <a:p>
             <a:r>
               <a:rPr lang="en-US" sz="3200" b="1" dirty="0"/>
-              <a:t>Suppose C1 and C2 write concurrently, and after the writes have completed, C3 and C4 read. what can they see?</a:t>
+              <a:t>So the test is: could one machine have produced what the clients saw?</a:t>
+            </a:r>
+          </a:p>
+          <a:p>
+            <a:pPr marL="914400" indent="-457200">
+              <a:buFont typeface="Arial" panose="020B0604020202020204" pitchFamily="34" charset="0"/>
+              <a:buChar char="•"/>
+            </a:pPr>
+            <a:r>
+              <a:rPr lang="en-US" sz="2800" b="0" dirty="0"/>
+              <a:t>Not a particular answer, but an answer that fits one single order</a:t>
             </a:r>
           </a:p>
         </p:txBody>
@@ -28898,6 +29249,1826 @@
   <p:clrMapOvr>
     <a:masterClrMapping/>
   </p:clrMapOvr>
+</p:sld>
+</file>
+
+<file path=ppt/slides/slide52.xml><?xml version="1.0" encoding="utf-8"?>
+<p:sld xmlns:a="http://schemas.openxmlformats.org/drawingml/2006/main" xmlns:r="http://schemas.openxmlformats.org/officeDocument/2006/relationships" xmlns:p="http://schemas.openxmlformats.org/presentationml/2006/main">
+  <p:cSld>
+    <p:spTree>
+      <p:nvGrpSpPr>
+        <p:cNvPr id="1" name="">
+          <a:extLst>
+            <a:ext uri="{FF2B5EF4-FFF2-40B4-BE49-F238E27FC236}">
+              <a16:creationId xmlns:a16="http://schemas.microsoft.com/office/drawing/2014/main" id="{872729AB-5EBB-FD20-43DD-D6E0374E6833}"/>
+            </a:ext>
+          </a:extLst>
+        </p:cNvPr>
+        <p:cNvGrpSpPr/>
+        <p:nvPr/>
+      </p:nvGrpSpPr>
+      <p:grpSpPr>
+        <a:xfrm>
+          <a:off x="0" y="0"/>
+          <a:ext cx="0" cy="0"/>
+          <a:chOff x="0" y="0"/>
+          <a:chExt cx="0" cy="0"/>
+        </a:xfrm>
+      </p:grpSpPr>
+      <p:sp>
+        <p:nvSpPr>
+          <p:cNvPr id="7" name="Title 1">
+            <a:extLst>
+              <a:ext uri="{FF2B5EF4-FFF2-40B4-BE49-F238E27FC236}">
+                <a16:creationId xmlns:a16="http://schemas.microsoft.com/office/drawing/2014/main" id="{2ED557C7-2CDD-8C0B-07A1-1DABA8EF652A}"/>
+              </a:ext>
+            </a:extLst>
+          </p:cNvPr>
+          <p:cNvSpPr>
+            <a:spLocks noGrp="1"/>
+          </p:cNvSpPr>
+          <p:nvPr>
+            <p:ph type="title"/>
+          </p:nvPr>
+        </p:nvSpPr>
+        <p:spPr>
+          <a:xfrm>
+            <a:off x="0" y="1"/>
+            <a:ext cx="12191999" cy="914400"/>
+          </a:xfrm>
+        </p:spPr>
+        <p:txBody>
+          <a:bodyPr>
+            <a:normAutofit/>
+          </a:bodyPr>
+          <a:lstStyle/>
+          <a:p>
+            <a:pPr algn="ctr"/>
+            <a:r>
+              <a:rPr lang="en-US" b="1" dirty="0">
+                <a:latin typeface="Helvetica" panose="020B0604020202020204" pitchFamily="34" charset="0"/>
+                <a:cs typeface="Helvetica" panose="020B0604020202020204" pitchFamily="34" charset="0"/>
+              </a:rPr>
+              <a:t>The Fix Has a Price</a:t>
+            </a:r>
+          </a:p>
+        </p:txBody>
+      </p:sp>
+      <p:sp>
+        <p:nvSpPr>
+          <p:cNvPr id="8" name="Slide Number Placeholder 4">
+            <a:extLst>
+              <a:ext uri="{FF2B5EF4-FFF2-40B4-BE49-F238E27FC236}">
+                <a16:creationId xmlns:a16="http://schemas.microsoft.com/office/drawing/2014/main" id="{25E098EE-1299-32C0-2821-1DB599BAC8E9}"/>
+              </a:ext>
+            </a:extLst>
+          </p:cNvPr>
+          <p:cNvSpPr>
+            <a:spLocks noGrp="1"/>
+          </p:cNvSpPr>
+          <p:nvPr>
+            <p:ph type="sldNum" sz="quarter" idx="12"/>
+          </p:nvPr>
+        </p:nvSpPr>
+        <p:spPr>
+          <a:xfrm>
+            <a:off x="8610600" y="6356350"/>
+            <a:ext cx="2743200" cy="365125"/>
+          </a:xfrm>
+        </p:spPr>
+        <p:txBody>
+          <a:bodyPr/>
+          <a:lstStyle/>
+          <a:p>
+            <a:fld id="{212DA15D-5F50-8B40-811F-34F736B90848}" type="slidenum">
+              <a:rPr lang="en-US" smtClean="0"/>
+              <a:t>7</a:t>
+            </a:fld>
+            <a:endParaRPr lang="en-US"/>
+          </a:p>
+        </p:txBody>
+      </p:sp>
+      <p:sp>
+        <p:nvSpPr>
+          <p:cNvPr id="3" name="TextBox 2">
+            <a:extLst>
+              <a:ext uri="{FF2B5EF4-FFF2-40B4-BE49-F238E27FC236}">
+                <a16:creationId xmlns:a16="http://schemas.microsoft.com/office/drawing/2014/main" id="{857EC8A2-DB9F-8BB1-7445-FE716E76BAC5}"/>
+              </a:ext>
+            </a:extLst>
+          </p:cNvPr>
+          <p:cNvSpPr txBox="1"/>
+          <p:nvPr/>
+        </p:nvSpPr>
+        <p:spPr>
+          <a:xfrm>
+            <a:off x="88135" y="914401"/>
+            <a:ext cx="12191998" cy="4585871"/>
+          </a:xfrm>
+          <a:prstGeom prst="rect">
+            <a:avLst/>
+          </a:prstGeom>
+          <a:noFill/>
+        </p:spPr>
+        <p:txBody>
+          <a:bodyPr wrap="square" rtlCol="0">
+            <a:spAutoFit/>
+          </a:bodyPr>
+          <a:lstStyle/>
+          <a:p>
+            <a:r>
+              <a:rPr lang="en-US" sz="3200" b="1" dirty="0"/>
+              <a:t>The replicas disagreed because nobody chose an order</a:t>
+            </a:r>
+          </a:p>
+          <a:p>
+            <a:pPr marL="914400" indent="-457200">
+              <a:buFont typeface="Arial" panose="020B0604020202020204" pitchFamily="34" charset="0"/>
+              <a:buChar char="•"/>
+            </a:pPr>
+            <a:r>
+              <a:rPr lang="en-US" sz="2800" b="0" dirty="0"/>
+              <a:t>Each server applied the writes in the order the network happened to deliver them</a:t>
+            </a:r>
+          </a:p>
+          <a:p>
+            <a:pPr marL="914400" indent="-457200">
+              <a:buFont typeface="Arial" panose="020B0604020202020204" pitchFamily="34" charset="0"/>
+              <a:buChar char="•"/>
+            </a:pPr>
+            <a:r>
+              <a:rPr lang="en-US" sz="2800" b="0" dirty="0"/>
+              <a:t>Any fix has to make all replicas agree on one order</a:t>
+            </a:r>
+          </a:p>
+          <a:p>
+            <a:pPr marL="457200"/>
+            <a:endParaRPr lang="en-US" sz="2800" b="0" dirty="0"/>
+          </a:p>
+          <a:p>
+            <a:r>
+              <a:rPr lang="en-US" sz="3200" b="1" dirty="0"/>
+              <a:t>Agreement is not free</a:t>
+            </a:r>
+          </a:p>
+          <a:p>
+            <a:pPr marL="914400" indent="-457200">
+              <a:buFont typeface="Arial" panose="020B0604020202020204" pitchFamily="34" charset="0"/>
+              <a:buChar char="•"/>
+            </a:pPr>
+            <a:r>
+              <a:rPr lang="en-US" sz="2800" b="0" dirty="0"/>
+              <a:t>More messages between the servers, and a more complicated protocol</a:t>
+            </a:r>
+          </a:p>
+          <a:p>
+            <a:pPr marL="914400" indent="-457200">
+              <a:buFont typeface="Arial" panose="020B0604020202020204" pitchFamily="34" charset="0"/>
+              <a:buChar char="•"/>
+            </a:pPr>
+            <a:r>
+              <a:rPr lang="en-US" sz="2800" b="0" dirty="0"/>
+              <a:t>A write is not done until the replicas agree, so clients wait longer</a:t>
+            </a:r>
+          </a:p>
+          <a:p>
+            <a:pPr marL="457200"/>
+            <a:endParaRPr lang="en-US" sz="2800" b="0" dirty="0"/>
+          </a:p>
+          <a:p>
+            <a:r>
+              <a:rPr lang="en-US" sz="3200" b="1" dirty="0"/>
+              <a:t>So there is no single answer, but a range of designs</a:t>
+            </a:r>
+          </a:p>
+          <a:p>
+            <a:pPr marL="914400" indent="-457200">
+              <a:buFont typeface="Arial" panose="020B0604020202020204" pitchFamily="34" charset="0"/>
+              <a:buChar char="•"/>
+            </a:pPr>
+            <a:r>
+              <a:rPr lang="en-US" sz="2800" b="0" dirty="0"/>
+              <a:t>Stronger consistency: more coordination, lower performance</a:t>
+            </a:r>
+          </a:p>
+          <a:p>
+            <a:pPr marL="914400" indent="-457200">
+              <a:buFont typeface="Arial" panose="020B0604020202020204" pitchFamily="34" charset="0"/>
+              <a:buChar char="•"/>
+            </a:pPr>
+            <a:r>
+              <a:rPr lang="en-US" sz="2800" b="0" dirty="0"/>
+              <a:t>Weaker consistency: less coordination, and anomalies the application must handle</a:t>
+            </a:r>
+          </a:p>
+          <a:p>
+            <a:pPr marL="457200"/>
+            <a:endParaRPr lang="en-US" sz="2800" b="0" dirty="0"/>
+          </a:p>
+          <a:p>
+            <a:r>
+              <a:rPr lang="en-US" sz="3200" b="1" dirty="0"/>
+              <a:t>GFS picks a point on this range: better than this design, deliberately not perfect</a:t>
+            </a:r>
+          </a:p>
+        </p:txBody>
+      </p:sp>
+    </p:spTree>
+    <p:extLst>
+      <p:ext uri="{BB962C8B-B14F-4D97-AF65-F5344CB8AC3E}">
+        <p14:creationId xmlns:p14="http://schemas.microsoft.com/office/powerpoint/2010/main" val="1720670694"/>
+      </p:ext>
+    </p:extLst>
+  </p:cSld>
+  <p:clrMapOvr>
+    <a:masterClrMapping/>
+  </p:clrMapOvr>
+</p:sld>
+</file>
+
+<file path=ppt/slides/slide53.xml><?xml version="1.0" encoding="utf-8"?>
+<p:sld xmlns:a="http://schemas.openxmlformats.org/drawingml/2006/main" xmlns:r="http://schemas.openxmlformats.org/officeDocument/2006/relationships" xmlns:p="http://schemas.openxmlformats.org/presentationml/2006/main">
+  <p:cSld>
+    <p:spTree>
+      <p:nvGrpSpPr>
+        <p:cNvPr id="1" name=""/>
+        <p:cNvGrpSpPr/>
+        <p:nvPr/>
+      </p:nvGrpSpPr>
+      <p:grpSpPr>
+        <a:xfrm>
+          <a:off x="0" y="0"/>
+          <a:ext cx="0" cy="0"/>
+          <a:chOff x="0" y="0"/>
+          <a:chExt cx="0" cy="0"/>
+        </a:xfrm>
+      </p:grpSpPr>
+      <p:sp>
+        <p:nvSpPr>
+          <p:cNvPr id="7" name="Title 1">
+            <a:extLst>
+              <a:ext uri="{FF2B5EF4-FFF2-40B4-BE49-F238E27FC236}">
+                <a16:creationId xmlns:a16="http://schemas.microsoft.com/office/drawing/2014/main" id="{9452C5CF-C823-F93B-EC88-BA4478E024CE}"/>
+              </a:ext>
+            </a:extLst>
+          </p:cNvPr>
+          <p:cNvSpPr>
+            <a:spLocks noGrp="1"/>
+          </p:cNvSpPr>
+          <p:nvPr>
+            <p:ph type="title"/>
+          </p:nvPr>
+        </p:nvSpPr>
+        <p:spPr>
+          <a:xfrm>
+            <a:off x="0" y="1"/>
+            <a:ext cx="12191999" cy="914400"/>
+          </a:xfrm>
+        </p:spPr>
+        <p:txBody>
+          <a:bodyPr>
+            <a:normAutofit/>
+          </a:bodyPr>
+          <a:lstStyle/>
+          <a:p>
+            <a:pPr algn="ctr">
+              <a:buNone/>
+            </a:pPr>
+            <a:r>
+              <a:rPr b="1">
+                <a:latin typeface="Helvetica"/>
+                <a:ea typeface="Helvetica"/>
+                <a:cs typeface="Helvetica"/>
+              </a:rPr>
+              <a:t>What Should the Readers See?</a:t>
+            </a:r>
+          </a:p>
+        </p:txBody>
+      </p:sp>
+      <p:sp>
+        <p:nvSpPr>
+          <p:cNvPr id="8" name="Slide Number Placeholder 4">
+            <a:extLst>
+              <a:ext uri="{FF2B5EF4-FFF2-40B4-BE49-F238E27FC236}">
+                <a16:creationId xmlns:a16="http://schemas.microsoft.com/office/drawing/2014/main" id="{16D0A24B-6300-8D05-5AB9-F3998A2F3009}"/>
+              </a:ext>
+            </a:extLst>
+          </p:cNvPr>
+          <p:cNvSpPr>
+            <a:spLocks noGrp="1"/>
+          </p:cNvSpPr>
+          <p:nvPr>
+            <p:ph type="sldNum" idx="12"/>
+          </p:nvPr>
+        </p:nvSpPr>
+        <p:spPr>
+          <a:xfrm>
+            <a:off x="8610600" y="6356350"/>
+            <a:ext cx="2743200" cy="365125"/>
+          </a:xfrm>
+        </p:spPr>
+        <p:txBody>
+          <a:bodyPr/>
+          <a:lstStyle/>
+          <a:p>
+            <a:fld id="{212DA15D-5F50-8B40-811F-34F736B90848}" type="slidenum">
+              <a:rPr/>
+              <a:t>8</a:t>
+            </a:fld>
+            <a:endParaRPr/>
+          </a:p>
+        </p:txBody>
+      </p:sp>
+      <p:sp>
+        <p:nvSpPr>
+          <p:cNvPr id="48" name="TextBox 47">
+            <a:extLst>
+              <a:ext uri="{FF2B5EF4-FFF2-40B4-BE49-F238E27FC236}">
+                <a16:creationId xmlns:a16="http://schemas.microsoft.com/office/drawing/2014/main" id="{51F35555-7DB3-0E9F-0CC1-8DCCA40D364A}"/>
+              </a:ext>
+            </a:extLst>
+          </p:cNvPr>
+          <p:cNvSpPr>
+            <a:spLocks noGrp="1"/>
+          </p:cNvSpPr>
+          <p:nvPr/>
+        </p:nvSpPr>
+        <p:spPr>
+          <a:xfrm>
+            <a:off x="7325250" y="1373218"/>
+            <a:ext cx="4706595" cy="4154984"/>
+          </a:xfrm>
+          <a:prstGeom prst="rect">
+            <a:avLst/>
+          </a:prstGeom>
+          <a:noFill/>
+        </p:spPr>
+        <p:txBody>
+          <a:bodyPr wrap="square">
+            <a:spAutoFit/>
+          </a:bodyPr>
+          <a:lstStyle/>
+          <a:p>
+            <a:pPr marL="342900" indent="-342900">
+              <a:buFont typeface="Arial"/>
+              <a:buChar char="•"/>
+            </a:pPr>
+            <a:r>
+              <a:rPr sz="2400" dirty="0"/>
+              <a:t>Suppose C1 and C2 write concurrently, and after the writes have completed, C3 and C4 read. what can they see?</a:t>
+            </a:r>
+          </a:p>
+          <a:p>
+            <a:pPr marL="342900" indent="-342900">
+              <a:buFont typeface="Arial"/>
+              <a:buChar char="•"/>
+            </a:pPr>
+            <a:endParaRPr sz="1200" dirty="0"/>
+          </a:p>
+          <a:p>
+            <a:pPr marL="342900" indent="-342900">
+              <a:buFont typeface="Arial"/>
+              <a:buChar char="•"/>
+            </a:pPr>
+            <a:r>
+              <a:rPr sz="2400" dirty="0"/>
+              <a:t>One correct machine would pick an order and stick to it</a:t>
+            </a:r>
+          </a:p>
+          <a:p>
+            <a:pPr marL="342900" indent="-342900">
+              <a:buFont typeface="Arial"/>
+              <a:buChar char="•"/>
+            </a:pPr>
+            <a:endParaRPr sz="1200" dirty="0"/>
+          </a:p>
+          <a:p>
+            <a:pPr marL="342900" indent="-342900">
+              <a:buFont typeface="Arial"/>
+              <a:buChar char="•"/>
+            </a:pPr>
+            <a:r>
+              <a:rPr sz="2400" dirty="0"/>
+              <a:t>Either order is acceptable</a:t>
+            </a:r>
+          </a:p>
+          <a:p>
+            <a:pPr marL="342900" indent="-342900">
+              <a:buFont typeface="Arial"/>
+              <a:buChar char="•"/>
+            </a:pPr>
+            <a:endParaRPr sz="1200" dirty="0"/>
+          </a:p>
+          <a:p>
+            <a:pPr marL="342900" indent="-342900">
+              <a:buFont typeface="Arial"/>
+              <a:buChar char="•"/>
+            </a:pPr>
+            <a:r>
+              <a:rPr sz="2400" dirty="0"/>
+              <a:t>The two readers disagreeing is not</a:t>
+            </a:r>
+          </a:p>
+        </p:txBody>
+      </p:sp>
+      <p:sp>
+        <p:nvSpPr>
+          <p:cNvPr id="49" name="Scenario heading">
+            <a:extLst>
+              <a:ext uri="{FF2B5EF4-FFF2-40B4-BE49-F238E27FC236}">
+                <a16:creationId xmlns:a16="http://schemas.microsoft.com/office/drawing/2014/main" id="{661EE3E6-4BC3-4749-8762-CC8F835B020D}"/>
+              </a:ext>
+            </a:extLst>
+          </p:cNvPr>
+          <p:cNvSpPr>
+            <a:spLocks noGrp="1"/>
+          </p:cNvSpPr>
+          <p:nvPr/>
+        </p:nvSpPr>
+        <p:spPr>
+          <a:xfrm>
+            <a:off x="409575" y="1057275"/>
+            <a:ext cx="6429375" cy="323850"/>
+          </a:xfrm>
+          <a:prstGeom prst="rect">
+            <a:avLst/>
+          </a:prstGeom>
+          <a:noFill/>
+          <a:ln w="0">
+            <a:noFill/>
+          </a:ln>
+        </p:spPr>
+        <p:txBody>
+          <a:bodyPr>
+            <a:normAutofit/>
+          </a:bodyPr>
+          <a:lstStyle/>
+          <a:p>
+            <a:pPr>
+              <a:defRPr sz="1725" b="1">
+                <a:solidFill>
+                  <a:srgbClr val="0E2841"/>
+                </a:solidFill>
+                <a:latin typeface="Aptos"/>
+                <a:ea typeface="Aptos"/>
+                <a:cs typeface="Aptos"/>
+              </a:defRPr>
+            </a:pPr>
+            <a:r>
+              <a:rPr sz="1725" b="1">
+                <a:solidFill>
+                  <a:srgbClr val="0E2841"/>
+                </a:solidFill>
+                <a:latin typeface="Aptos"/>
+                <a:ea typeface="Aptos"/>
+                <a:cs typeface="Aptos"/>
+              </a:rPr>
+              <a:t>C1 and C2 write at the same time, then C3 and C4 read</a:t>
+            </a:r>
+          </a:p>
+        </p:txBody>
+      </p:sp>
+      <p:sp>
+        <p:nvSpPr>
+          <p:cNvPr id="50" name="Client 1 write">
+            <a:extLst>
+              <a:ext uri="{FF2B5EF4-FFF2-40B4-BE49-F238E27FC236}">
+                <a16:creationId xmlns:a16="http://schemas.microsoft.com/office/drawing/2014/main" id="{75D3A3DE-8E0D-482B-BCFD-2AD2458A4DA5}"/>
+              </a:ext>
+            </a:extLst>
+          </p:cNvPr>
+          <p:cNvSpPr>
+            <a:spLocks noGrp="1"/>
+          </p:cNvSpPr>
+          <p:nvPr/>
+        </p:nvSpPr>
+        <p:spPr>
+          <a:xfrm>
+            <a:off x="450000" y="1500000"/>
+            <a:ext cx="1400000" cy="590550"/>
+          </a:xfrm>
+          <a:prstGeom prst="roundRect">
+            <a:avLst>
+              <a:gd name="adj" fmla="val 16129"/>
+            </a:avLst>
+          </a:prstGeom>
+          <a:solidFill>
+            <a:srgbClr val="A02B93"/>
+          </a:solidFill>
+          <a:ln w="19050">
+            <a:solidFill>
+              <a:srgbClr val="A02B93"/>
+            </a:solidFill>
+            <a:prstDash val="solid"/>
+          </a:ln>
+        </p:spPr>
+        <p:txBody>
+          <a:bodyPr lIns="47625" tIns="47625" rIns="47625" bIns="47625" anchor="ctr">
+            <a:normAutofit/>
+          </a:bodyPr>
+          <a:lstStyle/>
+          <a:p>
+            <a:pPr algn="ctr">
+              <a:defRPr sz="1425" b="1">
+                <a:solidFill>
+                  <a:srgbClr val="FFFFFF"/>
+                </a:solidFill>
+                <a:latin typeface="Aptos"/>
+                <a:ea typeface="Aptos"/>
+                <a:cs typeface="Aptos"/>
+              </a:defRPr>
+            </a:pPr>
+            <a:r>
+              <a:rPr sz="1425" b="1">
+                <a:solidFill>
+                  <a:srgbClr val="FFFFFF"/>
+                </a:solidFill>
+                <a:latin typeface="Aptos"/>
+                <a:ea typeface="Aptos"/>
+                <a:cs typeface="Aptos"/>
+              </a:rPr>
+              <a:t>C1</a:t>
+            </a:r>
+          </a:p>
+          <a:p>
+            <a:pPr algn="ctr">
+              <a:defRPr sz="1425" b="1">
+                <a:solidFill>
+                  <a:srgbClr val="FFFFFF"/>
+                </a:solidFill>
+                <a:latin typeface="Aptos"/>
+                <a:ea typeface="Aptos"/>
+                <a:cs typeface="Aptos"/>
+              </a:defRPr>
+            </a:pPr>
+            <a:r>
+              <a:rPr sz="1425" b="1">
+                <a:solidFill>
+                  <a:srgbClr val="FFFFFF"/>
+                </a:solidFill>
+                <a:latin typeface="Aptos"/>
+                <a:ea typeface="Aptos"/>
+                <a:cs typeface="Aptos"/>
+              </a:rPr>
+              <a:t>write x = 1</a:t>
+            </a:r>
+          </a:p>
+        </p:txBody>
+      </p:sp>
+      <p:sp>
+        <p:nvSpPr>
+          <p:cNvPr id="51" name="Client 2 write">
+            <a:extLst>
+              <a:ext uri="{FF2B5EF4-FFF2-40B4-BE49-F238E27FC236}">
+                <a16:creationId xmlns:a16="http://schemas.microsoft.com/office/drawing/2014/main" id="{75D3A3DE-8E0D-482B-BCFD-2AD2458A4DA5}"/>
+              </a:ext>
+            </a:extLst>
+          </p:cNvPr>
+          <p:cNvSpPr>
+            <a:spLocks noGrp="1"/>
+          </p:cNvSpPr>
+          <p:nvPr/>
+        </p:nvSpPr>
+        <p:spPr>
+          <a:xfrm>
+            <a:off x="450000" y="2250000"/>
+            <a:ext cx="1400000" cy="590550"/>
+          </a:xfrm>
+          <a:prstGeom prst="roundRect">
+            <a:avLst>
+              <a:gd name="adj" fmla="val 16129"/>
+            </a:avLst>
+          </a:prstGeom>
+          <a:solidFill>
+            <a:srgbClr val="A02B93"/>
+          </a:solidFill>
+          <a:ln w="19050">
+            <a:solidFill>
+              <a:srgbClr val="A02B93"/>
+            </a:solidFill>
+            <a:prstDash val="solid"/>
+          </a:ln>
+        </p:spPr>
+        <p:txBody>
+          <a:bodyPr lIns="47625" tIns="47625" rIns="47625" bIns="47625" anchor="ctr">
+            <a:normAutofit/>
+          </a:bodyPr>
+          <a:lstStyle/>
+          <a:p>
+            <a:pPr algn="ctr">
+              <a:defRPr sz="1425" b="1">
+                <a:solidFill>
+                  <a:srgbClr val="FFFFFF"/>
+                </a:solidFill>
+                <a:latin typeface="Aptos"/>
+                <a:ea typeface="Aptos"/>
+                <a:cs typeface="Aptos"/>
+              </a:defRPr>
+            </a:pPr>
+            <a:r>
+              <a:rPr sz="1425" b="1">
+                <a:solidFill>
+                  <a:srgbClr val="FFFFFF"/>
+                </a:solidFill>
+                <a:latin typeface="Aptos"/>
+                <a:ea typeface="Aptos"/>
+                <a:cs typeface="Aptos"/>
+              </a:rPr>
+              <a:t>C2</a:t>
+            </a:r>
+          </a:p>
+          <a:p>
+            <a:pPr algn="ctr">
+              <a:defRPr sz="1425" b="1">
+                <a:solidFill>
+                  <a:srgbClr val="FFFFFF"/>
+                </a:solidFill>
+                <a:latin typeface="Aptos"/>
+                <a:ea typeface="Aptos"/>
+                <a:cs typeface="Aptos"/>
+              </a:defRPr>
+            </a:pPr>
+            <a:r>
+              <a:rPr sz="1425" b="1">
+                <a:solidFill>
+                  <a:srgbClr val="FFFFFF"/>
+                </a:solidFill>
+                <a:latin typeface="Aptos"/>
+                <a:ea typeface="Aptos"/>
+                <a:cs typeface="Aptos"/>
+              </a:rPr>
+              <a:t>write x = 2</a:t>
+            </a:r>
+          </a:p>
+        </p:txBody>
+      </p:sp>
+      <p:sp>
+        <p:nvSpPr>
+          <p:cNvPr id="52" name="One machine">
+            <a:extLst>
+              <a:ext uri="{FF2B5EF4-FFF2-40B4-BE49-F238E27FC236}">
+                <a16:creationId xmlns:a16="http://schemas.microsoft.com/office/drawing/2014/main" id="{C047F16D-4224-436C-BA2F-7F4F14E7970E}"/>
+              </a:ext>
+            </a:extLst>
+          </p:cNvPr>
+          <p:cNvSpPr>
+            <a:spLocks noGrp="1"/>
+          </p:cNvSpPr>
+          <p:nvPr/>
+        </p:nvSpPr>
+        <p:spPr>
+          <a:xfrm>
+            <a:off x="2400000" y="1650275"/>
+            <a:ext cx="2200000" cy="1040000"/>
+          </a:xfrm>
+          <a:prstGeom prst="roundRect">
+            <a:avLst>
+              <a:gd name="adj" fmla="val 13889"/>
+            </a:avLst>
+          </a:prstGeom>
+          <a:solidFill>
+            <a:srgbClr val="E8F0F5"/>
+          </a:solidFill>
+          <a:ln w="19050">
+            <a:solidFill>
+              <a:srgbClr val="0E2841"/>
+            </a:solidFill>
+            <a:prstDash val="solid"/>
+          </a:ln>
+        </p:spPr>
+        <p:txBody>
+          <a:bodyPr lIns="47625" tIns="47625" rIns="47625" bIns="47625" anchor="ctr">
+            <a:normAutofit/>
+          </a:bodyPr>
+          <a:lstStyle/>
+          <a:p>
+            <a:pPr algn="ctr">
+              <a:defRPr sz="1350" b="1">
+                <a:solidFill>
+                  <a:srgbClr val="0E2841"/>
+                </a:solidFill>
+                <a:latin typeface="Aptos"/>
+                <a:ea typeface="Aptos"/>
+                <a:cs typeface="Aptos"/>
+              </a:defRPr>
+            </a:pPr>
+            <a:r>
+              <a:rPr sz="1350" b="1">
+                <a:solidFill>
+                  <a:srgbClr val="0E2841"/>
+                </a:solidFill>
+                <a:latin typeface="Aptos"/>
+                <a:ea typeface="Aptos"/>
+                <a:cs typeface="Aptos"/>
+              </a:rPr>
+              <a:t>One correct machine</a:t>
+            </a:r>
+          </a:p>
+          <a:p>
+            <a:pPr algn="ctr">
+              <a:defRPr sz="1350" b="1">
+                <a:solidFill>
+                  <a:srgbClr val="0E2841"/>
+                </a:solidFill>
+                <a:latin typeface="Aptos"/>
+                <a:ea typeface="Aptos"/>
+                <a:cs typeface="Aptos"/>
+              </a:defRPr>
+            </a:pPr>
+            <a:r>
+              <a:rPr sz="1350" b="1">
+                <a:solidFill>
+                  <a:srgbClr val="0E2841"/>
+                </a:solidFill>
+                <a:latin typeface="Aptos"/>
+                <a:ea typeface="Aptos"/>
+                <a:cs typeface="Aptos"/>
+              </a:rPr>
+              <a:t>one request at a time</a:t>
+            </a:r>
+          </a:p>
+        </p:txBody>
+      </p:sp>
+      <p:sp>
+        <p:nvSpPr>
+          <p:cNvPr id="53" name="Client 3 read">
+            <a:extLst>
+              <a:ext uri="{FF2B5EF4-FFF2-40B4-BE49-F238E27FC236}">
+                <a16:creationId xmlns:a16="http://schemas.microsoft.com/office/drawing/2014/main" id="{C047F16D-4224-436C-BA2F-7F4F14E7970E}"/>
+              </a:ext>
+            </a:extLst>
+          </p:cNvPr>
+          <p:cNvSpPr>
+            <a:spLocks noGrp="1"/>
+          </p:cNvSpPr>
+          <p:nvPr/>
+        </p:nvSpPr>
+        <p:spPr>
+          <a:xfrm>
+            <a:off x="5100000" y="1500000"/>
+            <a:ext cx="1400000" cy="590550"/>
+          </a:xfrm>
+          <a:prstGeom prst="roundRect">
+            <a:avLst>
+              <a:gd name="adj" fmla="val 13889"/>
+            </a:avLst>
+          </a:prstGeom>
+          <a:solidFill>
+            <a:srgbClr val="E8F0F5"/>
+          </a:solidFill>
+          <a:ln w="19050">
+            <a:solidFill>
+              <a:srgbClr val="0E2841"/>
+            </a:solidFill>
+            <a:prstDash val="solid"/>
+          </a:ln>
+        </p:spPr>
+        <p:txBody>
+          <a:bodyPr lIns="47625" tIns="47625" rIns="47625" bIns="47625" anchor="ctr">
+            <a:normAutofit/>
+          </a:bodyPr>
+          <a:lstStyle/>
+          <a:p>
+            <a:pPr algn="ctr">
+              <a:defRPr sz="1350" b="1">
+                <a:solidFill>
+                  <a:srgbClr val="0E2841"/>
+                </a:solidFill>
+                <a:latin typeface="Aptos"/>
+                <a:ea typeface="Aptos"/>
+                <a:cs typeface="Aptos"/>
+              </a:defRPr>
+            </a:pPr>
+            <a:r>
+              <a:rPr sz="1350" b="1">
+                <a:solidFill>
+                  <a:srgbClr val="0E2841"/>
+                </a:solidFill>
+                <a:latin typeface="Aptos"/>
+                <a:ea typeface="Aptos"/>
+                <a:cs typeface="Aptos"/>
+              </a:rPr>
+              <a:t>C3</a:t>
+            </a:r>
+          </a:p>
+          <a:p>
+            <a:pPr algn="ctr">
+              <a:defRPr sz="1350" b="1">
+                <a:solidFill>
+                  <a:srgbClr val="0E2841"/>
+                </a:solidFill>
+                <a:latin typeface="Aptos"/>
+                <a:ea typeface="Aptos"/>
+                <a:cs typeface="Aptos"/>
+              </a:defRPr>
+            </a:pPr>
+            <a:r>
+              <a:rPr sz="1350" b="1">
+                <a:solidFill>
+                  <a:srgbClr val="0E2841"/>
+                </a:solidFill>
+                <a:latin typeface="Aptos"/>
+                <a:ea typeface="Aptos"/>
+                <a:cs typeface="Aptos"/>
+              </a:rPr>
+              <a:t>read x</a:t>
+            </a:r>
+          </a:p>
+        </p:txBody>
+      </p:sp>
+      <p:sp>
+        <p:nvSpPr>
+          <p:cNvPr id="57" name="Client 4 read">
+            <a:extLst>
+              <a:ext uri="{FF2B5EF4-FFF2-40B4-BE49-F238E27FC236}">
+                <a16:creationId xmlns:a16="http://schemas.microsoft.com/office/drawing/2014/main" id="{C047F16D-4224-436C-BA2F-7F4F14E7970E}"/>
+              </a:ext>
+            </a:extLst>
+          </p:cNvPr>
+          <p:cNvSpPr>
+            <a:spLocks noGrp="1"/>
+          </p:cNvSpPr>
+          <p:nvPr/>
+        </p:nvSpPr>
+        <p:spPr>
+          <a:xfrm>
+            <a:off x="5100000" y="2250000"/>
+            <a:ext cx="1400000" cy="590550"/>
+          </a:xfrm>
+          <a:prstGeom prst="roundRect">
+            <a:avLst>
+              <a:gd name="adj" fmla="val 13889"/>
+            </a:avLst>
+          </a:prstGeom>
+          <a:solidFill>
+            <a:srgbClr val="E8F0F5"/>
+          </a:solidFill>
+          <a:ln w="19050">
+            <a:solidFill>
+              <a:srgbClr val="0E2841"/>
+            </a:solidFill>
+            <a:prstDash val="solid"/>
+          </a:ln>
+        </p:spPr>
+        <p:txBody>
+          <a:bodyPr lIns="47625" tIns="47625" rIns="47625" bIns="47625" anchor="ctr">
+            <a:normAutofit/>
+          </a:bodyPr>
+          <a:lstStyle/>
+          <a:p>
+            <a:pPr algn="ctr">
+              <a:defRPr sz="1350" b="1">
+                <a:solidFill>
+                  <a:srgbClr val="0E2841"/>
+                </a:solidFill>
+                <a:latin typeface="Aptos"/>
+                <a:ea typeface="Aptos"/>
+                <a:cs typeface="Aptos"/>
+              </a:defRPr>
+            </a:pPr>
+            <a:r>
+              <a:rPr sz="1350" b="1">
+                <a:solidFill>
+                  <a:srgbClr val="0E2841"/>
+                </a:solidFill>
+                <a:latin typeface="Aptos"/>
+                <a:ea typeface="Aptos"/>
+                <a:cs typeface="Aptos"/>
+              </a:rPr>
+              <a:t>C4</a:t>
+            </a:r>
+          </a:p>
+          <a:p>
+            <a:pPr algn="ctr">
+              <a:defRPr sz="1350" b="1">
+                <a:solidFill>
+                  <a:srgbClr val="0E2841"/>
+                </a:solidFill>
+                <a:latin typeface="Aptos"/>
+                <a:ea typeface="Aptos"/>
+                <a:cs typeface="Aptos"/>
+              </a:defRPr>
+            </a:pPr>
+            <a:r>
+              <a:rPr sz="1350" b="1">
+                <a:solidFill>
+                  <a:srgbClr val="0E2841"/>
+                </a:solidFill>
+                <a:latin typeface="Aptos"/>
+                <a:ea typeface="Aptos"/>
+                <a:cs typeface="Aptos"/>
+              </a:rPr>
+              <a:t>read x</a:t>
+            </a:r>
+          </a:p>
+        </p:txBody>
+      </p:sp>
+      <p:cxnSp>
+        <p:nvCxnSpPr>
+          <p:cNvPr id="76" name="Write arrow 1"/>
+          <p:cNvCxnSpPr/>
+          <p:nvPr/>
+        </p:nvCxnSpPr>
+        <p:spPr>
+          <a:xfrm>
+            <a:off x="1850000" y="1795275"/>
+            <a:ext cx="550000" cy="375000"/>
+          </a:xfrm>
+          <a:prstGeom prst="straightConnector1">
+            <a:avLst/>
+          </a:prstGeom>
+          <a:ln w="19050">
+            <a:solidFill>
+              <a:srgbClr val="A02B93"/>
+            </a:solidFill>
+            <a:prstDash val="solid"/>
+            <a:tailEnd type="triangle" w="sm" len="sm"/>
+          </a:ln>
+        </p:spPr>
+      </p:cxnSp>
+      <p:cxnSp>
+        <p:nvCxnSpPr>
+          <p:cNvPr id="77" name="Write arrow 2"/>
+          <p:cNvCxnSpPr/>
+          <p:nvPr/>
+        </p:nvCxnSpPr>
+        <p:spPr>
+          <a:xfrm flipV="1">
+            <a:off x="1850000" y="2170275"/>
+            <a:ext cx="550000" cy="375000"/>
+          </a:xfrm>
+          <a:prstGeom prst="straightConnector1">
+            <a:avLst/>
+          </a:prstGeom>
+          <a:ln w="19050">
+            <a:solidFill>
+              <a:srgbClr val="A02B93"/>
+            </a:solidFill>
+            <a:prstDash val="solid"/>
+            <a:tailEnd type="triangle" w="sm" len="sm"/>
+          </a:ln>
+        </p:spPr>
+      </p:cxnSp>
+      <p:cxnSp>
+        <p:nvCxnSpPr>
+          <p:cNvPr id="78" name="Read arrow 1"/>
+          <p:cNvCxnSpPr/>
+          <p:nvPr/>
+        </p:nvCxnSpPr>
+        <p:spPr>
+          <a:xfrm flipV="1">
+            <a:off x="4600000" y="1795275"/>
+            <a:ext cx="500000" cy="375000"/>
+          </a:xfrm>
+          <a:prstGeom prst="straightConnector1">
+            <a:avLst/>
+          </a:prstGeom>
+          <a:ln w="19050">
+            <a:solidFill>
+              <a:srgbClr val="5B6573"/>
+            </a:solidFill>
+            <a:prstDash val="solid"/>
+            <a:tailEnd type="triangle" w="sm" len="sm"/>
+          </a:ln>
+        </p:spPr>
+      </p:cxnSp>
+      <p:cxnSp>
+        <p:nvCxnSpPr>
+          <p:cNvPr id="79" name="Read arrow 2"/>
+          <p:cNvCxnSpPr/>
+          <p:nvPr/>
+        </p:nvCxnSpPr>
+        <p:spPr>
+          <a:xfrm>
+            <a:off x="4600000" y="2170275"/>
+            <a:ext cx="500000" cy="375000"/>
+          </a:xfrm>
+          <a:prstGeom prst="straightConnector1">
+            <a:avLst/>
+          </a:prstGeom>
+          <a:ln w="19050">
+            <a:solidFill>
+              <a:srgbClr val="5B6573"/>
+            </a:solidFill>
+            <a:prstDash val="solid"/>
+            <a:tailEnd type="triangle" w="sm" len="sm"/>
+          </a:ln>
+        </p:spPr>
+      </p:cxnSp>
+      <p:sp>
+        <p:nvSpPr>
+          <p:cNvPr id="68" name="Same value label">
+            <a:extLst>
+              <a:ext uri="{FF2B5EF4-FFF2-40B4-BE49-F238E27FC236}">
+                <a16:creationId xmlns:a16="http://schemas.microsoft.com/office/drawing/2014/main" id="{8E2343DF-2BB9-401F-B950-594DD72F33BC}"/>
+              </a:ext>
+            </a:extLst>
+          </p:cNvPr>
+          <p:cNvSpPr>
+            <a:spLocks noGrp="1"/>
+          </p:cNvSpPr>
+          <p:nvPr/>
+        </p:nvSpPr>
+        <p:spPr>
+          <a:xfrm>
+            <a:off x="5100000" y="2900000"/>
+            <a:ext cx="1400000" cy="257175"/>
+          </a:xfrm>
+          <a:prstGeom prst="rect">
+            <a:avLst/>
+          </a:prstGeom>
+          <a:noFill/>
+          <a:ln w="0">
+            <a:noFill/>
+          </a:ln>
+        </p:spPr>
+        <p:txBody>
+          <a:bodyPr>
+            <a:normAutofit/>
+          </a:bodyPr>
+          <a:lstStyle/>
+          <a:p>
+            <a:pPr algn="ctr">
+              <a:defRPr sz="1425" b="1">
+                <a:solidFill>
+                  <a:srgbClr val="A02B93"/>
+                </a:solidFill>
+                <a:latin typeface="Aptos"/>
+                <a:ea typeface="Aptos"/>
+                <a:cs typeface="Aptos"/>
+              </a:defRPr>
+            </a:pPr>
+            <a:r>
+              <a:rPr sz="1425" b="1">
+                <a:solidFill>
+                  <a:srgbClr val="A02B93"/>
+                </a:solidFill>
+                <a:latin typeface="Aptos"/>
+                <a:ea typeface="Aptos"/>
+                <a:cs typeface="Aptos"/>
+              </a:rPr>
+              <a:t>same value?</a:t>
+            </a:r>
+          </a:p>
+        </p:txBody>
+      </p:sp>
+      <p:sp>
+        <p:nvSpPr>
+          <p:cNvPr id="58" name="Diagram divider">
+            <a:extLst>
+              <a:ext uri="{FF2B5EF4-FFF2-40B4-BE49-F238E27FC236}">
+                <a16:creationId xmlns:a16="http://schemas.microsoft.com/office/drawing/2014/main" id="{F5D6858F-3BE5-4C9A-98FD-301B4CE6E4D8}"/>
+              </a:ext>
+            </a:extLst>
+          </p:cNvPr>
+          <p:cNvSpPr>
+            <a:spLocks noGrp="1"/>
+          </p:cNvSpPr>
+          <p:nvPr/>
+        </p:nvSpPr>
+        <p:spPr>
+          <a:xfrm>
+            <a:off x="409575" y="3352800"/>
+            <a:ext cx="6334125" cy="0"/>
+          </a:xfrm>
+          <a:prstGeom prst="line">
+            <a:avLst/>
+          </a:prstGeom>
+          <a:noFill/>
+          <a:ln w="9525">
+            <a:solidFill>
+              <a:srgbClr val="C9D1D9"/>
+            </a:solidFill>
+            <a:prstDash val="solid"/>
+          </a:ln>
+        </p:spPr>
+        <p:txBody>
+          <a:bodyPr/>
+          <a:lstStyle/>
+          <a:p>
+            <a:endParaRPr lang="en-US"/>
+          </a:p>
+        </p:txBody>
+      </p:sp>
+      <p:sp>
+        <p:nvSpPr>
+          <p:cNvPr id="59" name="Answer heading">
+            <a:extLst>
+              <a:ext uri="{FF2B5EF4-FFF2-40B4-BE49-F238E27FC236}">
+                <a16:creationId xmlns:a16="http://schemas.microsoft.com/office/drawing/2014/main" id="{661EE3E6-4BC3-4749-8762-CC8F835B020D}"/>
+              </a:ext>
+            </a:extLst>
+          </p:cNvPr>
+          <p:cNvSpPr>
+            <a:spLocks noGrp="1"/>
+          </p:cNvSpPr>
+          <p:nvPr/>
+        </p:nvSpPr>
+        <p:spPr>
+          <a:xfrm>
+            <a:off x="409575" y="3514725"/>
+            <a:ext cx="6429375" cy="323850"/>
+          </a:xfrm>
+          <a:prstGeom prst="rect">
+            <a:avLst/>
+          </a:prstGeom>
+          <a:noFill/>
+          <a:ln w="0">
+            <a:noFill/>
+          </a:ln>
+        </p:spPr>
+        <p:txBody>
+          <a:bodyPr>
+            <a:normAutofit/>
+          </a:bodyPr>
+          <a:lstStyle/>
+          <a:p>
+            <a:pPr>
+              <a:defRPr sz="1725" b="1">
+                <a:solidFill>
+                  <a:srgbClr val="0E2841"/>
+                </a:solidFill>
+                <a:latin typeface="Aptos"/>
+                <a:ea typeface="Aptos"/>
+                <a:cs typeface="Aptos"/>
+              </a:defRPr>
+            </a:pPr>
+            <a:r>
+              <a:rPr sz="1725" b="1">
+                <a:solidFill>
+                  <a:srgbClr val="0E2841"/>
+                </a:solidFill>
+                <a:latin typeface="Aptos"/>
+                <a:ea typeface="Aptos"/>
+                <a:cs typeface="Aptos"/>
+              </a:rPr>
+              <a:t>What are they allowed to see?</a:t>
+            </a:r>
+          </a:p>
+        </p:txBody>
+      </p:sp>
+      <p:sp>
+        <p:nvSpPr>
+          <p:cNvPr id="60" name="Outcome 1">
+            <a:extLst>
+              <a:ext uri="{FF2B5EF4-FFF2-40B4-BE49-F238E27FC236}">
+                <a16:creationId xmlns:a16="http://schemas.microsoft.com/office/drawing/2014/main" id="{C047F16D-4224-436C-BA2F-7F4F14E7970E}"/>
+              </a:ext>
+            </a:extLst>
+          </p:cNvPr>
+          <p:cNvSpPr>
+            <a:spLocks noGrp="1"/>
+          </p:cNvSpPr>
+          <p:nvPr/>
+        </p:nvSpPr>
+        <p:spPr>
+          <a:xfrm>
+            <a:off x="409575" y="4095750"/>
+            <a:ext cx="1900000" cy="800000"/>
+          </a:xfrm>
+          <a:prstGeom prst="roundRect">
+            <a:avLst>
+              <a:gd name="adj" fmla="val 13889"/>
+            </a:avLst>
+          </a:prstGeom>
+          <a:solidFill>
+            <a:srgbClr val="E8F0F5"/>
+          </a:solidFill>
+          <a:ln w="19050">
+            <a:solidFill>
+              <a:srgbClr val="0E2841"/>
+            </a:solidFill>
+            <a:prstDash val="solid"/>
+          </a:ln>
+        </p:spPr>
+        <p:txBody>
+          <a:bodyPr lIns="47625" tIns="47625" rIns="47625" bIns="47625" anchor="ctr">
+            <a:normAutofit/>
+          </a:bodyPr>
+          <a:lstStyle/>
+          <a:p>
+            <a:pPr algn="ctr">
+              <a:defRPr sz="1350" b="1">
+                <a:solidFill>
+                  <a:srgbClr val="0E2841"/>
+                </a:solidFill>
+                <a:latin typeface="Aptos"/>
+                <a:ea typeface="Aptos"/>
+                <a:cs typeface="Aptos"/>
+              </a:defRPr>
+            </a:pPr>
+            <a:r>
+              <a:rPr sz="1350" b="1">
+                <a:solidFill>
+                  <a:srgbClr val="0E2841"/>
+                </a:solidFill>
+                <a:latin typeface="Aptos"/>
+                <a:ea typeface="Aptos"/>
+                <a:cs typeface="Aptos"/>
+              </a:rPr>
+              <a:t>both read 1</a:t>
+            </a:r>
+          </a:p>
+          <a:p>
+            <a:pPr algn="ctr">
+              <a:defRPr sz="1350" b="1">
+                <a:solidFill>
+                  <a:srgbClr val="0E2841"/>
+                </a:solidFill>
+                <a:latin typeface="Aptos"/>
+                <a:ea typeface="Aptos"/>
+                <a:cs typeface="Aptos"/>
+              </a:defRPr>
+            </a:pPr>
+            <a:r>
+              <a:rPr sz="1350" b="1">
+                <a:solidFill>
+                  <a:srgbClr val="0E2841"/>
+                </a:solidFill>
+                <a:latin typeface="Aptos"/>
+                <a:ea typeface="Aptos"/>
+                <a:cs typeface="Aptos"/>
+              </a:rPr>
+              <a:t>allowed</a:t>
+            </a:r>
+          </a:p>
+        </p:txBody>
+      </p:sp>
+      <p:sp>
+        <p:nvSpPr>
+          <p:cNvPr id="61" name="Outcome 2">
+            <a:extLst>
+              <a:ext uri="{FF2B5EF4-FFF2-40B4-BE49-F238E27FC236}">
+                <a16:creationId xmlns:a16="http://schemas.microsoft.com/office/drawing/2014/main" id="{C047F16D-4224-436C-BA2F-7F4F14E7970E}"/>
+              </a:ext>
+            </a:extLst>
+          </p:cNvPr>
+          <p:cNvSpPr>
+            <a:spLocks noGrp="1"/>
+          </p:cNvSpPr>
+          <p:nvPr/>
+        </p:nvSpPr>
+        <p:spPr>
+          <a:xfrm>
+            <a:off x="2674262" y="4095750"/>
+            <a:ext cx="1900000" cy="800000"/>
+          </a:xfrm>
+          <a:prstGeom prst="roundRect">
+            <a:avLst>
+              <a:gd name="adj" fmla="val 13889"/>
+            </a:avLst>
+          </a:prstGeom>
+          <a:solidFill>
+            <a:srgbClr val="E8F0F5"/>
+          </a:solidFill>
+          <a:ln w="19050">
+            <a:solidFill>
+              <a:srgbClr val="0E2841"/>
+            </a:solidFill>
+            <a:prstDash val="solid"/>
+          </a:ln>
+        </p:spPr>
+        <p:txBody>
+          <a:bodyPr lIns="47625" tIns="47625" rIns="47625" bIns="47625" anchor="ctr">
+            <a:normAutofit/>
+          </a:bodyPr>
+          <a:lstStyle/>
+          <a:p>
+            <a:pPr algn="ctr">
+              <a:defRPr sz="1350" b="1">
+                <a:solidFill>
+                  <a:srgbClr val="0E2841"/>
+                </a:solidFill>
+                <a:latin typeface="Aptos"/>
+                <a:ea typeface="Aptos"/>
+                <a:cs typeface="Aptos"/>
+              </a:defRPr>
+            </a:pPr>
+            <a:r>
+              <a:rPr sz="1350" b="1">
+                <a:solidFill>
+                  <a:srgbClr val="0E2841"/>
+                </a:solidFill>
+                <a:latin typeface="Aptos"/>
+                <a:ea typeface="Aptos"/>
+                <a:cs typeface="Aptos"/>
+              </a:rPr>
+              <a:t>both read 2</a:t>
+            </a:r>
+          </a:p>
+          <a:p>
+            <a:pPr algn="ctr">
+              <a:defRPr sz="1350" b="1">
+                <a:solidFill>
+                  <a:srgbClr val="0E2841"/>
+                </a:solidFill>
+                <a:latin typeface="Aptos"/>
+                <a:ea typeface="Aptos"/>
+                <a:cs typeface="Aptos"/>
+              </a:defRPr>
+            </a:pPr>
+            <a:r>
+              <a:rPr sz="1350" b="1">
+                <a:solidFill>
+                  <a:srgbClr val="0E2841"/>
+                </a:solidFill>
+                <a:latin typeface="Aptos"/>
+                <a:ea typeface="Aptos"/>
+                <a:cs typeface="Aptos"/>
+              </a:rPr>
+              <a:t>allowed</a:t>
+            </a:r>
+          </a:p>
+        </p:txBody>
+      </p:sp>
+      <p:sp>
+        <p:nvSpPr>
+          <p:cNvPr id="62" name="Outcome 3">
+            <a:extLst>
+              <a:ext uri="{FF2B5EF4-FFF2-40B4-BE49-F238E27FC236}">
+                <a16:creationId xmlns:a16="http://schemas.microsoft.com/office/drawing/2014/main" id="{C047F16D-4224-436C-BA2F-7F4F14E7970E}"/>
+              </a:ext>
+            </a:extLst>
+          </p:cNvPr>
+          <p:cNvSpPr>
+            <a:spLocks noGrp="1"/>
+          </p:cNvSpPr>
+          <p:nvPr/>
+        </p:nvSpPr>
+        <p:spPr>
+          <a:xfrm>
+            <a:off x="4938949" y="4095750"/>
+            <a:ext cx="1900000" cy="800000"/>
+          </a:xfrm>
+          <a:prstGeom prst="roundRect">
+            <a:avLst>
+              <a:gd name="adj" fmla="val 13889"/>
+            </a:avLst>
+          </a:prstGeom>
+          <a:solidFill>
+            <a:srgbClr val="F7E8F5"/>
+          </a:solidFill>
+          <a:ln w="19050">
+            <a:solidFill>
+              <a:srgbClr val="A02B93"/>
+            </a:solidFill>
+            <a:prstDash val="solid"/>
+          </a:ln>
+        </p:spPr>
+        <p:txBody>
+          <a:bodyPr lIns="47625" tIns="47625" rIns="47625" bIns="47625" anchor="ctr">
+            <a:normAutofit/>
+          </a:bodyPr>
+          <a:lstStyle/>
+          <a:p>
+            <a:pPr algn="ctr">
+              <a:defRPr sz="1350" b="1">
+                <a:solidFill>
+                  <a:srgbClr val="A02B93"/>
+                </a:solidFill>
+                <a:latin typeface="Aptos"/>
+                <a:ea typeface="Aptos"/>
+                <a:cs typeface="Aptos"/>
+              </a:defRPr>
+            </a:pPr>
+            <a:r>
+              <a:rPr sz="1350" b="1">
+                <a:solidFill>
+                  <a:srgbClr val="A02B93"/>
+                </a:solidFill>
+                <a:latin typeface="Aptos"/>
+                <a:ea typeface="Aptos"/>
+                <a:cs typeface="Aptos"/>
+              </a:rPr>
+              <a:t>one reads 1,</a:t>
+            </a:r>
+          </a:p>
+          <a:p>
+            <a:pPr algn="ctr">
+              <a:defRPr sz="1350" b="1">
+                <a:solidFill>
+                  <a:srgbClr val="A02B93"/>
+                </a:solidFill>
+                <a:latin typeface="Aptos"/>
+                <a:ea typeface="Aptos"/>
+                <a:cs typeface="Aptos"/>
+              </a:defRPr>
+            </a:pPr>
+            <a:r>
+              <a:rPr sz="1350" b="1">
+                <a:solidFill>
+                  <a:srgbClr val="A02B93"/>
+                </a:solidFill>
+                <a:latin typeface="Aptos"/>
+                <a:ea typeface="Aptos"/>
+                <a:cs typeface="Aptos"/>
+              </a:rPr>
+              <a:t>the other reads 2</a:t>
+            </a:r>
+          </a:p>
+          <a:p>
+            <a:pPr algn="ctr">
+              <a:defRPr sz="1350" b="1">
+                <a:solidFill>
+                  <a:srgbClr val="A02B93"/>
+                </a:solidFill>
+                <a:latin typeface="Aptos"/>
+                <a:ea typeface="Aptos"/>
+                <a:cs typeface="Aptos"/>
+              </a:defRPr>
+            </a:pPr>
+            <a:r>
+              <a:rPr sz="1350" b="1">
+                <a:solidFill>
+                  <a:srgbClr val="A02B93"/>
+                </a:solidFill>
+                <a:latin typeface="Aptos"/>
+                <a:ea typeface="Aptos"/>
+                <a:cs typeface="Aptos"/>
+              </a:rPr>
+              <a:t>not allowed</a:t>
+            </a:r>
+          </a:p>
+        </p:txBody>
+      </p:sp>
+      <p:sp>
+        <p:nvSpPr>
+          <p:cNvPr id="63" name="Answer caption">
+            <a:extLst>
+              <a:ext uri="{FF2B5EF4-FFF2-40B4-BE49-F238E27FC236}">
+                <a16:creationId xmlns:a16="http://schemas.microsoft.com/office/drawing/2014/main" id="{F52DF72F-2902-473C-9FF3-D23AA5738F62}"/>
+              </a:ext>
+            </a:extLst>
+          </p:cNvPr>
+          <p:cNvSpPr>
+            <a:spLocks noGrp="1"/>
+          </p:cNvSpPr>
+          <p:nvPr/>
+        </p:nvSpPr>
+        <p:spPr>
+          <a:xfrm>
+            <a:off x="409575" y="5105400"/>
+            <a:ext cx="6429375" cy="352425"/>
+          </a:xfrm>
+          <a:prstGeom prst="rect">
+            <a:avLst/>
+          </a:prstGeom>
+          <a:noFill/>
+          <a:ln w="0">
+            <a:noFill/>
+          </a:ln>
+        </p:spPr>
+        <p:txBody>
+          <a:bodyPr>
+            <a:normAutofit/>
+          </a:bodyPr>
+          <a:lstStyle/>
+          <a:p>
+            <a:pPr algn="ctr">
+              <a:defRPr sz="1650" b="1">
+                <a:solidFill>
+                  <a:srgbClr val="A02B93"/>
+                </a:solidFill>
+                <a:latin typeface="Aptos"/>
+                <a:ea typeface="Aptos"/>
+                <a:cs typeface="Aptos"/>
+              </a:defRPr>
+            </a:pPr>
+            <a:r>
+              <a:rPr sz="1650" b="1">
+                <a:solidFill>
+                  <a:srgbClr val="A02B93"/>
+                </a:solidFill>
+                <a:latin typeface="Aptos"/>
+                <a:ea typeface="Aptos"/>
+                <a:cs typeface="Aptos"/>
+              </a:rPr>
+              <a:t>Either order is fine; disagreeing is not</a:t>
+            </a:r>
+          </a:p>
+        </p:txBody>
+      </p:sp>
+    </p:spTree>
+  </p:cSld>
+  <p:clrMapOvr>
+    <a:masterClrMapping/>
+  </p:clrMapOvr>
+  <p:timing>
+    <p:tnLst>
+      <p:par>
+        <p:cTn id="1" dur="indefinite" restart="never" nodeType="tmRoot">
+          <p:childTnLst>
+            <p:seq concurrent="1" nextAc="seek">
+              <p:cTn id="2" dur="indefinite" nodeType="mainSeq">
+                <p:childTnLst>
+                  <p:par>
+                    <p:cTn id="3" fill="hold">
+                      <p:stCondLst>
+                        <p:cond delay="indefinite"/>
+                      </p:stCondLst>
+                      <p:childTnLst>
+                        <p:par>
+                          <p:cTn id="4" fill="hold">
+                            <p:stCondLst>
+                              <p:cond delay="0"/>
+                            </p:stCondLst>
+                            <p:childTnLst>
+                              <p:par>
+                                <p:cTn id="5" presetID="9" presetClass="entr" presetSubtype="0" fill="hold" nodeType="clickEffect">
+                                  <p:stCondLst>
+                                    <p:cond delay="0"/>
+                                  </p:stCondLst>
+                                  <p:childTnLst>
+                                    <p:set>
+                                      <p:cBhvr>
+                                        <p:cTn id="6" dur="1" fill="hold">
+                                          <p:stCondLst>
+                                            <p:cond delay="0"/>
+                                          </p:stCondLst>
+                                        </p:cTn>
+                                        <p:tgtEl>
+                                          <p:spTgt spid="48">
+                                            <p:txEl>
+                                              <p:pRg st="4" end="4"/>
+                                            </p:txEl>
+                                          </p:spTgt>
+                                        </p:tgtEl>
+                                        <p:attrNameLst>
+                                          <p:attrName>style.visibility</p:attrName>
+                                        </p:attrNameLst>
+                                      </p:cBhvr>
+                                      <p:to>
+                                        <p:strVal val="visible"/>
+                                      </p:to>
+                                    </p:set>
+                                    <p:animEffect transition="in" filter="dissolve">
+                                      <p:cBhvr>
+                                        <p:cTn id="7" dur="500"/>
+                                        <p:tgtEl>
+                                          <p:spTgt spid="48">
+                                            <p:txEl>
+                                              <p:pRg st="4" end="4"/>
+                                            </p:txEl>
+                                          </p:spTgt>
+                                        </p:tgtEl>
+                                      </p:cBhvr>
+                                    </p:animEffect>
+                                  </p:childTnLst>
+                                </p:cTn>
+                              </p:par>
+                              <p:par>
+                                <p:cTn id="8" presetID="9" presetClass="entr" presetSubtype="0" fill="hold" nodeType="withEffect">
+                                  <p:stCondLst>
+                                    <p:cond delay="0"/>
+                                  </p:stCondLst>
+                                  <p:childTnLst>
+                                    <p:set>
+                                      <p:cBhvr>
+                                        <p:cTn id="9" dur="1" fill="hold">
+                                          <p:stCondLst>
+                                            <p:cond delay="0"/>
+                                          </p:stCondLst>
+                                        </p:cTn>
+                                        <p:tgtEl>
+                                          <p:spTgt spid="48">
+                                            <p:txEl>
+                                              <p:pRg st="6" end="6"/>
+                                            </p:txEl>
+                                          </p:spTgt>
+                                        </p:tgtEl>
+                                        <p:attrNameLst>
+                                          <p:attrName>style.visibility</p:attrName>
+                                        </p:attrNameLst>
+                                      </p:cBhvr>
+                                      <p:to>
+                                        <p:strVal val="visible"/>
+                                      </p:to>
+                                    </p:set>
+                                    <p:animEffect transition="in" filter="dissolve">
+                                      <p:cBhvr>
+                                        <p:cTn id="10" dur="500"/>
+                                        <p:tgtEl>
+                                          <p:spTgt spid="48">
+                                            <p:txEl>
+                                              <p:pRg st="6" end="6"/>
+                                            </p:txEl>
+                                          </p:spTgt>
+                                        </p:tgtEl>
+                                      </p:cBhvr>
+                                    </p:animEffect>
+                                  </p:childTnLst>
+                                </p:cTn>
+                              </p:par>
+                              <p:par>
+                                <p:cTn id="11" presetID="9" presetClass="entr" presetSubtype="0" fill="hold" grpId="0" nodeType="withEffect">
+                                  <p:stCondLst>
+                                    <p:cond delay="0"/>
+                                  </p:stCondLst>
+                                  <p:childTnLst>
+                                    <p:set>
+                                      <p:cBhvr>
+                                        <p:cTn id="12" dur="1" fill="hold">
+                                          <p:stCondLst>
+                                            <p:cond delay="0"/>
+                                          </p:stCondLst>
+                                        </p:cTn>
+                                        <p:tgtEl>
+                                          <p:spTgt spid="59"/>
+                                        </p:tgtEl>
+                                        <p:attrNameLst>
+                                          <p:attrName>style.visibility</p:attrName>
+                                        </p:attrNameLst>
+                                      </p:cBhvr>
+                                      <p:to>
+                                        <p:strVal val="visible"/>
+                                      </p:to>
+                                    </p:set>
+                                    <p:animEffect transition="in" filter="dissolve">
+                                      <p:cBhvr>
+                                        <p:cTn id="13" dur="500"/>
+                                        <p:tgtEl>
+                                          <p:spTgt spid="59"/>
+                                        </p:tgtEl>
+                                      </p:cBhvr>
+                                    </p:animEffect>
+                                  </p:childTnLst>
+                                </p:cTn>
+                              </p:par>
+                              <p:par>
+                                <p:cTn id="14" presetID="9" presetClass="entr" presetSubtype="0" fill="hold" grpId="0" nodeType="withEffect">
+                                  <p:stCondLst>
+                                    <p:cond delay="0"/>
+                                  </p:stCondLst>
+                                  <p:childTnLst>
+                                    <p:set>
+                                      <p:cBhvr>
+                                        <p:cTn id="15" dur="1" fill="hold">
+                                          <p:stCondLst>
+                                            <p:cond delay="0"/>
+                                          </p:stCondLst>
+                                        </p:cTn>
+                                        <p:tgtEl>
+                                          <p:spTgt spid="60"/>
+                                        </p:tgtEl>
+                                        <p:attrNameLst>
+                                          <p:attrName>style.visibility</p:attrName>
+                                        </p:attrNameLst>
+                                      </p:cBhvr>
+                                      <p:to>
+                                        <p:strVal val="visible"/>
+                                      </p:to>
+                                    </p:set>
+                                    <p:animEffect transition="in" filter="dissolve">
+                                      <p:cBhvr>
+                                        <p:cTn id="16" dur="500"/>
+                                        <p:tgtEl>
+                                          <p:spTgt spid="60"/>
+                                        </p:tgtEl>
+                                      </p:cBhvr>
+                                    </p:animEffect>
+                                  </p:childTnLst>
+                                </p:cTn>
+                              </p:par>
+                              <p:par>
+                                <p:cTn id="17" presetID="9" presetClass="entr" presetSubtype="0" fill="hold" grpId="0" nodeType="withEffect">
+                                  <p:stCondLst>
+                                    <p:cond delay="0"/>
+                                  </p:stCondLst>
+                                  <p:childTnLst>
+                                    <p:set>
+                                      <p:cBhvr>
+                                        <p:cTn id="18" dur="1" fill="hold">
+                                          <p:stCondLst>
+                                            <p:cond delay="0"/>
+                                          </p:stCondLst>
+                                        </p:cTn>
+                                        <p:tgtEl>
+                                          <p:spTgt spid="61"/>
+                                        </p:tgtEl>
+                                        <p:attrNameLst>
+                                          <p:attrName>style.visibility</p:attrName>
+                                        </p:attrNameLst>
+                                      </p:cBhvr>
+                                      <p:to>
+                                        <p:strVal val="visible"/>
+                                      </p:to>
+                                    </p:set>
+                                    <p:animEffect transition="in" filter="dissolve">
+                                      <p:cBhvr>
+                                        <p:cTn id="19" dur="500"/>
+                                        <p:tgtEl>
+                                          <p:spTgt spid="61"/>
+                                        </p:tgtEl>
+                                      </p:cBhvr>
+                                    </p:animEffect>
+                                  </p:childTnLst>
+                                </p:cTn>
+                              </p:par>
+                              <p:par>
+                                <p:cTn id="20" presetID="9" presetClass="entr" presetSubtype="0" fill="hold" grpId="0" nodeType="withEffect">
+                                  <p:stCondLst>
+                                    <p:cond delay="0"/>
+                                  </p:stCondLst>
+                                  <p:childTnLst>
+                                    <p:set>
+                                      <p:cBhvr>
+                                        <p:cTn id="21" dur="1" fill="hold">
+                                          <p:stCondLst>
+                                            <p:cond delay="0"/>
+                                          </p:stCondLst>
+                                        </p:cTn>
+                                        <p:tgtEl>
+                                          <p:spTgt spid="62"/>
+                                        </p:tgtEl>
+                                        <p:attrNameLst>
+                                          <p:attrName>style.visibility</p:attrName>
+                                        </p:attrNameLst>
+                                      </p:cBhvr>
+                                      <p:to>
+                                        <p:strVal val="visible"/>
+                                      </p:to>
+                                    </p:set>
+                                    <p:animEffect transition="in" filter="dissolve">
+                                      <p:cBhvr>
+                                        <p:cTn id="22" dur="500"/>
+                                        <p:tgtEl>
+                                          <p:spTgt spid="62"/>
+                                        </p:tgtEl>
+                                      </p:cBhvr>
+                                    </p:animEffect>
+                                  </p:childTnLst>
+                                </p:cTn>
+                              </p:par>
+                              <p:par>
+                                <p:cTn id="23" presetID="9" presetClass="entr" presetSubtype="0" fill="hold" grpId="0" nodeType="withEffect">
+                                  <p:stCondLst>
+                                    <p:cond delay="0"/>
+                                  </p:stCondLst>
+                                  <p:childTnLst>
+                                    <p:set>
+                                      <p:cBhvr>
+                                        <p:cTn id="24" dur="1" fill="hold">
+                                          <p:stCondLst>
+                                            <p:cond delay="0"/>
+                                          </p:stCondLst>
+                                        </p:cTn>
+                                        <p:tgtEl>
+                                          <p:spTgt spid="63"/>
+                                        </p:tgtEl>
+                                        <p:attrNameLst>
+                                          <p:attrName>style.visibility</p:attrName>
+                                        </p:attrNameLst>
+                                      </p:cBhvr>
+                                      <p:to>
+                                        <p:strVal val="visible"/>
+                                      </p:to>
+                                    </p:set>
+                                    <p:animEffect transition="in" filter="dissolve">
+                                      <p:cBhvr>
+                                        <p:cTn id="25" dur="500"/>
+                                        <p:tgtEl>
+                                          <p:spTgt spid="63"/>
+                                        </p:tgtEl>
+                                      </p:cBhvr>
+                                    </p:animEffect>
+                                  </p:childTnLst>
+                                </p:cTn>
+                              </p:par>
+                            </p:childTnLst>
+                          </p:cTn>
+                        </p:par>
+                      </p:childTnLst>
+                    </p:cTn>
+                  </p:par>
+                </p:childTnLst>
+              </p:cTn>
+              <p:prevCondLst>
+                <p:cond evt="onPrev" delay="0">
+                  <p:tgtEl>
+                    <p:sldTgt/>
+                  </p:tgtEl>
+                </p:cond>
+              </p:prevCondLst>
+              <p:nextCondLst>
+                <p:cond evt="onNext" delay="0">
+                  <p:tgtEl>
+                    <p:sldTgt/>
+                  </p:tgtEl>
+                </p:cond>
+              </p:nextCondLst>
+            </p:seq>
+          </p:childTnLst>
+        </p:cTn>
+      </p:par>
+    </p:tnLst>
+    <p:bldLst>
+      <p:bldP spid="59" grpId="0"/>
+      <p:bldP spid="60" grpId="0" animBg="1"/>
+      <p:bldP spid="61" grpId="0" animBg="1"/>
+      <p:bldP spid="62" grpId="0" animBg="1"/>
+      <p:bldP spid="63" grpId="0"/>
+    </p:bldLst>
+  </p:timing>
 </p:sld>
 </file>
 

</xml_diff>

<commit_message>
Align GFS consistency scripts with revised slides
</commit_message>
<xml_diff>
--- a/slides/fall26/4-gfs.pptx
+++ b/slides/fall26/4-gfs.pptx
@@ -710,7 +710,7 @@
           <a:p>
             <a:r>
               <a:rPr lang="en-US" dirty="0"/>
-              <a:t>Before looking at the GFS write protocol, establish the behavior we would ideally like from storage.</a:t>
+              <a:t>Before we discuss replication, establish the behavior we would ideally like the storage system to provide.</a:t>
             </a:r>
           </a:p>
           <a:p>
@@ -719,7 +719,7 @@
           <a:p>
             <a:r>
               <a:rPr lang="en-US" dirty="0"/>
-              <a:t>Imagine one correct, single-threaded server holding a table of keys and values. Many clients may send requests at the same time, but the server processes those requests one at a time. It chooses one request, runs it to completion, and then processes the next. Each operation therefore sees the effects of all operations that came before it in that single order.</a:t>
+              <a:t>The intuitive goal is a single-server illusion. The implementation may contain hundreds of machines and several copies of the data, but from the application's point of view, it should behave like one correct machine with one copy of the data.</a:t>
             </a:r>
           </a:p>
           <a:p>
@@ -728,7 +728,7 @@
           <a:p>
             <a:r>
               <a:rPr lang="en-US" dirty="0"/>
-              <a:t>Now suppose client 1 writes x equals 1 and client 2 writes x equals 2 concurrently. Because the requests overlap, we cannot insist that client 1 must go first or that client 2 must go first. Either order is legal. If the server processes x equals 1 and then x equals 2, the final value is 2. If it processes them in the opposite order, the final value is 1.</a:t>
+              <a:t>For this simplified model, imagine that the machine is single-threaded. Many clients may send requests concurrently, but the machine performs only one operation at a time. It chooses one request, runs that request to completion, and then starts the next request. A read therefore observes the effects of all the writes that came before it in the order chosen by the machine.</a:t>
             </a:r>
           </a:p>
           <a:p>
@@ -737,7 +737,7 @@
           <a:p>
             <a:r>
               <a:rPr lang="en-US" dirty="0"/>
-              <a:t>The important requirement comes after both writes have completed. Suppose client 3 and client 4 now read x. Both readers must observe a result consistent with the same order chosen by the server. If the final write was x equals 2, both later reads should return 2. If the final write was x equals 1, both should return 1.</a:t>
+              <a:t>The important point is that concurrent requests still have to be placed into some order. We may not know that order in advance, and the clients may not be able to determine it from network timing. The machine is allowed to choose either request first. Once it chooses, however, all later results must remain consistent with that one choice.</a:t>
             </a:r>
           </a:p>
           <a:p>
@@ -746,7 +746,7 @@
           <a:p>
             <a:r>
               <a:rPr lang="en-US" dirty="0"/>
-              <a:t>Notice what strong consistency does and does not require. It does not tell us in advance which concurrent write wins. From the outside, there may be no way to determine which request reached the server first. Strong consistency requires that there be one legal ordering of the operations and that every client observe results consistent with that ordering.</a:t>
+              <a:t>This gives us a practical test for the examples that follow: could one correct machine, executing one request at a time, have produced everything the clients observed? We do not require one predetermined answer for concurrent requests. We require that all the answers fit one possible sequential order.</a:t>
             </a:r>
           </a:p>
           <a:p>
@@ -755,16 +755,7 @@
           <a:p>
             <a:r>
               <a:rPr lang="en-US" dirty="0"/>
-              <a:t>So a result such as client 3 reading 2 and client 4 later reading 1, with no intervening write, is not merely surprising. It cannot be explained by any execution of this one-server model. The value would appear to move backward by itself.</a:t>
-            </a:r>
-          </a:p>
-          <a:p>
-            <a:endParaRPr lang="en-US" dirty="0"/>
-          </a:p>
-          <a:p>
-            <a:r>
-              <a:rPr lang="en-US" dirty="0"/>
-              <a:t>This is the illusion distributed storage tries to preserve: hundreds of machines and several copies inside, but one coherent logical server from the application's point of view. Replication makes that illusion difficult because different replicas may independently choose different orders.</a:t>
+              <a:t>The next slide applies that test to two concurrent writes and two later reads.</a:t>
             </a:r>
           </a:p>
           <a:p>
@@ -774,11 +765,9 @@
             <a:r>
               <a:rPr lang="en-US" dirty="0"/>
               <a:t>SOURCE
-MIT 6.824, Spring 2020, Lecture 3 transcript/video, 05:42–10:47.
+MIT 6.824, Spring 2020, Lecture 3 transcript/video, 05:42–08:11.
 Local transcript: fall2026/lectures/references/mit-6824-2020-lecture3-gfs-transcript.txt
-https://www.youtube.com/watch?v=EpIgvowZr00
-MIT 6.5840, GFS lecture notes.
-https://pdos.csail.mit.edu/6.824/notes/l-gfs.txt</a:t>
+https://www.youtube.com/watch?v=EpIgvowZr00</a:t>
             </a:r>
           </a:p>
         </p:txBody>
@@ -8869,51 +8858,69 @@
             </a:r>
           </a:p>
           <a:p>
+            <a:endParaRPr lang="en-US" dirty="0"/>
+          </a:p>
+          <a:p>
             <a:r>
               <a:rPr lang="en-US" dirty="0"/>
-              <a:t>Set up the top half: C1 and C2 write the same key at the same time, and afterwards C3 and C4 each read it. Ask what the two readers can see.</a:t>
-            </a:r>
+              <a:t>Set up the top half. Client 1 writes x equals 1, and client 2 writes x equals 2 at the same time. After both writes have completed, client 3 and client 4 each read x. Ask the class: what are the readers allowed to see?</a:t>
+            </a:r>
+          </a:p>
+          <a:p>
+            <a:endParaRPr lang="en-US" dirty="0"/>
           </a:p>
           <a:p>
             <a:r>
               <a:rPr lang="en-US" dirty="0"/>
-              <a:t>Then click. Both readers seeing 1 is correct, and both seeing 2 is correct: the writes were concurrent, so either one could have gone first, and we do not get to insist on which. What is ruled out is the third card, where the readers disagree, because no single machine running one request at a time could have produced that.</a:t>
-            </a:r>
+              <a:t>There is not enough information to say which write the machine processed first. The two writes overlap, so either order is legal. If the machine executes the write of 2 and then the write of 1, the final value is 1, so both readers may return 1. If it executes the write of 1 and then the write of 2, the final value is 2, so both readers may return 2.</a:t>
+            </a:r>
+          </a:p>
+          <a:p>
+            <a:endParaRPr lang="en-US" dirty="0"/>
           </a:p>
           <a:p>
             <a:r>
               <a:rPr lang="en-US" dirty="0"/>
-              <a:t>The sentence to leave them with: consistency is not a claim about which value you get back. It is a claim that everything the clients saw can be explained by one order.</a:t>
-            </a:r>
+              <a:t>Then click. The first two cards are both allowed. Strong consistency does not promise which concurrent write wins. It promises that every result can be explained by one order chosen by the machine.</a:t>
+            </a:r>
+          </a:p>
+          <a:p>
+            <a:endParaRPr lang="en-US" dirty="0"/>
           </a:p>
           <a:p>
             <a:r>
               <a:rPr lang="en-US" dirty="0"/>
-              <a:t>This is the last slide on which the ideal is free. One correct machine gives all of it at no cost, but the earlier slides ruled out running on one machine, so from here on we replicate, and the next two slides are where that goes wrong.</a:t>
-            </a:r>
+              <a:t>The third card is not allowed. If client 3 reads 1 while client 4 reads 2 after both writes have finished, the two observations cannot both fit the same final order. One of the writes would have to be last, and without another intervening write, both later readers should see the value produced by that same last write.</a:t>
+            </a:r>
+          </a:p>
+          <a:p>
+            <a:endParaRPr lang="en-US" dirty="0"/>
           </a:p>
           <a:p>
             <a:r>
               <a:rPr lang="en-US" dirty="0"/>
-              <a:t>SOURCE</a:t>
-            </a:r>
+              <a:t>This is the sentence to leave them with: consistency is not a claim about one particular value that must come back. It is a claim that everything the clients observed can be explained by one coherent order.</a:t>
+            </a:r>
+          </a:p>
+          <a:p>
+            <a:endParaRPr lang="en-US" dirty="0"/>
           </a:p>
           <a:p>
             <a:r>
               <a:rPr lang="en-US" dirty="0"/>
-              <a:t>MIT 6.824, Spring 2020, Lecture 3 video, 08:11-10:47.</a:t>
-            </a:r>
+              <a:t>This is also the last slide on which that ideal is free. One correct machine naturally chooses one order, but one machine has poor fault tolerance. If it or its disk fails, the data is unavailable. We therefore replicate the data, and the next two slides show how a naive replication design loses this single-machine behavior.</a:t>
+            </a:r>
+          </a:p>
+          <a:p>
+            <a:endParaRPr lang="en-US" dirty="0"/>
           </a:p>
           <a:p>
             <a:r>
               <a:rPr lang="en-US" dirty="0"/>
-              <a:t>https://www.youtube.com/watch?v=EpIgvowZr00</a:t>
-            </a:r>
-          </a:p>
-          <a:p>
-            <a:r>
-              <a:rPr lang="en-US" dirty="0"/>
-              <a:t>Local transcript: fall2026/lectures/references/mit-6824-2020-lecture3-gfs-transcript.txt</a:t>
+              <a:t>SOURCE
+MIT 6.824, Spring 2020, Lecture 3 transcript/video, 08:11–10:47.
+Local transcript: fall2026/lectures/references/mit-6824-2020-lecture3-gfs-transcript.txt
+https://www.youtube.com/watch?v=EpIgvowZr00</a:t>
             </a:r>
           </a:p>
         </p:txBody>

</xml_diff>

<commit_message>
Make GFS consistency scripts lecture-ready
</commit_message>
<xml_diff>
--- a/slides/fall26/4-gfs.pptx
+++ b/slides/fall26/4-gfs.pptx
@@ -21,6 +21,7 @@
     <p:sldId id="486" r:id="rId60"/>
     <p:sldId id="444" r:id="rId12"/>
     <p:sldId id="445" r:id="rId13"/>
+    <p:sldId id="487" r:id="rId61"/>
     <p:sldId id="485" r:id="rId59"/>
     <p:sldId id="262" r:id="rId14"/>
     <p:sldId id="430" r:id="rId15"/>
@@ -710,7 +711,7 @@
           <a:p>
             <a:r>
               <a:rPr lang="en-US" dirty="0"/>
-              <a:t>Before we discuss replication, establish the behavior we would ideally like the storage system to provide.</a:t>
+              <a:t>From the application's point of view, the ideal distributed storage system behaves like one correct machine with one copy of the data. The implementation may contain hundreds of machines and several replicas, but those internal details should not change the behavior that clients observe.</a:t>
             </a:r>
           </a:p>
           <a:p>
@@ -719,7 +720,7 @@
           <a:p>
             <a:r>
               <a:rPr lang="en-US" dirty="0"/>
-              <a:t>The intuitive goal is a single-server illusion. The implementation may contain hundreds of machines and several copies of the data, but from the application's point of view, it should behave like one correct machine with one copy of the data.</a:t>
+              <a:t>Imagine that this one machine is single-threaded. Many clients may send requests concurrently, but the machine performs only one operation at a time. It chooses one request, runs it to completion, and then starts the next request. Every operation therefore has a position in one single order.</a:t>
             </a:r>
           </a:p>
           <a:p>
@@ -728,7 +729,7 @@
           <a:p>
             <a:r>
               <a:rPr lang="en-US" dirty="0"/>
-              <a:t>For this simplified model, imagine that the machine is single-threaded. Many clients may send requests concurrently, but the machine performs only one operation at a time. It chooses one request, runs that request to completion, and then starts the next request. A read therefore observes the effects of all the writes that came before it in the order chosen by the machine.</a:t>
+              <a:t>If the operation is a write, it updates the machine's state. If the operation is a read, it returns a value that reflects all the writes that came before it in that order. Concurrent requests still have to be ordered, but we may not know that order in advance. The machine is allowed to choose either concurrent request first. Once it chooses, all later results must remain consistent with that choice.</a:t>
             </a:r>
           </a:p>
           <a:p>
@@ -737,7 +738,7 @@
           <a:p>
             <a:r>
               <a:rPr lang="en-US" dirty="0"/>
-              <a:t>The important point is that concurrent requests still have to be placed into some order. We may not know that order in advance, and the clients may not be able to determine it from network timing. The machine is allowed to choose either request first. Once it chooses, however, all later results must remain consistent with that one choice.</a:t>
+              <a:t>That gives us the test shown at the bottom of the slide: could one correct machine, executing one request at a time, have produced everything the clients observed? We do not require one predetermined result for concurrent requests. We require that all the results fit one possible sequential order.</a:t>
             </a:r>
           </a:p>
           <a:p>
@@ -746,16 +747,7 @@
           <a:p>
             <a:r>
               <a:rPr lang="en-US" dirty="0"/>
-              <a:t>This gives us a practical test for the examples that follow: could one correct machine, executing one request at a time, have produced everything the clients observed? We do not require one predetermined answer for concurrent requests. We require that all the answers fit one possible sequential order.</a:t>
-            </a:r>
-          </a:p>
-          <a:p>
-            <a:endParaRPr lang="en-US" dirty="0"/>
-          </a:p>
-          <a:p>
-            <a:r>
-              <a:rPr lang="en-US" dirty="0"/>
-              <a:t>The next slide applies that test to two concurrent writes and two later reads.</a:t>
+              <a:t>Now suppose two clients write the same key at the same time.</a:t>
             </a:r>
           </a:p>
           <a:p>
@@ -8854,7 +8846,7 @@
           <a:p>
             <a:r>
               <a:rPr lang="en-US" dirty="0"/>
-              <a:t>Do this one as a question to the class before clicking.</a:t>
+              <a:t>Client 1 writes x equals 1, and client 2 writes x equals 2 at the same time. After both writes have completed, client 3 and client 4 each read x. What are the two readers allowed to see?</a:t>
             </a:r>
           </a:p>
           <a:p>
@@ -8863,7 +8855,7 @@
           <a:p>
             <a:r>
               <a:rPr lang="en-US" dirty="0"/>
-              <a:t>Set up the top half. Client 1 writes x equals 1, and client 2 writes x equals 2 at the same time. After both writes have completed, client 3 and client 4 each read x. Ask the class: what are the readers allowed to see?</a:t>
+              <a:t>There is not enough information to say which write the machine processed first. Because the two writes overlap, either order is legal. If the machine executes the write of 2 and then the write of 1, the final value is 1, so both readers may return 1. If it executes the write of 1 and then the write of 2, the final value is 2, so both readers may return 2.</a:t>
             </a:r>
           </a:p>
           <a:p>
@@ -8872,7 +8864,7 @@
           <a:p>
             <a:r>
               <a:rPr lang="en-US" dirty="0"/>
-              <a:t>There is not enough information to say which write the machine processed first. The two writes overlap, so either order is legal. If the machine executes the write of 2 and then the write of 1, the final value is 1, so both readers may return 1. If it executes the write of 1 and then the write of 2, the final value is 2, so both readers may return 2.</a:t>
+              <a:t>Those are the first two outcomes on the slide. Strong consistency does not promise which concurrent write wins. It promises that every result can be explained by one order chosen by the machine.</a:t>
             </a:r>
           </a:p>
           <a:p>
@@ -8881,7 +8873,7 @@
           <a:p>
             <a:r>
               <a:rPr lang="en-US" dirty="0"/>
-              <a:t>Then click. The first two cards are both allowed. Strong consistency does not promise which concurrent write wins. It promises that every result can be explained by one order chosen by the machine.</a:t>
+              <a:t>The third outcome is not allowed. If client 3 reads 1 while client 4 reads 2 after both writes have finished, the two observations cannot fit the same final order. One of the writes must be last, and without another intervening write, both later readers should see the value produced by that same last write.</a:t>
             </a:r>
           </a:p>
           <a:p>
@@ -8890,7 +8882,7 @@
           <a:p>
             <a:r>
               <a:rPr lang="en-US" dirty="0"/>
-              <a:t>The third card is not allowed. If client 3 reads 1 while client 4 reads 2 after both writes have finished, the two observations cannot both fit the same final order. One of the writes would have to be last, and without another intervening write, both later readers should see the value produced by that same last write.</a:t>
+              <a:t>So consistency is not a claim that one particular value must come back. It is a claim that everything the clients observed can be explained by one coherent order.</a:t>
             </a:r>
           </a:p>
           <a:p>
@@ -8899,16 +8891,7 @@
           <a:p>
             <a:r>
               <a:rPr lang="en-US" dirty="0"/>
-              <a:t>This is the sentence to leave them with: consistency is not a claim about one particular value that must come back. It is a claim that everything the clients observed can be explained by one coherent order.</a:t>
-            </a:r>
-          </a:p>
-          <a:p>
-            <a:endParaRPr lang="en-US" dirty="0"/>
-          </a:p>
-          <a:p>
-            <a:r>
-              <a:rPr lang="en-US" dirty="0"/>
-              <a:t>This is also the last slide on which that ideal is free. One correct machine naturally chooses one order, but one machine has poor fault tolerance. If it or its disk fails, the data is unavailable. We therefore replicate the data, and the next two slides show how a naive replication design loses this single-machine behavior.</a:t>
+              <a:t>With one machine, choosing one order comes naturally. But one machine cannot survive a machine or disk failure. Once we keep multiple copies, those copies must somehow preserve the same order. That is where replication becomes difficult.</a:t>
             </a:r>
           </a:p>
           <a:p>
@@ -8921,6 +8904,171 @@
 MIT 6.824, Spring 2020, Lecture 3 transcript/video, 08:11–10:47.
 Local transcript: fall2026/lectures/references/mit-6824-2020-lecture3-gfs-transcript.txt
 https://www.youtube.com/watch?v=EpIgvowZr00</a:t>
+            </a:r>
+          </a:p>
+        </p:txBody>
+      </p:sp>
+      <p:sp>
+        <p:nvSpPr>
+          <p:cNvPr id="4" name="Slide Number Placeholder 3">
+            <a:extLst>
+              <a:ext uri="{FF2B5EF4-FFF2-40B4-BE49-F238E27FC236}">
+                <a16:creationId xmlns:a16="http://schemas.microsoft.com/office/drawing/2014/main" id="{B1960F15-BADC-8306-DE62-2CD20BDF9BC7}"/>
+              </a:ext>
+            </a:extLst>
+          </p:cNvPr>
+          <p:cNvSpPr>
+            <a:spLocks noGrp="1"/>
+          </p:cNvSpPr>
+          <p:nvPr>
+            <p:ph type="sldNum" sz="quarter" idx="5"/>
+          </p:nvPr>
+        </p:nvSpPr>
+        <p:spPr/>
+        <p:txBody>
+          <a:bodyPr/>
+          <a:lstStyle/>
+          <a:p>
+            <a:fld id="{1C9584DC-3658-4054-9DA4-7B68A1D8CC6D}" type="slidenum">
+              <a:rPr lang="zh-CN" altLang="en-US" smtClean="0"/>
+              <a:t>12</a:t>
+            </a:fld>
+            <a:endParaRPr lang="zh-CN" altLang="en-US"/>
+          </a:p>
+        </p:txBody>
+      </p:sp>
+    </p:spTree>
+    <p:extLst>
+      <p:ext uri="{BB962C8B-B14F-4D97-AF65-F5344CB8AC3E}">
+        <p14:creationId xmlns:p14="http://schemas.microsoft.com/office/powerpoint/2010/main" val="2004993241"/>
+      </p:ext>
+    </p:extLst>
+  </p:cSld>
+  <p:clrMapOvr>
+    <a:masterClrMapping/>
+  </p:clrMapOvr>
+</p:notes>
+</file>
+
+<file path=ppt/notesSlides/notesSlide54.xml><?xml version="1.0" encoding="utf-8"?>
+<p:notes xmlns:a="http://schemas.openxmlformats.org/drawingml/2006/main" xmlns:r="http://schemas.openxmlformats.org/officeDocument/2006/relationships" xmlns:p="http://schemas.openxmlformats.org/presentationml/2006/main">
+  <p:cSld>
+    <p:spTree>
+      <p:nvGrpSpPr>
+        <p:cNvPr id="1" name="">
+          <a:extLst>
+            <a:ext uri="{FF2B5EF4-FFF2-40B4-BE49-F238E27FC236}">
+              <a16:creationId xmlns:a16="http://schemas.microsoft.com/office/drawing/2014/main" id="{4FD57F6F-974F-F53C-ED3C-4EABC142FAE9}"/>
+            </a:ext>
+          </a:extLst>
+        </p:cNvPr>
+        <p:cNvGrpSpPr/>
+        <p:nvPr/>
+      </p:nvGrpSpPr>
+      <p:grpSpPr>
+        <a:xfrm>
+          <a:off x="0" y="0"/>
+          <a:ext cx="0" cy="0"/>
+          <a:chOff x="0" y="0"/>
+          <a:chExt cx="0" cy="0"/>
+        </a:xfrm>
+      </p:grpSpPr>
+      <p:sp>
+        <p:nvSpPr>
+          <p:cNvPr id="2" name="Slide Image Placeholder 1">
+            <a:extLst>
+              <a:ext uri="{FF2B5EF4-FFF2-40B4-BE49-F238E27FC236}">
+                <a16:creationId xmlns:a16="http://schemas.microsoft.com/office/drawing/2014/main" id="{D27769DE-EE2B-CDF0-B3A8-4860B154D68E}"/>
+              </a:ext>
+            </a:extLst>
+          </p:cNvPr>
+          <p:cNvSpPr>
+            <a:spLocks noGrp="1" noRot="1" noChangeAspect="1"/>
+          </p:cNvSpPr>
+          <p:nvPr>
+            <p:ph type="sldImg"/>
+          </p:nvPr>
+        </p:nvSpPr>
+        <p:spPr/>
+      </p:sp>
+      <p:sp>
+        <p:nvSpPr>
+          <p:cNvPr id="3" name="Notes Placeholder 2">
+            <a:extLst>
+              <a:ext uri="{FF2B5EF4-FFF2-40B4-BE49-F238E27FC236}">
+                <a16:creationId xmlns:a16="http://schemas.microsoft.com/office/drawing/2014/main" id="{DCB13888-86BD-70E9-CE9B-FF85C31CFD9A}"/>
+              </a:ext>
+            </a:extLst>
+          </p:cNvPr>
+          <p:cNvSpPr>
+            <a:spLocks noGrp="1"/>
+          </p:cNvSpPr>
+          <p:nvPr>
+            <p:ph type="body" idx="1"/>
+          </p:nvPr>
+        </p:nvSpPr>
+        <p:spPr/>
+        <p:txBody>
+          <a:bodyPr/>
+          <a:lstStyle/>
+          <a:p>
+            <a:r>
+              <a:rPr lang="en-US" dirty="0"/>
+              <a:t>Students propose this fix themselves, so it is worth putting up and knocking down.</a:t>
+            </a:r>
+          </a:p>
+          <a:p>
+            <a:r>
+              <a:rPr lang="en-US" dirty="0"/>
+              <a:t>The replicas have already diverged on the previous slide: S1 holds 2 and S2 holds 1. The patch is the obvious one - send every read to S1, and use S2 only when S1 cannot be reached. While S1 is up it appears to work. Every reader sees 2 and nobody ever observes a disagreement.</a:t>
+            </a:r>
+          </a:p>
+          <a:p>
+            <a:r>
+              <a:rPr lang="en-US" dirty="0"/>
+              <a:t>Click. S1 fails. The readers fall back to S2 and now see 1. No client wrote anything between the two reads, and the value still moved backwards.</a:t>
+            </a:r>
+          </a:p>
+          <a:p>
+            <a:r>
+              <a:rPr lang="en-US" dirty="0"/>
+              <a:t>Apply the test from the What Should the Readers See? slide: could one correct machine have produced this? No. A machine that handles one request at a time changes a value only when somebody writes it.</a:t>
+            </a:r>
+          </a:p>
+          <a:p>
+            <a:r>
+              <a:rPr lang="en-US" dirty="0"/>
+              <a:t>The lesson is that reading from a designated server hides the divergence instead of removing it. The divergence is still there, and a failure is exactly when it surfaces, which is the worst possible moment for it to do so.</a:t>
+            </a:r>
+          </a:p>
+          <a:p>
+            <a:r>
+              <a:rPr lang="en-US" dirty="0"/>
+              <a:t>This is also why the next slide can claim that a real fix costs something: the cheap fix has just been shown to be no fix at all.</a:t>
+            </a:r>
+          </a:p>
+          <a:p>
+            <a:r>
+              <a:rPr lang="en-US" dirty="0"/>
+              <a:t>SOURCE</a:t>
+            </a:r>
+          </a:p>
+          <a:p>
+            <a:r>
+              <a:rPr lang="en-US" dirty="0"/>
+              <a:t>MIT 6.824, Spring 2020, Lecture 3 video, 13:18-14:07.</a:t>
+            </a:r>
+          </a:p>
+          <a:p>
+            <a:r>
+              <a:rPr lang="en-US" dirty="0"/>
+              <a:t>https://www.youtube.com/watch?v=EpIgvowZr00</a:t>
+            </a:r>
+          </a:p>
+          <a:p>
+            <a:r>
+              <a:rPr lang="en-US" dirty="0"/>
+              <a:t>Local transcript: fall2026/lectures/references/mit-6824-2020-lecture3-gfs-transcript.txt</a:t>
             </a:r>
           </a:p>
         </p:txBody>
@@ -9407,7 +9555,7 @@
           <a:p>
             <a:r>
               <a:rPr lang="en-US" dirty="0"/>
-              <a:t>The chain on the previous slide leaves us with two questions that will organize the rest of this lecture.</a:t>
+              <a:t>Replication leaves us with two questions that will organize the rest of this lecture.</a:t>
             </a:r>
           </a:p>
           <a:p>
@@ -9416,7 +9564,7 @@
           <a:p>
             <a:r>
               <a:rPr lang="en-US" dirty="0"/>
-              <a:t>The first is a correctness question. Once data is split and replicated across machines, and those machines can fail independently, what does it mean for the storage system to return the correct result? Before we look at GFS, we need a simple reference model for the behavior we would ideally like. The next slide uses the most intuitive model: even though the implementation contains many machines and many copies, applications should be able to reason as if they were talking to one correct server.</a:t>
+              <a:t>The first is a correctness question. Once data is split and replicated across machines that can fail independently, what does it mean for the storage system to return the correct result? Different copies may receive requests at different times, and a client may reach a different copy after a failure. We need a clear model for deciding whether the behavior observed by the clients is still correct.</a:t>
             </a:r>
           </a:p>
           <a:p>
@@ -9425,7 +9573,7 @@
           <a:p>
             <a:r>
               <a:rPr lang="en-US" dirty="0"/>
-              <a:t>The second is a performance question. How much coordination do we need to preserve that illusion? If replicas must agree on every operation before replying, the system adds messages, waits for other machines, and may have to stop when one of them is slow or unreachable. Those costs sit directly on the path of every read or write.</a:t>
+              <a:t>The second is a performance question. How much coordination do we need to obtain that behavior? If replicas must communicate and agree before every reply, each operation requires more messages and more waiting. A slow or unreachable replica may also delay the others.</a:t>
             </a:r>
           </a:p>
           <a:p>
@@ -9434,7 +9582,16 @@
           <a:p>
             <a:r>
               <a:rPr lang="en-US" dirty="0"/>
-              <a:t>These questions are connected. Better coordination usually gives applications simpler behavior, but it costs performance and availability during failures. GFS does not pay the full cost of the strongest possible behavior. It chooses guarantees that match Google's workloads. First, however, let us make the ideal behavior concrete.</a:t>
+              <a:t>These two questions create the central tradeoff. More coordination usually gives applications simpler behavior, but it costs latency, throughput, and sometimes availability during failures. GFS chooses guarantees that fit Google's workloads instead of paying the full cost of the strongest possible consistency.</a:t>
+            </a:r>
+          </a:p>
+          <a:p>
+            <a:endParaRPr lang="en-US" dirty="0"/>
+          </a:p>
+          <a:p>
+            <a:r>
+              <a:rPr lang="en-US" dirty="0"/>
+              <a:t>To understand that choice, we first need a baseline: what behavior would one correct machine with one copy of the data provide?</a:t>
             </a:r>
           </a:p>
           <a:p>
@@ -13184,7 +13341,7 @@
                                         <p:tgtEl>
                                           <p:spTgt spid="2">
                                             <p:txEl>
-                                              <p:pRg st="4" end="4"/>
+                                              <p:pRg st="6" end="7"/>
                                             </p:txEl>
                                           </p:spTgt>
                                         </p:tgtEl>
@@ -13202,7 +13359,7 @@
                                         <p:tgtEl>
                                           <p:spTgt spid="2">
                                             <p:txEl>
-                                              <p:pRg st="4" end="4"/>
+                                              <p:pRg st="6" end="7"/>
                                             </p:txEl>
                                           </p:spTgt>
                                         </p:tgtEl>
@@ -30751,6 +30908,1436 @@
                 <a:cs typeface="Aptos"/>
               </a:rPr>
               <a:t>Either order is fine; disagreeing is not</a:t>
+            </a:r>
+          </a:p>
+        </p:txBody>
+      </p:sp>
+    </p:spTree>
+  </p:cSld>
+  <p:clrMapOvr>
+    <a:masterClrMapping/>
+  </p:clrMapOvr>
+  <p:timing>
+    <p:tnLst>
+      <p:par>
+        <p:cTn id="1" dur="indefinite" restart="never" nodeType="tmRoot">
+          <p:childTnLst>
+            <p:seq concurrent="1" nextAc="seek">
+              <p:cTn id="2" dur="indefinite" nodeType="mainSeq">
+                <p:childTnLst>
+                  <p:par>
+                    <p:cTn id="3" fill="hold">
+                      <p:stCondLst>
+                        <p:cond delay="indefinite"/>
+                      </p:stCondLst>
+                      <p:childTnLst>
+                        <p:par>
+                          <p:cTn id="4" fill="hold">
+                            <p:stCondLst>
+                              <p:cond delay="0"/>
+                            </p:stCondLst>
+                            <p:childTnLst>
+                              <p:par>
+                                <p:cTn id="5" presetID="9" presetClass="entr" presetSubtype="0" fill="hold" nodeType="clickEffect">
+                                  <p:stCondLst>
+                                    <p:cond delay="0"/>
+                                  </p:stCondLst>
+                                  <p:childTnLst>
+                                    <p:set>
+                                      <p:cBhvr>
+                                        <p:cTn id="6" dur="1" fill="hold">
+                                          <p:stCondLst>
+                                            <p:cond delay="0"/>
+                                          </p:stCondLst>
+                                        </p:cTn>
+                                        <p:tgtEl>
+                                          <p:spTgt spid="48">
+                                            <p:txEl>
+                                              <p:pRg st="4" end="4"/>
+                                            </p:txEl>
+                                          </p:spTgt>
+                                        </p:tgtEl>
+                                        <p:attrNameLst>
+                                          <p:attrName>style.visibility</p:attrName>
+                                        </p:attrNameLst>
+                                      </p:cBhvr>
+                                      <p:to>
+                                        <p:strVal val="visible"/>
+                                      </p:to>
+                                    </p:set>
+                                    <p:animEffect transition="in" filter="dissolve">
+                                      <p:cBhvr>
+                                        <p:cTn id="7" dur="500"/>
+                                        <p:tgtEl>
+                                          <p:spTgt spid="48">
+                                            <p:txEl>
+                                              <p:pRg st="4" end="4"/>
+                                            </p:txEl>
+                                          </p:spTgt>
+                                        </p:tgtEl>
+                                      </p:cBhvr>
+                                    </p:animEffect>
+                                  </p:childTnLst>
+                                </p:cTn>
+                              </p:par>
+                              <p:par>
+                                <p:cTn id="8" presetID="9" presetClass="entr" presetSubtype="0" fill="hold" nodeType="withEffect">
+                                  <p:stCondLst>
+                                    <p:cond delay="0"/>
+                                  </p:stCondLst>
+                                  <p:childTnLst>
+                                    <p:set>
+                                      <p:cBhvr>
+                                        <p:cTn id="9" dur="1" fill="hold">
+                                          <p:stCondLst>
+                                            <p:cond delay="0"/>
+                                          </p:stCondLst>
+                                        </p:cTn>
+                                        <p:tgtEl>
+                                          <p:spTgt spid="48">
+                                            <p:txEl>
+                                              <p:pRg st="6" end="6"/>
+                                            </p:txEl>
+                                          </p:spTgt>
+                                        </p:tgtEl>
+                                        <p:attrNameLst>
+                                          <p:attrName>style.visibility</p:attrName>
+                                        </p:attrNameLst>
+                                      </p:cBhvr>
+                                      <p:to>
+                                        <p:strVal val="visible"/>
+                                      </p:to>
+                                    </p:set>
+                                    <p:animEffect transition="in" filter="dissolve">
+                                      <p:cBhvr>
+                                        <p:cTn id="10" dur="500"/>
+                                        <p:tgtEl>
+                                          <p:spTgt spid="48">
+                                            <p:txEl>
+                                              <p:pRg st="6" end="6"/>
+                                            </p:txEl>
+                                          </p:spTgt>
+                                        </p:tgtEl>
+                                      </p:cBhvr>
+                                    </p:animEffect>
+                                  </p:childTnLst>
+                                </p:cTn>
+                              </p:par>
+                              <p:par>
+                                <p:cTn id="11" presetID="9" presetClass="entr" presetSubtype="0" fill="hold" grpId="0" nodeType="withEffect">
+                                  <p:stCondLst>
+                                    <p:cond delay="0"/>
+                                  </p:stCondLst>
+                                  <p:childTnLst>
+                                    <p:set>
+                                      <p:cBhvr>
+                                        <p:cTn id="12" dur="1" fill="hold">
+                                          <p:stCondLst>
+                                            <p:cond delay="0"/>
+                                          </p:stCondLst>
+                                        </p:cTn>
+                                        <p:tgtEl>
+                                          <p:spTgt spid="59"/>
+                                        </p:tgtEl>
+                                        <p:attrNameLst>
+                                          <p:attrName>style.visibility</p:attrName>
+                                        </p:attrNameLst>
+                                      </p:cBhvr>
+                                      <p:to>
+                                        <p:strVal val="visible"/>
+                                      </p:to>
+                                    </p:set>
+                                    <p:animEffect transition="in" filter="dissolve">
+                                      <p:cBhvr>
+                                        <p:cTn id="13" dur="500"/>
+                                        <p:tgtEl>
+                                          <p:spTgt spid="59"/>
+                                        </p:tgtEl>
+                                      </p:cBhvr>
+                                    </p:animEffect>
+                                  </p:childTnLst>
+                                </p:cTn>
+                              </p:par>
+                              <p:par>
+                                <p:cTn id="14" presetID="9" presetClass="entr" presetSubtype="0" fill="hold" grpId="0" nodeType="withEffect">
+                                  <p:stCondLst>
+                                    <p:cond delay="0"/>
+                                  </p:stCondLst>
+                                  <p:childTnLst>
+                                    <p:set>
+                                      <p:cBhvr>
+                                        <p:cTn id="15" dur="1" fill="hold">
+                                          <p:stCondLst>
+                                            <p:cond delay="0"/>
+                                          </p:stCondLst>
+                                        </p:cTn>
+                                        <p:tgtEl>
+                                          <p:spTgt spid="60"/>
+                                        </p:tgtEl>
+                                        <p:attrNameLst>
+                                          <p:attrName>style.visibility</p:attrName>
+                                        </p:attrNameLst>
+                                      </p:cBhvr>
+                                      <p:to>
+                                        <p:strVal val="visible"/>
+                                      </p:to>
+                                    </p:set>
+                                    <p:animEffect transition="in" filter="dissolve">
+                                      <p:cBhvr>
+                                        <p:cTn id="16" dur="500"/>
+                                        <p:tgtEl>
+                                          <p:spTgt spid="60"/>
+                                        </p:tgtEl>
+                                      </p:cBhvr>
+                                    </p:animEffect>
+                                  </p:childTnLst>
+                                </p:cTn>
+                              </p:par>
+                              <p:par>
+                                <p:cTn id="17" presetID="9" presetClass="entr" presetSubtype="0" fill="hold" grpId="0" nodeType="withEffect">
+                                  <p:stCondLst>
+                                    <p:cond delay="0"/>
+                                  </p:stCondLst>
+                                  <p:childTnLst>
+                                    <p:set>
+                                      <p:cBhvr>
+                                        <p:cTn id="18" dur="1" fill="hold">
+                                          <p:stCondLst>
+                                            <p:cond delay="0"/>
+                                          </p:stCondLst>
+                                        </p:cTn>
+                                        <p:tgtEl>
+                                          <p:spTgt spid="61"/>
+                                        </p:tgtEl>
+                                        <p:attrNameLst>
+                                          <p:attrName>style.visibility</p:attrName>
+                                        </p:attrNameLst>
+                                      </p:cBhvr>
+                                      <p:to>
+                                        <p:strVal val="visible"/>
+                                      </p:to>
+                                    </p:set>
+                                    <p:animEffect transition="in" filter="dissolve">
+                                      <p:cBhvr>
+                                        <p:cTn id="19" dur="500"/>
+                                        <p:tgtEl>
+                                          <p:spTgt spid="61"/>
+                                        </p:tgtEl>
+                                      </p:cBhvr>
+                                    </p:animEffect>
+                                  </p:childTnLst>
+                                </p:cTn>
+                              </p:par>
+                              <p:par>
+                                <p:cTn id="20" presetID="9" presetClass="entr" presetSubtype="0" fill="hold" grpId="0" nodeType="withEffect">
+                                  <p:stCondLst>
+                                    <p:cond delay="0"/>
+                                  </p:stCondLst>
+                                  <p:childTnLst>
+                                    <p:set>
+                                      <p:cBhvr>
+                                        <p:cTn id="21" dur="1" fill="hold">
+                                          <p:stCondLst>
+                                            <p:cond delay="0"/>
+                                          </p:stCondLst>
+                                        </p:cTn>
+                                        <p:tgtEl>
+                                          <p:spTgt spid="62"/>
+                                        </p:tgtEl>
+                                        <p:attrNameLst>
+                                          <p:attrName>style.visibility</p:attrName>
+                                        </p:attrNameLst>
+                                      </p:cBhvr>
+                                      <p:to>
+                                        <p:strVal val="visible"/>
+                                      </p:to>
+                                    </p:set>
+                                    <p:animEffect transition="in" filter="dissolve">
+                                      <p:cBhvr>
+                                        <p:cTn id="22" dur="500"/>
+                                        <p:tgtEl>
+                                          <p:spTgt spid="62"/>
+                                        </p:tgtEl>
+                                      </p:cBhvr>
+                                    </p:animEffect>
+                                  </p:childTnLst>
+                                </p:cTn>
+                              </p:par>
+                              <p:par>
+                                <p:cTn id="23" presetID="9" presetClass="entr" presetSubtype="0" fill="hold" grpId="0" nodeType="withEffect">
+                                  <p:stCondLst>
+                                    <p:cond delay="0"/>
+                                  </p:stCondLst>
+                                  <p:childTnLst>
+                                    <p:set>
+                                      <p:cBhvr>
+                                        <p:cTn id="24" dur="1" fill="hold">
+                                          <p:stCondLst>
+                                            <p:cond delay="0"/>
+                                          </p:stCondLst>
+                                        </p:cTn>
+                                        <p:tgtEl>
+                                          <p:spTgt spid="63"/>
+                                        </p:tgtEl>
+                                        <p:attrNameLst>
+                                          <p:attrName>style.visibility</p:attrName>
+                                        </p:attrNameLst>
+                                      </p:cBhvr>
+                                      <p:to>
+                                        <p:strVal val="visible"/>
+                                      </p:to>
+                                    </p:set>
+                                    <p:animEffect transition="in" filter="dissolve">
+                                      <p:cBhvr>
+                                        <p:cTn id="25" dur="500"/>
+                                        <p:tgtEl>
+                                          <p:spTgt spid="63"/>
+                                        </p:tgtEl>
+                                      </p:cBhvr>
+                                    </p:animEffect>
+                                  </p:childTnLst>
+                                </p:cTn>
+                              </p:par>
+                            </p:childTnLst>
+                          </p:cTn>
+                        </p:par>
+                      </p:childTnLst>
+                    </p:cTn>
+                  </p:par>
+                </p:childTnLst>
+              </p:cTn>
+              <p:prevCondLst>
+                <p:cond evt="onPrev" delay="0">
+                  <p:tgtEl>
+                    <p:sldTgt/>
+                  </p:tgtEl>
+                </p:cond>
+              </p:prevCondLst>
+              <p:nextCondLst>
+                <p:cond evt="onNext" delay="0">
+                  <p:tgtEl>
+                    <p:sldTgt/>
+                  </p:tgtEl>
+                </p:cond>
+              </p:nextCondLst>
+            </p:seq>
+          </p:childTnLst>
+        </p:cTn>
+      </p:par>
+    </p:tnLst>
+    <p:bldLst>
+      <p:bldP spid="59" grpId="0"/>
+      <p:bldP spid="60" grpId="0" animBg="1"/>
+      <p:bldP spid="61" grpId="0" animBg="1"/>
+      <p:bldP spid="62" grpId="0" animBg="1"/>
+      <p:bldP spid="63" grpId="0"/>
+    </p:bldLst>
+  </p:timing>
+</p:sld>
+</file>
+
+<file path=ppt/slides/slide54.xml><?xml version="1.0" encoding="utf-8"?>
+<p:sld xmlns:a="http://schemas.openxmlformats.org/drawingml/2006/main" xmlns:r="http://schemas.openxmlformats.org/officeDocument/2006/relationships" xmlns:p="http://schemas.openxmlformats.org/presentationml/2006/main">
+  <p:cSld>
+    <p:spTree>
+      <p:nvGrpSpPr>
+        <p:cNvPr id="1" name=""/>
+        <p:cNvGrpSpPr/>
+        <p:nvPr/>
+      </p:nvGrpSpPr>
+      <p:grpSpPr>
+        <a:xfrm>
+          <a:off x="0" y="0"/>
+          <a:ext cx="0" cy="0"/>
+          <a:chOff x="0" y="0"/>
+          <a:chExt cx="0" cy="0"/>
+        </a:xfrm>
+      </p:grpSpPr>
+      <p:sp>
+        <p:nvSpPr>
+          <p:cNvPr id="7" name="Title 1">
+            <a:extLst>
+              <a:ext uri="{FF2B5EF4-FFF2-40B4-BE49-F238E27FC236}">
+                <a16:creationId xmlns:a16="http://schemas.microsoft.com/office/drawing/2014/main" id="{9452C5CF-C823-F93B-EC88-BA4478E024CE}"/>
+              </a:ext>
+            </a:extLst>
+          </p:cNvPr>
+          <p:cNvSpPr>
+            <a:spLocks noGrp="1"/>
+          </p:cNvSpPr>
+          <p:nvPr>
+            <p:ph type="title"/>
+          </p:nvPr>
+        </p:nvSpPr>
+        <p:spPr>
+          <a:xfrm>
+            <a:off x="0" y="1"/>
+            <a:ext cx="12191999" cy="914400"/>
+          </a:xfrm>
+        </p:spPr>
+        <p:txBody>
+          <a:bodyPr>
+            <a:normAutofit/>
+          </a:bodyPr>
+          <a:lstStyle/>
+          <a:p>
+            <a:pPr algn="ctr">
+              <a:buNone/>
+            </a:pPr>
+            <a:r>
+              <a:rPr b="1">
+                <a:latin typeface="Helvetica"/>
+                <a:ea typeface="Helvetica"/>
+                <a:cs typeface="Helvetica"/>
+              </a:rPr>
+              <a:t>Can We Just Always Read from Server 1?</a:t>
+            </a:r>
+          </a:p>
+        </p:txBody>
+      </p:sp>
+      <p:sp>
+        <p:nvSpPr>
+          <p:cNvPr id="8" name="Slide Number Placeholder 4">
+            <a:extLst>
+              <a:ext uri="{FF2B5EF4-FFF2-40B4-BE49-F238E27FC236}">
+                <a16:creationId xmlns:a16="http://schemas.microsoft.com/office/drawing/2014/main" id="{16D0A24B-6300-8D05-5AB9-F3998A2F3009}"/>
+              </a:ext>
+            </a:extLst>
+          </p:cNvPr>
+          <p:cNvSpPr>
+            <a:spLocks noGrp="1"/>
+          </p:cNvSpPr>
+          <p:nvPr>
+            <p:ph type="sldNum" idx="12"/>
+          </p:nvPr>
+        </p:nvSpPr>
+        <p:spPr>
+          <a:xfrm>
+            <a:off x="8610600" y="6356350"/>
+            <a:ext cx="2743200" cy="365125"/>
+          </a:xfrm>
+        </p:spPr>
+        <p:txBody>
+          <a:bodyPr/>
+          <a:lstStyle/>
+          <a:p>
+            <a:fld id="{212DA15D-5F50-8B40-811F-34F736B90848}" type="slidenum">
+              <a:rPr/>
+              <a:t>8</a:t>
+            </a:fld>
+            <a:endParaRPr/>
+          </a:p>
+        </p:txBody>
+      </p:sp>
+      <p:sp>
+        <p:nvSpPr>
+          <p:cNvPr id="48" name="TextBox 47">
+            <a:extLst>
+              <a:ext uri="{FF2B5EF4-FFF2-40B4-BE49-F238E27FC236}">
+                <a16:creationId xmlns:a16="http://schemas.microsoft.com/office/drawing/2014/main" id="{51F35555-7DB3-0E9F-0CC1-8DCCA40D364A}"/>
+              </a:ext>
+            </a:extLst>
+          </p:cNvPr>
+          <p:cNvSpPr>
+            <a:spLocks noGrp="1"/>
+          </p:cNvSpPr>
+          <p:nvPr/>
+        </p:nvSpPr>
+        <p:spPr>
+          <a:xfrm>
+            <a:off x="7325250" y="1373218"/>
+            <a:ext cx="4706595" cy="4154984"/>
+          </a:xfrm>
+          <a:prstGeom prst="rect">
+            <a:avLst/>
+          </a:prstGeom>
+          <a:noFill/>
+        </p:spPr>
+        <p:txBody>
+          <a:bodyPr wrap="square">
+            <a:spAutoFit/>
+          </a:bodyPr>
+          <a:lstStyle/>
+          <a:p>
+            <a:pPr marL="342900" indent="-342900">
+              <a:buFont typeface="Arial"/>
+              <a:buChar char="•"/>
+            </a:pPr>
+            <a:r>
+              <a:rPr sz="2400" dirty="0"/>
+              <a:t>A natural patch: everyone reads Server 1, and falls back to Server 2 only when S1 is down</a:t>
+            </a:r>
+          </a:p>
+          <a:p>
+            <a:pPr marL="342900" indent="-342900">
+              <a:buFont typeface="Arial"/>
+              <a:buChar char="•"/>
+            </a:pPr>
+            <a:endParaRPr sz="1200" dirty="0"/>
+          </a:p>
+          <a:p>
+            <a:pPr marL="342900" indent="-342900">
+              <a:buFont typeface="Arial"/>
+              <a:buChar char="•"/>
+            </a:pPr>
+            <a:r>
+              <a:rPr sz="2400" dirty="0"/>
+              <a:t>While S1 is up every reader sees 2, so the disagreement is hidden, not repaired</a:t>
+            </a:r>
+          </a:p>
+          <a:p>
+            <a:pPr marL="342900" indent="-342900">
+              <a:buFont typeface="Arial"/>
+              <a:buChar char="•"/>
+            </a:pPr>
+            <a:endParaRPr sz="1200" dirty="0"/>
+          </a:p>
+          <a:p>
+            <a:pPr marL="342900" indent="-342900">
+              <a:buFont typeface="Arial"/>
+              <a:buChar char="•"/>
+            </a:pPr>
+            <a:r>
+              <a:rPr sz="2400" dirty="0"/>
+              <a:t>S1 dies, the readers fall back to S2, and the value goes back to 1</a:t>
+            </a:r>
+          </a:p>
+          <a:p>
+            <a:pPr marL="342900" indent="-342900">
+              <a:buFont typeface="Arial"/>
+              <a:buChar char="•"/>
+            </a:pPr>
+            <a:endParaRPr sz="1200" dirty="0"/>
+          </a:p>
+          <a:p>
+            <a:pPr marL="342900" indent="-342900">
+              <a:buFont typeface="Arial"/>
+              <a:buChar char="•"/>
+            </a:pPr>
+            <a:r>
+              <a:rPr sz="2400" dirty="0"/>
+              <a:t>Nobody wrote. One machine could never do that.</a:t>
+            </a:r>
+          </a:p>
+        </p:txBody>
+      </p:sp>
+      <p:sp>
+        <p:nvSpPr>
+          <p:cNvPr id="49" name="Rule heading">
+            <a:extLst>
+              <a:ext uri="{FF2B5EF4-FFF2-40B4-BE49-F238E27FC236}">
+                <a16:creationId xmlns:a16="http://schemas.microsoft.com/office/drawing/2014/main" id="{661EE3E6-4BC3-4749-8762-CC8F835B020D}"/>
+              </a:ext>
+            </a:extLst>
+          </p:cNvPr>
+          <p:cNvSpPr>
+            <a:spLocks noGrp="1"/>
+          </p:cNvSpPr>
+          <p:nvPr/>
+        </p:nvSpPr>
+        <p:spPr>
+          <a:xfrm>
+            <a:off x="409575" y="1057275"/>
+            <a:ext cx="6429375" cy="323850"/>
+          </a:xfrm>
+          <a:prstGeom prst="rect">
+            <a:avLst/>
+          </a:prstGeom>
+          <a:noFill/>
+          <a:ln w="0">
+            <a:noFill/>
+          </a:ln>
+        </p:spPr>
+        <p:txBody>
+          <a:bodyPr>
+            <a:normAutofit/>
+          </a:bodyPr>
+          <a:lstStyle/>
+          <a:p>
+            <a:pPr>
+              <a:defRPr sz="1725" b="1">
+                <a:solidFill>
+                  <a:srgbClr val="0E2841"/>
+                </a:solidFill>
+                <a:latin typeface="Aptos"/>
+                <a:ea typeface="Aptos"/>
+                <a:cs typeface="Aptos"/>
+              </a:defRPr>
+            </a:pPr>
+            <a:r>
+              <a:rPr sz="1725" b="1">
+                <a:solidFill>
+                  <a:srgbClr val="0E2841"/>
+                </a:solidFill>
+                <a:latin typeface="Aptos"/>
+                <a:ea typeface="Aptos"/>
+                <a:cs typeface="Aptos"/>
+              </a:rPr>
+              <a:t>Rule: always read S1, fall back to S2</a:t>
+            </a:r>
+          </a:p>
+        </p:txBody>
+      </p:sp>
+      <p:sp>
+        <p:nvSpPr>
+          <p:cNvPr id="50" name="Server 1 up">
+            <a:extLst>
+              <a:ext uri="{FF2B5EF4-FFF2-40B4-BE49-F238E27FC236}">
+                <a16:creationId xmlns:a16="http://schemas.microsoft.com/office/drawing/2014/main" id="{C047F16D-4224-436C-BA2F-7F4F14E7970E}"/>
+              </a:ext>
+            </a:extLst>
+          </p:cNvPr>
+          <p:cNvSpPr>
+            <a:spLocks noGrp="1"/>
+          </p:cNvSpPr>
+          <p:nvPr/>
+        </p:nvSpPr>
+        <p:spPr>
+          <a:xfrm>
+            <a:off x="450000" y="1500000"/>
+            <a:ext cx="1600000" cy="590550"/>
+          </a:xfrm>
+          <a:prstGeom prst="roundRect">
+            <a:avLst>
+              <a:gd name="adj" fmla="val 13889"/>
+            </a:avLst>
+          </a:prstGeom>
+          <a:solidFill>
+            <a:srgbClr val="E8F0F5"/>
+          </a:solidFill>
+          <a:ln w="19050">
+            <a:solidFill>
+              <a:srgbClr val="0E2841"/>
+            </a:solidFill>
+            <a:prstDash val="solid"/>
+          </a:ln>
+        </p:spPr>
+        <p:txBody>
+          <a:bodyPr lIns="47625" tIns="47625" rIns="47625" bIns="47625" anchor="ctr">
+            <a:normAutofit/>
+          </a:bodyPr>
+          <a:lstStyle/>
+          <a:p>
+            <a:pPr algn="ctr">
+              <a:defRPr sz="1350" b="1">
+                <a:solidFill>
+                  <a:srgbClr val="0E2841"/>
+                </a:solidFill>
+                <a:latin typeface="Aptos"/>
+                <a:ea typeface="Aptos"/>
+                <a:cs typeface="Aptos"/>
+              </a:defRPr>
+            </a:pPr>
+            <a:r>
+              <a:rPr sz="1350" b="1">
+                <a:solidFill>
+                  <a:srgbClr val="0E2841"/>
+                </a:solidFill>
+                <a:latin typeface="Aptos"/>
+                <a:ea typeface="Aptos"/>
+                <a:cs typeface="Aptos"/>
+              </a:rPr>
+              <a:t>Server 1</a:t>
+            </a:r>
+          </a:p>
+          <a:p>
+            <a:pPr algn="ctr">
+              <a:defRPr sz="1350" b="1">
+                <a:solidFill>
+                  <a:srgbClr val="0E2841"/>
+                </a:solidFill>
+                <a:latin typeface="Aptos"/>
+                <a:ea typeface="Aptos"/>
+                <a:cs typeface="Aptos"/>
+              </a:defRPr>
+            </a:pPr>
+            <a:r>
+              <a:rPr sz="1350" b="1">
+                <a:solidFill>
+                  <a:srgbClr val="0E2841"/>
+                </a:solidFill>
+                <a:latin typeface="Aptos"/>
+                <a:ea typeface="Aptos"/>
+                <a:cs typeface="Aptos"/>
+              </a:rPr>
+              <a:t>x = 2</a:t>
+            </a:r>
+          </a:p>
+        </p:txBody>
+      </p:sp>
+      <p:sp>
+        <p:nvSpPr>
+          <p:cNvPr id="51" name="Server 2">
+            <a:extLst>
+              <a:ext uri="{FF2B5EF4-FFF2-40B4-BE49-F238E27FC236}">
+                <a16:creationId xmlns:a16="http://schemas.microsoft.com/office/drawing/2014/main" id="{C047F16D-4224-436C-BA2F-7F4F14E7970E}"/>
+              </a:ext>
+            </a:extLst>
+          </p:cNvPr>
+          <p:cNvSpPr>
+            <a:spLocks noGrp="1"/>
+          </p:cNvSpPr>
+          <p:nvPr/>
+        </p:nvSpPr>
+        <p:spPr>
+          <a:xfrm>
+            <a:off x="450000" y="2250000"/>
+            <a:ext cx="1600000" cy="590550"/>
+          </a:xfrm>
+          <a:prstGeom prst="roundRect">
+            <a:avLst>
+              <a:gd name="adj" fmla="val 13889"/>
+            </a:avLst>
+          </a:prstGeom>
+          <a:solidFill>
+            <a:srgbClr val="E8F0F5"/>
+          </a:solidFill>
+          <a:ln w="19050">
+            <a:solidFill>
+              <a:srgbClr val="0E2841"/>
+            </a:solidFill>
+            <a:prstDash val="solid"/>
+          </a:ln>
+        </p:spPr>
+        <p:txBody>
+          <a:bodyPr lIns="47625" tIns="47625" rIns="47625" bIns="47625" anchor="ctr">
+            <a:normAutofit/>
+          </a:bodyPr>
+          <a:lstStyle/>
+          <a:p>
+            <a:pPr algn="ctr">
+              <a:defRPr sz="1350" b="1">
+                <a:solidFill>
+                  <a:srgbClr val="0E2841"/>
+                </a:solidFill>
+                <a:latin typeface="Aptos"/>
+                <a:ea typeface="Aptos"/>
+                <a:cs typeface="Aptos"/>
+              </a:defRPr>
+            </a:pPr>
+            <a:r>
+              <a:rPr sz="1350" b="1">
+                <a:solidFill>
+                  <a:srgbClr val="0E2841"/>
+                </a:solidFill>
+                <a:latin typeface="Aptos"/>
+                <a:ea typeface="Aptos"/>
+                <a:cs typeface="Aptos"/>
+              </a:rPr>
+              <a:t>Server 2</a:t>
+            </a:r>
+          </a:p>
+          <a:p>
+            <a:pPr algn="ctr">
+              <a:defRPr sz="1350" b="1">
+                <a:solidFill>
+                  <a:srgbClr val="0E2841"/>
+                </a:solidFill>
+                <a:latin typeface="Aptos"/>
+                <a:ea typeface="Aptos"/>
+                <a:cs typeface="Aptos"/>
+              </a:defRPr>
+            </a:pPr>
+            <a:r>
+              <a:rPr sz="1350" b="1">
+                <a:solidFill>
+                  <a:srgbClr val="0E2841"/>
+                </a:solidFill>
+                <a:latin typeface="Aptos"/>
+                <a:ea typeface="Aptos"/>
+                <a:cs typeface="Aptos"/>
+              </a:rPr>
+              <a:t>x = 1</a:t>
+            </a:r>
+          </a:p>
+        </p:txBody>
+      </p:sp>
+      <p:sp>
+        <p:nvSpPr>
+          <p:cNvPr id="52" name="Reader C3">
+            <a:extLst>
+              <a:ext uri="{FF2B5EF4-FFF2-40B4-BE49-F238E27FC236}">
+                <a16:creationId xmlns:a16="http://schemas.microsoft.com/office/drawing/2014/main" id="{C047F16D-4224-436C-BA2F-7F4F14E7970E}"/>
+              </a:ext>
+            </a:extLst>
+          </p:cNvPr>
+          <p:cNvSpPr>
+            <a:spLocks noGrp="1"/>
+          </p:cNvSpPr>
+          <p:nvPr/>
+        </p:nvSpPr>
+        <p:spPr>
+          <a:xfrm>
+            <a:off x="4400000" y="1500000"/>
+            <a:ext cx="1500000" cy="590550"/>
+          </a:xfrm>
+          <a:prstGeom prst="roundRect">
+            <a:avLst>
+              <a:gd name="adj" fmla="val 13889"/>
+            </a:avLst>
+          </a:prstGeom>
+          <a:solidFill>
+            <a:srgbClr val="E8F0F5"/>
+          </a:solidFill>
+          <a:ln w="19050">
+            <a:solidFill>
+              <a:srgbClr val="0E2841"/>
+            </a:solidFill>
+            <a:prstDash val="solid"/>
+          </a:ln>
+        </p:spPr>
+        <p:txBody>
+          <a:bodyPr lIns="47625" tIns="47625" rIns="47625" bIns="47625" anchor="ctr">
+            <a:normAutofit/>
+          </a:bodyPr>
+          <a:lstStyle/>
+          <a:p>
+            <a:pPr algn="ctr">
+              <a:defRPr sz="1350" b="1">
+                <a:solidFill>
+                  <a:srgbClr val="0E2841"/>
+                </a:solidFill>
+                <a:latin typeface="Aptos"/>
+                <a:ea typeface="Aptos"/>
+                <a:cs typeface="Aptos"/>
+              </a:defRPr>
+            </a:pPr>
+            <a:r>
+              <a:rPr sz="1350" b="1">
+                <a:solidFill>
+                  <a:srgbClr val="0E2841"/>
+                </a:solidFill>
+                <a:latin typeface="Aptos"/>
+                <a:ea typeface="Aptos"/>
+                <a:cs typeface="Aptos"/>
+              </a:rPr>
+              <a:t>C3</a:t>
+            </a:r>
+          </a:p>
+          <a:p>
+            <a:pPr algn="ctr">
+              <a:defRPr sz="1350" b="1">
+                <a:solidFill>
+                  <a:srgbClr val="0E2841"/>
+                </a:solidFill>
+                <a:latin typeface="Aptos"/>
+                <a:ea typeface="Aptos"/>
+                <a:cs typeface="Aptos"/>
+              </a:defRPr>
+            </a:pPr>
+            <a:r>
+              <a:rPr sz="1350" b="1">
+                <a:solidFill>
+                  <a:srgbClr val="0E2841"/>
+                </a:solidFill>
+                <a:latin typeface="Aptos"/>
+                <a:ea typeface="Aptos"/>
+                <a:cs typeface="Aptos"/>
+              </a:rPr>
+              <a:t>reads 2</a:t>
+            </a:r>
+          </a:p>
+        </p:txBody>
+      </p:sp>
+      <p:sp>
+        <p:nvSpPr>
+          <p:cNvPr id="53" name="Reader C4">
+            <a:extLst>
+              <a:ext uri="{FF2B5EF4-FFF2-40B4-BE49-F238E27FC236}">
+                <a16:creationId xmlns:a16="http://schemas.microsoft.com/office/drawing/2014/main" id="{C047F16D-4224-436C-BA2F-7F4F14E7970E}"/>
+              </a:ext>
+            </a:extLst>
+          </p:cNvPr>
+          <p:cNvSpPr>
+            <a:spLocks noGrp="1"/>
+          </p:cNvSpPr>
+          <p:nvPr/>
+        </p:nvSpPr>
+        <p:spPr>
+          <a:xfrm>
+            <a:off x="4400000" y="2250000"/>
+            <a:ext cx="1500000" cy="590550"/>
+          </a:xfrm>
+          <a:prstGeom prst="roundRect">
+            <a:avLst>
+              <a:gd name="adj" fmla="val 13889"/>
+            </a:avLst>
+          </a:prstGeom>
+          <a:solidFill>
+            <a:srgbClr val="E8F0F5"/>
+          </a:solidFill>
+          <a:ln w="19050">
+            <a:solidFill>
+              <a:srgbClr val="0E2841"/>
+            </a:solidFill>
+            <a:prstDash val="solid"/>
+          </a:ln>
+        </p:spPr>
+        <p:txBody>
+          <a:bodyPr lIns="47625" tIns="47625" rIns="47625" bIns="47625" anchor="ctr">
+            <a:normAutofit/>
+          </a:bodyPr>
+          <a:lstStyle/>
+          <a:p>
+            <a:pPr algn="ctr">
+              <a:defRPr sz="1350" b="1">
+                <a:solidFill>
+                  <a:srgbClr val="0E2841"/>
+                </a:solidFill>
+                <a:latin typeface="Aptos"/>
+                <a:ea typeface="Aptos"/>
+                <a:cs typeface="Aptos"/>
+              </a:defRPr>
+            </a:pPr>
+            <a:r>
+              <a:rPr sz="1350" b="1">
+                <a:solidFill>
+                  <a:srgbClr val="0E2841"/>
+                </a:solidFill>
+                <a:latin typeface="Aptos"/>
+                <a:ea typeface="Aptos"/>
+                <a:cs typeface="Aptos"/>
+              </a:rPr>
+              <a:t>C4</a:t>
+            </a:r>
+          </a:p>
+          <a:p>
+            <a:pPr algn="ctr">
+              <a:defRPr sz="1350" b="1">
+                <a:solidFill>
+                  <a:srgbClr val="0E2841"/>
+                </a:solidFill>
+                <a:latin typeface="Aptos"/>
+                <a:ea typeface="Aptos"/>
+                <a:cs typeface="Aptos"/>
+              </a:defRPr>
+            </a:pPr>
+            <a:r>
+              <a:rPr sz="1350" b="1">
+                <a:solidFill>
+                  <a:srgbClr val="0E2841"/>
+                </a:solidFill>
+                <a:latin typeface="Aptos"/>
+                <a:ea typeface="Aptos"/>
+                <a:cs typeface="Aptos"/>
+              </a:rPr>
+              <a:t>reads 2</a:t>
+            </a:r>
+          </a:p>
+        </p:txBody>
+      </p:sp>
+      <p:cxnSp>
+        <p:nvCxnSpPr>
+          <p:cNvPr id="76" name="Read arrow 1"/>
+          <p:cNvCxnSpPr/>
+          <p:nvPr/>
+        </p:nvCxnSpPr>
+        <p:spPr>
+          <a:xfrm>
+            <a:off x="2050000" y="1795275"/>
+            <a:ext cx="2350000" cy="0"/>
+          </a:xfrm>
+          <a:prstGeom prst="straightConnector1">
+            <a:avLst/>
+          </a:prstGeom>
+          <a:ln w="19050">
+            <a:solidFill>
+              <a:srgbClr val="5B6573"/>
+            </a:solidFill>
+            <a:prstDash val="solid"/>
+            <a:tailEnd type="triangle" w="sm" len="sm"/>
+          </a:ln>
+        </p:spPr>
+      </p:cxnSp>
+      <p:cxnSp>
+        <p:nvCxnSpPr>
+          <p:cNvPr id="77" name="Read arrow 2"/>
+          <p:cNvCxnSpPr/>
+          <p:nvPr/>
+        </p:nvCxnSpPr>
+        <p:spPr>
+          <a:xfrm>
+            <a:off x="2050000" y="1795275"/>
+            <a:ext cx="2350000" cy="750000"/>
+          </a:xfrm>
+          <a:prstGeom prst="straightConnector1">
+            <a:avLst/>
+          </a:prstGeom>
+          <a:ln w="19050">
+            <a:solidFill>
+              <a:srgbClr val="5B6573"/>
+            </a:solidFill>
+            <a:prstDash val="solid"/>
+            <a:tailEnd type="triangle" w="sm" len="sm"/>
+          </a:ln>
+        </p:spPr>
+      </p:cxnSp>
+      <p:sp>
+        <p:nvSpPr>
+          <p:cNvPr id="68" name="Looks fine label">
+            <a:extLst>
+              <a:ext uri="{FF2B5EF4-FFF2-40B4-BE49-F238E27FC236}">
+                <a16:creationId xmlns:a16="http://schemas.microsoft.com/office/drawing/2014/main" id="{8E2343DF-2BB9-401F-B950-594DD72F33BC}"/>
+              </a:ext>
+            </a:extLst>
+          </p:cNvPr>
+          <p:cNvSpPr>
+            <a:spLocks noGrp="1"/>
+          </p:cNvSpPr>
+          <p:nvPr/>
+        </p:nvSpPr>
+        <p:spPr>
+          <a:xfrm>
+            <a:off x="4400000" y="2900000"/>
+            <a:ext cx="1500000" cy="257175"/>
+          </a:xfrm>
+          <a:prstGeom prst="rect">
+            <a:avLst/>
+          </a:prstGeom>
+          <a:noFill/>
+          <a:ln w="0">
+            <a:noFill/>
+          </a:ln>
+        </p:spPr>
+        <p:txBody>
+          <a:bodyPr>
+            <a:normAutofit/>
+          </a:bodyPr>
+          <a:lstStyle/>
+          <a:p>
+            <a:pPr algn="ctr">
+              <a:defRPr sz="1425" b="1">
+                <a:solidFill>
+                  <a:srgbClr val="A02B93"/>
+                </a:solidFill>
+                <a:latin typeface="Aptos"/>
+                <a:ea typeface="Aptos"/>
+                <a:cs typeface="Aptos"/>
+              </a:defRPr>
+            </a:pPr>
+            <a:r>
+              <a:rPr sz="1425" b="1">
+                <a:solidFill>
+                  <a:srgbClr val="A02B93"/>
+                </a:solidFill>
+                <a:latin typeface="Aptos"/>
+                <a:ea typeface="Aptos"/>
+                <a:cs typeface="Aptos"/>
+              </a:rPr>
+              <a:t>looks fine</a:t>
+            </a:r>
+          </a:p>
+        </p:txBody>
+      </p:sp>
+      <p:sp>
+        <p:nvSpPr>
+          <p:cNvPr id="58" name="Diagram divider">
+            <a:extLst>
+              <a:ext uri="{FF2B5EF4-FFF2-40B4-BE49-F238E27FC236}">
+                <a16:creationId xmlns:a16="http://schemas.microsoft.com/office/drawing/2014/main" id="{F5D6858F-3BE5-4C9A-98FD-301B4CE6E4D8}"/>
+              </a:ext>
+            </a:extLst>
+          </p:cNvPr>
+          <p:cNvSpPr>
+            <a:spLocks noGrp="1"/>
+          </p:cNvSpPr>
+          <p:nvPr/>
+        </p:nvSpPr>
+        <p:spPr>
+          <a:xfrm>
+            <a:off x="409575" y="3352800"/>
+            <a:ext cx="6334125" cy="0"/>
+          </a:xfrm>
+          <a:prstGeom prst="line">
+            <a:avLst/>
+          </a:prstGeom>
+          <a:noFill/>
+          <a:ln w="9525">
+            <a:solidFill>
+              <a:srgbClr val="C9D1D9"/>
+            </a:solidFill>
+            <a:prstDash val="solid"/>
+          </a:ln>
+        </p:spPr>
+        <p:txBody>
+          <a:bodyPr/>
+          <a:lstStyle/>
+          <a:p>
+            <a:endParaRPr lang="en-US"/>
+          </a:p>
+        </p:txBody>
+      </p:sp>
+      <p:sp>
+        <p:nvSpPr>
+          <p:cNvPr id="59" name="Failure heading">
+            <a:extLst>
+              <a:ext uri="{FF2B5EF4-FFF2-40B4-BE49-F238E27FC236}">
+                <a16:creationId xmlns:a16="http://schemas.microsoft.com/office/drawing/2014/main" id="{661EE3E6-4BC3-4749-8762-CC8F835B020D}"/>
+              </a:ext>
+            </a:extLst>
+          </p:cNvPr>
+          <p:cNvSpPr>
+            <a:spLocks noGrp="1"/>
+          </p:cNvSpPr>
+          <p:nvPr/>
+        </p:nvSpPr>
+        <p:spPr>
+          <a:xfrm>
+            <a:off x="409575" y="3514725"/>
+            <a:ext cx="6429375" cy="323850"/>
+          </a:xfrm>
+          <a:prstGeom prst="rect">
+            <a:avLst/>
+          </a:prstGeom>
+          <a:noFill/>
+          <a:ln w="0">
+            <a:noFill/>
+          </a:ln>
+        </p:spPr>
+        <p:txBody>
+          <a:bodyPr>
+            <a:normAutofit/>
+          </a:bodyPr>
+          <a:lstStyle/>
+          <a:p>
+            <a:pPr>
+              <a:defRPr sz="1725" b="1">
+                <a:solidFill>
+                  <a:srgbClr val="0E2841"/>
+                </a:solidFill>
+                <a:latin typeface="Aptos"/>
+                <a:ea typeface="Aptos"/>
+                <a:cs typeface="Aptos"/>
+              </a:defRPr>
+            </a:pPr>
+            <a:r>
+              <a:rPr sz="1725" b="1">
+                <a:solidFill>
+                  <a:srgbClr val="0E2841"/>
+                </a:solidFill>
+                <a:latin typeface="Aptos"/>
+                <a:ea typeface="Aptos"/>
+                <a:cs typeface="Aptos"/>
+              </a:rPr>
+              <a:t>Then Server 1 fails</a:t>
+            </a:r>
+          </a:p>
+        </p:txBody>
+      </p:sp>
+      <p:sp>
+        <p:nvSpPr>
+          <p:cNvPr id="60" name="Outcome 1">
+            <a:extLst>
+              <a:ext uri="{FF2B5EF4-FFF2-40B4-BE49-F238E27FC236}">
+                <a16:creationId xmlns:a16="http://schemas.microsoft.com/office/drawing/2014/main" id="{C047F16D-4224-436C-BA2F-7F4F14E7970E}"/>
+              </a:ext>
+            </a:extLst>
+          </p:cNvPr>
+          <p:cNvSpPr>
+            <a:spLocks noGrp="1"/>
+          </p:cNvSpPr>
+          <p:nvPr/>
+        </p:nvSpPr>
+        <p:spPr>
+          <a:xfrm>
+            <a:off x="409575" y="4095750"/>
+            <a:ext cx="1900000" cy="800000"/>
+          </a:xfrm>
+          <a:prstGeom prst="roundRect">
+            <a:avLst>
+              <a:gd name="adj" fmla="val 13889"/>
+            </a:avLst>
+          </a:prstGeom>
+          <a:solidFill>
+            <a:srgbClr val="E8F0F5"/>
+          </a:solidFill>
+          <a:ln w="19050">
+            <a:solidFill>
+              <a:srgbClr val="0E2841"/>
+            </a:solidFill>
+            <a:prstDash val="solid"/>
+          </a:ln>
+        </p:spPr>
+        <p:txBody>
+          <a:bodyPr lIns="47625" tIns="47625" rIns="47625" bIns="47625" anchor="ctr">
+            <a:normAutofit/>
+          </a:bodyPr>
+          <a:lstStyle/>
+          <a:p>
+            <a:pPr algn="ctr">
+              <a:defRPr sz="1350" b="1">
+                <a:solidFill>
+                  <a:srgbClr val="0E2841"/>
+                </a:solidFill>
+                <a:latin typeface="Aptos"/>
+                <a:ea typeface="Aptos"/>
+                <a:cs typeface="Aptos"/>
+              </a:defRPr>
+            </a:pPr>
+            <a:r>
+              <a:rPr sz="1350" b="1">
+                <a:solidFill>
+                  <a:srgbClr val="0E2841"/>
+                </a:solidFill>
+                <a:latin typeface="Aptos"/>
+                <a:ea typeface="Aptos"/>
+                <a:cs typeface="Aptos"/>
+              </a:rPr>
+              <a:t>S1 is gone</a:t>
+            </a:r>
+          </a:p>
+          <a:p>
+            <a:pPr algn="ctr">
+              <a:defRPr sz="1350" b="1">
+                <a:solidFill>
+                  <a:srgbClr val="0E2841"/>
+                </a:solidFill>
+                <a:latin typeface="Aptos"/>
+                <a:ea typeface="Aptos"/>
+                <a:cs typeface="Aptos"/>
+              </a:defRPr>
+            </a:pPr>
+            <a:r>
+              <a:rPr sz="1350" b="1">
+                <a:solidFill>
+                  <a:srgbClr val="0E2841"/>
+                </a:solidFill>
+                <a:latin typeface="Aptos"/>
+                <a:ea typeface="Aptos"/>
+                <a:cs typeface="Aptos"/>
+              </a:rPr>
+              <a:t>reads go to S2</a:t>
+            </a:r>
+          </a:p>
+        </p:txBody>
+      </p:sp>
+      <p:sp>
+        <p:nvSpPr>
+          <p:cNvPr id="61" name="Outcome 2">
+            <a:extLst>
+              <a:ext uri="{FF2B5EF4-FFF2-40B4-BE49-F238E27FC236}">
+                <a16:creationId xmlns:a16="http://schemas.microsoft.com/office/drawing/2014/main" id="{C047F16D-4224-436C-BA2F-7F4F14E7970E}"/>
+              </a:ext>
+            </a:extLst>
+          </p:cNvPr>
+          <p:cNvSpPr>
+            <a:spLocks noGrp="1"/>
+          </p:cNvSpPr>
+          <p:nvPr/>
+        </p:nvSpPr>
+        <p:spPr>
+          <a:xfrm>
+            <a:off x="2674262" y="4095750"/>
+            <a:ext cx="1900000" cy="800000"/>
+          </a:xfrm>
+          <a:prstGeom prst="roundRect">
+            <a:avLst>
+              <a:gd name="adj" fmla="val 13889"/>
+            </a:avLst>
+          </a:prstGeom>
+          <a:solidFill>
+            <a:srgbClr val="E8F0F5"/>
+          </a:solidFill>
+          <a:ln w="19050">
+            <a:solidFill>
+              <a:srgbClr val="0E2841"/>
+            </a:solidFill>
+            <a:prstDash val="solid"/>
+          </a:ln>
+        </p:spPr>
+        <p:txBody>
+          <a:bodyPr lIns="47625" tIns="47625" rIns="47625" bIns="47625" anchor="ctr">
+            <a:normAutofit/>
+          </a:bodyPr>
+          <a:lstStyle/>
+          <a:p>
+            <a:pPr algn="ctr">
+              <a:defRPr sz="1350" b="1">
+                <a:solidFill>
+                  <a:srgbClr val="0E2841"/>
+                </a:solidFill>
+                <a:latin typeface="Aptos"/>
+                <a:ea typeface="Aptos"/>
+                <a:cs typeface="Aptos"/>
+              </a:defRPr>
+            </a:pPr>
+            <a:r>
+              <a:rPr sz="1350" b="1">
+                <a:solidFill>
+                  <a:srgbClr val="0E2841"/>
+                </a:solidFill>
+                <a:latin typeface="Aptos"/>
+                <a:ea typeface="Aptos"/>
+                <a:cs typeface="Aptos"/>
+              </a:rPr>
+              <a:t>C3 reads 1</a:t>
+            </a:r>
+          </a:p>
+          <a:p>
+            <a:pPr algn="ctr">
+              <a:defRPr sz="1350" b="1">
+                <a:solidFill>
+                  <a:srgbClr val="0E2841"/>
+                </a:solidFill>
+                <a:latin typeface="Aptos"/>
+                <a:ea typeface="Aptos"/>
+                <a:cs typeface="Aptos"/>
+              </a:defRPr>
+            </a:pPr>
+            <a:r>
+              <a:rPr sz="1350" b="1">
+                <a:solidFill>
+                  <a:srgbClr val="0E2841"/>
+                </a:solidFill>
+                <a:latin typeface="Aptos"/>
+                <a:ea typeface="Aptos"/>
+                <a:cs typeface="Aptos"/>
+              </a:rPr>
+              <a:t>C4 reads 1</a:t>
+            </a:r>
+          </a:p>
+        </p:txBody>
+      </p:sp>
+      <p:sp>
+        <p:nvSpPr>
+          <p:cNvPr id="62" name="Outcome 3">
+            <a:extLst>
+              <a:ext uri="{FF2B5EF4-FFF2-40B4-BE49-F238E27FC236}">
+                <a16:creationId xmlns:a16="http://schemas.microsoft.com/office/drawing/2014/main" id="{C047F16D-4224-436C-BA2F-7F4F14E7970E}"/>
+              </a:ext>
+            </a:extLst>
+          </p:cNvPr>
+          <p:cNvSpPr>
+            <a:spLocks noGrp="1"/>
+          </p:cNvSpPr>
+          <p:nvPr/>
+        </p:nvSpPr>
+        <p:spPr>
+          <a:xfrm>
+            <a:off x="4938949" y="4095750"/>
+            <a:ext cx="1900000" cy="800000"/>
+          </a:xfrm>
+          <a:prstGeom prst="roundRect">
+            <a:avLst>
+              <a:gd name="adj" fmla="val 13889"/>
+            </a:avLst>
+          </a:prstGeom>
+          <a:solidFill>
+            <a:srgbClr val="F7E8F5"/>
+          </a:solidFill>
+          <a:ln w="19050">
+            <a:solidFill>
+              <a:srgbClr val="A02B93"/>
+            </a:solidFill>
+            <a:prstDash val="solid"/>
+          </a:ln>
+        </p:spPr>
+        <p:txBody>
+          <a:bodyPr lIns="47625" tIns="47625" rIns="47625" bIns="47625" anchor="ctr">
+            <a:normAutofit/>
+          </a:bodyPr>
+          <a:lstStyle/>
+          <a:p>
+            <a:pPr algn="ctr">
+              <a:defRPr sz="1350" b="1">
+                <a:solidFill>
+                  <a:srgbClr val="A02B93"/>
+                </a:solidFill>
+                <a:latin typeface="Aptos"/>
+                <a:ea typeface="Aptos"/>
+                <a:cs typeface="Aptos"/>
+              </a:defRPr>
+            </a:pPr>
+            <a:r>
+              <a:rPr sz="1350" b="1">
+                <a:solidFill>
+                  <a:srgbClr val="A02B93"/>
+                </a:solidFill>
+                <a:latin typeface="Aptos"/>
+                <a:ea typeface="Aptos"/>
+                <a:cs typeface="Aptos"/>
+              </a:rPr>
+              <a:t>x:  2 → 1</a:t>
+            </a:r>
+          </a:p>
+          <a:p>
+            <a:pPr algn="ctr">
+              <a:defRPr sz="1350" b="1">
+                <a:solidFill>
+                  <a:srgbClr val="A02B93"/>
+                </a:solidFill>
+                <a:latin typeface="Aptos"/>
+                <a:ea typeface="Aptos"/>
+                <a:cs typeface="Aptos"/>
+              </a:defRPr>
+            </a:pPr>
+            <a:r>
+              <a:rPr sz="1350" b="1">
+                <a:solidFill>
+                  <a:srgbClr val="A02B93"/>
+                </a:solidFill>
+                <a:latin typeface="Aptos"/>
+                <a:ea typeface="Aptos"/>
+                <a:cs typeface="Aptos"/>
+              </a:rPr>
+              <a:t>nobody wrote</a:t>
+            </a:r>
+          </a:p>
+        </p:txBody>
+      </p:sp>
+      <p:sp>
+        <p:nvSpPr>
+          <p:cNvPr id="63" name="Failure caption">
+            <a:extLst>
+              <a:ext uri="{FF2B5EF4-FFF2-40B4-BE49-F238E27FC236}">
+                <a16:creationId xmlns:a16="http://schemas.microsoft.com/office/drawing/2014/main" id="{F52DF72F-2902-473C-9FF3-D23AA5738F62}"/>
+              </a:ext>
+            </a:extLst>
+          </p:cNvPr>
+          <p:cNvSpPr>
+            <a:spLocks noGrp="1"/>
+          </p:cNvSpPr>
+          <p:nvPr/>
+        </p:nvSpPr>
+        <p:spPr>
+          <a:xfrm>
+            <a:off x="409575" y="5105400"/>
+            <a:ext cx="6429375" cy="352425"/>
+          </a:xfrm>
+          <a:prstGeom prst="rect">
+            <a:avLst/>
+          </a:prstGeom>
+          <a:noFill/>
+          <a:ln w="0">
+            <a:noFill/>
+          </a:ln>
+        </p:spPr>
+        <p:txBody>
+          <a:bodyPr>
+            <a:normAutofit/>
+          </a:bodyPr>
+          <a:lstStyle/>
+          <a:p>
+            <a:pPr algn="ctr">
+              <a:defRPr sz="1650" b="1">
+                <a:solidFill>
+                  <a:srgbClr val="A02B93"/>
+                </a:solidFill>
+                <a:latin typeface="Aptos"/>
+                <a:ea typeface="Aptos"/>
+                <a:cs typeface="Aptos"/>
+              </a:defRPr>
+            </a:pPr>
+            <a:r>
+              <a:rPr sz="1650" b="1">
+                <a:solidFill>
+                  <a:srgbClr val="A02B93"/>
+                </a:solidFill>
+                <a:latin typeface="Aptos"/>
+                <a:ea typeface="Aptos"/>
+                <a:cs typeface="Aptos"/>
+              </a:rPr>
+              <a:t>Nobody wrote, yet the value changed</a:t>
             </a:r>
           </a:p>
         </p:txBody>

</xml_diff>

<commit_message>
Rewrite GFS replication example scripts
</commit_message>
<xml_diff>
--- a/slides/fall26/4-gfs.pptx
+++ b/slides/fall26/4-gfs.pptx
@@ -870,7 +870,7 @@
           <a:p>
             <a:r>
               <a:rPr lang="en-US" dirty="0"/>
-              <a:t>Now consider the simplest replication design we might try.</a:t>
+              <a:t>The simplest way to add fault tolerance is to keep two complete copies of the data. If either server fails, the other server still has a copy and can continue serving clients.</a:t>
             </a:r>
           </a:p>
           <a:p>
@@ -879,7 +879,7 @@
           <a:p>
             <a:r>
               <a:rPr lang="en-US" dirty="0"/>
-              <a:t>We keep two servers, and each server stores a complete copy of the data. The goal is fault tolerance: if either server fails, the other still has the data. Therefore every write has to be applied to both copies. At the same time, a read should be able to use either server by itself. If every read had to consult both servers, losing one server would make the system unavailable and replication would not have achieved its purpose.</a:t>
+              <a:t>That goal gives us two requirements. Every write must eventually reach both servers, so their copies remain up to date. But a read must be able to use either server by itself. If every read had to consult both servers, then losing one server would still make the system unavailable, and replication would not have solved the failure problem.</a:t>
             </a:r>
           </a:p>
           <a:p>
@@ -888,7 +888,7 @@
           <a:p>
             <a:r>
               <a:rPr lang="en-US" dirty="0"/>
-              <a:t>The tempting protocol is exactly what this slide shows. The client sends the update independently to both servers, and each server applies the update when it arrives. If the two copies start in the same state and receive the same operations, it seems that they should remain identical.</a:t>
+              <a:t>The obvious protocol is for the client to send each update to both replicas. Each server applies the update to its own copy when the request arrives. If the two servers begin with the same data and receive the same updates, this initially sounds sufficient to keep them identical.</a:t>
             </a:r>
           </a:p>
           <a:p>
@@ -897,25 +897,7 @@
           <a:p>
             <a:r>
               <a:rPr lang="en-US" dirty="0"/>
-              <a:t>The hidden assumption is that the servers will apply concurrent operations in the same order. Nothing in this protocol enforces that assumption. The network can deliver messages to server 1 in one order and to server 2 in the opposite order. Each server may individually behave like a perfectly reasonable single server, yet the two final copies can still disagree because they chose different legal orders.</a:t>
-            </a:r>
-          </a:p>
-          <a:p>
-            <a:endParaRPr lang="en-US" dirty="0"/>
-          </a:p>
-          <a:p>
-            <a:r>
-              <a:rPr lang="en-US" dirty="0"/>
-              <a:t>There is no common authority here that decides the order, and the replicas do not communicate before applying the writes. Once they diverge, a read can return a different value depending on which server it contacts. A failover can even make the visible value change without any new write. The next slide traces that failure using two clients that write the same data concurrently.</a:t>
-            </a:r>
-          </a:p>
-          <a:p>
-            <a:endParaRPr lang="en-US" dirty="0"/>
-          </a:p>
-          <a:p>
-            <a:r>
-              <a:rPr lang="en-US" dirty="0"/>
-              <a:t>Fixing the design requires some mechanism that establishes one order: for example, a primary that orders the mutations, plus communication that makes the other replicas follow that order. That is the coordination cost introduced on the previous slide. GFS uses a primary for each chunk, but its exact guarantees still depend on what happens when a mutation reaches only some replicas.</a:t>
+              <a:t>The protocol is missing one rule: it never says that the two servers must apply concurrent updates in the same order. Each server simply follows the order in which messages happen to arrive over the network. With one writer, that may be enough. With two clients writing concurrently, the arrival orders can differ, and the two copies can diverge even though neither server has failed.</a:t>
             </a:r>
           </a:p>
           <a:p>
@@ -927,9 +909,7 @@
               <a:t>SOURCE
 MIT 6.824, Spring 2020, Lecture 3 transcript/video, 10:47–12:29.
 Local transcript: fall2026/lectures/references/mit-6824-2020-lecture3-gfs-transcript.txt
-https://www.youtube.com/watch?v=EpIgvowZr00
-Ghemawat, Gobioff, and Leung, The Google File System, Sections 3.1 and 3.2.
-https://pdos.csail.mit.edu/6.824/papers/gfs.pdf</a:t>
+https://www.youtube.com/watch?v=EpIgvowZr00</a:t>
             </a:r>
           </a:p>
         </p:txBody>
@@ -1039,81 +1019,66 @@
           <a:lstStyle/>
           <a:p>
             <a:r>
-              <a:t>Now add a second client that writes the same region concurrently.</a:t>
-            </a:r>
+              <a:rPr lang="en-US" dirty="0"/>
+              <a:t>Now client 1 writes x equals 1, and client 2 writes x equals 2. Each client sends its write to both servers because both replicas are supposed to contain the complete data.</a:t>
+            </a:r>
+          </a:p>
+          <a:p>
             <a:endParaRPr lang="en-US" dirty="0"/>
           </a:p>
           <a:p>
+            <a:r>
+              <a:rPr lang="en-US" dirty="0"/>
+              <a:t>The network does not promise to deliver those messages in the same order. Suppose server 1 receives client 1's write first and client 2's write second. It sets x to 1 and then overwrites it with 2, so server 1 ends with x equal to 2.</a:t>
+            </a:r>
+          </a:p>
+          <a:p>
             <a:endParaRPr lang="en-US" dirty="0"/>
           </a:p>
           <a:p>
             <a:r>
-              <a:t>Server 1 may receive client 1's request first and client 2's request second. Server 2 may receive the opposite order. If the writes overlap, the final bytes on the two servers can differ.</a:t>
-            </a:r>
+              <a:rPr lang="en-US" dirty="0"/>
+              <a:t>Server 2 may receive the same two requests in the opposite order. It sets x to 2 and then overwrites it with 1, so server 2 ends with x equal to 1.</a:t>
+            </a:r>
+          </a:p>
+          <a:p>
             <a:endParaRPr lang="en-US" dirty="0"/>
           </a:p>
           <a:p>
+            <a:r>
+              <a:rPr lang="en-US" dirty="0"/>
+              <a:t>Notice that neither server behaved incorrectly by itself. Each one processed one request at a time, and each one chose a legal order for two concurrent writes. The failure is that they chose different orders. The replicated system no longer behaves like one logical machine.</a:t>
+            </a:r>
+          </a:p>
+          <a:p>
             <a:endParaRPr lang="en-US" dirty="0"/>
           </a:p>
           <a:p>
             <a:r>
-              <a:t>A later reader can then get a different answer depending on which replica it contacts. Even worse, if clients normally read from server 1 and that server fails, the visible value can suddenly change without any new write.</a:t>
-            </a:r>
+              <a:rPr lang="en-US" dirty="0"/>
+              <a:t>A client reading from server 1 now receives 2, while a client reading from server 2 receives 1. Those results cannot both be explained by one final write order. The replicas were meant to be interchangeable, but the answer now depends on which replica the client happens to contact.</a:t>
+            </a:r>
+          </a:p>
+          <a:p>
             <a:endParaRPr lang="en-US" dirty="0"/>
           </a:p>
           <a:p>
+            <a:r>
+              <a:rPr lang="en-US" dirty="0"/>
+              <a:t>A natural response is to stop reading from arbitrary replicas and always read from one designated server. That makes the disagreement harder to see, but it does not make the copies agree.</a:t>
+            </a:r>
+          </a:p>
+          <a:p>
             <a:endParaRPr lang="en-US" dirty="0"/>
           </a:p>
           <a:p>
             <a:r>
-              <a:t>The missing ingredient is one authority that chooses the mutation order for this chunk.</a:t>
-            </a:r>
-            <a:endParaRPr lang="en-US" dirty="0"/>
-          </a:p>
-          <a:p>
-            <a:endParaRPr lang="en-US" dirty="0"/>
-          </a:p>
-          <a:p>
-            <a:r>
-              <a:t>SOURCE</a:t>
-            </a:r>
-            <a:endParaRPr lang="en-US" dirty="0"/>
-          </a:p>
-          <a:p>
-            <a:r>
-              <a:t>MIT 6.824, Spring 2020, Lecture 3 video, 10:11-15:13.</a:t>
-            </a:r>
-            <a:endParaRPr lang="en-US" dirty="0"/>
-          </a:p>
-          <a:p>
-            <a:r>
-              <a:t>https://www.youtube.com/watch?v=EpIgvowZr00</a:t>
-            </a:r>
-            <a:endParaRPr lang="en-US" dirty="0"/>
-          </a:p>
-          <a:p>
-            <a:r>
-              <a:t>MIT 6.5840, GFS lecture notes.</a:t>
-            </a:r>
-            <a:endParaRPr lang="en-US" dirty="0"/>
-          </a:p>
-          <a:p>
-            <a:r>
-              <a:t>https://pdos.csail.mit.edu/6.824/notes/l-gfs.txt</a:t>
-            </a:r>
-            <a:endParaRPr lang="en-US" dirty="0"/>
-          </a:p>
-          <a:p>
-            <a:r>
-              <a:t>Ghemawat, Gobioff, and Leung, The Google File System, Sections 3.1 and 3.2.</a:t>
-            </a:r>
-            <a:endParaRPr lang="en-US" dirty="0"/>
-          </a:p>
-          <a:p>
-            <a:r>
-              <a:t>https://pdos.csail.mit.edu/6.824/papers/gfs.pdf</a:t>
-            </a:r>
-            <a:endParaRPr lang="en-US" dirty="0"/>
+              <a:rPr lang="en-US" dirty="0"/>
+              <a:t>SOURCE
+MIT 6.824, Spring 2020, Lecture 3 transcript/video, 12:29–13:18.
+Local transcript: fall2026/lectures/references/mit-6824-2020-lecture3-gfs-transcript.txt
+https://www.youtube.com/watch?v=EpIgvowZr00</a:t>
+            </a:r>
           </a:p>
         </p:txBody>
       </p:sp>
@@ -8687,7 +8652,7 @@
           <a:p>
             <a:r>
               <a:rPr lang="en-US" dirty="0"/>
-              <a:t>The design on the previous slides failed for one reason: no component decided the order in which the replicas applied the writes. Every possible repair has to supply that missing decision.</a:t>
+              <a:t>The previous two slides showed two different failures, and they share one root: the replicas were allowed to diverge, and nothing ever pulled them back together. In What Can Go Wrong? they diverged because no component chose an order for the two writes. In Can We Just Always Read from Server 1? the divergence already existed, and reading from one designated server only hid it until that server died. Every real repair has to stop the replicas from diverging, not merely choose which one to read.</a:t>
             </a:r>
           </a:p>
           <a:p>
@@ -8705,7 +8670,7 @@
           <a:p>
             <a:r>
               <a:rPr lang="en-US" dirty="0"/>
-              <a:t>GFS sits at a deliberate point on that range: much better than the design we just took apart, and knowingly not perfect. Where exactly it sits, and why Google was willing to accept that, is the rest of the lecture.</a:t>
+              <a:t>GFS sits at a deliberate point on that range: much better than the naive scheme from the Bad Replication Design slide, and knowingly not perfect. Where exactly it sits, and why Google was willing to accept that, is the rest of the lecture.</a:t>
             </a:r>
           </a:p>
           <a:p>
@@ -9014,61 +8979,55 @@
           <a:p>
             <a:r>
               <a:rPr lang="en-US" dirty="0"/>
-              <a:t>Students propose this fix themselves, so it is worth putting up and knocking down.</a:t>
-            </a:r>
+              <a:t>Suppose every client reads from server 1 while it is available and uses server 2 only as a backup. Server 1 contains 2 and server 2 contains 1, but while server 1 is running, every reader sees 2. The system appears consistent because the disagreement is hidden.</a:t>
+            </a:r>
+          </a:p>
+          <a:p>
+            <a:endParaRPr lang="en-US" dirty="0"/>
           </a:p>
           <a:p>
             <a:r>
               <a:rPr lang="en-US" dirty="0"/>
-              <a:t>The replicas have already diverged on the previous slide: S1 holds 2 and S2 holds 1. The patch is the obvious one - send every read to S1, and use S2 only when S1 cannot be reached. While S1 is up it appears to work. Every reader sees 2 and nobody ever observes a disagreement.</a:t>
-            </a:r>
+              <a:t>Now server 1 fails. The clients fall back to server 2, and the visible value becomes 1. No client wrote x between those reads. The value changed from 2 back to 1 only because the system switched replicas.</a:t>
+            </a:r>
+          </a:p>
+          <a:p>
+            <a:endParaRPr lang="en-US" dirty="0"/>
           </a:p>
           <a:p>
             <a:r>
               <a:rPr lang="en-US" dirty="0"/>
-              <a:t>Click. S1 fails. The readers fall back to S2 and now see 1. No client wrote anything between the two reads, and the value still moved backwards.</a:t>
-            </a:r>
+              <a:t>This cannot be explained by the one-machine model. A correct machine that performs one request at a time changes a stored value only when some operation changes it. Here the clients observe a change that corresponds to no write at all.</a:t>
+            </a:r>
+          </a:p>
+          <a:p>
+            <a:endParaRPr lang="en-US" dirty="0"/>
           </a:p>
           <a:p>
             <a:r>
               <a:rPr lang="en-US" dirty="0"/>
-              <a:t>Apply the test from the What Should the Readers See? slide: could one correct machine have produced this? No. A machine that handles one request at a time changes a value only when somebody writes it.</a:t>
-            </a:r>
+              <a:t>Always reading from one designated server therefore hides divergence instead of repairing it. The stale copy remains in the system, and the disagreement becomes visible at exactly the moment when the preferred server fails.</a:t>
+            </a:r>
+          </a:p>
+          <a:p>
+            <a:endParaRPr lang="en-US" dirty="0"/>
           </a:p>
           <a:p>
             <a:r>
               <a:rPr lang="en-US" dirty="0"/>
-              <a:t>The lesson is that reading from a designated server hides the divergence instead of removing it. The divergence is still there, and a failure is exactly when it surfaces, which is the worst possible moment for it to do so.</a:t>
-            </a:r>
+              <a:t>Preventing this behavior requires the replicas to agree on one order before the system treats a write as complete. That agreement requires communication between the servers, a protocol for deciding the order, and additional waiting before the client receives a reply. Consistency can be improved, but the coordination has a cost.</a:t>
+            </a:r>
+          </a:p>
+          <a:p>
+            <a:endParaRPr lang="en-US" dirty="0"/>
           </a:p>
           <a:p>
             <a:r>
               <a:rPr lang="en-US" dirty="0"/>
-              <a:t>This is also why the next slide can claim that a real fix costs something: the cheap fix has just been shown to be no fix at all.</a:t>
-            </a:r>
-          </a:p>
-          <a:p>
-            <a:r>
-              <a:rPr lang="en-US" dirty="0"/>
-              <a:t>SOURCE</a:t>
-            </a:r>
-          </a:p>
-          <a:p>
-            <a:r>
-              <a:rPr lang="en-US" dirty="0"/>
-              <a:t>MIT 6.824, Spring 2020, Lecture 3 video, 13:18-14:07.</a:t>
-            </a:r>
-          </a:p>
-          <a:p>
-            <a:r>
-              <a:rPr lang="en-US" dirty="0"/>
-              <a:t>https://www.youtube.com/watch?v=EpIgvowZr00</a:t>
-            </a:r>
-          </a:p>
-          <a:p>
-            <a:r>
-              <a:rPr lang="en-US" dirty="0"/>
-              <a:t>Local transcript: fall2026/lectures/references/mit-6824-2020-lecture3-gfs-transcript.txt</a:t>
+              <a:t>SOURCE
+MIT 6.824, Spring 2020, Lecture 3 transcript/video, 13:18–14:54.
+Local transcript: fall2026/lectures/references/mit-6824-2020-lecture3-gfs-transcript.txt
+https://www.youtube.com/watch?v=EpIgvowZr00</a:t>
             </a:r>
           </a:p>
         </p:txBody>
@@ -13976,6 +13935,124 @@
   <p:clrMapOvr>
     <a:masterClrMapping/>
   </p:clrMapOvr>
+  <p:timing>
+    <p:tnLst>
+      <p:par>
+        <p:cTn id="1" dur="indefinite" restart="never" nodeType="tmRoot">
+          <p:childTnLst>
+            <p:seq concurrent="1" nextAc="seek">
+              <p:cTn id="2" dur="indefinite" nodeType="mainSeq">
+                <p:childTnLst>
+                  <p:par>
+                    <p:cTn id="3" fill="hold">
+                      <p:stCondLst>
+                        <p:cond delay="indefinite"/>
+                      </p:stCondLst>
+                      <p:childTnLst>
+                        <p:par>
+                          <p:cTn id="4" fill="hold">
+                            <p:stCondLst>
+                              <p:cond delay="0"/>
+                            </p:stCondLst>
+                            <p:childTnLst>
+                              <p:par>
+                                <p:cTn id="5" presetID="9" presetClass="entr" presetSubtype="0" fill="hold" nodeType="clickEffect">
+                                  <p:stCondLst>
+                                    <p:cond delay="0"/>
+                                  </p:stCondLst>
+                                  <p:childTnLst>
+                                    <p:set>
+                                      <p:cBhvr>
+                                        <p:cTn id="6" dur="1" fill="hold">
+                                          <p:stCondLst>
+                                            <p:cond delay="0"/>
+                                          </p:stCondLst>
+                                        </p:cTn>
+                                        <p:tgtEl>
+                                          <p:spTgt spid="5"/>
+                                        </p:tgtEl>
+                                        <p:attrNameLst>
+                                          <p:attrName>style.visibility</p:attrName>
+                                        </p:attrNameLst>
+                                      </p:cBhvr>
+                                      <p:to>
+                                        <p:strVal val="visible"/>
+                                      </p:to>
+                                    </p:set>
+                                    <p:animEffect transition="in" filter="dissolve">
+                                      <p:cBhvr>
+                                        <p:cTn id="7" dur="500"/>
+                                        <p:tgtEl>
+                                          <p:spTgt spid="5"/>
+                                        </p:tgtEl>
+                                      </p:cBhvr>
+                                    </p:animEffect>
+                                  </p:childTnLst>
+                                </p:cTn>
+                              </p:par>
+                              <p:par>
+                                <p:cTn id="8" presetID="9" presetClass="entr" presetSubtype="0" fill="hold" nodeType="withEffect">
+                                  <p:stCondLst>
+                                    <p:cond delay="0"/>
+                                  </p:stCondLst>
+                                  <p:childTnLst>
+                                    <p:set>
+                                      <p:cBhvr>
+                                        <p:cTn id="9" dur="1" fill="hold">
+                                          <p:stCondLst>
+                                            <p:cond delay="0"/>
+                                          </p:stCondLst>
+                                        </p:cTn>
+                                        <p:tgtEl>
+                                          <p:spTgt spid="10"/>
+                                        </p:tgtEl>
+                                        <p:attrNameLst>
+                                          <p:attrName>style.visibility</p:attrName>
+                                        </p:attrNameLst>
+                                      </p:cBhvr>
+                                      <p:to>
+                                        <p:strVal val="visible"/>
+                                      </p:to>
+                                    </p:set>
+                                    <p:animEffect transition="in" filter="dissolve">
+                                      <p:cBhvr>
+                                        <p:cTn id="10" dur="500"/>
+                                        <p:tgtEl>
+                                          <p:spTgt spid="10"/>
+                                        </p:tgtEl>
+                                      </p:cBhvr>
+                                    </p:animEffect>
+                                  </p:childTnLst>
+                                </p:cTn>
+                              </p:par>
+                            </p:childTnLst>
+                          </p:cTn>
+                        </p:par>
+                      </p:childTnLst>
+                    </p:cTn>
+                  </p:par>
+                </p:childTnLst>
+              </p:cTn>
+              <p:prevCondLst>
+                <p:cond evt="onPrev" delay="0">
+                  <p:tgtEl>
+                    <p:sldTgt/>
+                  </p:tgtEl>
+                </p:cond>
+              </p:prevCondLst>
+              <p:nextCondLst>
+                <p:cond evt="onNext" delay="0">
+                  <p:tgtEl>
+                    <p:sldTgt/>
+                  </p:tgtEl>
+                </p:cond>
+              </p:nextCondLst>
+            </p:seq>
+          </p:childTnLst>
+        </p:cTn>
+      </p:par>
+    </p:tnLst>
+  </p:timing>
 </p:sld>
 </file>
 
@@ -14637,6 +14714,27 @@
             </a:p>
           </p:txBody>
         </p:sp>
+      </p:grpSp>
+      <p:grpSp>
+        <p:nvGrpSpPr>
+          <p:cNvPr id="21" name="object 21">
+            <a:extLst>
+              <a:ext uri="{FF2B5EF4-FFF2-40B4-BE49-F238E27FC236}">
+                <a16:creationId xmlns:a16="http://schemas.microsoft.com/office/drawing/2014/main" id="{CCCA86B4-DCA6-DD25-ADCD-4C223D6A7014}"/>
+              </a:ext>
+            </a:extLst>
+          </p:cNvPr>
+          <p:cNvGrpSpPr/>
+          <p:nvPr/>
+        </p:nvGrpSpPr>
+        <p:grpSpPr>
+          <a:xfrm>
+            <a:off x="4058033" y="3958154"/>
+            <a:ext cx="3156585" cy="1154430"/>
+            <a:chOff x="5287744" y="7863184"/>
+            <a:chExt cx="3156585" cy="1154430"/>
+          </a:xfrm>
+        </p:grpSpPr>
         <p:sp>
           <p:nvSpPr>
             <p:cNvPr id="16" name="object 16">
@@ -14867,6 +14965,226 @@
           </p:txBody>
         </p:sp>
       </p:grpSp>
+      <p:sp>
+        <p:nvSpPr>
+          <p:cNvPr id="22" name="C1 value">
+            <a:extLst>
+              <a:ext uri="{FF2B5EF4-FFF2-40B4-BE49-F238E27FC236}">
+                <a16:creationId xmlns:a16="http://schemas.microsoft.com/office/drawing/2014/main" id="{B3234D3B-6A3A-C4E5-86E3-56006E2E9CDE}"/>
+              </a:ext>
+            </a:extLst>
+          </p:cNvPr>
+          <p:cNvSpPr txBox="1"/>
+          <p:nvPr/>
+        </p:nvSpPr>
+        <p:spPr>
+          <a:xfrm>
+            <a:off x="2245261" y="4260000"/>
+            <a:ext cx="1812925" cy="350000"/>
+          </a:xfrm>
+          <a:prstGeom prst="rect">
+            <a:avLst/>
+          </a:prstGeom>
+          <a:ln>
+            <a:noFill/>
+          </a:ln>
+        </p:spPr>
+        <p:txBody>
+          <a:bodyPr vert="horz" wrap="square" lIns="0" tIns="0" rIns="0" bIns="0" rtlCol="0">
+            <a:spAutoFit/>
+          </a:bodyPr>
+          <a:lstStyle/>
+          <a:p>
+            <a:pPr marL="254000">
+              <a:lnSpc>
+                <a:spcPct val="100000"/>
+              </a:lnSpc>
+              <a:spcBef>
+                <a:spcPts val="2125"/>
+              </a:spcBef>
+            </a:pPr>
+            <a:r>
+              <a:rPr sz="2000" b="1" spc="-10" dirty="0">
+                <a:solidFill>
+                  <a:srgbClr val="222C4A"/>
+                </a:solidFill>
+                <a:latin typeface="Arial"/>
+                <a:cs typeface="Arial"/>
+              </a:rPr>
+              <a:t>writes x = 1</a:t>
+            </a:r>
+            <a:endParaRPr sz="2000" b="1">
+              <a:latin typeface="Arial"/>
+              <a:cs typeface="Arial"/>
+            </a:endParaRPr>
+          </a:p>
+        </p:txBody>
+      </p:sp>
+      <p:sp>
+        <p:nvSpPr>
+          <p:cNvPr id="23" name="C2 value">
+            <a:extLst>
+              <a:ext uri="{FF2B5EF4-FFF2-40B4-BE49-F238E27FC236}">
+                <a16:creationId xmlns:a16="http://schemas.microsoft.com/office/drawing/2014/main" id="{B3234D3B-6A3A-C4E5-86E3-56006E2E9CDE}"/>
+              </a:ext>
+            </a:extLst>
+          </p:cNvPr>
+          <p:cNvSpPr txBox="1"/>
+          <p:nvPr/>
+        </p:nvSpPr>
+        <p:spPr>
+          <a:xfrm>
+            <a:off x="2245261" y="5770000"/>
+            <a:ext cx="1812925" cy="350000"/>
+          </a:xfrm>
+          <a:prstGeom prst="rect">
+            <a:avLst/>
+          </a:prstGeom>
+          <a:ln>
+            <a:noFill/>
+          </a:ln>
+        </p:spPr>
+        <p:txBody>
+          <a:bodyPr vert="horz" wrap="square" lIns="0" tIns="0" rIns="0" bIns="0" rtlCol="0">
+            <a:spAutoFit/>
+          </a:bodyPr>
+          <a:lstStyle/>
+          <a:p>
+            <a:pPr marL="254000">
+              <a:lnSpc>
+                <a:spcPct val="100000"/>
+              </a:lnSpc>
+              <a:spcBef>
+                <a:spcPts val="2125"/>
+              </a:spcBef>
+            </a:pPr>
+            <a:r>
+              <a:rPr sz="2000" b="1" spc="-10" dirty="0">
+                <a:solidFill>
+                  <a:srgbClr val="222C4A"/>
+                </a:solidFill>
+                <a:latin typeface="Arial"/>
+                <a:cs typeface="Arial"/>
+              </a:rPr>
+              <a:t>writes x = 2</a:t>
+            </a:r>
+            <a:endParaRPr sz="2000" b="1">
+              <a:latin typeface="Arial"/>
+              <a:cs typeface="Arial"/>
+            </a:endParaRPr>
+          </a:p>
+        </p:txBody>
+      </p:sp>
+      <p:sp>
+        <p:nvSpPr>
+          <p:cNvPr id="24" name="S1 result">
+            <a:extLst>
+              <a:ext uri="{FF2B5EF4-FFF2-40B4-BE49-F238E27FC236}">
+                <a16:creationId xmlns:a16="http://schemas.microsoft.com/office/drawing/2014/main" id="{B3234D3B-6A3A-C4E5-86E3-56006E2E9CDE}"/>
+              </a:ext>
+            </a:extLst>
+          </p:cNvPr>
+          <p:cNvSpPr txBox="1"/>
+          <p:nvPr/>
+        </p:nvSpPr>
+        <p:spPr>
+          <a:xfrm>
+            <a:off x="9200000" y="3500000"/>
+            <a:ext cx="2300000" cy="400000"/>
+          </a:xfrm>
+          <a:prstGeom prst="rect">
+            <a:avLst/>
+          </a:prstGeom>
+          <a:ln>
+            <a:noFill/>
+          </a:ln>
+        </p:spPr>
+        <p:txBody>
+          <a:bodyPr vert="horz" wrap="square" lIns="0" tIns="0" rIns="0" bIns="0" rtlCol="0">
+            <a:spAutoFit/>
+          </a:bodyPr>
+          <a:lstStyle/>
+          <a:p>
+            <a:pPr marL="254000">
+              <a:lnSpc>
+                <a:spcPct val="100000"/>
+              </a:lnSpc>
+              <a:spcBef>
+                <a:spcPts val="2125"/>
+              </a:spcBef>
+            </a:pPr>
+            <a:r>
+              <a:rPr sz="2000" b="1" spc="-10" dirty="0">
+                <a:solidFill>
+                  <a:srgbClr val="222C4A"/>
+                </a:solidFill>
+                <a:latin typeface="Arial"/>
+                <a:cs typeface="Arial"/>
+              </a:rPr>
+              <a:t>ends with x = 2</a:t>
+            </a:r>
+            <a:endParaRPr sz="2000" b="1">
+              <a:latin typeface="Arial"/>
+              <a:cs typeface="Arial"/>
+            </a:endParaRPr>
+          </a:p>
+        </p:txBody>
+      </p:sp>
+      <p:sp>
+        <p:nvSpPr>
+          <p:cNvPr id="25" name="S2 result">
+            <a:extLst>
+              <a:ext uri="{FF2B5EF4-FFF2-40B4-BE49-F238E27FC236}">
+                <a16:creationId xmlns:a16="http://schemas.microsoft.com/office/drawing/2014/main" id="{B3234D3B-6A3A-C4E5-86E3-56006E2E9CDE}"/>
+              </a:ext>
+            </a:extLst>
+          </p:cNvPr>
+          <p:cNvSpPr txBox="1"/>
+          <p:nvPr/>
+        </p:nvSpPr>
+        <p:spPr>
+          <a:xfrm>
+            <a:off x="9200000" y="5220000"/>
+            <a:ext cx="2300000" cy="400000"/>
+          </a:xfrm>
+          <a:prstGeom prst="rect">
+            <a:avLst/>
+          </a:prstGeom>
+          <a:ln>
+            <a:noFill/>
+          </a:ln>
+        </p:spPr>
+        <p:txBody>
+          <a:bodyPr vert="horz" wrap="square" lIns="0" tIns="0" rIns="0" bIns="0" rtlCol="0">
+            <a:spAutoFit/>
+          </a:bodyPr>
+          <a:lstStyle/>
+          <a:p>
+            <a:pPr marL="254000">
+              <a:lnSpc>
+                <a:spcPct val="100000"/>
+              </a:lnSpc>
+              <a:spcBef>
+                <a:spcPts val="2125"/>
+              </a:spcBef>
+            </a:pPr>
+            <a:r>
+              <a:rPr sz="2000" b="1" spc="-10" dirty="0">
+                <a:solidFill>
+                  <a:srgbClr val="222C4A"/>
+                </a:solidFill>
+                <a:latin typeface="Arial"/>
+                <a:cs typeface="Arial"/>
+              </a:rPr>
+              <a:t>ends with x = 1</a:t>
+            </a:r>
+            <a:endParaRPr sz="2000" b="1">
+              <a:latin typeface="Arial"/>
+              <a:cs typeface="Arial"/>
+            </a:endParaRPr>
+          </a:p>
+        </p:txBody>
+      </p:sp>
     </p:spTree>
     <p:extLst>
       <p:ext uri="{BB962C8B-B14F-4D97-AF65-F5344CB8AC3E}">
@@ -14898,7 +15216,7 @@
                             </p:stCondLst>
                             <p:childTnLst>
                               <p:par>
-                                <p:cTn id="5" presetID="9" presetClass="entr" presetSubtype="0" fill="hold" grpId="0" nodeType="clickEffect">
+                                <p:cTn id="5" presetID="9" presetClass="entr" presetSubtype="0" fill="hold" nodeType="clickEffect">
                                   <p:stCondLst>
                                     <p:cond delay="0"/>
                                   </p:stCondLst>
@@ -14906,146 +15224,6 @@
                                     <p:set>
                                       <p:cBhvr>
                                         <p:cTn id="6" dur="1" fill="hold">
-                                          <p:stCondLst>
-                                            <p:cond delay="0"/>
-                                          </p:stCondLst>
-                                        </p:cTn>
-                                        <p:tgtEl>
-                                          <p:spTgt spid="4"/>
-                                        </p:tgtEl>
-                                        <p:attrNameLst>
-                                          <p:attrName>style.visibility</p:attrName>
-                                        </p:attrNameLst>
-                                      </p:cBhvr>
-                                      <p:to>
-                                        <p:strVal val="visible"/>
-                                      </p:to>
-                                    </p:set>
-                                    <p:animEffect transition="in" filter="dissolve">
-                                      <p:cBhvr>
-                                        <p:cTn id="7" dur="500"/>
-                                        <p:tgtEl>
-                                          <p:spTgt spid="4"/>
-                                        </p:tgtEl>
-                                      </p:cBhvr>
-                                    </p:animEffect>
-                                  </p:childTnLst>
-                                </p:cTn>
-                              </p:par>
-                              <p:par>
-                                <p:cTn id="8" presetID="9" presetClass="entr" presetSubtype="0" fill="hold" grpId="0" nodeType="withEffect">
-                                  <p:stCondLst>
-                                    <p:cond delay="0"/>
-                                  </p:stCondLst>
-                                  <p:childTnLst>
-                                    <p:set>
-                                      <p:cBhvr>
-                                        <p:cTn id="9" dur="1" fill="hold">
-                                          <p:stCondLst>
-                                            <p:cond delay="0"/>
-                                          </p:stCondLst>
-                                        </p:cTn>
-                                        <p:tgtEl>
-                                          <p:spTgt spid="5"/>
-                                        </p:tgtEl>
-                                        <p:attrNameLst>
-                                          <p:attrName>style.visibility</p:attrName>
-                                        </p:attrNameLst>
-                                      </p:cBhvr>
-                                      <p:to>
-                                        <p:strVal val="visible"/>
-                                      </p:to>
-                                    </p:set>
-                                    <p:animEffect transition="in" filter="dissolve">
-                                      <p:cBhvr>
-                                        <p:cTn id="10" dur="500"/>
-                                        <p:tgtEl>
-                                          <p:spTgt spid="5"/>
-                                        </p:tgtEl>
-                                      </p:cBhvr>
-                                    </p:animEffect>
-                                  </p:childTnLst>
-                                </p:cTn>
-                              </p:par>
-                              <p:par>
-                                <p:cTn id="11" presetID="9" presetClass="entr" presetSubtype="0" fill="hold" grpId="0" nodeType="withEffect">
-                                  <p:stCondLst>
-                                    <p:cond delay="0"/>
-                                  </p:stCondLst>
-                                  <p:childTnLst>
-                                    <p:set>
-                                      <p:cBhvr>
-                                        <p:cTn id="12" dur="1" fill="hold">
-                                          <p:stCondLst>
-                                            <p:cond delay="0"/>
-                                          </p:stCondLst>
-                                        </p:cTn>
-                                        <p:tgtEl>
-                                          <p:spTgt spid="6"/>
-                                        </p:tgtEl>
-                                        <p:attrNameLst>
-                                          <p:attrName>style.visibility</p:attrName>
-                                        </p:attrNameLst>
-                                      </p:cBhvr>
-                                      <p:to>
-                                        <p:strVal val="visible"/>
-                                      </p:to>
-                                    </p:set>
-                                    <p:animEffect transition="in" filter="dissolve">
-                                      <p:cBhvr>
-                                        <p:cTn id="13" dur="500"/>
-                                        <p:tgtEl>
-                                          <p:spTgt spid="6"/>
-                                        </p:tgtEl>
-                                      </p:cBhvr>
-                                    </p:animEffect>
-                                  </p:childTnLst>
-                                </p:cTn>
-                              </p:par>
-                              <p:par>
-                                <p:cTn id="14" presetID="9" presetClass="entr" presetSubtype="0" fill="hold" grpId="0" nodeType="withEffect">
-                                  <p:stCondLst>
-                                    <p:cond delay="0"/>
-                                  </p:stCondLst>
-                                  <p:childTnLst>
-                                    <p:set>
-                                      <p:cBhvr>
-                                        <p:cTn id="15" dur="1" fill="hold">
-                                          <p:stCondLst>
-                                            <p:cond delay="0"/>
-                                          </p:stCondLst>
-                                        </p:cTn>
-                                        <p:tgtEl>
-                                          <p:spTgt spid="9"/>
-                                        </p:tgtEl>
-                                        <p:attrNameLst>
-                                          <p:attrName>style.visibility</p:attrName>
-                                        </p:attrNameLst>
-                                      </p:cBhvr>
-                                      <p:to>
-                                        <p:strVal val="visible"/>
-                                      </p:to>
-                                    </p:set>
-                                    <p:animEffect transition="in" filter="dissolve">
-                                      <p:cBhvr>
-                                        <p:cTn id="16" dur="500"/>
-                                        <p:tgtEl>
-                                          <p:spTgt spid="9"/>
-                                        </p:tgtEl>
-                                      </p:cBhvr>
-                                    </p:animEffect>
-                                  </p:childTnLst>
-                                </p:cTn>
-                              </p:par>
-                              <p:par>
-                                <p:cTn id="17" presetID="9" presetClass="entr" presetSubtype="0" fill="hold" nodeType="withEffect">
-                                  <p:stCondLst>
-                                    <p:cond delay="0"/>
-                                  </p:stCondLst>
-                                  <p:childTnLst>
-                                    <p:set>
-                                      <p:cBhvr>
-                                        <p:cTn id="18" dur="1" fill="hold">
                                           <p:stCondLst>
                                             <p:cond delay="0"/>
                                           </p:stCondLst>
@@ -15063,7 +15241,7 @@
                                     </p:set>
                                     <p:animEffect transition="in" filter="dissolve">
                                       <p:cBhvr>
-                                        <p:cTn id="19" dur="500"/>
+                                        <p:cTn id="7" dur="500"/>
                                         <p:tgtEl>
                                           <p:spTgt spid="10"/>
                                         </p:tgtEl>
@@ -15073,14 +15251,14 @@
                                 </p:cTn>
                               </p:par>
                               <p:par>
-                                <p:cTn id="20" presetID="9" presetClass="entr" presetSubtype="0" fill="hold" nodeType="withEffect">
+                                <p:cTn id="8" presetID="9" presetClass="entr" presetSubtype="0" fill="hold" nodeType="withEffect">
                                   <p:stCondLst>
                                     <p:cond delay="0"/>
                                   </p:stCondLst>
                                   <p:childTnLst>
                                     <p:set>
                                       <p:cBhvr>
-                                        <p:cTn id="21" dur="1" fill="hold">
+                                        <p:cTn id="9" dur="1" fill="hold">
                                           <p:stCondLst>
                                             <p:cond delay="0"/>
                                           </p:stCondLst>
@@ -15098,7 +15276,7 @@
                                     </p:set>
                                     <p:animEffect transition="in" filter="dissolve">
                                       <p:cBhvr>
-                                        <p:cTn id="22" dur="500"/>
+                                        <p:cTn id="10" dur="500"/>
                                         <p:tgtEl>
                                           <p:spTgt spid="13"/>
                                         </p:tgtEl>
@@ -15107,15 +15285,68 @@
                                   </p:childTnLst>
                                 </p:cTn>
                               </p:par>
+                            </p:childTnLst>
+                          </p:cTn>
+                        </p:par>
+                      </p:childTnLst>
+                    </p:cTn>
+                  </p:par>
+                  <p:par>
+                    <p:cTn id="11" fill="hold">
+                      <p:stCondLst>
+                        <p:cond delay="indefinite"/>
+                      </p:stCondLst>
+                      <p:childTnLst>
+                        <p:par>
+                          <p:cTn id="12" fill="hold">
+                            <p:stCondLst>
+                              <p:cond delay="0"/>
+                            </p:stCondLst>
+                            <p:childTnLst>
                               <p:par>
-                                <p:cTn id="23" presetID="9" presetClass="entr" presetSubtype="0" fill="hold" nodeType="withEffect">
+                                <p:cTn id="13" presetID="9" presetClass="entr" presetSubtype="0" fill="hold" nodeType="clickEffect">
                                   <p:stCondLst>
                                     <p:cond delay="0"/>
                                   </p:stCondLst>
                                   <p:childTnLst>
                                     <p:set>
                                       <p:cBhvr>
-                                        <p:cTn id="24" dur="1" fill="hold">
+                                        <p:cTn id="14" dur="1" fill="hold">
+                                          <p:stCondLst>
+                                            <p:cond delay="0"/>
+                                          </p:stCondLst>
+                                        </p:cTn>
+                                        <p:tgtEl>
+                                          <p:spTgt spid="21"/>
+                                        </p:tgtEl>
+                                        <p:attrNameLst>
+                                          <p:attrName>style.visibility</p:attrName>
+                                        </p:attrNameLst>
+                                      </p:cBhvr>
+                                      <p:to>
+                                        <p:strVal val="visible"/>
+                                      </p:to>
+                                    </p:set>
+                                    <p:animEffect transition="in" filter="dissolve">
+                                      <p:cBhvr>
+                                        <p:cTn id="15" dur="500"/>
+                                        <p:tgtEl>
+                                          <p:spTgt spid="21"/>
+                                        </p:tgtEl>
+                                      </p:cBhvr>
+                                    </p:animEffect>
+                                  </p:childTnLst>
+                                </p:cTn>
+                              </p:par>
+                              <p:par>
+                                <p:cTn id="16" presetID="9" presetClass="entr" presetSubtype="0" fill="hold" nodeType="withEffect">
+                                  <p:stCondLst>
+                                    <p:cond delay="0"/>
+                                  </p:stCondLst>
+                                  <p:childTnLst>
+                                    <p:set>
+                                      <p:cBhvr>
+                                        <p:cTn id="17" dur="1" fill="hold">
                                           <p:stCondLst>
                                             <p:cond delay="0"/>
                                           </p:stCondLst>
@@ -15133,7 +15364,7 @@
                                     </p:set>
                                     <p:animEffect transition="in" filter="dissolve">
                                       <p:cBhvr>
-                                        <p:cTn id="25" dur="500"/>
+                                        <p:cTn id="18" dur="500"/>
                                         <p:tgtEl>
                                           <p:spTgt spid="18"/>
                                         </p:tgtEl>
@@ -15142,21 +15373,39 @@
                                   </p:childTnLst>
                                 </p:cTn>
                               </p:par>
+                            </p:childTnLst>
+                          </p:cTn>
+                        </p:par>
+                      </p:childTnLst>
+                    </p:cTn>
+                  </p:par>
+                  <p:par>
+                    <p:cTn id="19" fill="hold">
+                      <p:stCondLst>
+                        <p:cond delay="indefinite"/>
+                      </p:stCondLst>
+                      <p:childTnLst>
+                        <p:par>
+                          <p:cTn id="20" fill="hold">
+                            <p:stCondLst>
+                              <p:cond delay="0"/>
+                            </p:stCondLst>
+                            <p:childTnLst>
                               <p:par>
-                                <p:cTn id="26" presetID="9" presetClass="entr" presetSubtype="0" fill="hold" grpId="0" nodeType="withEffect">
+                                <p:cTn id="21" presetID="9" presetClass="entr" presetSubtype="0" fill="hold" nodeType="clickEffect">
                                   <p:stCondLst>
                                     <p:cond delay="0"/>
                                   </p:stCondLst>
                                   <p:childTnLst>
                                     <p:set>
                                       <p:cBhvr>
-                                        <p:cTn id="27" dur="1" fill="hold">
+                                        <p:cTn id="22" dur="1" fill="hold">
                                           <p:stCondLst>
                                             <p:cond delay="0"/>
                                           </p:stCondLst>
                                         </p:cTn>
                                         <p:tgtEl>
-                                          <p:spTgt spid="3"/>
+                                          <p:spTgt spid="24"/>
                                         </p:tgtEl>
                                         <p:attrNameLst>
                                           <p:attrName>style.visibility</p:attrName>
@@ -15168,9 +15417,44 @@
                                     </p:set>
                                     <p:animEffect transition="in" filter="dissolve">
                                       <p:cBhvr>
-                                        <p:cTn id="28" dur="500"/>
+                                        <p:cTn id="23" dur="500"/>
                                         <p:tgtEl>
-                                          <p:spTgt spid="3"/>
+                                          <p:spTgt spid="24"/>
+                                        </p:tgtEl>
+                                      </p:cBhvr>
+                                    </p:animEffect>
+                                  </p:childTnLst>
+                                </p:cTn>
+                              </p:par>
+                              <p:par>
+                                <p:cTn id="24" presetID="9" presetClass="entr" presetSubtype="0" fill="hold" nodeType="withEffect">
+                                  <p:stCondLst>
+                                    <p:cond delay="0"/>
+                                  </p:stCondLst>
+                                  <p:childTnLst>
+                                    <p:set>
+                                      <p:cBhvr>
+                                        <p:cTn id="25" dur="1" fill="hold">
+                                          <p:stCondLst>
+                                            <p:cond delay="0"/>
+                                          </p:stCondLst>
+                                        </p:cTn>
+                                        <p:tgtEl>
+                                          <p:spTgt spid="25"/>
+                                        </p:tgtEl>
+                                        <p:attrNameLst>
+                                          <p:attrName>style.visibility</p:attrName>
+                                        </p:attrNameLst>
+                                      </p:cBhvr>
+                                      <p:to>
+                                        <p:strVal val="visible"/>
+                                      </p:to>
+                                    </p:set>
+                                    <p:animEffect transition="in" filter="dissolve">
+                                      <p:cBhvr>
+                                        <p:cTn id="26" dur="500"/>
+                                        <p:tgtEl>
+                                          <p:spTgt spid="25"/>
                                         </p:tgtEl>
                                       </p:cBhvr>
                                     </p:animEffect>
@@ -15205,11 +15489,8 @@
       </p:par>
     </p:tnLst>
     <p:bldLst>
-      <p:bldP spid="3" grpId="0"/>
-      <p:bldP spid="4" grpId="0" animBg="1"/>
-      <p:bldP spid="5" grpId="0" animBg="1"/>
-      <p:bldP spid="6" grpId="0" animBg="1"/>
-      <p:bldP spid="9" grpId="0" animBg="1"/>
+      <p:bldP spid="24" grpId="0"/>
+      <p:bldP spid="25" grpId="0"/>
     </p:bldLst>
   </p:timing>
 </p:sld>
@@ -29527,7 +29808,7 @@
         <p:spPr>
           <a:xfrm>
             <a:off x="88135" y="914401"/>
-            <a:ext cx="12191998" cy="4585871"/>
+            <a:ext cx="12015730" cy="3200000"/>
           </a:xfrm>
           <a:prstGeom prst="rect">
             <a:avLst/>
@@ -29542,7 +29823,7 @@
           <a:p>
             <a:r>
               <a:rPr lang="en-US" sz="3200" b="1" dirty="0"/>
-              <a:t>The replicas disagreed because nobody chose an order</a:t>
+              <a:t>Both failures have one root: the replicas diverged</a:t>
             </a:r>
           </a:p>
           <a:p>
@@ -29552,7 +29833,17 @@
             </a:pPr>
             <a:r>
               <a:rPr lang="en-US" sz="2800" b="0" dirty="0"/>
-              <a:t>Each server applied the writes in the order the network happened to deliver them</a:t>
+              <a:t>A fix must prevent divergence, not pick who to read</a:t>
+            </a:r>
+          </a:p>
+          <a:p>
+            <a:pPr marL="457200"/>
+            <a:endParaRPr lang="en-US" sz="1400" b="0" dirty="0"/>
+          </a:p>
+          <a:p>
+            <a:r>
+              <a:rPr lang="en-US" sz="3200" b="1" dirty="0"/>
+              <a:t>Agreement is not free</a:t>
             </a:r>
           </a:p>
           <a:p>
@@ -29562,17 +29853,17 @@
             </a:pPr>
             <a:r>
               <a:rPr lang="en-US" sz="2800" b="0" dirty="0"/>
-              <a:t>Any fix has to make all replicas agree on one order</a:t>
+              <a:t>More messages, more complexity, longer waits</a:t>
             </a:r>
           </a:p>
           <a:p>
             <a:pPr marL="457200"/>
-            <a:endParaRPr lang="en-US" sz="2800" b="0" dirty="0"/>
+            <a:endParaRPr lang="en-US" sz="1400" b="0" dirty="0"/>
           </a:p>
           <a:p>
             <a:r>
               <a:rPr lang="en-US" sz="3200" b="1" dirty="0"/>
-              <a:t>Agreement is not free</a:t>
+              <a:t>So there is a range of designs, not one answer</a:t>
             </a:r>
           </a:p>
           <a:p>
@@ -29582,7 +29873,7 @@
             </a:pPr>
             <a:r>
               <a:rPr lang="en-US" sz="2800" b="0" dirty="0"/>
-              <a:t>More messages between the servers, and a more complicated protocol</a:t>
+              <a:t>Stronger consistency costs performance</a:t>
             </a:r>
           </a:p>
           <a:p>
@@ -29592,47 +29883,17 @@
             </a:pPr>
             <a:r>
               <a:rPr lang="en-US" sz="2800" b="0" dirty="0"/>
-              <a:t>A write is not done until the replicas agree, so clients wait longer</a:t>
+              <a:t>Weaker consistency costs the application</a:t>
             </a:r>
           </a:p>
           <a:p>
             <a:pPr marL="457200"/>
-            <a:endParaRPr lang="en-US" sz="2800" b="0" dirty="0"/>
+            <a:endParaRPr lang="en-US" sz="1400" b="0" dirty="0"/>
           </a:p>
           <a:p>
             <a:r>
               <a:rPr lang="en-US" sz="3200" b="1" dirty="0"/>
-              <a:t>So there is no single answer, but a range of designs</a:t>
-            </a:r>
-          </a:p>
-          <a:p>
-            <a:pPr marL="914400" indent="-457200">
-              <a:buFont typeface="Arial" panose="020B0604020202020204" pitchFamily="34" charset="0"/>
-              <a:buChar char="•"/>
-            </a:pPr>
-            <a:r>
-              <a:rPr lang="en-US" sz="2800" b="0" dirty="0"/>
-              <a:t>Stronger consistency: more coordination, lower performance</a:t>
-            </a:r>
-          </a:p>
-          <a:p>
-            <a:pPr marL="914400" indent="-457200">
-              <a:buFont typeface="Arial" panose="020B0604020202020204" pitchFamily="34" charset="0"/>
-              <a:buChar char="•"/>
-            </a:pPr>
-            <a:r>
-              <a:rPr lang="en-US" sz="2800" b="0" dirty="0"/>
-              <a:t>Weaker consistency: less coordination, and anomalies the application must handle</a:t>
-            </a:r>
-          </a:p>
-          <a:p>
-            <a:pPr marL="457200"/>
-            <a:endParaRPr lang="en-US" sz="2800" b="0" dirty="0"/>
-          </a:p>
-          <a:p>
-            <a:r>
-              <a:rPr lang="en-US" sz="3200" b="1" dirty="0"/>
-              <a:t>GFS picks a point on this range: better than this design, deliberately not perfect</a:t>
+              <a:t>GFS picks a point on it, deliberately not perfect</a:t>
             </a:r>
           </a:p>
         </p:txBody>

</xml_diff>

<commit_message>
Refine GFS consistency tradeoff script
</commit_message>
<xml_diff>
--- a/slides/fall26/4-gfs.pptx
+++ b/slides/fall26/4-gfs.pptx
@@ -8646,61 +8646,46 @@
           <a:p>
             <a:r>
               <a:rPr lang="en-US" dirty="0"/>
-              <a:t>This slide is the bridge from the broken design to the paper.</a:t>
-            </a:r>
+              <a:t>The two failures we just saw have the same root cause: the replicas were allowed to diverge. In the first case, the two servers applied concurrent writes in different orders. In the second case, always reading from server 1 merely hid that disagreement until server 1 failed. A real fix cannot simply choose which copy to read. It has to prevent the copies from diverging.</a:t>
+            </a:r>
+          </a:p>
+          <a:p>
+            <a:endParaRPr lang="en-US" dirty="0"/>
           </a:p>
           <a:p>
             <a:r>
               <a:rPr lang="en-US" dirty="0"/>
-              <a:t>The previous two slides showed two different failures, and they share one root: the replicas were allowed to diverge, and nothing ever pulled them back together. In What Can Go Wrong? they diverged because no component chose an order for the two writes. In Can We Just Always Read from Server 1? the divergence already existed, and reading from one designated server only hid it until that server died. Every real repair has to stop the replicas from diverging, not merely choose which one to read.</a:t>
-            </a:r>
+              <a:t>That is possible, but it is not free. The servers need to exchange more messages and run a more complicated protocol so that they agree on one order. A write may also have to wait for that agreement before the system can report success to the client. The extra communication and waiting reduce performance.</a:t>
+            </a:r>
+          </a:p>
+          <a:p>
+            <a:endParaRPr lang="en-US" dirty="0"/>
           </a:p>
           <a:p>
             <a:r>
               <a:rPr lang="en-US" dirty="0"/>
-              <a:t>Supplying it costs something. The servers have to exchange more messages, the protocol becomes more complicated, and a write cannot be reported as finished until the replicas have agreed. That waiting is the performance price, and it is the answer to the second question on the Two Questions slide.</a:t>
-            </a:r>
+              <a:t>Once we recognize that cost, there is no single obvious design. A system can coordinate more and provide behavior closer to one correct machine, or coordinate less and expose more anomalies that applications must handle.</a:t>
+            </a:r>
+          </a:p>
+          <a:p>
+            <a:endParaRPr lang="en-US" dirty="0"/>
           </a:p>
           <a:p>
             <a:r>
               <a:rPr lang="en-US" dirty="0"/>
-              <a:t>Because the price is real, there is no single answer. There is a range of designs offering different strengths of guarantee, and a matching range of anomalies that people are willing to live with.</a:t>
-            </a:r>
+              <a:t>GFS deliberately chooses a point in that range. Its behavior is much better than the naive replication scheme, but it does not pay the full cost of perfect consistency. The rest of the lecture explains what guarantees GFS provides and why those guarantees were a reasonable match for Google's workloads.</a:t>
+            </a:r>
+          </a:p>
+          <a:p>
+            <a:endParaRPr lang="en-US" dirty="0"/>
           </a:p>
           <a:p>
             <a:r>
               <a:rPr lang="en-US" dirty="0"/>
-              <a:t>GFS sits at a deliberate point on that range: much better than the naive scheme from the Bad Replication Design slide, and knowingly not perfect. Where exactly it sits, and why Google was willing to accept that, is the rest of the lecture.</a:t>
-            </a:r>
-          </a:p>
-          <a:p>
-            <a:r>
-              <a:rPr lang="en-US" dirty="0"/>
-              <a:t>Do not give the mechanism here. Leases, a primary, and how the primary orders mutations come later; at this point the class only needs to know that a fix exists and that it is paid for.</a:t>
-            </a:r>
-          </a:p>
-          <a:p>
-            <a:r>
-              <a:rPr lang="en-US" dirty="0"/>
-              <a:t>SOURCE</a:t>
-            </a:r>
-          </a:p>
-          <a:p>
-            <a:r>
-              <a:rPr lang="en-US" dirty="0"/>
-              <a:t>MIT 6.824, Spring 2020, Lecture 3 video, 14:07-15:00.</a:t>
-            </a:r>
-          </a:p>
-          <a:p>
-            <a:r>
-              <a:rPr lang="en-US" dirty="0"/>
-              <a:t>https://www.youtube.com/watch?v=EpIgvowZr00</a:t>
-            </a:r>
-          </a:p>
-          <a:p>
-            <a:r>
-              <a:rPr lang="en-US" dirty="0"/>
-              <a:t>Local transcript: fall2026/lectures/references/mit-6824-2020-lecture3-gfs-transcript.txt</a:t>
+              <a:t>SOURCE
+MIT 6.824, Spring 2020, Lecture 3 transcript/video, 14:07–15:00.
+Local transcript: fall2026/lectures/references/mit-6824-2020-lecture3-gfs-transcript.txt
+https://www.youtube.com/watch?v=EpIgvowZr00</a:t>
             </a:r>
           </a:p>
         </p:txBody>

</xml_diff>

<commit_message>
Update GFS paper context scripts
</commit_message>
<xml_diff>
--- a/slides/fall26/4-gfs.pptx
+++ b/slides/fall26/4-gfs.pptx
@@ -1187,27 +1187,41 @@
           <a:lstStyle/>
           <a:p>
             <a:r>
-              <a:t>TRANSITION: the problem statement is now on the table - shard for speed, replicate for failures, then fight the inconsistency that replication creates. This is the paper that picks one point in that trade-off. Keep this slide to about 30 seconds.</a:t>
-            </a:r>
-            <a:endParaRPr lang="en-US"/>
-          </a:p>
-          <a:p>
-            <a:r>
-              <a:t>Same people as last lecture: Sanjay Ghemawat is also an author of the MapReduce paper (Dean and Ghemawat, OSDI 2004). MapReduce runs on top of GFS, and the two papers are one year apart from the same group. Lecture 3 was the computation layer; this is the storage layer underneath it.</a:t>
-            </a:r>
-            <a:endParaRPr lang="en-US"/>
-          </a:p>
-          <a:p>
-            <a:r>
-              <a:t>The year matters: 2003, commodity Linux machines, one disk about 30 MB/s, a network card about 10 MB/s, and in a cluster of thousands something fails every day. Every trade-off in this paper follows from that hardware.</a:t>
-            </a:r>
-            <a:endParaRPr lang="en-US"/>
-          </a:p>
-          <a:p>
-            <a:r>
-              <a:t>Next slide: why we are reading this paper.</a:t>
-            </a:r>
-            <a:endParaRPr lang="en-US"/>
+              <a:rPr lang="en-US" dirty="0"/>
+              <a:t>The failure examples give us a concrete question: how much coordination should a storage system pay for, and which anomalies can its applications tolerate?</a:t>
+            </a:r>
+          </a:p>
+          <a:p>
+            <a:endParaRPr lang="en-US" dirty="0"/>
+          </a:p>
+          <a:p>
+            <a:r>
+              <a:rPr lang="en-US" dirty="0"/>
+              <a:t>GFS is Google's answer from 2003. It gives replicas much better behavior than the naive protocol, but it deliberately stops short of making every operation look exactly like one operation on one machine. That choice only makes sense in the setting Google was facing.</a:t>
+            </a:r>
+          </a:p>
+          <a:p>
+            <a:endParaRPr lang="en-US" dirty="0"/>
+          </a:p>
+          <a:p>
+            <a:r>
+              <a:rPr lang="en-US" dirty="0"/>
+              <a:t>The authors are Sanjay Ghemawat, Howard Gobioff, and Shun-Tak Leung. Ghemawat later coauthored the MapReduce paper, so this connects directly to the previous lecture. MapReduce is the computation layer, and GFS is the shared storage underneath it.</a:t>
+            </a:r>
+          </a:p>
+          <a:p>
+            <a:endParaRPr lang="en-US" dirty="0"/>
+          </a:p>
+          <a:p>
+            <a:r>
+              <a:rPr lang="en-US" dirty="0"/>
+              <a:t>SOURCE
+MIT 6.824, Spring 2020, Lecture 3 transcript/video, 14:54–15:43.
+Local transcript: fall2026/lectures/references/mit-6824-2020-lecture3-gfs-transcript.txt
+https://www.youtube.com/watch?v=EpIgvowZr00
+Ghemawat, Gobioff, and Leung, The Google File System, 2003.
+https://pdos.csail.mit.edu/6.824/papers/gfs.pdf</a:t>
+            </a:r>
           </a:p>
         </p:txBody>
       </p:sp>
@@ -1317,7 +1331,7 @@
           <a:p>
             <a:r>
               <a:rPr lang="en-US" dirty="0"/>
-              <a:t>We read GFS because distributed storage is one of the most useful abstractions in distributed systems.</a:t>
+              <a:t>Why spend a lecture on a file system from 2003? Large distributed storage became one of the basic building blocks of distributed systems. A simple storage interface can support many different applications, and many other systems assume that a large, reasonably well-behaved storage service already exists underneath them.</a:t>
             </a:r>
           </a:p>
           <a:p>
@@ -1326,7 +1340,7 @@
           <a:p>
             <a:r>
               <a:rPr lang="en-US" dirty="0"/>
-              <a:t>This is where the interface question belongs: what should a large distributed storage system expose to applications? GFS presents a familiar file interface, but it adapts the operations and guarantees to Google's large, sequential, data-intensive workloads. A useful interface hides placement, replication, failures, and recovery without promising behavior the implementation cannot provide efficiently.</a:t>
+              <a:t>GFS also brings together several themes that will recur throughout the course. Sharding gives parallel performance. At large scale, failures become routine, so the system replicates data. Replication then raises the consistency problem we have just examined, and stronger consistency requires more communication and waiting. GFS lets us see how a real system chose among those costs.</a:t>
             </a:r>
           </a:p>
           <a:p>
@@ -1335,16 +1349,7 @@
           <a:p>
             <a:r>
               <a:rPr lang="en-US" dirty="0"/>
-              <a:t>The paper also connects several themes from this course. Sharding gives parallel performance. Replication gives fault tolerance, but it creates consistency problems. The designers then choose where to spend coordination cost and where to accept weaker behavior.</a:t>
-            </a:r>
-          </a:p>
-          <a:p>
-            <a:endParaRPr lang="en-US" dirty="0"/>
-          </a:p>
-          <a:p>
-            <a:r>
-              <a:rPr lang="en-US" dirty="0"/>
-              <a:t>This is also a strong systems paper because it connects application workloads to machine-level details. The system succeeded in production, so we can judge the tradeoffs using real experience rather than only a conceptual design.</a:t>
+              <a:t>It is also a useful example of a systems paper. The argument runs from hardware constraints and failure rates all the way up to the behavior that applications see. More importantly, this was a production system used inside Google for years. We can evaluate the design using operating experience rather than treating it only as a conceptual proposal.</a:t>
             </a:r>
           </a:p>
           <a:p>
@@ -1354,10 +1359,9 @@
             <a:r>
               <a:rPr lang="en-US" dirty="0"/>
               <a:t>SOURCE
-MIT 6.824, Spring 2020, Lecture 3 video, 0:00-5:09.
+MIT 6.824, Spring 2020, Lecture 3 transcript/video, 00:00–05:09.
+Local transcript: fall2026/lectures/references/mit-6824-2020-lecture3-gfs-transcript.txt
 https://www.youtube.com/watch?v=EpIgvowZr00
-MIT 6.5840, GFS lecture notes.
-https://pdos.csail.mit.edu/6.824/notes/l-gfs.txt
 Ghemawat, Gobioff, and Leung, The Google File System, Sections 1, 2, and 6.
 https://pdos.csail.mit.edu/6.824/papers/gfs.pdf</a:t>
             </a:r>
@@ -1470,7 +1474,7 @@
           <a:p>
             <a:r>
               <a:rPr lang="en-US" dirty="0"/>
-              <a:t>Google needed one large shared storage system for crawled pages, search indexes, logs, MapReduce inputs, and later many other services.</a:t>
+              <a:t>Google had data sets far larger than one disk could hold: copies of the crawled web, intermediate files used to build the search index, and enormous server logs. Video became another example later. Storing these data sets required many disks, and processing them quickly with systems such as MapReduce required parallel access to those disks.</a:t>
             </a:r>
           </a:p>
           <a:p>
@@ -1479,7 +1483,7 @@
           <a:p>
             <a:r>
               <a:rPr lang="en-US" dirty="0"/>
-              <a:t>The first goal was scale. GFS automatically splits a file across many chunkservers, so a file can exceed the capacity of one disk and many clients can read different chunks in parallel. The second goal was automatic recovery. Losing one commodity machine should not require an operator to reconstruct every affected file by hand.</a:t>
+              <a:t>The first goal was therefore to make the file system big and fast. GFS automatically divides each file into chunks and spreads those chunks across many servers. One file can be larger than any single disk, and many clients can read different chunks in parallel to obtain high aggregate throughput.</a:t>
             </a:r>
           </a:p>
           <a:p>
@@ -1488,7 +1492,7 @@
           <a:p>
             <a:r>
               <a:rPr lang="en-US" dirty="0"/>
-              <a:t>The shared namespace also matters. One application can produce a data set and another application can consume it without building a separate storage system or copying everything into a new silo.</a:t>
+              <a:t>Google also wanted one shared file system for many internal applications. Here global means shared across one GFS deployment in a data center. A crawler can write a data set, and an indexing job can read the same files without either team building a separate storage system or copying the data into another silo.</a:t>
             </a:r>
           </a:p>
           <a:p>
@@ -1497,43 +1501,21 @@
           <a:p>
             <a:r>
               <a:rPr lang="en-US" dirty="0"/>
-              <a:t>SOURCE</a:t>
-            </a:r>
+              <a:t>Finally, recovery had to be automatic. Once a system uses hundreds of commodity machines, some machine or disk will fail routinely. GFS must detect the loss, keep the data available from another replica, and create replacement replicas without requiring an operator to repair each file by hand.</a:t>
+            </a:r>
+          </a:p>
+          <a:p>
+            <a:endParaRPr lang="en-US" dirty="0"/>
           </a:p>
           <a:p>
             <a:r>
               <a:rPr lang="en-US" dirty="0"/>
-              <a:t>MIT 6.824, Spring 2020, Lecture 3 video, 15:13-20:22.</a:t>
-            </a:r>
-          </a:p>
-          <a:p>
-            <a:r>
-              <a:rPr lang="en-US" dirty="0"/>
-              <a:t>https://www.youtube.com/watch?v=EpIgvowZr00</a:t>
-            </a:r>
-          </a:p>
-          <a:p>
-            <a:r>
-              <a:rPr lang="en-US" dirty="0"/>
-              <a:t>MIT 6.5840, GFS lecture notes.</a:t>
-            </a:r>
-          </a:p>
-          <a:p>
-            <a:r>
-              <a:rPr lang="en-US" dirty="0"/>
-              <a:t>https://pdos.csail.mit.edu/6.824/notes/l-gfs.txt</a:t>
-            </a:r>
-          </a:p>
-          <a:p>
-            <a:r>
-              <a:rPr lang="en-US" dirty="0"/>
-              <a:t>Ghemawat, Gobioff, and Leung, The Google File System, Sections 1, 2.1, and 2.3.</a:t>
-            </a:r>
-          </a:p>
-          <a:p>
-            <a:r>
-              <a:rPr lang="en-US" dirty="0"/>
-              <a:t>https://pdos.csail.mit.edu/6.824/papers/gfs.pdf</a:t>
+              <a:t>SOURCE
+MIT 6.824, Spring 2020, Lecture 3 transcript/video, 15:43–18:55.
+Local transcript: fall2026/lectures/references/mit-6824-2020-lecture3-gfs-transcript.txt
+https://www.youtube.com/watch?v=EpIgvowZr00
+Ghemawat, Gobioff, and Leung, The Google File System, Sections 1, 2.1, and 2.3.
+https://pdos.csail.mit.edu/6.824/papers/gfs.pdf</a:t>
             </a:r>
           </a:p>
         </p:txBody>
@@ -1643,63 +1625,9 @@
           <a:lstStyle/>
           <a:p>
             <a:r>
-              <a:t>LIVE DEMO, about 7 minutes.</a:t>
-            </a:r>
-            <a:endParaRPr lang="en-US"/>
-          </a:p>
-          <a:p>
-            <a:r>
-              <a:t>In a terminal: cd ~/work/BU/teaching/ec528/fall2026/lectures/demo/hdfs-gfs &amp;&amp; bash demo-hdfs.sh</a:t>
-            </a:r>
-            <a:endParaRPr lang="en-US"/>
-          </a:p>
-          <a:p>
-            <a:r>
-              <a:t>Seven steps; press Enter between them. Rehearsed 09/15: 51 seconds unattended with a clean teardown. Talking points for each step are in README.md in that folder, and fallback-hdfs-demo.txt has the expected output if the live run breaks.</a:t>
-            </a:r>
-            <a:endParaRPr lang="en-US"/>
-          </a:p>
-          <a:p>
-            <a:r>
-              <a:t>Say the vocabulary out loud as it appears: NameNode is the master, DataNode is a chunkserver, block is a chunk. Block size is 16 MB and replication is 2 here, against 64 MB and 3 in the paper, so that a 100 MB file splits into something readable on screen.</a:t>
-            </a:r>
-            <a:endParaRPr lang="en-US"/>
-          </a:p>
-          <a:p>
-            <a:r>
-              <a:t>Step 6 has a wait of roughly 30 seconds: after one DataNode is killed the replica count sits at 9 while the master waits out missed heartbeats, then jumps to 14. That pause is the point, not a hang - it is the same detection trade-off as the lease timeout later in the lecture. Talk through the goal slide while it runs.</a:t>
-            </a:r>
-            <a:endParaRPr lang="en-US"/>
-          </a:p>
-          <a:p>
-            <a:r>
-              <a:t>Key line to land: this is the shape of the paper - one master for names and locations, many chunkservers for the data, fixed-size chunks, replicas, and automatic re-replication after a failure. The rest of the lecture is how the paper makes that correct as well as fast.</a:t>
-            </a:r>
-            <a:endParaRPr lang="en-US"/>
-          </a:p>
-          <a:p>
-            <a:r>
-              <a:t>SOURCE</a:t>
-            </a:r>
-            <a:endParaRPr lang="en-US"/>
-          </a:p>
-          <a:p>
-            <a:r>
-              <a:t>Local demo: fall2026/lectures/demo/hdfs-gfs/README.md (Hadoop 3.5.0).</a:t>
-            </a:r>
-            <a:endParaRPr lang="en-US"/>
-          </a:p>
-          <a:p>
-            <a:r>
-              <a:t>Ghemawat, Gobioff, and Leung, The Google File System, Sections 2.1-2.5.</a:t>
-            </a:r>
-            <a:endParaRPr lang="en-US"/>
-          </a:p>
-          <a:p>
-            <a:r>
-              <a:t>https://pdos.csail.mit.edu/6.824/papers/gfs.pdf</a:t>
-            </a:r>
-            <a:endParaRPr lang="en-US"/>
+              <a:rPr lang="en-US" dirty="0"/>
+              <a:t>TERMINAL</a:t>
+            </a:r>
           </a:p>
         </p:txBody>
       </p:sp>
@@ -1808,111 +1736,50 @@
           <a:lstStyle/>
           <a:p>
             <a:r>
-              <a:t>CUES</a:t>
-            </a:r>
+              <a:rPr lang="en-US" dirty="0"/>
+              <a:t>Those goals come with clear boundaries. One GFS deployment lives inside a single data center. The paper does not try to keep replicas synchronized across distant sites with wide-area delays and network partitions.</a:t>
+            </a:r>
+          </a:p>
+          <a:p>
             <a:endParaRPr lang="en-US" dirty="0"/>
           </a:p>
           <a:p>
             <a:r>
-              <a:t>One data center</a:t>
-            </a:r>
+              <a:rPr lang="en-US" dirty="0"/>
+              <a:t>GFS is also an internal service for Google applications. Google controls both the storage system and most of the software that uses it, so application developers can understand the file system's guarantees and adapt their data formats when necessary.</a:t>
+            </a:r>
+          </a:p>
+          <a:p>
             <a:endParaRPr lang="en-US" dirty="0"/>
           </a:p>
           <a:p>
             <a:r>
-              <a:t>Internal Google applications</a:t>
-            </a:r>
+              <a:rPr lang="en-US" dirty="0"/>
+              <a:t>The expected workload is dominated by very large files. Reads are usually long sequential streams, with some small random reads. Writes are mainly large sequential appends, including cases where many clients append to the same file. Small writes at arbitrary offsets are supported, but the system does not optimize for them.</a:t>
+            </a:r>
+          </a:p>
+          <a:p>
             <a:endParaRPr lang="en-US" dirty="0"/>
           </a:p>
           <a:p>
             <a:r>
-              <a:t>Huge files and streaming access</a:t>
-            </a:r>
+              <a:rPr lang="en-US" dirty="0"/>
+              <a:t>That workload favors aggregate throughput over the latency of one small operation. A database holding tiny bank-account records needs fast random updates and strong transactional behavior. GFS was built for crawls, indexes, logs, and batch-processing pipelines. These assumptions explain why its later consistency choices can work for its applications.</a:t>
+            </a:r>
+          </a:p>
+          <a:p>
             <a:endParaRPr lang="en-US" dirty="0"/>
           </a:p>
           <a:p>
             <a:r>
-              <a:t>Append-heavy mutations</a:t>
-            </a:r>
-            <a:endParaRPr lang="en-US" dirty="0"/>
-          </a:p>
-          <a:p>
-            <a:r>
-              <a:t>Throughput over latency</a:t>
-            </a:r>
-            <a:endParaRPr lang="en-US" dirty="0"/>
-          </a:p>
-          <a:p>
-            <a:endParaRPr lang="en-US" dirty="0"/>
-          </a:p>
-          <a:p>
-            <a:r>
-              <a:t>GFS targets one data center, rather than replicas distributed around the world. Its clients are internal Google applications written by engineers who know the file system's behavior.</a:t>
-            </a:r>
-            <a:endParaRPr lang="en-US" dirty="0"/>
-          </a:p>
-          <a:p>
-            <a:endParaRPr lang="en-US" dirty="0"/>
-          </a:p>
-          <a:p>
-            <a:r>
-              <a:t>The paper's precise workload assumption is large streaming reads plus some small random reads. Writes are mainly large sequential appends. Small writes at arbitrary offsets remain possible, but GFS does not optimize for them.</a:t>
-            </a:r>
-            <a:endParaRPr lang="en-US" dirty="0"/>
-          </a:p>
-          <a:p>
-            <a:endParaRPr lang="en-US" dirty="0"/>
-          </a:p>
-          <a:p>
-            <a:r>
-              <a:t>This makes GFS a poor match for a low-latency transactional database with many tiny records. It is designed for bulk data processing where sustained bandwidth matters more than the latency of one operation.</a:t>
-            </a:r>
-            <a:endParaRPr lang="en-US" dirty="0"/>
-          </a:p>
-          <a:p>
-            <a:endParaRPr lang="en-US" dirty="0"/>
-          </a:p>
-          <a:p>
-            <a:r>
-              <a:t>SOURCE</a:t>
-            </a:r>
-            <a:endParaRPr lang="en-US" dirty="0"/>
-          </a:p>
-          <a:p>
-            <a:r>
-              <a:t>MIT 6.824, Spring 2020, Lecture 3 video, 15:13-20:22.</a:t>
-            </a:r>
-            <a:endParaRPr lang="en-US" dirty="0"/>
-          </a:p>
-          <a:p>
-            <a:r>
-              <a:t>https://www.youtube.com/watch?v=EpIgvowZr00</a:t>
-            </a:r>
-            <a:endParaRPr lang="en-US" dirty="0"/>
-          </a:p>
-          <a:p>
-            <a:r>
-              <a:t>MIT 6.5840, GFS lecture notes.</a:t>
-            </a:r>
-            <a:endParaRPr lang="en-US" dirty="0"/>
-          </a:p>
-          <a:p>
-            <a:r>
-              <a:t>https://pdos.csail.mit.edu/6.824/notes/l-gfs.txt</a:t>
-            </a:r>
-            <a:endParaRPr lang="en-US" dirty="0"/>
-          </a:p>
-          <a:p>
-            <a:r>
-              <a:t>Ghemawat, Gobioff, and Leung, The Google File System, Sections 1 and 2.1.</a:t>
-            </a:r>
-            <a:endParaRPr lang="en-US" dirty="0"/>
-          </a:p>
-          <a:p>
-            <a:r>
-              <a:t>https://pdos.csail.mit.edu/6.824/papers/gfs.pdf</a:t>
-            </a:r>
-            <a:endParaRPr lang="en-US" dirty="0"/>
+              <a:rPr lang="en-US" dirty="0"/>
+              <a:t>SOURCE
+MIT 6.824, Spring 2020, Lecture 3 transcript/video, 18:07–20:39.
+Local transcript: fall2026/lectures/references/mit-6824-2020-lecture3-gfs-transcript.txt
+https://www.youtube.com/watch?v=EpIgvowZr00
+Ghemawat, Gobioff, and Leung, The Google File System, Sections 1 and 2.1.
+https://pdos.csail.mit.edu/6.824/papers/gfs.pdf</a:t>
+            </a:r>
           </a:p>
         </p:txBody>
       </p:sp>
@@ -2021,72 +1888,59 @@
           <a:lstStyle/>
           <a:p>
             <a:r>
-              <a:t>The paper's contribution is the complete design and the evidence that its tradeoffs worked at unprecedented production scale.</a:t>
-            </a:r>
+              <a:rPr lang="en-US" dirty="0"/>
+              <a:t>SOSP papers are expected to contribute new systems knowledge. The individual ingredients in GFS, including distribution, sharding, replication, and fault tolerance, were already familiar in 2003. The paper's contribution lies in the complete design and the evidence that its choices worked in a deployed system at a scale far beyond typical academic prototypes.</a:t>
+            </a:r>
+          </a:p>
+          <a:p>
             <a:endParaRPr lang="en-US" dirty="0"/>
           </a:p>
           <a:p>
+            <a:r>
+              <a:rPr lang="en-US" dirty="0"/>
+              <a:t>Production experience is part of that contribution. Google needed a system that kept working under real failures, supported real applications, and remained economical on commodity machines. The paper reports the choices that survived those constraints rather than presenting only an idealized design.</a:t>
+            </a:r>
+          </a:p>
+          <a:p>
             <a:endParaRPr lang="en-US" dirty="0"/>
           </a:p>
           <a:p>
             <a:r>
-              <a:t>Sharding, replication, and fault tolerance already existed. GFS combines them for clusters with hundreds of chunkservers and for applications that process multi-gigabyte files. The paper reports operational experience, not only a prototype.</a:t>
-            </a:r>
+              <a:rPr lang="en-US" dirty="0"/>
+              <a:t>Two choices were especially provocative. The first was relaxed consistency. At the time, the academic instinct was often to make distributed storage behave as closely as possible to one correct server. GFS accepts some anomalous results when doing so avoids expensive coordination. That can be acceptable for a search index, where one missing result may go unnoticed. It is unacceptable for ad billing, where every recorded impression affects money.</a:t>
+            </a:r>
+          </a:p>
+          <a:p>
             <a:endParaRPr lang="en-US" dirty="0"/>
           </a:p>
           <a:p>
+            <a:r>
+              <a:rPr lang="en-US" dirty="0"/>
+              <a:t>Applications can also defend themselves against the anomalies GFS permits. The paper recommends checksums so readers can detect corrupted data and explicit record boundaries so they can recognize incomplete records and skip them.</a:t>
+            </a:r>
+          </a:p>
+          <a:p>
             <a:endParaRPr lang="en-US" dirty="0"/>
           </a:p>
           <a:p>
             <a:r>
-              <a:t>Two choices were especially provocative. GFS uses one master for metadata and accepts a relaxed consistency model. Both choices simplify the design. They work because the master stays out of the data path and because Google controls the applications that consume the data.</a:t>
-            </a:r>
+              <a:rPr lang="en-US" dirty="0"/>
+              <a:t>The second provocative choice was one master for metadata. A more conventional academic design might replicate or partition the master logic. GFS keeps the design simpler and keeps file data off the master's path. The production evidence showed that this choice worked for the original workload. The contribution is the particular set of tradeoffs, together with evidence about where they succeeded.</a:t>
+            </a:r>
+          </a:p>
+          <a:p>
             <a:endParaRPr lang="en-US" dirty="0"/>
           </a:p>
           <a:p>
-            <a:endParaRPr lang="en-US" dirty="0"/>
-          </a:p>
-          <a:p>
-            <a:r>
-              <a:t>SOURCE</a:t>
-            </a:r>
-            <a:endParaRPr lang="en-US" dirty="0"/>
-          </a:p>
-          <a:p>
-            <a:r>
-              <a:t>MIT 6.824, Spring 2020, Lecture 3 video, 20:22-25:23.</a:t>
-            </a:r>
-            <a:endParaRPr lang="en-US" dirty="0"/>
-          </a:p>
-          <a:p>
-            <a:r>
-              <a:t>https://www.youtube.com/watch?v=EpIgvowZr00</a:t>
-            </a:r>
-            <a:endParaRPr lang="en-US" dirty="0"/>
-          </a:p>
-          <a:p>
-            <a:r>
-              <a:t>MIT 6.5840, GFS lecture notes.</a:t>
-            </a:r>
-            <a:endParaRPr lang="en-US" dirty="0"/>
-          </a:p>
-          <a:p>
-            <a:r>
-              <a:t>https://pdos.csail.mit.edu/6.824/notes/l-gfs.txt</a:t>
-            </a:r>
-            <a:endParaRPr lang="en-US" dirty="0"/>
-          </a:p>
-          <a:p>
-            <a:r>
-              <a:t>Ghemawat, Gobioff, and Leung, The Google File System, Sections 1, 2.4, 2.7, and 6.</a:t>
-            </a:r>
-            <a:endParaRPr lang="en-US" dirty="0"/>
-          </a:p>
-          <a:p>
-            <a:r>
-              <a:t>https://pdos.csail.mit.edu/6.824/papers/gfs.pdf</a:t>
-            </a:r>
-            <a:endParaRPr lang="en-US" dirty="0"/>
+            <a:r>
+              <a:rPr lang="en-US" dirty="0"/>
+              <a:t>SOURCE
+MIT 6.824, Spring 2020, Lecture 3 transcript/video, 20:39–23:05.
+Local transcript: fall2026/lectures/references/mit-6824-2020-lecture3-gfs-transcript.txt
+https://www.youtube.com/watch?v=EpIgvowZr00
+Ghemawat, Gobioff, and Leung, The Google File System, Sections 1, 2.4, 2.7, and 6.
+https://pdos.csail.mit.edu/6.824/papers/gfs.pdf</a:t>
+            </a:r>
           </a:p>
         </p:txBody>
       </p:sp>
@@ -3691,6 +3545,12 @@
         <p:txBody>
           <a:bodyPr/>
           <a:lstStyle/>
+          <a:p>
+            <a:r>
+              <a:rPr lang="en-US" dirty="0"/>
+              <a:t>ASK THE CLASS HERE: what interface should a large distributed storage system expose to applications? GFS presents a familiar file interface - open, read, write - plus a record append that has no counterpart in an ordinary file system. The operations and their guarantees are adapted to Google's large, sequential workloads. A good interface hides placement, replication, failure and recovery, without promising behaviour the implementation cannot deliver cheaply. Record Append, a few slides later, is the concrete answer.</a:t>
+            </a:r>
+          </a:p>
           <a:p>
             <a:r>
               <a:t>With the architecture in place, we can trace the two basic operations.</a:t>
@@ -16006,25 +15866,7 @@
           <a:p>
             <a:r>
               <a:rPr lang="en-US" sz="3200" b="1" dirty="0"/>
-              <a:t>Distributed storage is a key abstraction</a:t>
-            </a:r>
-          </a:p>
-          <a:p>
-            <a:r>
-              <a:rPr lang="en-US" sz="2800" b="1" dirty="0">
-                <a:solidFill>
-                  <a:srgbClr val="A02B93"/>
-                </a:solidFill>
-              </a:rPr>
-              <a:t>What interface should GFS expose to applications?</a:t>
-            </a:r>
-          </a:p>
-          <a:p>
-            <a:r>
-              <a:rPr lang="en-US" sz="3200" b="1" dirty="0">
-                <a:effectLst/>
-              </a:rPr>
-              <a:t>GFS paper touches on many themes of this course</a:t>
+              <a:t>GFS touches many themes of this course</a:t>
             </a:r>
           </a:p>
           <a:p>
@@ -16033,62 +15875,27 @@
               <a:buChar char="•"/>
             </a:pPr>
             <a:r>
-              <a:rPr lang="en-US" sz="2800" dirty="0">
-                <a:effectLst/>
-              </a:rPr>
-              <a:t>parallel performance, fault tolerance, replication,</a:t>
-            </a:r>
-          </a:p>
-          <a:p>
-            <a:endParaRPr lang="en-US" sz="2800" dirty="0"/>
-          </a:p>
-          <a:p>
-            <a:r>
-              <a:rPr lang="en-US" sz="2800" b="1" dirty="0">
-                <a:effectLst/>
-              </a:rPr>
-              <a:t> </a:t>
-            </a:r>
+              <a:rPr lang="en-US" sz="2800" dirty="0"/>
+              <a:t>parallel performance, fault tolerance, replication, consistency</a:t>
+            </a:r>
+          </a:p>
+          <a:p>
+            <a:endParaRPr lang="en-US" sz="1600" b="1" dirty="0"/>
+          </a:p>
+          <a:p>
             <a:r>
               <a:rPr lang="en-US" sz="3200" b="1" dirty="0"/>
-              <a:t>C</a:t>
-            </a:r>
-            <a:r>
-              <a:rPr lang="en-US" sz="3200" b="1" dirty="0">
-                <a:effectLst/>
-              </a:rPr>
-              <a:t>onsistency</a:t>
-            </a:r>
-          </a:p>
-          <a:p>
-            <a:pPr marL="742950" lvl="1" indent="-285750">
-              <a:buFont typeface="Arial" panose="020B0604020202020204" pitchFamily="34" charset="0"/>
-              <a:buChar char="•"/>
-            </a:pPr>
-            <a:r>
-              <a:rPr lang="en-US" sz="2800" dirty="0">
-                <a:effectLst/>
-              </a:rPr>
-              <a:t>good systems paper -- details from apps all the way to network</a:t>
-            </a:r>
-          </a:p>
-          <a:p>
-            <a:endParaRPr lang="en-US" sz="2800" dirty="0">
-              <a:effectLst/>
-            </a:endParaRPr>
-          </a:p>
-          <a:p>
-            <a:r>
-              <a:rPr lang="en-US" sz="3200" b="1" dirty="0">
-                <a:effectLst/>
-              </a:rPr>
-              <a:t>successful real-world design</a:t>
-            </a:r>
-          </a:p>
-          <a:p>
-            <a:endParaRPr lang="en-US" sz="2800" dirty="0">
-              <a:effectLst/>
-            </a:endParaRPr>
+              <a:t>A good systems paper: applications down to the network</a:t>
+            </a:r>
+          </a:p>
+          <a:p>
+            <a:endParaRPr lang="en-US" sz="1600" b="1" dirty="0"/>
+          </a:p>
+          <a:p>
+            <a:r>
+              <a:rPr lang="en-US" sz="3200" b="1" dirty="0"/>
+              <a:t>A successful real-world design, judged on production experience</a:t>
+            </a:r>
           </a:p>
         </p:txBody>
       </p:sp>
@@ -17356,38 +17163,58 @@
           <a:p>
             <a:r>
               <a:rPr lang="en-US" sz="3200" b="1" dirty="0"/>
-              <a:t>Not the basic ideas of distribution, sharding, fault-tolerance. </a:t>
-            </a:r>
-          </a:p>
-          <a:p>
-            <a:endParaRPr lang="en-US" sz="3200" b="1" dirty="0"/>
+              <a:t>Not the basic ideas of distribution, sharding, fault-tolerance.</a:t>
+            </a:r>
+          </a:p>
+          <a:p>
+            <a:endParaRPr lang="en-US" sz="1600" b="1" dirty="0"/>
           </a:p>
           <a:p>
             <a:r>
               <a:rPr lang="en-US" sz="3200" b="1" dirty="0"/>
-              <a:t>Huge scale. </a:t>
-            </a:r>
-          </a:p>
-          <a:p>
-            <a:endParaRPr lang="en-US" sz="3200" b="1" dirty="0"/>
+              <a:t>Huge scale.</a:t>
+            </a:r>
+          </a:p>
+          <a:p>
+            <a:endParaRPr lang="en-US" sz="1600" b="1" dirty="0"/>
           </a:p>
           <a:p>
             <a:r>
               <a:rPr lang="en-US" sz="3200" b="1" dirty="0"/>
-              <a:t>Used in industry, real-world experience. </a:t>
-            </a:r>
-          </a:p>
-          <a:p>
-            <a:endParaRPr lang="en-US" sz="3200" b="1" dirty="0"/>
+              <a:t>Used in industry, real-world experience.</a:t>
+            </a:r>
+          </a:p>
+          <a:p>
+            <a:endParaRPr lang="en-US" sz="1600" b="1" dirty="0"/>
           </a:p>
           <a:p>
             <a:r>
               <a:rPr lang="en-US" sz="3200" b="1" dirty="0"/>
-              <a:t>Successful use of weak consistency. </a:t>
-            </a:r>
-          </a:p>
-          <a:p>
-            <a:endParaRPr lang="en-US" sz="3200" b="1" dirty="0"/>
+              <a:t>Successful use of weak consistency.</a:t>
+            </a:r>
+          </a:p>
+          <a:p>
+            <a:pPr marL="742950" lvl="1" indent="-285750">
+              <a:buFont typeface="Arial" panose="020B0604020202020204" pitchFamily="34" charset="0"/>
+              <a:buChar char="•"/>
+            </a:pPr>
+            <a:r>
+              <a:rPr lang="en-US" sz="2800" dirty="0"/>
+              <a:t>A missing search result goes unnoticed; ad billing does not</a:t>
+            </a:r>
+          </a:p>
+          <a:p>
+            <a:pPr marL="742950" lvl="1" indent="-285750">
+              <a:buFont typeface="Arial" panose="020B0604020202020204" pitchFamily="34" charset="0"/>
+              <a:buChar char="•"/>
+            </a:pPr>
+            <a:r>
+              <a:rPr lang="en-US" sz="2800" dirty="0"/>
+              <a:t>Applications compensate: checksums and explicit record boundaries</a:t>
+            </a:r>
+          </a:p>
+          <a:p>
+            <a:endParaRPr lang="en-US" sz="1600" b="1" dirty="0"/>
           </a:p>
           <a:p>
             <a:r>

</xml_diff>

<commit_message>
Expand GFS read and write scripts
</commit_message>
<xml_diff>
--- a/slides/fall26/4-gfs.pptx
+++ b/slides/fall26/4-gfs.pptx
@@ -26,7 +26,6 @@
     <p:sldId id="262" r:id="rId17"/>
     <p:sldId id="430" r:id="rId18"/>
     <p:sldId id="435" r:id="rId19"/>
-    <p:sldId id="480" r:id="rId20"/>
     <p:sldId id="431" r:id="rId21"/>
     <p:sldId id="433" r:id="rId22"/>
     <p:sldId id="434" r:id="rId23"/>
@@ -34,6 +33,7 @@
     <p:sldId id="437" r:id="rId25"/>
     <p:sldId id="468" r:id="rId26"/>
     <p:sldId id="439" r:id="rId27"/>
+    <p:sldId id="480" r:id="rId20"/>
     <p:sldId id="469" r:id="rId28"/>
     <p:sldId id="440" r:id="rId29"/>
     <p:sldId id="441" r:id="rId30"/>
@@ -3368,7 +3368,7 @@
           <a:p>
             <a:r>
               <a:rPr lang="en-US" dirty="0"/>
-              <a:t>We now know the roles, the metadata, and what survives a reboot. We can use them to trace the read and write paths.</a:t>
+              <a:t>The HDFS demo now makes these roles concrete at a smaller scale: the NameNode holds metadata, the DataNodes hold the block files, and losing one DataNode causes the system to rebuild the missing replicas automatically.</a:t>
             </a:r>
           </a:p>
           <a:p>
@@ -3652,23 +3652,49 @@
           <a:p>
             <a:r>
               <a:rPr lang="en-US" dirty="0"/>
-              <a:t>ASK THE CLASS HERE: what interface should a large distributed storage system expose to applications? GFS presents a familiar file interface - open, read, write - plus a record append that has no counterpart in an ordinary file system. The operations and their guarantees are adapted to Google's large, sequential workloads. A good interface hides placement, replication, failure and recovery, without promising behaviour the implementation cannot deliver cheaply. Record Append, a few slides later, is the concrete answer.</a:t>
-            </a:r>
-          </a:p>
-          <a:p>
-            <a:r>
-              <a:t>With the architecture in place, we can trace the two basic operations.</a:t>
-            </a:r>
+              <a:t>The demo gave us the static picture: one service holds the metadata, many servers hold the data, and the system repairs lost replicas. Now we can follow what happens when an application actually accesses a file.</a:t>
+            </a:r>
+          </a:p>
+          <a:p>
             <a:endParaRPr lang="en-US" dirty="0"/>
           </a:p>
           <a:p>
+            <a:r>
+              <a:rPr lang="en-US" dirty="0"/>
+              <a:t>We will begin with a read because it uses the architecture in its simplest form. The client needs the master to translate a file name and a position into a chunk handle and replica locations. Once it has that metadata, it reads the bytes directly from a chunkserver.</a:t>
+            </a:r>
+          </a:p>
+          <a:p>
             <a:endParaRPr lang="en-US" dirty="0"/>
           </a:p>
           <a:p>
             <a:r>
-              <a:t>Reads are relatively simple because a client can fetch data from one up-to-date replica. Writes are harder because all replicas must apply mutations in the same order. We will use the read path first to see why the master stays out of the data path, then use the write path to introduce primary and secondary replication.</a:t>
-            </a:r>
+              <a:rPr lang="en-US" dirty="0"/>
+              <a:t>A write uses the same separation between metadata and data, but it introduces an additional problem. Every replica must apply mutations in one common order. Otherwise we recreate the divergent replicas from the beginning of the lecture.</a:t>
+            </a:r>
+          </a:p>
+          <a:p>
             <a:endParaRPr lang="en-US" dirty="0"/>
+          </a:p>
+          <a:p>
+            <a:r>
+              <a:rPr lang="en-US" dirty="0"/>
+              <a:t>So the read path will show why one master can remain lightly loaded. The write path will show how GFS adds a primary, secondaries, leases, and version numbers to coordinate replicated data.</a:t>
+            </a:r>
+          </a:p>
+          <a:p>
+            <a:endParaRPr lang="en-US" dirty="0"/>
+          </a:p>
+          <a:p>
+            <a:r>
+              <a:rPr lang="en-US" dirty="0"/>
+              <a:t>SOURCE
+MIT 6.824, Spring 2020, Lecture 3 transcript/video, 31:21–32:12 and 39:17–40:51.
+Local transcript: fall2026/lectures/references/mit-6824-2020-lecture3-gfs-transcript.txt
+https://www.youtube.com/watch?v=EpIgvowZr00
+Ghemawat, Gobioff, and Leung, The Google File System, Sections 2.4 and 3.1.
+https://pdos.csail.mit.edu/6.824/papers/gfs.pdf</a:t>
+            </a:r>
           </a:p>
         </p:txBody>
       </p:sp>
@@ -3777,105 +3803,59 @@
           <a:lstStyle/>
           <a:p>
             <a:r>
-              <a:t>CUES</a:t>
-            </a:r>
+              <a:rPr lang="en-US" dirty="0"/>
+              <a:t>Suppose the application wants to read a range of bytes from a named file. The GFS client library first uses the fixed 64-megabyte chunk size to determine which chunk contains the starting offset.</a:t>
+            </a:r>
+          </a:p>
+          <a:p>
             <a:endParaRPr lang="en-US" dirty="0"/>
           </a:p>
           <a:p>
             <a:r>
-              <a:t>Translate file offset to chunk index</a:t>
-            </a:r>
+              <a:rPr lang="en-US" dirty="0"/>
+              <a:t>If the client has not cached the answer, it sends the file name and chunk index to the master. The master uses its file-to-chunk table to find the chunk handle, then uses the chunk metadata to find the chunkservers holding replicas. It returns the handle and the replica locations to the client.</a:t>
+            </a:r>
+          </a:p>
+          <a:p>
             <a:endParaRPr lang="en-US" dirty="0"/>
           </a:p>
           <a:p>
             <a:r>
-              <a:t>Ask master for handle and replica locations</a:t>
-            </a:r>
+              <a:rPr lang="en-US" dirty="0"/>
+              <a:t>The client caches that mapping. This matters because an application may read a large file in many smaller operations. As long as those reads remain in the same chunk and the cached information is valid, the client does not need to ask the master again.</a:t>
+            </a:r>
+          </a:p>
+          <a:p>
             <a:endParaRPr lang="en-US" dirty="0"/>
           </a:p>
           <a:p>
             <a:r>
-              <a:t>Cache metadata</a:t>
-            </a:r>
+              <a:rPr lang="en-US" dirty="0"/>
+              <a:t>The client chooses one replica, normally a chunkserver that appears close in the network, and sends that server the chunk handle and the byte range within the chunk. The chunkserver opens the corresponding Linux file, reads the requested bytes, and returns them directly to the client.</a:t>
+            </a:r>
+          </a:p>
+          <a:p>
             <a:endParaRPr lang="en-US" dirty="0"/>
           </a:p>
           <a:p>
             <a:r>
-              <a:t>Read from a nearby chunkserver</a:t>
-            </a:r>
+              <a:rPr lang="en-US" dirty="0"/>
+              <a:t>If a request crosses a chunk boundary, the client library divides it into separate chunk requests and combines the returned bytes for the application. The application continues to think in terms of a file name and file offsets. The library and master translate that view into chunk operations.</a:t>
+            </a:r>
+          </a:p>
+          <a:p>
             <a:endParaRPr lang="en-US" dirty="0"/>
           </a:p>
           <a:p>
-            <a:endParaRPr lang="en-US" dirty="0"/>
-          </a:p>
-          <a:p>
-            <a:r>
-              <a:t>Suppose a client wants bytes at a particular offset. The GFS client library computes the chunk index from the fixed chunk size and sends the file name and chunk index to the master, unless it already cached the answer.</a:t>
-            </a:r>
-            <a:endParaRPr lang="en-US" dirty="0"/>
-          </a:p>
-          <a:p>
-            <a:endParaRPr lang="en-US" dirty="0"/>
-          </a:p>
-          <a:p>
-            <a:r>
-              <a:t>The master looks up the chunk handle and returns the locations of the replicas. The client caches that metadata and chooses a nearby chunkserver, often one in the same rack.</a:t>
-            </a:r>
-            <a:endParaRPr lang="en-US" dirty="0"/>
-          </a:p>
-          <a:p>
-            <a:endParaRPr lang="en-US" dirty="0"/>
-          </a:p>
-          <a:p>
-            <a:r>
-              <a:t>The client then sends the chunk handle and byte range directly to that chunkserver. The chunkserver reads the corresponding Linux file and returns the data. Repeated reads from the same chunk do not contact the master again until the cached metadata expires.</a:t>
-            </a:r>
-            <a:endParaRPr lang="en-US" dirty="0"/>
-          </a:p>
-          <a:p>
-            <a:endParaRPr lang="en-US" dirty="0"/>
-          </a:p>
-          <a:p>
-            <a:r>
-              <a:t>SOURCE</a:t>
-            </a:r>
-            <a:endParaRPr lang="en-US" dirty="0"/>
-          </a:p>
-          <a:p>
-            <a:r>
-              <a:t>MIT 6.824, Spring 2020, Lecture 3 video, 30:24-35:30.</a:t>
-            </a:r>
-            <a:endParaRPr lang="en-US" dirty="0"/>
-          </a:p>
-          <a:p>
-            <a:r>
-              <a:t>https://www.youtube.com/watch?v=EpIgvowZr00</a:t>
-            </a:r>
-            <a:endParaRPr lang="en-US" dirty="0"/>
-          </a:p>
-          <a:p>
-            <a:r>
-              <a:t>MIT 6.5840, GFS lecture notes.</a:t>
-            </a:r>
-            <a:endParaRPr lang="en-US" dirty="0"/>
-          </a:p>
-          <a:p>
-            <a:r>
-              <a:t>https://pdos.csail.mit.edu/6.824/notes/l-gfs.txt</a:t>
-            </a:r>
-            <a:endParaRPr lang="en-US" dirty="0"/>
-          </a:p>
-          <a:p>
-            <a:r>
-              <a:t>Ghemawat, Gobioff, and Leung, The Google File System, Section 2.4.</a:t>
-            </a:r>
-            <a:endParaRPr lang="en-US" dirty="0"/>
-          </a:p>
-          <a:p>
-            <a:r>
-              <a:t>https://pdos.csail.mit.edu/6.824/papers/gfs.pdf</a:t>
-            </a:r>
-            <a:endParaRPr lang="en-US" dirty="0"/>
+            <a:r>
+              <a:rPr lang="en-US" dirty="0"/>
+              <a:t>SOURCE
+MIT 6.824, Spring 2020, Lecture 3 transcript/video, 31:21–39:17.
+Local transcript: fall2026/lectures/references/mit-6824-2020-lecture3-gfs-transcript.txt
+https://www.youtube.com/watch?v=EpIgvowZr00
+Ghemawat, Gobioff, and Leung, The Google File System, Section 2.4.
+https://pdos.csail.mit.edu/6.824/papers/gfs.pdf</a:t>
+            </a:r>
           </a:p>
         </p:txBody>
       </p:sp>
@@ -4113,72 +4093,50 @@
           <a:lstStyle/>
           <a:p>
             <a:r>
-              <a:t>The main architectural point is that the master performs naming and placement, while chunkservers perform data transfer.</a:t>
-            </a:r>
+              <a:rPr lang="en-US" dirty="0"/>
+              <a:t>The read path explains how GFS can use one master without sending all traffic through one machine. The master answers the naming question: which chunk represents this part of the file, and which servers hold it? The chunkserver answers the data question by returning the bytes.</a:t>
+            </a:r>
+          </a:p>
+          <a:p>
             <a:endParaRPr lang="en-US" dirty="0"/>
           </a:p>
           <a:p>
+            <a:r>
+              <a:rPr lang="en-US" dirty="0"/>
+              <a:t>The client caches the master's answer, so a long sequential scan needs far fewer master requests than data requests. The master handles small metadata messages, while many clients read different chunks from many chunkservers in parallel.</a:t>
+            </a:r>
+          </a:p>
+          <a:p>
             <a:endParaRPr lang="en-US" dirty="0"/>
           </a:p>
           <a:p>
             <a:r>
-              <a:t>Clients cache the mapping from a file and chunk index to the chunk handle and replica locations. That reduces repeated load on the master. The master can therefore serve many clients even though it is centralized.</a:t>
-            </a:r>
+              <a:rPr lang="en-US" dirty="0"/>
+              <a:t>Reading needs only one suitable replica. Writing is harder because the replicas are no longer interchangeable if they apply concurrent mutations in different orders. The client already knows which chunkservers hold the replicas, but it cannot let each server choose its own order.</a:t>
+            </a:r>
+          </a:p>
+          <a:p>
             <a:endParaRPr lang="en-US" dirty="0"/>
           </a:p>
           <a:p>
+            <a:r>
+              <a:rPr lang="en-US" dirty="0"/>
+              <a:t>This brings us back to the failure from the first part of the lecture. Two servers received the same writes in opposite orders and ended with different values. GFS prevents that by giving one replica the authority to order mutations for the chunk.</a:t>
+            </a:r>
+          </a:p>
+          <a:p>
             <a:endParaRPr lang="en-US" dirty="0"/>
           </a:p>
           <a:p>
             <a:r>
-              <a:t>For a read, one replica is enough. For a write, the client knows all replicas that need the mutation, but we still need a protocol that keeps their update order consistent. That is the next problem.</a:t>
-            </a:r>
-            <a:endParaRPr lang="en-US" dirty="0"/>
-          </a:p>
-          <a:p>
-            <a:endParaRPr lang="en-US" dirty="0"/>
-          </a:p>
-          <a:p>
-            <a:r>
-              <a:t>SOURCE</a:t>
-            </a:r>
-            <a:endParaRPr lang="en-US" dirty="0"/>
-          </a:p>
-          <a:p>
-            <a:r>
-              <a:t>MIT 6.824, Spring 2020, Lecture 3 video, 30:24-40:32.</a:t>
-            </a:r>
-            <a:endParaRPr lang="en-US" dirty="0"/>
-          </a:p>
-          <a:p>
-            <a:r>
-              <a:t>https://www.youtube.com/watch?v=EpIgvowZr00</a:t>
-            </a:r>
-            <a:endParaRPr lang="en-US" dirty="0"/>
-          </a:p>
-          <a:p>
-            <a:r>
-              <a:t>MIT 6.5840, GFS lecture notes.</a:t>
-            </a:r>
-            <a:endParaRPr lang="en-US" dirty="0"/>
-          </a:p>
-          <a:p>
-            <a:r>
-              <a:t>https://pdos.csail.mit.edu/6.824/notes/l-gfs.txt</a:t>
-            </a:r>
-            <a:endParaRPr lang="en-US" dirty="0"/>
-          </a:p>
-          <a:p>
-            <a:r>
-              <a:t>Ghemawat, Gobioff, and Leung, The Google File System, Sections 2.4 and 3.1.</a:t>
-            </a:r>
-            <a:endParaRPr lang="en-US" dirty="0"/>
-          </a:p>
-          <a:p>
-            <a:r>
-              <a:t>https://pdos.csail.mit.edu/6.824/papers/gfs.pdf</a:t>
-            </a:r>
-            <a:endParaRPr lang="en-US" dirty="0"/>
+              <a:rPr lang="en-US" dirty="0"/>
+              <a:t>SOURCE
+MIT 6.824, Spring 2020, Lecture 3 transcript/video, 33:11–40:51.
+Local transcript: fall2026/lectures/references/mit-6824-2020-lecture3-gfs-transcript.txt
+https://www.youtube.com/watch?v=EpIgvowZr00
+Ghemawat, Gobioff, and Leung, The Google File System, Sections 2.4 and 3.1.
+https://pdos.csail.mit.edu/6.824/papers/gfs.pdf</a:t>
+            </a:r>
           </a:p>
         </p:txBody>
       </p:sp>
@@ -4288,31 +4246,43 @@
           <a:p>
             <a:r>
               <a:rPr lang="en-US" dirty="0"/>
-              <a:t>CUES</a:t>
-            </a:r>
+              <a:t>For every chunk being modified, the master designates one up-to-date replica as the primary. The other up-to-date replicas are secondaries. The primary receives the write command and chooses one serial order for all concurrent mutations to that chunk.</a:t>
+            </a:r>
+          </a:p>
+          <a:p>
+            <a:endParaRPr lang="en-US" dirty="0"/>
           </a:p>
           <a:p>
             <a:r>
               <a:rPr lang="en-US" dirty="0"/>
-              <a:t>One primary per chunk</a:t>
-            </a:r>
+              <a:t>The primary then tells the secondaries to apply the mutations in that same order. The network may deliver requests to different servers at different times, but the replicas no longer use arrival order to decide what happens. They follow the order selected by the primary.</a:t>
+            </a:r>
+          </a:p>
+          <a:p>
+            <a:endParaRPr lang="en-US" dirty="0"/>
           </a:p>
           <a:p>
             <a:r>
               <a:rPr lang="en-US" dirty="0"/>
-              <a:t>Primary chooses the mutation order</a:t>
-            </a:r>
+              <a:t>This is the rule missing from the broken replication design earlier in the lecture. There, two servers independently chose different legal orders. Here, one primary chooses the order once, and every secondary follows it.</a:t>
+            </a:r>
+          </a:p>
+          <a:p>
+            <a:endParaRPr lang="en-US" dirty="0"/>
           </a:p>
           <a:p>
             <a:r>
               <a:rPr lang="en-US" dirty="0"/>
-              <a:t>Secondaries follow that order</a:t>
-            </a:r>
+              <a:t>The authority to act as primary comes from a lease granted by the master. The lease has an expiration time, so an old primary eventually loses the right to process mutations even if a network failure prevents the master from contacting it. We will return to the version and lease details after tracing one write.</a:t>
+            </a:r>
+          </a:p>
+          <a:p>
+            <a:endParaRPr lang="en-US" dirty="0"/>
           </a:p>
           <a:p>
             <a:r>
               <a:rPr lang="en-US" dirty="0"/>
-              <a:t>Reads may use any replica under GFS's consistency model</a:t>
+              <a:t>One wording detail on the slide matters: the client sends the write command to the primary. The file bytes take a separate path to all replicas, which we will see in the next steps.</a:t>
             </a:r>
           </a:p>
           <a:p>
@@ -4321,77 +4291,13 @@
           <a:p>
             <a:r>
               <a:rPr lang="en-US" dirty="0"/>
-              <a:t>GFS designates one replica as the primary for each actively mutated chunk. The other replicas act as secondaries.</a:t>
-            </a:r>
-          </a:p>
-          <a:p>
-            <a:endParaRPr lang="en-US" dirty="0"/>
-          </a:p>
-          <a:p>
-            <a:r>
-              <a:rPr lang="en-US" dirty="0"/>
-              <a:t>The primary receives concurrent write requests and assigns one serial order. It applies the mutations in that order and sends the same order to every secondary. The secondaries may receive data earlier, but they do not decide the operation order themselves.</a:t>
-            </a:r>
-          </a:p>
-          <a:p>
-            <a:endParaRPr lang="en-US" dirty="0"/>
-          </a:p>
-          <a:p>
-            <a:r>
-              <a:rPr lang="en-US" dirty="0"/>
-              <a:t>The master grants primary status through a lease and records a new chunk version when it establishes a new replica group. Version numbers let the master recognize stale replicas that missed an earlier period of updates.</a:t>
-            </a:r>
-          </a:p>
-          <a:p>
-            <a:endParaRPr lang="en-US" dirty="0"/>
-          </a:p>
-          <a:p>
-            <a:r>
-              <a:rPr lang="en-US" dirty="0"/>
-              <a:t>SOURCE</a:t>
-            </a:r>
-          </a:p>
-          <a:p>
-            <a:r>
-              <a:rPr lang="en-US" dirty="0"/>
-              <a:t>MIT 6.824, Spring 2020, Lecture 3 video, 40:32-50:35.</a:t>
-            </a:r>
-          </a:p>
-          <a:p>
-            <a:r>
-              <a:rPr lang="en-US" dirty="0"/>
-              <a:t>https://www.youtube.com/watch?v=EpIgvowZr00</a:t>
-            </a:r>
-          </a:p>
-          <a:p>
-            <a:r>
-              <a:rPr lang="en-US" dirty="0"/>
-              <a:t>MIT 6.5840, GFS lecture notes.</a:t>
-            </a:r>
-          </a:p>
-          <a:p>
-            <a:r>
-              <a:rPr lang="en-US" dirty="0"/>
-              <a:t>https://pdos.csail.mit.edu/6.824/notes/l-gfs.txt</a:t>
-            </a:r>
-          </a:p>
-          <a:p>
-            <a:r>
-              <a:rPr lang="en-US" dirty="0"/>
-              <a:t>Ghemawat, Gobioff, and Leung, The Google File System, Sections 3.1, 3.2, and 4.5.</a:t>
-            </a:r>
-          </a:p>
-          <a:p>
-            <a:r>
-              <a:rPr lang="en-US" dirty="0"/>
-              <a:t>https://pdos.csail.mit.edu/6.824/papers/gfs.pdf</a:t>
-            </a:r>
-          </a:p>
-          <a:p>
-            <a:r>
-              <a:t>Call back to the broken design at the start of class: the two servers applied the same two writes in different orders. A primary exists to pick one order and impose it on every replica.</a:t>
-            </a:r>
-            <a:endParaRPr lang="en-US"/>
+              <a:t>SOURCE
+MIT 6.824, Spring 2020, Lecture 3 transcript/video, 49:51–53:26 and 61:49–64:14.
+Local transcript: fall2026/lectures/references/mit-6824-2020-lecture3-gfs-transcript.txt
+https://www.youtube.com/watch?v=EpIgvowZr00
+Ghemawat, Gobioff, and Leung, The Google File System, Sections 3.1 and 4.5.
+https://pdos.csail.mit.edu/6.824/papers/gfs.pdf</a:t>
+            </a:r>
           </a:p>
         </p:txBody>
       </p:sp>
@@ -4500,126 +4406,68 @@
           <a:lstStyle/>
           <a:p>
             <a:r>
-              <a:t>CUES</a:t>
-            </a:r>
+              <a:rPr lang="en-US" dirty="0"/>
+              <a:t>A mutation separates moving the data from deciding when and where to apply it.</a:t>
+            </a:r>
+          </a:p>
+          <a:p>
             <a:endParaRPr lang="en-US" dirty="0"/>
           </a:p>
           <a:p>
             <a:r>
-              <a:t>Ask master for primary and secondaries</a:t>
-            </a:r>
+              <a:rPr lang="en-US" dirty="0"/>
+              <a:t>First, the client asks the master for the current primary and secondaries of the target chunk. The master returns only replicas with the current chunk version.</a:t>
+            </a:r>
+          </a:p>
+          <a:p>
             <a:endParaRPr lang="en-US" dirty="0"/>
           </a:p>
           <a:p>
             <a:r>
-              <a:t>Push data to every replica</a:t>
-            </a:r>
+              <a:rPr lang="en-US" dirty="0"/>
+              <a:t>Next, the client pushes the data to every replica. The replicas store those bytes temporarily; receiving the bytes does not yet change the visible chunk. In the optimized implementation, the data travels through a pipeline rather than being sent independently from the client to every server.</a:t>
+            </a:r>
+          </a:p>
+          <a:p>
             <a:endParaRPr lang="en-US" dirty="0"/>
           </a:p>
           <a:p>
             <a:r>
-              <a:t>Send the write command to the primary</a:t>
-            </a:r>
+              <a:rPr lang="en-US" dirty="0"/>
+              <a:t>Once every replica has buffered the data, the client sends the write command to the primary. The primary checks that its lease is still valid, assigns the mutation its place in the serial order, and tells the secondaries to apply the buffered bytes in that same order. Each replica writes the mutation to its local chunk file and acknowledges the primary.</a:t>
+            </a:r>
+          </a:p>
+          <a:p>
             <a:endParaRPr lang="en-US" dirty="0"/>
           </a:p>
           <a:p>
             <a:r>
-              <a:t>Primary orders the mutation</a:t>
-            </a:r>
+              <a:rPr lang="en-US" dirty="0"/>
+              <a:t>If every secondary acknowledges, the primary reports success to the client. If a server returns an error or does not reply, the primary reports failure. The client then retries the operation from the beginning, including asking the master again in case the replica group has changed.</a:t>
+            </a:r>
+          </a:p>
+          <a:p>
             <a:endParaRPr lang="en-US" dirty="0"/>
           </a:p>
           <a:p>
             <a:r>
-              <a:t>Secondaries apply that order</a:t>
-            </a:r>
+              <a:rPr lang="en-US" dirty="0"/>
+              <a:t>A retry improves the chance that the operation eventually succeeds, but it also means that part of an earlier attempt may remain on some replicas. That behavior becomes especially important for record append.</a:t>
+            </a:r>
+          </a:p>
+          <a:p>
             <a:endParaRPr lang="en-US" dirty="0"/>
           </a:p>
           <a:p>
             <a:r>
-              <a:t>Return success only after acknowledgments</a:t>
-            </a:r>
-            <a:endParaRPr lang="en-US" dirty="0"/>
-          </a:p>
-          <a:p>
-            <a:endParaRPr lang="en-US" dirty="0"/>
-          </a:p>
-          <a:p>
-            <a:r>
-              <a:t>The write path separates moving bytes from ordering the mutation.</a:t>
-            </a:r>
-            <a:endParaRPr lang="en-US" dirty="0"/>
-          </a:p>
-          <a:p>
-            <a:endParaRPr lang="en-US" dirty="0"/>
-          </a:p>
-          <a:p>
-            <a:r>
-              <a:t>First, the client asks the master for the current primary and secondaries. The client pushes the data to all replicas, where each server holds it temporarily. After the replicas have the bytes, the client sends the write request to the primary.</a:t>
-            </a:r>
-            <a:endParaRPr lang="en-US" dirty="0"/>
-          </a:p>
-          <a:p>
-            <a:endParaRPr lang="en-US" dirty="0"/>
-          </a:p>
-          <a:p>
-            <a:r>
-              <a:t>The primary verifies its lease, chooses the order, writes its local chunk, and tells the secondaries to apply the same mutation. It waits for their acknowledgments and then returns success or failure to the client. If the client receives an error, it retries the operation from the beginning.</a:t>
-            </a:r>
-            <a:endParaRPr lang="en-US" dirty="0"/>
-          </a:p>
-          <a:p>
-            <a:endParaRPr lang="en-US" dirty="0"/>
-          </a:p>
-          <a:p>
-            <a:r>
-              <a:t>This retry behavior improves availability, but it can create duplicates or inconsistent regions when only some replicas completed an earlier attempt.</a:t>
-            </a:r>
-            <a:endParaRPr lang="en-US" dirty="0"/>
-          </a:p>
-          <a:p>
-            <a:endParaRPr lang="en-US" dirty="0"/>
-          </a:p>
-          <a:p>
-            <a:r>
-              <a:t>SOURCE</a:t>
-            </a:r>
-            <a:endParaRPr lang="en-US" dirty="0"/>
-          </a:p>
-          <a:p>
-            <a:r>
-              <a:t>MIT 6.824, Spring 2020, Lecture 3 video, 40:32-60:46.</a:t>
-            </a:r>
-            <a:endParaRPr lang="en-US" dirty="0"/>
-          </a:p>
-          <a:p>
-            <a:r>
-              <a:t>https://www.youtube.com/watch?v=EpIgvowZr00</a:t>
-            </a:r>
-            <a:endParaRPr lang="en-US" dirty="0"/>
-          </a:p>
-          <a:p>
-            <a:r>
-              <a:t>MIT 6.5840, GFS lecture notes.</a:t>
-            </a:r>
-            <a:endParaRPr lang="en-US" dirty="0"/>
-          </a:p>
-          <a:p>
-            <a:r>
-              <a:t>https://pdos.csail.mit.edu/6.824/notes/l-gfs.txt</a:t>
-            </a:r>
-            <a:endParaRPr lang="en-US" dirty="0"/>
-          </a:p>
-          <a:p>
-            <a:r>
-              <a:t>Ghemawat, Gobioff, and Leung, The Google File System, Section 3.1.</a:t>
-            </a:r>
-            <a:endParaRPr lang="en-US" dirty="0"/>
-          </a:p>
-          <a:p>
-            <a:r>
-              <a:t>https://pdos.csail.mit.edu/6.824/papers/gfs.pdf</a:t>
-            </a:r>
-            <a:endParaRPr lang="en-US" dirty="0"/>
+              <a:rPr lang="en-US" dirty="0"/>
+              <a:t>SOURCE
+MIT 6.824, Spring 2020, Lecture 3 transcript/video, 51:39–57:36.
+Local transcript: fall2026/lectures/references/mit-6824-2020-lecture3-gfs-transcript.txt
+https://www.youtube.com/watch?v=EpIgvowZr00
+Ghemawat, Gobioff, and Leung, The Google File System, Sections 3.1 and 3.2.
+https://pdos.csail.mit.edu/6.824/papers/gfs.pdf</a:t>
+            </a:r>
           </a:p>
         </p:txBody>
       </p:sp>
@@ -4728,66 +4576,59 @@
           <a:lstStyle/>
           <a:p>
             <a:r>
-              <a:rPr dirty="0"/>
-              <a:t>This is the write operation that matters for GFS, and the one the paper optimises. MIT makes the same choice in lecture: it starts to describe an ordinary offset write, then deliberately backs up and says it will only talk about record append.</a:t>
-            </a:r>
+              <a:rPr lang="en-US" dirty="0"/>
+              <a:t>An ordinary write includes a file name, a byte offset, and a buffer. If several clients write the same region concurrently, they must coordinate their offsets or accept that the writes may overlap.</a:t>
+            </a:r>
+          </a:p>
+          <a:p>
             <a:endParaRPr lang="en-US" dirty="0"/>
           </a:p>
           <a:p>
             <a:r>
-              <a:rPr dirty="0"/>
-              <a:t>Contrast it with the previous slide, where the client knew the offset. Here it does not, and that is the point: with many clients appending to one file, letting each pick its own offset would force them to coordinate, which is exactly what GFS wants to avoid. Think of a log that hundreds of web servers append to at once.</a:t>
-            </a:r>
+              <a:rPr lang="en-US" dirty="0"/>
+              <a:t>Record append changes the interface. The client supplies the file name and the record, but it does not choose an offset. The primary chooses a location at the current end of the chunk and tells every secondary to use that same offset. This allows hundreds of producers to append to one log or queue without coordinating with one another.</a:t>
+            </a:r>
+          </a:p>
+          <a:p>
             <a:endParaRPr lang="en-US" dirty="0"/>
           </a:p>
           <a:p>
             <a:r>
-              <a:rPr dirty="0"/>
-              <a:t>The at-least-once promise is where the anomalies later in the lecture come from. A failed append is retried, so a record can land twice, and abandoned attempts leave padding behind. Point forward to "Why Are These Anomalies OK?".</a:t>
-            </a:r>
+              <a:rPr lang="en-US" dirty="0"/>
+              <a:t>If the client receives success, every replica has written the record at the same offset. The guarantee is at least once rather than exactly once. If the client receives an error, some replicas may already contain the record while others do not. The client retries the complete append, and the successful retry may place another copy later in the file.</a:t>
+            </a:r>
+          </a:p>
+          <a:p>
             <a:endParaRPr lang="en-US" dirty="0"/>
           </a:p>
           <a:p>
             <a:r>
-              <a:rPr dirty="0"/>
-              <a:t>This is also the honest answer to the first of the two questions: the interface is a file name plus a buffer, offered by a client library, not a POSIX file system.</a:t>
-            </a:r>
+              <a:rPr lang="en-US" dirty="0"/>
+              <a:t>A reader may therefore encounter padding from abandoned attempts or duplicate records from retries. GFS asks applications to make records self-identifying and self-validating so readers can discard padding, incomplete fragments, and duplicates when necessary.</a:t>
+            </a:r>
+          </a:p>
+          <a:p>
             <a:endParaRPr lang="en-US" dirty="0"/>
           </a:p>
           <a:p>
             <a:r>
-              <a:rPr dirty="0"/>
-              <a:t>SOURCE</a:t>
-            </a:r>
+              <a:rPr lang="en-US" dirty="0"/>
+              <a:t>This interface is closely matched to Google's workload. The system gives many concurrent producers an efficient atomic append, while applications accept and handle the limited anomalies created by failures and retries.</a:t>
+            </a:r>
+          </a:p>
+          <a:p>
             <a:endParaRPr lang="en-US" dirty="0"/>
           </a:p>
           <a:p>
             <a:r>
-              <a:rPr dirty="0"/>
-              <a:t>MIT 6.824, Spring 2020, Lecture 3 video, 40:04-43:00.</a:t>
-            </a:r>
-            <a:endParaRPr lang="en-US" dirty="0"/>
-          </a:p>
-          <a:p>
-            <a:r>
-              <a:rPr dirty="0"/>
-              <a:t>https://www.youtube.com/watch?v=EpIgvowZr00</a:t>
-            </a:r>
-            <a:endParaRPr lang="en-US" dirty="0"/>
-          </a:p>
-          <a:p>
-            <a:r>
-              <a:rPr dirty="0"/>
-              <a:t>Ghemawat, Gobioff, and Leung, The Google File System, Sections 2.3 and 3.3.</a:t>
-            </a:r>
-            <a:endParaRPr lang="en-US" dirty="0"/>
-          </a:p>
-          <a:p>
-            <a:r>
-              <a:rPr dirty="0"/>
-              <a:t>https://pdos.csail.mit.edu/6.824/papers/gfs.pdf</a:t>
-            </a:r>
-            <a:endParaRPr lang="en-US" dirty="0"/>
+              <a:rPr lang="en-US" dirty="0"/>
+              <a:t>SOURCE
+MIT 6.824, Spring 2020, Lecture 3 transcript/video, 40:04–40:51 and 52:29–57:36.
+Local transcript: fall2026/lectures/references/mit-6824-2020-lecture3-gfs-transcript.txt
+https://www.youtube.com/watch?v=EpIgvowZr00
+Ghemawat, Gobioff, and Leung, The Google File System, Sections 2.2, 2.7, and 3.3.
+https://pdos.csail.mit.edu/6.824/papers/gfs.pdf</a:t>
+            </a:r>
           </a:p>
         </p:txBody>
       </p:sp>
@@ -4896,63 +4737,59 @@
           <a:lstStyle/>
           <a:p>
             <a:r>
-              <a:t>Ask the class: the master forgets the replica list on a reboot and asks the chunkservers instead. Why can it not also ask them for the version number and take the highest answer?</a:t>
-            </a:r>
-            <a:endParaRPr lang="en-US"/>
-          </a:p>
-          <a:p>
-            <a:r>
-              <a:t>Because the chunkservers holding the newest copy may still be down. The ones that answer first could be the machines that were offline last week, and their version is old. So the version number has to be on the master disk.</a:t>
-            </a:r>
-            <a:endParaRPr lang="en-US"/>
-          </a:p>
-          <a:p>
-            <a:r>
-              <a:t>Whole-building power failure is the case to describe: the master comes back before most chunkservers. If no replica reports the version the master expects, it waits or tells the client to retry rather than hand out old data.</a:t>
-            </a:r>
-            <a:endParaRPr lang="en-US"/>
-          </a:p>
-          <a:p>
-            <a:r>
-              <a:t>SOURCE</a:t>
-            </a:r>
-            <a:endParaRPr lang="en-US"/>
-          </a:p>
-          <a:p>
-            <a:r>
-              <a:t>MIT 6.824, Spring 2020, Lecture 3 video, 41:39-49:51.</a:t>
-            </a:r>
-            <a:endParaRPr lang="en-US"/>
-          </a:p>
-          <a:p>
-            <a:r>
-              <a:t>https://www.youtube.com/watch?v=EpIgvowZr00</a:t>
-            </a:r>
-            <a:endParaRPr lang="en-US"/>
-          </a:p>
-          <a:p>
-            <a:r>
-              <a:t>MIT 6.5840, GFS lecture notes.</a:t>
-            </a:r>
-            <a:endParaRPr lang="en-US"/>
-          </a:p>
-          <a:p>
-            <a:r>
-              <a:t>https://pdos.csail.mit.edu/6.824/notes/l-gfs.txt</a:t>
-            </a:r>
-            <a:endParaRPr lang="en-US"/>
-          </a:p>
-          <a:p>
-            <a:r>
-              <a:t>Ghemawat, Gobioff, and Leung, The Google File System, Section 4.5.</a:t>
-            </a:r>
-            <a:endParaRPr lang="en-US"/>
-          </a:p>
-          <a:p>
-            <a:r>
-              <a:t>https://pdos.csail.mit.edu/6.824/papers/gfs.pdf</a:t>
-            </a:r>
-            <a:endParaRPr lang="en-US"/>
+              <a:rPr lang="en-US" dirty="0"/>
+              <a:t>The write and record-append paths have assumed that the master can return a current primary and set of secondaries. But a chunkserver may have been offline while other replicas received mutations, so simply possessing a chunk with the correct handle does not mean that its contents are up to date.</a:t>
+            </a:r>
+          </a:p>
+          <a:p>
+            <a:endParaRPr lang="en-US" dirty="0"/>
+          </a:p>
+          <a:p>
+            <a:r>
+              <a:rPr lang="en-US" dirty="0"/>
+              <a:t>The master assigns a version number to every chunk. Whenever it establishes a new lease and replica group, it advances that version. The master records the new number persistently, and the selected primary and secondaries record it on their own disks before the group begins serving new mutations.</a:t>
+            </a:r>
+          </a:p>
+          <a:p>
+            <a:endParaRPr lang="en-US" dirty="0"/>
+          </a:p>
+          <a:p>
+            <a:r>
+              <a:rPr lang="en-US" dirty="0"/>
+              <a:t>A replica that was unavailable during this step keeps the older version. When it later reports to the master, the number reveals that it is stale. The master excludes that replica from reads, never designates it as a primary, and eventually garbage-collects it.</a:t>
+            </a:r>
+          </a:p>
+          <a:p>
+            <a:endParaRPr lang="en-US" dirty="0"/>
+          </a:p>
+          <a:p>
+            <a:r>
+              <a:rPr lang="en-US" dirty="0"/>
+              <a:t>The power-failure example explains why the master's copy of the version number must survive. Suppose the master restarts before the chunkservers holding the newest replicas. If it merely accepted the highest version among the first servers to respond, it could mistake an old copy for the current one. Instead, it waits for a replica carrying the version it already knows is current, or it tells the client to retry later.</a:t>
+            </a:r>
+          </a:p>
+          <a:p>
+            <a:endParaRPr lang="en-US" dirty="0"/>
+          </a:p>
+          <a:p>
+            <a:r>
+              <a:rPr lang="en-US" dirty="0"/>
+              <a:t>The system therefore prefers temporary unavailability to silently serving stale data.</a:t>
+            </a:r>
+          </a:p>
+          <a:p>
+            <a:endParaRPr lang="en-US" dirty="0"/>
+          </a:p>
+          <a:p>
+            <a:r>
+              <a:rPr lang="en-US" dirty="0"/>
+              <a:t>SOURCE
+MIT 6.824, Spring 2020, Lecture 3 transcript/video, 41:39–50:50.
+Local transcript: fall2026/lectures/references/mit-6824-2020-lecture3-gfs-transcript.txt
+https://www.youtube.com/watch?v=EpIgvowZr00
+Ghemawat, Gobioff, and Leung, The Google File System, Section 4.5.
+https://pdos.csail.mit.edu/6.824/papers/gfs.pdf</a:t>
+            </a:r>
           </a:p>
         </p:txBody>
       </p:sp>
@@ -5061,81 +4898,68 @@
           <a:lstStyle/>
           <a:p>
             <a:r>
-              <a:t>This diagram distinguishes control flow from data flow.</a:t>
-            </a:r>
+              <a:rPr lang="en-US" dirty="0"/>
+              <a:t>This diagram puts the complete mutation path together and separates control messages from the data path.</a:t>
+            </a:r>
+          </a:p>
+          <a:p>
             <a:endParaRPr lang="en-US" dirty="0"/>
           </a:p>
           <a:p>
+            <a:r>
+              <a:rPr lang="en-US" dirty="0"/>
+              <a:t>First, the client asks the master which chunkservers hold current replicas and which one has the primary lease. The master returns the primary and secondaries. These are small control messages; no file data passes through the master.</a:t>
+            </a:r>
+          </a:p>
+          <a:p>
             <a:endParaRPr lang="en-US" dirty="0"/>
           </a:p>
           <a:p>
             <a:r>
-              <a:t>The client first asks the master which replicas hold the chunk and which replica has the lease. That message contains only metadata. The file data then moves directly among the client and chunkservers.</a:t>
-            </a:r>
+              <a:rPr lang="en-US" dirty="0"/>
+              <a:t>The client then pushes the data through the replicas. GFS orders the pipeline by network proximity. The client sends the bytes to one chunkserver, that server forwards them to the next, and the chain continues until every replica has buffered the data. Each machine uses its outgoing bandwidth once, and the path can avoid repeatedly crossing a bottleneck link.</a:t>
+            </a:r>
+          </a:p>
+          <a:p>
             <a:endParaRPr lang="en-US" dirty="0"/>
           </a:p>
           <a:p>
+            <a:r>
+              <a:rPr lang="en-US" dirty="0"/>
+              <a:t>After the replicas acknowledge that they have the bytes, the client sends the write command to the primary. The primary places the mutation in its serial order and forwards the command to the secondaries. Every replica applies the buffered data in that order, and the acknowledgments return through the primary to the client.</a:t>
+            </a:r>
+          </a:p>
+          <a:p>
             <a:endParaRPr lang="en-US" dirty="0"/>
           </a:p>
           <a:p>
             <a:r>
-              <a:t>GFS pipelines the data through the replicas in an order chosen to reduce network distance. This uses each machine's outgoing bandwidth once instead of having the client send the full data separately across the network to every replica.</a:t>
-            </a:r>
+              <a:rPr lang="en-US" dirty="0"/>
+              <a:t>The separation serves two different goals. The data pipeline uses the network efficiently. The primary controls the mutation order needed to keep replicas aligned.</a:t>
+            </a:r>
+          </a:p>
+          <a:p>
             <a:endParaRPr lang="en-US" dirty="0"/>
           </a:p>
           <a:p>
+            <a:r>
+              <a:rPr lang="en-US" dirty="0"/>
+              <a:t>The next demo makes the same architectural separation visible in HDFS: a metadata lookup goes to the NameNode, while the file bytes move directly through a DataNode pipeline. HDFS does not implement GFS leases or record append, so those GFS-specific guarantees remain part of the paper rather than the demo.</a:t>
+            </a:r>
+          </a:p>
+          <a:p>
             <a:endParaRPr lang="en-US" dirty="0"/>
           </a:p>
           <a:p>
             <a:r>
-              <a:t>After all replicas buffer the data, the client sends the control request to the primary. The primary orders the write and tells the secondaries when and where to apply the buffered bytes. The final acknowledgment travels back through the primary.</a:t>
-            </a:r>
-            <a:endParaRPr lang="en-US" dirty="0"/>
-          </a:p>
-          <a:p>
-            <a:endParaRPr lang="en-US" dirty="0"/>
-          </a:p>
-          <a:p>
-            <a:r>
-              <a:t>SOURCE</a:t>
-            </a:r>
-            <a:endParaRPr lang="en-US" dirty="0"/>
-          </a:p>
-          <a:p>
-            <a:r>
-              <a:t>MIT 6.824, Spring 2020, Lecture 3 video, 50:35-60:46.</a:t>
-            </a:r>
-            <a:endParaRPr lang="en-US" dirty="0"/>
-          </a:p>
-          <a:p>
-            <a:r>
-              <a:t>https://www.youtube.com/watch?v=EpIgvowZr00</a:t>
-            </a:r>
-            <a:endParaRPr lang="en-US" dirty="0"/>
-          </a:p>
-          <a:p>
-            <a:r>
-              <a:t>MIT 6.5840, GFS lecture notes.</a:t>
-            </a:r>
-            <a:endParaRPr lang="en-US" dirty="0"/>
-          </a:p>
-          <a:p>
-            <a:r>
-              <a:t>https://pdos.csail.mit.edu/6.824/notes/l-gfs.txt</a:t>
-            </a:r>
-            <a:endParaRPr lang="en-US" dirty="0"/>
-          </a:p>
-          <a:p>
-            <a:r>
-              <a:t>Ghemawat, Gobioff, and Leung, The Google File System, Sections 3.1 and 3.2.</a:t>
-            </a:r>
-            <a:endParaRPr lang="en-US" dirty="0"/>
-          </a:p>
-          <a:p>
-            <a:r>
-              <a:t>https://pdos.csail.mit.edu/6.824/papers/gfs.pdf</a:t>
-            </a:r>
-            <a:endParaRPr lang="en-US" dirty="0"/>
+              <a:rPr lang="en-US" dirty="0"/>
+              <a:t>SOURCE
+MIT 6.824, Spring 2020, Lecture 3 transcript/video, 51:39–58:24.
+Local transcript: fall2026/lectures/references/mit-6824-2020-lecture3-gfs-transcript.txt
+https://www.youtube.com/watch?v=EpIgvowZr00
+Ghemawat, Gobioff, and Leung, The Google File System, Sections 3.1 and 3.2.
+https://pdos.csail.mit.edu/6.824/papers/gfs.pdf</a:t>
+            </a:r>
           </a:p>
         </p:txBody>
       </p:sp>

</xml_diff>

<commit_message>
Emphasize GFS performance design
</commit_message>
<xml_diff>
--- a/slides/fall26/4-gfs.pptx
+++ b/slides/fall26/4-gfs.pptx
@@ -2858,7 +2858,25 @@
           <a:p>
             <a:r>
               <a:rPr lang="en-US" dirty="0"/>
-              <a:t>The arrows in the figure therefore represent two different paths. Small control messages go through the master. Large data transfers bypass it. Many clients can communicate with many chunkservers in parallel, while the master remains responsible for the global organization of the file system.</a:t>
+              <a:t>This direct transfer between clients and chunkservers is one of the most important performance decisions in GFS. If every read and write passed through the single master, the master's network link and memory bandwidth would limit the throughput of the entire cluster. Adding more chunkservers would add disks, but all of their data would still have to cross one machine.</a:t>
+            </a:r>
+          </a:p>
+          <a:p>
+            <a:endParaRPr lang="en-US" dirty="0"/>
+          </a:p>
+          <a:p>
+            <a:r>
+              <a:rPr lang="en-US" dirty="0"/>
+              <a:t>GFS removes that bottleneck. The master handles small metadata requests, and clients cache the replies. The much larger streams of file data are distributed across many client-to-chunkserver connections. As the cluster adds chunkservers, it also adds data-serving bandwidth without forcing the master to carry those bytes.</a:t>
+            </a:r>
+          </a:p>
+          <a:p>
+            <a:endParaRPr lang="en-US" dirty="0"/>
+          </a:p>
+          <a:p>
+            <a:r>
+              <a:rPr lang="en-US" dirty="0"/>
+              <a:t>That is the meaning of the two arrow types in the figure. Control messages go through the master. Data messages bypass it. The single master supplies a global view, while the chunkservers provide parallel data throughput.</a:t>
             </a:r>
           </a:p>
           <a:p>
@@ -3001,7 +3019,7 @@
           <a:p>
             <a:r>
               <a:rPr lang="en-US" dirty="0"/>
-              <a:t>All of this metadata stays in the master's memory, which makes lookups and background scans fast. The amount is small because GFS has large chunks. At less than 64 bytes per 64-megabyte chunk, 640 terabytes of full chunks requires less than about 640 megabytes of per-chunk metadata.</a:t>
+              <a:t>Keeping all metadata in memory is the second key performance decision behind the single-master design. A client needs a metadata answer before it can contact a chunkserver. If the master performed a disk access for every lookup, that delay and disk throughput would quickly make one master a bottleneck. An in-memory lookup is fast, so the master can answer many clients while the data transfers proceed elsewhere.</a:t>
             </a:r>
           </a:p>
           <a:p>
@@ -3010,7 +3028,25 @@
           <a:p>
             <a:r>
               <a:rPr lang="en-US" dirty="0"/>
-              <a:t>The master and chunkservers exchange periodic heartbeat messages. A chunkserver reports its state and the chunks it holds. The master uses the reply to send instructions, such as creating or deleting a replica. These heartbeats keep the master's view current as machines join, fail, and restart.</a:t>
+              <a:t>In-memory metadata also makes the master's background work efficient. It can scan the complete chunk table to find under-replicated chunks, identify garbage, and plan load balancing without issuing millions of random disk reads.</a:t>
+            </a:r>
+          </a:p>
+          <a:p>
+            <a:endParaRPr lang="en-US" dirty="0"/>
+          </a:p>
+          <a:p>
+            <a:r>
+              <a:rPr lang="en-US" dirty="0"/>
+              <a:t>The large chunk size makes this possible. At less than 64 bytes of metadata per 64-megabyte chunk, 640 terabytes of full chunks requires less than about 640 megabytes of per-chunk metadata. GFS deliberately pairs large chunks with in-memory metadata so that one master can retain a global view without slowing down the common lookup path.</a:t>
+            </a:r>
+          </a:p>
+          <a:p>
+            <a:endParaRPr lang="en-US" dirty="0"/>
+          </a:p>
+          <a:p>
+            <a:r>
+              <a:rPr lang="en-US" dirty="0"/>
+              <a:t>The master and chunkservers exchange periodic heartbeat messages. A chunkserver reports its state and the chunks it holds. The master uses the reply to send instructions, such as creating or deleting a replica. These heartbeats keep the in-memory view current as machines join, fail, and restart.</a:t>
             </a:r>
           </a:p>
           <a:p>

</xml_diff>

<commit_message>
Expand GFS consistency scripts
</commit_message>
<xml_diff>
--- a/slides/fall26/4-gfs.pptx
+++ b/slides/fall26/4-gfs.pptx
@@ -26,14 +26,14 @@
     <p:sldId id="262" r:id="rId17"/>
     <p:sldId id="430" r:id="rId18"/>
     <p:sldId id="435" r:id="rId19"/>
-    <p:sldId id="431" r:id="rId21"/>
-    <p:sldId id="433" r:id="rId22"/>
-    <p:sldId id="434" r:id="rId23"/>
-    <p:sldId id="436" r:id="rId24"/>
-    <p:sldId id="437" r:id="rId25"/>
-    <p:sldId id="468" r:id="rId26"/>
-    <p:sldId id="439" r:id="rId27"/>
-    <p:sldId id="480" r:id="rId20"/>
+    <p:sldId id="431" r:id="rId20"/>
+    <p:sldId id="433" r:id="rId21"/>
+    <p:sldId id="434" r:id="rId22"/>
+    <p:sldId id="436" r:id="rId23"/>
+    <p:sldId id="437" r:id="rId24"/>
+    <p:sldId id="468" r:id="rId25"/>
+    <p:sldId id="439" r:id="rId26"/>
+    <p:sldId id="480" r:id="rId27"/>
     <p:sldId id="469" r:id="rId28"/>
     <p:sldId id="440" r:id="rId29"/>
     <p:sldId id="441" r:id="rId30"/>
@@ -45,8 +45,8 @@
     <p:sldId id="448" r:id="rId36"/>
     <p:sldId id="482" r:id="rId37"/>
     <p:sldId id="449" r:id="rId38"/>
+    <p:sldId id="451" r:id="rId40"/>
     <p:sldId id="450" r:id="rId39"/>
-    <p:sldId id="451" r:id="rId40"/>
     <p:sldId id="471" r:id="rId41"/>
     <p:sldId id="472" r:id="rId42"/>
     <p:sldId id="452" r:id="rId43"/>
@@ -2064,7 +2064,7 @@
         <p:cNvPr id="1" name="">
           <a:extLst>
             <a:ext uri="{FF2B5EF4-FFF2-40B4-BE49-F238E27FC236}">
-              <a16:creationId xmlns:a16="http://schemas.microsoft.com/office/drawing/2014/main" id="{B2FBB8B7-6C3A-826B-BEDC-11B455E4E59E}"/>
+              <a16:creationId xmlns:a16="http://schemas.microsoft.com/office/drawing/2014/main" id="{14707305-DF4E-A6F8-F2A2-17B8D7640FD3}"/>
             </a:ext>
           </a:extLst>
         </p:cNvPr>
@@ -2084,7 +2084,7 @@
           <p:cNvPr id="2" name="Slide Image Placeholder 1">
             <a:extLst>
               <a:ext uri="{FF2B5EF4-FFF2-40B4-BE49-F238E27FC236}">
-                <a16:creationId xmlns:a16="http://schemas.microsoft.com/office/drawing/2014/main" id="{0059D6B3-B338-2117-3D33-BCA332753A2A}"/>
+                <a16:creationId xmlns:a16="http://schemas.microsoft.com/office/drawing/2014/main" id="{77C5DA89-110B-F02F-D7AE-1E3FA01AED05}"/>
               </a:ext>
             </a:extLst>
           </p:cNvPr>
@@ -2102,7 +2102,7 @@
           <p:cNvPr id="3" name="Notes Placeholder 2">
             <a:extLst>
               <a:ext uri="{FF2B5EF4-FFF2-40B4-BE49-F238E27FC236}">
-                <a16:creationId xmlns:a16="http://schemas.microsoft.com/office/drawing/2014/main" id="{FF01A163-C2DA-77C8-7422-DB4C8C9F21C5}"/>
+                <a16:creationId xmlns:a16="http://schemas.microsoft.com/office/drawing/2014/main" id="{3A0A9E07-475C-1777-8D7B-534AC6D8ADEF}"/>
               </a:ext>
             </a:extLst>
           </p:cNvPr>
@@ -2120,7 +2120,57 @@
           <a:p>
             <a:r>
               <a:rPr lang="en-US" dirty="0"/>
-              <a:t>TERMINAL</a:t>
+              <a:t>The demo showed the mechanisms at a small scale. Those mechanisms make sense because GFS serves a deliberately specialized environment rather than every possible storage workload.</a:t>
+            </a:r>
+          </a:p>
+          <a:p>
+            <a:endParaRPr lang="en-US" dirty="0"/>
+          </a:p>
+          <a:p>
+            <a:r>
+              <a:rPr lang="en-US" dirty="0"/>
+              <a:t>One GFS deployment lives inside a single data center. It does not try to keep replicas synchronized across distant sites with wide-area delays and network partitions. It is also an internal service for Google applications. Because Google controls both the storage system and most of its clients, application developers can understand the guarantees and adapt their data formats when necessary.</a:t>
+            </a:r>
+          </a:p>
+          <a:p>
+            <a:endParaRPr lang="en-US" dirty="0"/>
+          </a:p>
+          <a:p>
+            <a:r>
+              <a:rPr lang="en-US" dirty="0"/>
+              <a:t>The expected workload is dominated by very large files. Reads are usually long sequential streams, with some small random reads. Writes are mainly large sequential appends, including cases where many clients append to the same file. Small writes at arbitrary offsets are possible, but they are not the design center.</a:t>
+            </a:r>
+          </a:p>
+          <a:p>
+            <a:endParaRPr lang="en-US" dirty="0"/>
+          </a:p>
+          <a:p>
+            <a:r>
+              <a:rPr lang="en-US" dirty="0"/>
+              <a:t>This workload values aggregate throughput more than the response time of one tiny operation. A database holding bank-account records needs fast random updates and strong transactional behavior. GFS was designed for crawls, indexes, logs, and batch-processing pipelines.</a:t>
+            </a:r>
+          </a:p>
+          <a:p>
+            <a:endParaRPr lang="en-US" dirty="0"/>
+          </a:p>
+          <a:p>
+            <a:r>
+              <a:rPr lang="en-US" dirty="0"/>
+              <a:t>These assumptions provide design freedom. GFS can optimize the operations Google performs constantly and accept weaker behavior in cases its applications can detect, retry, or avoid.</a:t>
+            </a:r>
+          </a:p>
+          <a:p>
+            <a:endParaRPr lang="en-US" dirty="0"/>
+          </a:p>
+          <a:p>
+            <a:r>
+              <a:rPr lang="en-US" dirty="0"/>
+              <a:t>SOURCE
+MIT 6.824, Spring 2020, Lecture 3 transcript/video, 18:07–20:39.
+Local transcript: fall2026/lectures/references/mit-6824-2020-lecture3-gfs-transcript.txt
+https://www.youtube.com/watch?v=EpIgvowZr00
+Ghemawat, Gobioff, and Leung, The Google File System, Sections 1 and 2.1.
+https://pdos.csail.mit.edu/6.824/papers/gfs.pdf</a:t>
             </a:r>
           </a:p>
         </p:txBody>
@@ -2130,7 +2180,7 @@
           <p:cNvPr id="4" name="Slide Number Placeholder 3">
             <a:extLst>
               <a:ext uri="{FF2B5EF4-FFF2-40B4-BE49-F238E27FC236}">
-                <a16:creationId xmlns:a16="http://schemas.microsoft.com/office/drawing/2014/main" id="{09D73A9A-D881-2613-9D53-6BBD01037D23}"/>
+                <a16:creationId xmlns:a16="http://schemas.microsoft.com/office/drawing/2014/main" id="{42ECC76C-7CE7-C58A-1EBE-1940C2ECA583}"/>
               </a:ext>
             </a:extLst>
           </p:cNvPr>
@@ -2157,7 +2207,7 @@
     </p:spTree>
     <p:extLst>
       <p:ext uri="{BB962C8B-B14F-4D97-AF65-F5344CB8AC3E}">
-        <p14:creationId xmlns:p14="http://schemas.microsoft.com/office/powerpoint/2010/main" val="3354523721"/>
+        <p14:creationId xmlns:p14="http://schemas.microsoft.com/office/powerpoint/2010/main" val="1848237194"/>
       </p:ext>
     </p:extLst>
   </p:cSld>
@@ -2301,167 +2351,6 @@
         <p:cNvPr id="1" name="">
           <a:extLst>
             <a:ext uri="{FF2B5EF4-FFF2-40B4-BE49-F238E27FC236}">
-              <a16:creationId xmlns:a16="http://schemas.microsoft.com/office/drawing/2014/main" id="{14707305-DF4E-A6F8-F2A2-17B8D7640FD3}"/>
-            </a:ext>
-          </a:extLst>
-        </p:cNvPr>
-        <p:cNvGrpSpPr/>
-        <p:nvPr/>
-      </p:nvGrpSpPr>
-      <p:grpSpPr>
-        <a:xfrm>
-          <a:off x="0" y="0"/>
-          <a:ext cx="0" cy="0"/>
-          <a:chOff x="0" y="0"/>
-          <a:chExt cx="0" cy="0"/>
-        </a:xfrm>
-      </p:grpSpPr>
-      <p:sp>
-        <p:nvSpPr>
-          <p:cNvPr id="2" name="Slide Image Placeholder 1">
-            <a:extLst>
-              <a:ext uri="{FF2B5EF4-FFF2-40B4-BE49-F238E27FC236}">
-                <a16:creationId xmlns:a16="http://schemas.microsoft.com/office/drawing/2014/main" id="{77C5DA89-110B-F02F-D7AE-1E3FA01AED05}"/>
-              </a:ext>
-            </a:extLst>
-          </p:cNvPr>
-          <p:cNvSpPr>
-            <a:spLocks noGrp="1" noRot="1" noChangeAspect="1"/>
-          </p:cNvSpPr>
-          <p:nvPr>
-            <p:ph type="sldImg"/>
-          </p:nvPr>
-        </p:nvSpPr>
-        <p:spPr/>
-      </p:sp>
-      <p:sp>
-        <p:nvSpPr>
-          <p:cNvPr id="3" name="Notes Placeholder 2">
-            <a:extLst>
-              <a:ext uri="{FF2B5EF4-FFF2-40B4-BE49-F238E27FC236}">
-                <a16:creationId xmlns:a16="http://schemas.microsoft.com/office/drawing/2014/main" id="{3A0A9E07-475C-1777-8D7B-534AC6D8ADEF}"/>
-              </a:ext>
-            </a:extLst>
-          </p:cNvPr>
-          <p:cNvSpPr>
-            <a:spLocks noGrp="1"/>
-          </p:cNvSpPr>
-          <p:nvPr>
-            <p:ph type="body" idx="1"/>
-          </p:nvPr>
-        </p:nvSpPr>
-        <p:spPr/>
-        <p:txBody>
-          <a:bodyPr/>
-          <a:lstStyle/>
-          <a:p>
-            <a:r>
-              <a:rPr lang="en-US" dirty="0"/>
-              <a:t>The demo showed the mechanisms at a small scale. Those mechanisms make sense because GFS serves a deliberately specialized environment rather than every possible storage workload.</a:t>
-            </a:r>
-          </a:p>
-          <a:p>
-            <a:endParaRPr lang="en-US" dirty="0"/>
-          </a:p>
-          <a:p>
-            <a:r>
-              <a:rPr lang="en-US" dirty="0"/>
-              <a:t>One GFS deployment lives inside a single data center. It does not try to keep replicas synchronized across distant sites with wide-area delays and network partitions. It is also an internal service for Google applications. Because Google controls both the storage system and most of its clients, application developers can understand the guarantees and adapt their data formats when necessary.</a:t>
-            </a:r>
-          </a:p>
-          <a:p>
-            <a:endParaRPr lang="en-US" dirty="0"/>
-          </a:p>
-          <a:p>
-            <a:r>
-              <a:rPr lang="en-US" dirty="0"/>
-              <a:t>The expected workload is dominated by very large files. Reads are usually long sequential streams, with some small random reads. Writes are mainly large sequential appends, including cases where many clients append to the same file. Small writes at arbitrary offsets are possible, but they are not the design center.</a:t>
-            </a:r>
-          </a:p>
-          <a:p>
-            <a:endParaRPr lang="en-US" dirty="0"/>
-          </a:p>
-          <a:p>
-            <a:r>
-              <a:rPr lang="en-US" dirty="0"/>
-              <a:t>This workload values aggregate throughput more than the response time of one tiny operation. A database holding bank-account records needs fast random updates and strong transactional behavior. GFS was designed for crawls, indexes, logs, and batch-processing pipelines.</a:t>
-            </a:r>
-          </a:p>
-          <a:p>
-            <a:endParaRPr lang="en-US" dirty="0"/>
-          </a:p>
-          <a:p>
-            <a:r>
-              <a:rPr lang="en-US" dirty="0"/>
-              <a:t>These assumptions provide design freedom. GFS can optimize the operations Google performs constantly and accept weaker behavior in cases its applications can detect, retry, or avoid.</a:t>
-            </a:r>
-          </a:p>
-          <a:p>
-            <a:endParaRPr lang="en-US" dirty="0"/>
-          </a:p>
-          <a:p>
-            <a:r>
-              <a:rPr lang="en-US" dirty="0"/>
-              <a:t>SOURCE
-MIT 6.824, Spring 2020, Lecture 3 transcript/video, 18:07–20:39.
-Local transcript: fall2026/lectures/references/mit-6824-2020-lecture3-gfs-transcript.txt
-https://www.youtube.com/watch?v=EpIgvowZr00
-Ghemawat, Gobioff, and Leung, The Google File System, Sections 1 and 2.1.
-https://pdos.csail.mit.edu/6.824/papers/gfs.pdf</a:t>
-            </a:r>
-          </a:p>
-        </p:txBody>
-      </p:sp>
-      <p:sp>
-        <p:nvSpPr>
-          <p:cNvPr id="4" name="Slide Number Placeholder 3">
-            <a:extLst>
-              <a:ext uri="{FF2B5EF4-FFF2-40B4-BE49-F238E27FC236}">
-                <a16:creationId xmlns:a16="http://schemas.microsoft.com/office/drawing/2014/main" id="{42ECC76C-7CE7-C58A-1EBE-1940C2ECA583}"/>
-              </a:ext>
-            </a:extLst>
-          </p:cNvPr>
-          <p:cNvSpPr>
-            <a:spLocks noGrp="1"/>
-          </p:cNvSpPr>
-          <p:nvPr>
-            <p:ph type="sldNum" sz="quarter" idx="5"/>
-          </p:nvPr>
-        </p:nvSpPr>
-        <p:spPr/>
-        <p:txBody>
-          <a:bodyPr/>
-          <a:lstStyle/>
-          <a:p>
-            <a:fld id="{1C9584DC-3658-4054-9DA4-7B68A1D8CC6D}" type="slidenum">
-              <a:rPr lang="zh-CN" altLang="en-US" smtClean="0"/>
-              <a:t>20</a:t>
-            </a:fld>
-            <a:endParaRPr lang="zh-CN" altLang="en-US"/>
-          </a:p>
-        </p:txBody>
-      </p:sp>
-    </p:spTree>
-    <p:extLst>
-      <p:ext uri="{BB962C8B-B14F-4D97-AF65-F5344CB8AC3E}">
-        <p14:creationId xmlns:p14="http://schemas.microsoft.com/office/powerpoint/2010/main" val="1848237194"/>
-      </p:ext>
-    </p:extLst>
-  </p:cSld>
-  <p:clrMapOvr>
-    <a:masterClrMapping/>
-  </p:clrMapOvr>
-</p:notes>
-</file>
-
-<file path=ppt/notesSlides/notesSlide21.xml><?xml version="1.0" encoding="utf-8"?>
-<p:notes xmlns:a="http://schemas.openxmlformats.org/drawingml/2006/main" xmlns:r="http://schemas.openxmlformats.org/officeDocument/2006/relationships" xmlns:p="http://schemas.openxmlformats.org/presentationml/2006/main">
-  <p:cSld>
-    <p:spTree>
-      <p:nvGrpSpPr>
-        <p:cNvPr id="1" name="">
-          <a:extLst>
-            <a:ext uri="{FF2B5EF4-FFF2-40B4-BE49-F238E27FC236}">
               <a16:creationId xmlns:a16="http://schemas.microsoft.com/office/drawing/2014/main" id="{AFC96688-AA5D-D826-C009-5CF1269C9D27}"/>
             </a:ext>
           </a:extLst>
@@ -2596,7 +2485,7 @@
           <a:p>
             <a:fld id="{1C9584DC-3658-4054-9DA4-7B68A1D8CC6D}" type="slidenum">
               <a:rPr lang="zh-CN" altLang="en-US" smtClean="0"/>
-              <a:t>21</a:t>
+              <a:t>20</a:t>
             </a:fld>
             <a:endParaRPr lang="zh-CN" altLang="en-US"/>
           </a:p>
@@ -2615,7 +2504,7 @@
 </p:notes>
 </file>
 
-<file path=ppt/notesSlides/notesSlide22.xml><?xml version="1.0" encoding="utf-8"?>
+<file path=ppt/notesSlides/notesSlide21.xml><?xml version="1.0" encoding="utf-8"?>
 <p:notes xmlns:a="http://schemas.openxmlformats.org/drawingml/2006/main" xmlns:r="http://schemas.openxmlformats.org/officeDocument/2006/relationships" xmlns:p="http://schemas.openxmlformats.org/presentationml/2006/main">
   <p:cSld>
     <p:spTree>
@@ -2739,7 +2628,7 @@
           <a:p>
             <a:fld id="{1C9584DC-3658-4054-9DA4-7B68A1D8CC6D}" type="slidenum">
               <a:rPr lang="zh-CN" altLang="en-US" smtClean="0"/>
-              <a:t>22</a:t>
+              <a:t>21</a:t>
             </a:fld>
             <a:endParaRPr lang="zh-CN" altLang="en-US"/>
           </a:p>
@@ -2758,7 +2647,7 @@
 </p:notes>
 </file>
 
-<file path=ppt/notesSlides/notesSlide23.xml><?xml version="1.0" encoding="utf-8"?>
+<file path=ppt/notesSlides/notesSlide22.xml><?xml version="1.0" encoding="utf-8"?>
 <p:notes xmlns:a="http://schemas.openxmlformats.org/drawingml/2006/main" xmlns:r="http://schemas.openxmlformats.org/officeDocument/2006/relationships" xmlns:p="http://schemas.openxmlformats.org/presentationml/2006/main">
   <p:cSld>
     <p:spTree>
@@ -2918,7 +2807,7 @@
           <a:p>
             <a:fld id="{1C9584DC-3658-4054-9DA4-7B68A1D8CC6D}" type="slidenum">
               <a:rPr lang="zh-CN" altLang="en-US" smtClean="0"/>
-              <a:t>23</a:t>
+              <a:t>22</a:t>
             </a:fld>
             <a:endParaRPr lang="zh-CN" altLang="en-US"/>
           </a:p>
@@ -2937,7 +2826,7 @@
 </p:notes>
 </file>
 
-<file path=ppt/notesSlides/notesSlide24.xml><?xml version="1.0" encoding="utf-8"?>
+<file path=ppt/notesSlides/notesSlide23.xml><?xml version="1.0" encoding="utf-8"?>
 <p:notes xmlns:a="http://schemas.openxmlformats.org/drawingml/2006/main" xmlns:r="http://schemas.openxmlformats.org/officeDocument/2006/relationships" xmlns:p="http://schemas.openxmlformats.org/presentationml/2006/main">
   <p:cSld>
     <p:spTree>
@@ -3097,7 +2986,7 @@
           <a:p>
             <a:fld id="{1C9584DC-3658-4054-9DA4-7B68A1D8CC6D}" type="slidenum">
               <a:rPr lang="zh-CN" altLang="en-US" smtClean="0"/>
-              <a:t>24</a:t>
+              <a:t>23</a:t>
             </a:fld>
             <a:endParaRPr lang="zh-CN" altLang="en-US"/>
           </a:p>
@@ -3116,7 +3005,7 @@
 </p:notes>
 </file>
 
-<file path=ppt/notesSlides/notesSlide25.xml><?xml version="1.0" encoding="utf-8"?>
+<file path=ppt/notesSlides/notesSlide24.xml><?xml version="1.0" encoding="utf-8"?>
 <p:notes xmlns:a="http://schemas.openxmlformats.org/drawingml/2006/main" xmlns:r="http://schemas.openxmlformats.org/officeDocument/2006/relationships" xmlns:p="http://schemas.openxmlformats.org/presentationml/2006/main">
   <p:cSld>
     <p:spTree>
@@ -3276,7 +3165,7 @@
           <a:p>
             <a:fld id="{1C9584DC-3658-4054-9DA4-7B68A1D8CC6D}" type="slidenum">
               <a:rPr lang="zh-CN" altLang="en-US" smtClean="0"/>
-              <a:t>25</a:t>
+              <a:t>24</a:t>
             </a:fld>
             <a:endParaRPr lang="zh-CN" altLang="en-US"/>
           </a:p>
@@ -3295,7 +3184,7 @@
 </p:notes>
 </file>
 
-<file path=ppt/notesSlides/notesSlide26.xml><?xml version="1.0" encoding="utf-8"?>
+<file path=ppt/notesSlides/notesSlide25.xml><?xml version="1.0" encoding="utf-8"?>
 <p:notes xmlns:a="http://schemas.openxmlformats.org/drawingml/2006/main" xmlns:r="http://schemas.openxmlformats.org/officeDocument/2006/relationships" xmlns:p="http://schemas.openxmlformats.org/presentationml/2006/main">
   <p:cSld>
     <p:spTree>
@@ -3446,7 +3335,7 @@
           <a:p>
             <a:fld id="{1C9584DC-3658-4054-9DA4-7B68A1D8CC6D}" type="slidenum">
               <a:rPr lang="zh-CN" altLang="en-US" smtClean="0"/>
-              <a:t>26</a:t>
+              <a:t>25</a:t>
             </a:fld>
             <a:endParaRPr lang="zh-CN" altLang="en-US"/>
           </a:p>
@@ -3456,6 +3345,117 @@
     <p:extLst>
       <p:ext uri="{BB962C8B-B14F-4D97-AF65-F5344CB8AC3E}">
         <p14:creationId xmlns:p14="http://schemas.microsoft.com/office/powerpoint/2010/main" val="4256295583"/>
+      </p:ext>
+    </p:extLst>
+  </p:cSld>
+  <p:clrMapOvr>
+    <a:masterClrMapping/>
+  </p:clrMapOvr>
+</p:notes>
+</file>
+
+<file path=ppt/notesSlides/notesSlide26.xml><?xml version="1.0" encoding="utf-8"?>
+<p:notes xmlns:a="http://schemas.openxmlformats.org/drawingml/2006/main" xmlns:r="http://schemas.openxmlformats.org/officeDocument/2006/relationships" xmlns:p="http://schemas.openxmlformats.org/presentationml/2006/main">
+  <p:cSld>
+    <p:spTree>
+      <p:nvGrpSpPr>
+        <p:cNvPr id="1" name="">
+          <a:extLst>
+            <a:ext uri="{FF2B5EF4-FFF2-40B4-BE49-F238E27FC236}">
+              <a16:creationId xmlns:a16="http://schemas.microsoft.com/office/drawing/2014/main" id="{B2FBB8B7-6C3A-826B-BEDC-11B455E4E59E}"/>
+            </a:ext>
+          </a:extLst>
+        </p:cNvPr>
+        <p:cNvGrpSpPr/>
+        <p:nvPr/>
+      </p:nvGrpSpPr>
+      <p:grpSpPr>
+        <a:xfrm>
+          <a:off x="0" y="0"/>
+          <a:ext cx="0" cy="0"/>
+          <a:chOff x="0" y="0"/>
+          <a:chExt cx="0" cy="0"/>
+        </a:xfrm>
+      </p:grpSpPr>
+      <p:sp>
+        <p:nvSpPr>
+          <p:cNvPr id="2" name="Slide Image Placeholder 1">
+            <a:extLst>
+              <a:ext uri="{FF2B5EF4-FFF2-40B4-BE49-F238E27FC236}">
+                <a16:creationId xmlns:a16="http://schemas.microsoft.com/office/drawing/2014/main" id="{0059D6B3-B338-2117-3D33-BCA332753A2A}"/>
+              </a:ext>
+            </a:extLst>
+          </p:cNvPr>
+          <p:cNvSpPr>
+            <a:spLocks noGrp="1" noRot="1" noChangeAspect="1"/>
+          </p:cNvSpPr>
+          <p:nvPr>
+            <p:ph type="sldImg"/>
+          </p:nvPr>
+        </p:nvSpPr>
+        <p:spPr/>
+      </p:sp>
+      <p:sp>
+        <p:nvSpPr>
+          <p:cNvPr id="3" name="Notes Placeholder 2">
+            <a:extLst>
+              <a:ext uri="{FF2B5EF4-FFF2-40B4-BE49-F238E27FC236}">
+                <a16:creationId xmlns:a16="http://schemas.microsoft.com/office/drawing/2014/main" id="{FF01A163-C2DA-77C8-7422-DB4C8C9F21C5}"/>
+              </a:ext>
+            </a:extLst>
+          </p:cNvPr>
+          <p:cNvSpPr>
+            <a:spLocks noGrp="1"/>
+          </p:cNvSpPr>
+          <p:nvPr>
+            <p:ph type="body" idx="1"/>
+          </p:nvPr>
+        </p:nvSpPr>
+        <p:spPr/>
+        <p:txBody>
+          <a:bodyPr/>
+          <a:lstStyle/>
+          <a:p>
+            <a:r>
+              <a:rPr lang="en-US" dirty="0"/>
+              <a:t>TERMINAL</a:t>
+            </a:r>
+          </a:p>
+        </p:txBody>
+      </p:sp>
+      <p:sp>
+        <p:nvSpPr>
+          <p:cNvPr id="4" name="Slide Number Placeholder 3">
+            <a:extLst>
+              <a:ext uri="{FF2B5EF4-FFF2-40B4-BE49-F238E27FC236}">
+                <a16:creationId xmlns:a16="http://schemas.microsoft.com/office/drawing/2014/main" id="{09D73A9A-D881-2613-9D53-6BBD01037D23}"/>
+              </a:ext>
+            </a:extLst>
+          </p:cNvPr>
+          <p:cNvSpPr>
+            <a:spLocks noGrp="1"/>
+          </p:cNvSpPr>
+          <p:nvPr>
+            <p:ph type="sldNum" sz="quarter" idx="5"/>
+          </p:nvPr>
+        </p:nvSpPr>
+        <p:spPr/>
+        <p:txBody>
+          <a:bodyPr/>
+          <a:lstStyle/>
+          <a:p>
+            <a:fld id="{1C9584DC-3658-4054-9DA4-7B68A1D8CC6D}" type="slidenum">
+              <a:rPr lang="zh-CN" altLang="en-US" smtClean="0"/>
+              <a:t>26</a:t>
+            </a:fld>
+            <a:endParaRPr lang="zh-CN" altLang="en-US"/>
+          </a:p>
+        </p:txBody>
+      </p:sp>
+    </p:spTree>
+    <p:extLst>
+      <p:ext uri="{BB962C8B-B14F-4D97-AF65-F5344CB8AC3E}">
+        <p14:creationId xmlns:p14="http://schemas.microsoft.com/office/powerpoint/2010/main" val="3354523721"/>
       </p:ext>
     </p:extLst>
   </p:cSld>
@@ -5286,108 +5286,68 @@
           <a:lstStyle/>
           <a:p>
             <a:r>
-              <a:t>CUES</a:t>
-            </a:r>
+              <a:rPr lang="en-US" dirty="0"/>
+              <a:t>In the demo, we followed the requests and the data. Now consider what an application can observe when several replicas process a write.</a:t>
+            </a:r>
+          </a:p>
+          <a:p>
             <a:endParaRPr lang="en-US" dirty="0"/>
           </a:p>
           <a:p>
             <a:r>
-              <a:t>Defined means consistent and complete</a:t>
-            </a:r>
+              <a:rPr lang="en-US" dirty="0"/>
+              <a:t>GFS uses two separate terms here. A region is consistent when every client sees the same bytes, no matter which replica it reads. A region is defined when it is consistent and those bytes come from one complete mutation.</a:t>
+            </a:r>
+          </a:p>
+          <a:p>
             <a:endParaRPr lang="en-US" dirty="0"/>
           </a:p>
           <a:p>
             <a:r>
-              <a:t>Consistent means every replica returns the same bytes</a:t>
-            </a:r>
+              <a:rPr lang="en-US" dirty="0"/>
+              <a:t>Suppose one client performs a write and no other write overlaps it. If the write succeeds, all replicas contain the same result, and the result is exactly what that client wrote. The region is defined.</a:t>
+            </a:r>
+          </a:p>
+          <a:p>
             <a:endParaRPr lang="en-US" dirty="0"/>
           </a:p>
           <a:p>
             <a:r>
-              <a:t>Failed mutations may leave replicas different</a:t>
-            </a:r>
+              <a:rPr lang="en-US" dirty="0"/>
+              <a:t>Now suppose two clients write the same region concurrently. The primary still chooses one order for the individual mutations, and every secondary follows that order, so all replicas can end with the same bytes. But a large client write may have been divided into smaller mutations, and pieces from the two writes may be interleaved. Readers agree, but the result may not equal either complete write. GFS calls that consistent but undefined.</a:t>
+            </a:r>
+          </a:p>
+          <a:p>
             <a:endParaRPr lang="en-US" dirty="0"/>
           </a:p>
           <a:p>
+            <a:r>
+              <a:rPr lang="en-US" dirty="0"/>
+              <a:t>If a mutation fails after only some replicas apply it, readers can get different bytes from different replicas. That region is inconsistent.</a:t>
+            </a:r>
+          </a:p>
+          <a:p>
             <a:endParaRPr lang="en-US" dirty="0"/>
           </a:p>
           <a:p>
             <a:r>
-              <a:t>GFS uses precise terms for file regions.</a:t>
-            </a:r>
+              <a:rPr lang="en-US" dirty="0"/>
+              <a:t>So ask two questions separately. Do all readers agree? If they agree, did they receive one complete requested write? Those questions distinguish consistent from defined.</a:t>
+            </a:r>
+          </a:p>
+          <a:p>
             <a:endParaRPr lang="en-US" dirty="0"/>
           </a:p>
           <a:p>
-            <a:endParaRPr lang="en-US" dirty="0"/>
-          </a:p>
-          <a:p>
-            <a:r>
-              <a:t>A region is consistent when every client sees the same data regardless of which replica it reads. A region is defined when it is consistent and the bytes match one complete mutation.</a:t>
-            </a:r>
-            <a:endParaRPr lang="en-US" dirty="0"/>
-          </a:p>
-          <a:p>
-            <a:endParaRPr lang="en-US" dirty="0"/>
-          </a:p>
-          <a:p>
-            <a:r>
-              <a:t>After a successful write with no concurrent writer, the region is defined. After successful concurrent writes, the replicas agree, so the region is consistent, but the bytes may contain fragments from different writes and therefore remain undefined. If a mutation fails, some replicas may have applied it and others may not, leaving the region inconsistent.</a:t>
-            </a:r>
-            <a:endParaRPr lang="en-US" dirty="0"/>
-          </a:p>
-          <a:p>
-            <a:endParaRPr lang="en-US" dirty="0"/>
-          </a:p>
-          <a:p>
-            <a:r>
-              <a:t>This model is weaker than the single-server illusion. Google accepted it because its applications could avoid concurrent overwrites or detect unwanted records with checksums and identifiers.</a:t>
-            </a:r>
-            <a:endParaRPr lang="en-US" dirty="0"/>
-          </a:p>
-          <a:p>
-            <a:endParaRPr lang="en-US" dirty="0"/>
-          </a:p>
-          <a:p>
-            <a:r>
-              <a:t>SOURCE</a:t>
-            </a:r>
-            <a:endParaRPr lang="en-US" dirty="0"/>
-          </a:p>
-          <a:p>
-            <a:r>
-              <a:t>MIT 6.824, Spring 2020, Lecture 3 video, 65:47-75:56.</a:t>
-            </a:r>
-            <a:endParaRPr lang="en-US" dirty="0"/>
-          </a:p>
-          <a:p>
-            <a:r>
-              <a:t>https://www.youtube.com/watch?v=EpIgvowZr00</a:t>
-            </a:r>
-            <a:endParaRPr lang="en-US" dirty="0"/>
-          </a:p>
-          <a:p>
-            <a:r>
-              <a:t>MIT 6.5840, GFS lecture notes.</a:t>
-            </a:r>
-            <a:endParaRPr lang="en-US" dirty="0"/>
-          </a:p>
-          <a:p>
-            <a:r>
-              <a:t>https://pdos.csail.mit.edu/6.824/notes/l-gfs.txt</a:t>
-            </a:r>
-            <a:endParaRPr lang="en-US" dirty="0"/>
-          </a:p>
-          <a:p>
-            <a:r>
-              <a:t>Ghemawat, Gobioff, and Leung, The Google File System, Sections 2.7.1 and 2.7.2.</a:t>
-            </a:r>
-            <a:endParaRPr lang="en-US" dirty="0"/>
-          </a:p>
-          <a:p>
-            <a:r>
-              <a:t>https://pdos.csail.mit.edu/6.824/papers/gfs.pdf</a:t>
-            </a:r>
-            <a:endParaRPr lang="en-US" dirty="0"/>
+            <a:r>
+              <a:rPr lang="en-US" dirty="0"/>
+              <a:t>SOURCE
+MIT 6.824, Spring 2020, Lecture 3 transcript/video, 67:47–75:11.
+Local transcript: fall2026/lectures/references/mit-6824-2020-lecture3-gfs-transcript.txt
+https://www.youtube.com/watch?v=EpIgvowZr00
+Ghemawat, Gobioff, and Leung, The Google File System, Section 2.7.1.
+https://pdos.csail.mit.edu/6.824/papers/gfs.pdf</a:t>
+            </a:r>
           </a:p>
         </p:txBody>
       </p:sp>
@@ -5496,81 +5456,59 @@
           <a:lstStyle/>
           <a:p>
             <a:r>
-              <a:t>This is the concrete failure behind an inconsistent region.</a:t>
-            </a:r>
+              <a:rPr lang="en-US" dirty="0"/>
+              <a:t>Consistent but undefined means that all replicas still agree. Inconsistent content appears when one mutation reaches only part of the replica group.</a:t>
+            </a:r>
+          </a:p>
+          <a:p>
             <a:endParaRPr lang="en-US" dirty="0"/>
           </a:p>
           <a:p>
+            <a:r>
+              <a:rPr lang="en-US" dirty="0"/>
+              <a:t>Suppose the primary applies the mutation and sends it to both secondaries. One secondary writes it, but the other secondary is slow, loses the request, or returns an error. Because every replica did not acknowledge the mutation, the primary reports failure to the client.</a:t>
+            </a:r>
+          </a:p>
+          <a:p>
             <a:endParaRPr lang="en-US" dirty="0"/>
           </a:p>
           <a:p>
             <a:r>
-              <a:t>The primary applies a mutation, but one secondary does not. The secondary may have crashed, run out of disk space, or missed a network message. Because not every replica acknowledged the operation, the primary returns an error to the writer.</a:t>
-            </a:r>
+              <a:rPr lang="en-US" dirty="0"/>
+              <a:t>GFS does not roll back the copies that already changed. A reader that chooses the primary may see the new data, while another reader that chooses the secondary that missed the mutation may see the old data. The replicas now disagree.</a:t>
+            </a:r>
+          </a:p>
+          <a:p>
             <a:endParaRPr lang="en-US" dirty="0"/>
           </a:p>
           <a:p>
+            <a:r>
+              <a:rPr lang="en-US" dirty="0"/>
+              <a:t>Chunk version numbers do not solve this particular case. The master advances a chunk's version when it creates a new lease and replica group. It does not advance the version for every mutation. These replicas can therefore have the same current version number and still differ because one write failed partway through.</a:t>
+            </a:r>
+          </a:p>
+          <a:p>
             <a:endParaRPr lang="en-US" dirty="0"/>
           </a:p>
           <a:p>
             <a:r>
-              <a:t>The partial update still exists. A reader that contacts the primary may see the new bytes, while a reader that contacts the secondary may see the old bytes. GFS does not immediately roll back the successful replicas.</a:t>
-            </a:r>
+              <a:rPr lang="en-US" dirty="0"/>
+              <a:t>The error tells the writer that it cannot rely on that attempt. Retrying may produce a later successful copy, but the partial result from the failed attempt can remain. Record append makes that consequence easy to see.</a:t>
+            </a:r>
+          </a:p>
+          <a:p>
             <a:endParaRPr lang="en-US" dirty="0"/>
           </a:p>
           <a:p>
-            <a:endParaRPr lang="en-US" dirty="0"/>
-          </a:p>
-          <a:p>
-            <a:r>
-              <a:t>The application must treat a failed write as having an uncertain outcome. Retrying may eventually create one successful copy of the record, but earlier partial copies can remain.</a:t>
-            </a:r>
-            <a:endParaRPr lang="en-US" dirty="0"/>
-          </a:p>
-          <a:p>
-            <a:endParaRPr lang="en-US" dirty="0"/>
-          </a:p>
-          <a:p>
-            <a:r>
-              <a:t>SOURCE</a:t>
-            </a:r>
-            <a:endParaRPr lang="en-US" dirty="0"/>
-          </a:p>
-          <a:p>
-            <a:r>
-              <a:t>MIT 6.824, Spring 2020, Lecture 3 video, 50:35-60:46.</a:t>
-            </a:r>
-            <a:endParaRPr lang="en-US" dirty="0"/>
-          </a:p>
-          <a:p>
-            <a:r>
-              <a:t>https://www.youtube.com/watch?v=EpIgvowZr00</a:t>
-            </a:r>
-            <a:endParaRPr lang="en-US" dirty="0"/>
-          </a:p>
-          <a:p>
-            <a:r>
-              <a:t>MIT 6.5840, GFS lecture notes.</a:t>
-            </a:r>
-            <a:endParaRPr lang="en-US" dirty="0"/>
-          </a:p>
-          <a:p>
-            <a:r>
-              <a:t>https://pdos.csail.mit.edu/6.824/notes/l-gfs.txt</a:t>
-            </a:r>
-            <a:endParaRPr lang="en-US" dirty="0"/>
-          </a:p>
-          <a:p>
-            <a:r>
-              <a:t>Ghemawat, Gobioff, and Leung, The Google File System, Sections 2.7 and 3.1.</a:t>
-            </a:r>
-            <a:endParaRPr lang="en-US" dirty="0"/>
-          </a:p>
-          <a:p>
-            <a:r>
-              <a:t>https://pdos.csail.mit.edu/6.824/papers/gfs.pdf</a:t>
-            </a:r>
-            <a:endParaRPr lang="en-US" dirty="0"/>
+            <a:r>
+              <a:rPr lang="en-US" dirty="0"/>
+              <a:t>SOURCE
+MIT 6.824, Spring 2020, Lecture 3 transcript/video, 53:26–60:56 and 67:47–71:49.
+Local transcript: fall2026/lectures/references/mit-6824-2020-lecture3-gfs-transcript.txt
+https://www.youtube.com/watch?v=EpIgvowZr00
+Ghemawat, Gobioff, and Leung, The Google File System, Sections 2.7.1 and 3.1.
+https://pdos.csail.mit.edu/6.824/papers/gfs.pdf</a:t>
+            </a:r>
           </a:p>
         </p:txBody>
       </p:sp>
@@ -5679,72 +5617,59 @@
           <a:lstStyle/>
           <a:p>
             <a:r>
-              <a:t>Large writes can span chunk boundaries, so the client library breaks them into smaller mutations. Two clients performing such writes concurrently can interleave those pieces in different ways.</a:t>
-            </a:r>
+              <a:rPr lang="en-US" dirty="0"/>
+              <a:t>Here is how all replicas can agree on a result that does not equal either client's complete write.</a:t>
+            </a:r>
+          </a:p>
+          <a:p>
             <a:endParaRPr lang="en-US" dirty="0"/>
           </a:p>
           <a:p>
+            <a:r>
+              <a:rPr lang="en-US" dirty="0"/>
+              <a:t>Client one wants to write “ab,” and client two wants to write “xy” over the same region. From the application's point of view, each request looks like one write. Inside the client library, however, a large request may be divided at a chunk boundary or into smaller mutations that GFS can send and retry separately.</a:t>
+            </a:r>
+          </a:p>
+          <a:p>
             <a:endParaRPr lang="en-US" dirty="0"/>
           </a:p>
           <a:p>
             <a:r>
-              <a:t>GFS therefore emphasizes record append for workloads such as logs and producer-consumer queues. With record append, the primary chooses the offset and appends one record atomically. A retry can place the same record more than once, and a failed attempt can leave padding or an incomplete region.</a:t>
-            </a:r>
+              <a:rPr lang="en-US" dirty="0"/>
+              <a:t>The primary orders those smaller mutations. For example, one piece from client two may be followed by one piece from client one. Every secondary applies that same order, so each replica can finish with “xb.” Any reader, on any replica, sees “xb.” The data is therefore consistent.</a:t>
+            </a:r>
+          </a:p>
+          <a:p>
             <a:endParaRPr lang="en-US" dirty="0"/>
           </a:p>
           <a:p>
+            <a:r>
+              <a:rPr lang="en-US" dirty="0"/>
+              <a:t>But “xb” is neither the complete “ab” nor the complete “xy.” GFS cannot tell the application which complete write won, so the region is undefined.</a:t>
+            </a:r>
+          </a:p>
+          <a:p>
             <a:endParaRPr lang="en-US" dirty="0"/>
           </a:p>
           <a:p>
             <a:r>
-              <a:t>Applications can include record identifiers and checksums. Readers then discard padding and duplicate records. This is a clear example of co-design: GFS exposes weaker semantics, and applications include logic that makes those semantics usable.</a:t>
-            </a:r>
+              <a:rPr lang="en-US" dirty="0"/>
+              <a:t>No machine has to fail for this to happen. Concurrent overlapping writes are enough. An application that needs a whole record to appear atomically can use record append, or it can arrange for one writer to own that part of the file.</a:t>
+            </a:r>
+          </a:p>
+          <a:p>
             <a:endParaRPr lang="en-US" dirty="0"/>
           </a:p>
           <a:p>
-            <a:endParaRPr lang="en-US" dirty="0"/>
-          </a:p>
-          <a:p>
-            <a:r>
-              <a:t>SOURCE</a:t>
-            </a:r>
-            <a:endParaRPr lang="en-US" dirty="0"/>
-          </a:p>
-          <a:p>
-            <a:r>
-              <a:t>MIT 6.824, Spring 2020, Lecture 3 video, 65:47-75:56.</a:t>
-            </a:r>
-            <a:endParaRPr lang="en-US" dirty="0"/>
-          </a:p>
-          <a:p>
-            <a:r>
-              <a:t>https://www.youtube.com/watch?v=EpIgvowZr00</a:t>
-            </a:r>
-            <a:endParaRPr lang="en-US" dirty="0"/>
-          </a:p>
-          <a:p>
-            <a:r>
-              <a:t>MIT 6.5840, GFS lecture notes.</a:t>
-            </a:r>
-            <a:endParaRPr lang="en-US" dirty="0"/>
-          </a:p>
-          <a:p>
-            <a:r>
-              <a:t>https://pdos.csail.mit.edu/6.824/notes/l-gfs.txt</a:t>
-            </a:r>
-            <a:endParaRPr lang="en-US" dirty="0"/>
-          </a:p>
-          <a:p>
-            <a:r>
-              <a:t>Ghemawat, Gobioff, and Leung, The Google File System, Sections 2.7.2 and 3.3.</a:t>
-            </a:r>
-            <a:endParaRPr lang="en-US" dirty="0"/>
-          </a:p>
-          <a:p>
-            <a:r>
-              <a:t>https://pdos.csail.mit.edu/6.824/papers/gfs.pdf</a:t>
-            </a:r>
-            <a:endParaRPr lang="en-US" dirty="0"/>
+            <a:r>
+              <a:rPr lang="en-US" dirty="0"/>
+              <a:t>SOURCE
+MIT 6.824, Spring 2020, Lecture 3 transcript/video, 71:49–75:11.
+Local transcript: fall2026/lectures/references/mit-6824-2020-lecture3-gfs-transcript.txt
+https://www.youtube.com/watch?v=EpIgvowZr00
+Ghemawat, Gobioff, and Leung, The Google File System, Sections 2.7.1 and 3.3.
+https://pdos.csail.mit.edu/6.824/papers/gfs.pdf</a:t>
+            </a:r>
           </a:p>
         </p:txBody>
       </p:sp>
@@ -5973,69 +5898,86 @@
           <a:lstStyle/>
           <a:p>
             <a:r>
-              <a:t>Draw this on the board as you go; it is the concrete picture behind the consistency table.</a:t>
-            </a:r>
-            <a:endParaRPr lang="en-US"/>
-          </a:p>
-          <a:p>
-            <a:r>
-              <a:t>The key detail is step 3: the primary does not go back and fix B. It has already picked the offset for C, because appends from many clients are in flight at once and waiting would cost throughput.</a:t>
-            </a:r>
-            <a:endParaRPr lang="en-US"/>
-          </a:p>
-          <a:p>
-            <a:r>
-              <a:t>What the client is promised: if the append returned success, the record is in all replicas at the same offset. If it returned an error, anything is possible, which is why the client retries the whole append.</a:t>
-            </a:r>
-            <a:endParaRPr lang="en-US"/>
-          </a:p>
-          <a:p>
-            <a:r>
-              <a:t>That retry is what produces the duplicate B. An application that cannot live with duplicates has to filter them itself.</a:t>
-            </a:r>
-            <a:endParaRPr lang="en-US"/>
-          </a:p>
-          <a:p>
-            <a:r>
-              <a:t>SOURCE</a:t>
-            </a:r>
-            <a:endParaRPr lang="en-US"/>
-          </a:p>
-          <a:p>
-            <a:r>
-              <a:t>MIT 6.824, Spring 2020, Lecture 3 video, 67:47-75:11.</a:t>
-            </a:r>
-            <a:endParaRPr lang="en-US"/>
-          </a:p>
-          <a:p>
-            <a:r>
-              <a:t>https://www.youtube.com/watch?v=EpIgvowZr00</a:t>
-            </a:r>
-            <a:endParaRPr lang="en-US"/>
-          </a:p>
-          <a:p>
-            <a:r>
-              <a:t>MIT 6.5840, GFS lecture notes.</a:t>
-            </a:r>
-            <a:endParaRPr lang="en-US"/>
-          </a:p>
-          <a:p>
-            <a:r>
-              <a:t>https://pdos.csail.mit.edu/6.824/notes/l-gfs.txt</a:t>
-            </a:r>
-            <a:endParaRPr lang="en-US"/>
-          </a:p>
-          <a:p>
-            <a:r>
-              <a:t>Ghemawat, Gobioff, and Leung, The Google File System, Section 3.3.</a:t>
-            </a:r>
-            <a:endParaRPr lang="en-US"/>
-          </a:p>
-          <a:p>
-            <a:r>
-              <a:t>https://pdos.csail.mit.edu/6.824/papers/gfs.pdf</a:t>
-            </a:r>
-            <a:endParaRPr lang="en-US"/>
+              <a:rPr lang="en-US" dirty="0"/>
+              <a:t>Let us trace three appends across three replicas.</a:t>
+            </a:r>
+          </a:p>
+          <a:p>
+            <a:endParaRPr lang="en-US" dirty="0"/>
+          </a:p>
+          <a:p>
+            <a:r>
+              <a:rPr lang="en-US" dirty="0"/>
+              <a:t>The client first appends record A. The primary chooses the first offset, all three replicas write A there, and the client receives success. At this point the replicas agree.</a:t>
+            </a:r>
+          </a:p>
+          <a:p>
+            <a:endParaRPr lang="en-US" dirty="0"/>
+          </a:p>
+          <a:p>
+            <a:r>
+              <a:rPr lang="en-US" dirty="0"/>
+              <a:t>A second client appends B. The primary and one secondary write B, but the other secondary misses the mutation. The primary returns an error because it did not receive every acknowledgment. The two successful copies do not undo B.</a:t>
+            </a:r>
+          </a:p>
+          <a:p>
+            <a:endParaRPr lang="en-US" dirty="0"/>
+          </a:p>
+          <a:p>
+            <a:r>
+              <a:rPr lang="en-US" dirty="0"/>
+              <a:t>While that client is deciding what to do, another client appends C. For performance, the primary may have many appends in flight. It does not stop the file and resolve B before accepting C. It chooses the next offset and tells every replica to put C there. The replica that missed B leaves padding so that C still lands at the offset chosen by the primary.</a:t>
+            </a:r>
+          </a:p>
+          <a:p>
+            <a:endParaRPr lang="en-US" dirty="0"/>
+          </a:p>
+          <a:p>
+            <a:r>
+              <a:rPr lang="en-US" dirty="0"/>
+              <a:t>The client that received the error for B retries from the beginning. On this attempt all three replicas append B successfully at a later offset.</a:t>
+            </a:r>
+          </a:p>
+          <a:p>
+            <a:endParaRPr lang="en-US" dirty="0"/>
+          </a:p>
+          <a:p>
+            <a:r>
+              <a:rPr lang="en-US" dirty="0"/>
+              <a:t>One replica now contains A, the first B, C, and the retried B. Another contains A, padding where the first B would have been, then C and B. A reader can therefore encounter B twice on one replica, or see only the later copy on another. The relative order of B and C also depends on the replica.</a:t>
+            </a:r>
+          </a:p>
+          <a:p>
+            <a:endParaRPr lang="en-US" dirty="0"/>
+          </a:p>
+          <a:p>
+            <a:r>
+              <a:rPr lang="en-US" dirty="0"/>
+              <a:t>There is a worse case. If the client dies after the failed attempt and never retries, B may remain on only some replicas and never appear on the others.</a:t>
+            </a:r>
+          </a:p>
+          <a:p>
+            <a:endParaRPr lang="en-US" dirty="0"/>
+          </a:p>
+          <a:p>
+            <a:r>
+              <a:rPr lang="en-US" dirty="0"/>
+              <a:t>GFS could wait for every earlier append to finish, or run another protocol to complete or undo a partial mutation. That would require more coordination and would reduce append throughput. GFS instead exposes the uncertain result to the application when it reports an error.</a:t>
+            </a:r>
+          </a:p>
+          <a:p>
+            <a:endParaRPr lang="en-US" dirty="0"/>
+          </a:p>
+          <a:p>
+            <a:r>
+              <a:rPr lang="en-US" dirty="0"/>
+              <a:t>SOURCE
+MIT 6.824, Spring 2020, Lecture 3 transcript/video, 67:47–75:11.
+Local transcript: fall2026/lectures/references/mit-6824-2020-lecture3-gfs-transcript.txt
+https://www.youtube.com/watch?v=EpIgvowZr00
+Ghemawat, Gobioff, and Leung, The Google File System, Sections 2.7 and 3.3.
+https://pdos.csail.mit.edu/6.824/papers/gfs.pdf</a:t>
+            </a:r>
           </a:p>
         </p:txBody>
       </p:sp>
@@ -6144,63 +6086,79 @@
           <a:lstStyle/>
           <a:p>
             <a:r>
-              <a:t>The honest answer to "why is this acceptable" is that the system and its applications were written by the same company, and the applications were written knowing this behaviour.</a:t>
-            </a:r>
-            <a:endParaRPr lang="en-US"/>
-          </a:p>
-          <a:p>
-            <a:r>
-              <a:t>Ask: which of our own project workloads could tolerate a duplicated or reordered record, and which could not?</a:t>
-            </a:r>
-            <a:endParaRPr lang="en-US"/>
-          </a:p>
-          <a:p>
-            <a:r>
-              <a:t>The retrospective interview with a GFS engineer is worth quoting here: the relaxed consistency pushed real work into every application, and with hindsight they would have tightened it.</a:t>
-            </a:r>
-            <a:endParaRPr lang="en-US"/>
-          </a:p>
-          <a:p>
-            <a:r>
-              <a:t>SOURCE</a:t>
-            </a:r>
-            <a:endParaRPr lang="en-US"/>
-          </a:p>
-          <a:p>
-            <a:r>
-              <a:t>MIT 6.5840, GFS lecture notes.</a:t>
-            </a:r>
-            <a:endParaRPr lang="en-US"/>
-          </a:p>
-          <a:p>
-            <a:r>
-              <a:t>https://pdos.csail.mit.edu/6.824/notes/l-gfs.txt</a:t>
-            </a:r>
-            <a:endParaRPr lang="en-US"/>
-          </a:p>
-          <a:p>
-            <a:r>
-              <a:t>Ghemawat, Gobioff, and Leung, The Google File System, Section 2.7.</a:t>
-            </a:r>
-            <a:endParaRPr lang="en-US"/>
-          </a:p>
-          <a:p>
-            <a:r>
-              <a:t>https://pdos.csail.mit.edu/6.824/papers/gfs.pdf</a:t>
-            </a:r>
-            <a:endParaRPr lang="en-US"/>
-          </a:p>
-          <a:p>
-            <a:r>
-              <a:t>ACM Queue, GFS: Evolution on Fast-forward, interview with Sean Quinlan.</a:t>
-            </a:r>
-            <a:endParaRPr lang="en-US"/>
-          </a:p>
-          <a:p>
-            <a:r>
-              <a:t>http://queue.acm.org/detail.cfm?id=1594206</a:t>
-            </a:r>
-            <a:endParaRPr lang="en-US"/>
+              <a:rPr lang="en-US" dirty="0"/>
+              <a:t>These anomalies were acceptable only because GFS was designed for a narrow set of applications that Google controlled.</a:t>
+            </a:r>
+          </a:p>
+          <a:p>
+            <a:endParaRPr lang="en-US" dirty="0"/>
+          </a:p>
+          <a:p>
+            <a:r>
+              <a:rPr lang="en-US" dirty="0"/>
+              <a:t>Many files had one sequential writer. For files with many producers, applications used record append and treated the file as a sequence of self-contained records. Each record could carry a checksum and a unique identifier. A reader could reject an incomplete record, skip padding, and discard a duplicate created by a retry.</a:t>
+            </a:r>
+          </a:p>
+          <a:p>
+            <a:endParaRPr lang="en-US" dirty="0"/>
+          </a:p>
+          <a:p>
+            <a:r>
+              <a:rPr lang="en-US" dirty="0"/>
+              <a:t>Many data-processing jobs already expected retries. MapReduce may run a task again after a worker failure, so applications were often written to recognize repeated work or to regenerate an output partition. That made an at-least-once append easier to tolerate than it would be in a general-purpose file system.</a:t>
+            </a:r>
+          </a:p>
+          <a:p>
+            <a:endParaRPr lang="en-US" dirty="0"/>
+          </a:p>
+          <a:p>
+            <a:r>
+              <a:rPr lang="en-US" dirty="0"/>
+              <a:t>An application that required a strict order could avoid concurrent appends, use one writer, or include sequence numbers and reconstruct the order itself. GFS moved that responsibility into the application so the storage protocol could remain simple and keep many appends in flight.</a:t>
+            </a:r>
+          </a:p>
+          <a:p>
+            <a:endParaRPr lang="en-US" dirty="0"/>
+          </a:p>
+          <a:p>
+            <a:r>
+              <a:rPr lang="en-US" dirty="0"/>
+              <a:t>That choice had a real cost. In the later ACM Queue retrospective, Sean Quinlan said the relaxed record-append semantics were more painful for applications than the designers had expected, and Google narrowed the window in which inconsistencies could appear.</a:t>
+            </a:r>
+          </a:p>
+          <a:p>
+            <a:endParaRPr lang="en-US" dirty="0"/>
+          </a:p>
+          <a:p>
+            <a:r>
+              <a:rPr lang="en-US" dirty="0"/>
+              <a:t>This returns to the tradeoff we introduced earlier. Replication improves availability. Stronger consistency requires more coordination, which costs performance and adds recovery work. GFS chose a point that worked well for its main workloads, while leaving visible anomalies after failures.</a:t>
+            </a:r>
+          </a:p>
+          <a:p>
+            <a:endParaRPr lang="en-US" dirty="0"/>
+          </a:p>
+          <a:p>
+            <a:r>
+              <a:rPr lang="en-US" dirty="0"/>
+              <a:t>We can now examine those failures one at a time, beginning with a client that crashes while a write is in progress.</a:t>
+            </a:r>
+          </a:p>
+          <a:p>
+            <a:endParaRPr lang="en-US" dirty="0"/>
+          </a:p>
+          <a:p>
+            <a:r>
+              <a:rPr lang="en-US" dirty="0"/>
+              <a:t>SOURCE
+MIT 6.824, Spring 2020, Lecture 3 transcript/video, 71:49–80:05.
+Local transcript: fall2026/lectures/references/mit-6824-2020-lecture3-gfs-transcript.txt
+https://www.youtube.com/watch?v=EpIgvowZr00
+Ghemawat, Gobioff, and Leung, The Google File System, Section 2.7.2.
+https://pdos.csail.mit.edu/6.824/papers/gfs.pdf
+McKusick and Quinlan, GFS: Evolution on Fast-forward, ACM Queue, 2009.
+http://queue.acm.org/detail.cfm?id=1594206</a:t>
+            </a:r>
           </a:p>
         </p:txBody>
       </p:sp>
@@ -6492,30 +6450,43 @@
           <a:lstStyle/>
           <a:p>
             <a:r>
+              <a:rPr dirty="0"/>
               <a:t>CUES</a:t>
             </a:r>
             <a:endParaRPr lang="en-US" dirty="0"/>
           </a:p>
           <a:p>
             <a:r>
+              <a:rPr dirty="0"/>
               <a:t>Retry transient failures</a:t>
             </a:r>
             <a:endParaRPr lang="en-US" dirty="0"/>
           </a:p>
           <a:p>
             <a:r>
+              <a:rPr dirty="0"/>
               <a:t>Return an error if a secondary does not acknowledge</a:t>
             </a:r>
             <a:endParaRPr lang="en-US" dirty="0"/>
           </a:p>
           <a:p>
             <a:r>
-              <a:t>Detect dead chunkservers through heartbeats</a:t>
+              <a:rPr dirty="0"/>
+              <a:t>Detect dead </a:t>
+            </a:r>
+            <a:r>
+              <a:rPr dirty="0" err="1"/>
+              <a:t>chunkservers</a:t>
+            </a:r>
+            <a:r>
+              <a:rPr dirty="0"/>
+              <a:t> through heartbeats</a:t>
             </a:r>
             <a:endParaRPr lang="en-US" dirty="0"/>
           </a:p>
           <a:p>
             <a:r>
+              <a:rPr dirty="0"/>
               <a:t>Remove failed replicas and create replacements</a:t>
             </a:r>
             <a:endParaRPr lang="en-US" dirty="0"/>
@@ -6525,6 +6496,7 @@
           </a:p>
           <a:p>
             <a:r>
+              <a:rPr dirty="0"/>
               <a:t>Suppose a secondary crashes while the primary is applying a write. The primary can retry briefly in case the process or network recovers. If the secondary still cannot acknowledge, the primary returns an error to the client, and the client may retry the full operation.</a:t>
             </a:r>
             <a:endParaRPr lang="en-US" dirty="0"/>
@@ -6534,7 +6506,16 @@
           </a:p>
           <a:p>
             <a:r>
-              <a:t>Separately, the master exchanges heartbeat messages with every chunkserver. When it decides that a server has failed, it removes that server from the replica-location lists and schedules new replicas to restore the target replication level.</a:t>
+              <a:rPr dirty="0"/>
+              <a:t>Separately, the master exchanges heartbeat messages with every </a:t>
+            </a:r>
+            <a:r>
+              <a:rPr dirty="0" err="1"/>
+              <a:t>chunkserver</a:t>
+            </a:r>
+            <a:r>
+              <a:rPr dirty="0"/>
+              <a:t>. When it decides that a server has failed, it removes that server from the replica-location lists and schedules new replicas to restore the target replication level.</a:t>
             </a:r>
             <a:endParaRPr lang="en-US" dirty="0"/>
           </a:p>
@@ -6543,6 +6524,7 @@
           </a:p>
           <a:p>
             <a:r>
+              <a:rPr dirty="0"/>
               <a:t>A newly chosen replica group receives a new chunk version. That version lets the master exclude a server that later returns with a stale copy.</a:t>
             </a:r>
             <a:endParaRPr lang="en-US" dirty="0"/>
@@ -6552,43 +6534,98 @@
           </a:p>
           <a:p>
             <a:r>
+              <a:rPr dirty="0"/>
               <a:t>SOURCE</a:t>
             </a:r>
             <a:endParaRPr lang="en-US" dirty="0"/>
           </a:p>
           <a:p>
             <a:r>
+              <a:rPr dirty="0"/>
               <a:t>MIT 6.824, Spring 2020, Lecture 3 video, 60:46-65:47.</a:t>
             </a:r>
             <a:endParaRPr lang="en-US" dirty="0"/>
           </a:p>
           <a:p>
             <a:r>
-              <a:t>https://www.youtube.com/watch?v=EpIgvowZr00</a:t>
+              <a:rPr dirty="0"/>
+              <a:t>https://</a:t>
+            </a:r>
+            <a:r>
+              <a:rPr dirty="0" err="1"/>
+              <a:t>www.youtube.com</a:t>
+            </a:r>
+            <a:r>
+              <a:rPr dirty="0"/>
+              <a:t>/</a:t>
+            </a:r>
+            <a:r>
+              <a:rPr dirty="0" err="1"/>
+              <a:t>watch?v</a:t>
+            </a:r>
+            <a:r>
+              <a:rPr dirty="0"/>
+              <a:t>=EpIgvowZr00</a:t>
             </a:r>
             <a:endParaRPr lang="en-US" dirty="0"/>
           </a:p>
           <a:p>
             <a:r>
+              <a:rPr dirty="0"/>
               <a:t>MIT 6.5840, GFS lecture notes.</a:t>
             </a:r>
             <a:endParaRPr lang="en-US" dirty="0"/>
           </a:p>
           <a:p>
             <a:r>
-              <a:t>https://pdos.csail.mit.edu/6.824/notes/l-gfs.txt</a:t>
+              <a:rPr dirty="0"/>
+              <a:t>https://</a:t>
+            </a:r>
+            <a:r>
+              <a:rPr dirty="0" err="1"/>
+              <a:t>pdos.csail.mit.edu</a:t>
+            </a:r>
+            <a:r>
+              <a:rPr dirty="0"/>
+              <a:t>/6.824/notes/l-</a:t>
+            </a:r>
+            <a:r>
+              <a:rPr dirty="0" err="1"/>
+              <a:t>gfs.txt</a:t>
             </a:r>
             <a:endParaRPr lang="en-US" dirty="0"/>
           </a:p>
           <a:p>
             <a:r>
-              <a:t>Ghemawat, Gobioff, and Leung, The Google File System, Sections 4.3 and 4.5.</a:t>
+              <a:rPr dirty="0"/>
+              <a:t>Ghemawat, </a:t>
+            </a:r>
+            <a:r>
+              <a:rPr dirty="0" err="1"/>
+              <a:t>Gobioff</a:t>
+            </a:r>
+            <a:r>
+              <a:rPr dirty="0"/>
+              <a:t>, and Leung, The Google File System, Sections 4.3 and 4.5.</a:t>
             </a:r>
             <a:endParaRPr lang="en-US" dirty="0"/>
           </a:p>
           <a:p>
             <a:r>
-              <a:t>https://pdos.csail.mit.edu/6.824/papers/gfs.pdf</a:t>
+              <a:rPr dirty="0"/>
+              <a:t>https://</a:t>
+            </a:r>
+            <a:r>
+              <a:rPr dirty="0" err="1"/>
+              <a:t>pdos.csail.mit.edu</a:t>
+            </a:r>
+            <a:r>
+              <a:rPr dirty="0"/>
+              <a:t>/6.824/papers/</a:t>
+            </a:r>
+            <a:r>
+              <a:rPr dirty="0" err="1"/>
+              <a:t>gfs.pdf</a:t>
             </a:r>
             <a:endParaRPr lang="en-US" dirty="0"/>
           </a:p>
@@ -6699,6 +6736,7 @@
           <a:lstStyle/>
           <a:p>
             <a:r>
+              <a:rPr dirty="0"/>
               <a:t>Re-replication is necessary, but it consumes real time and bandwidth.</a:t>
             </a:r>
             <a:endParaRPr lang="en-US" dirty="0"/>
@@ -6708,6 +6746,7 @@
           </a:p>
           <a:p>
             <a:r>
+              <a:rPr dirty="0"/>
               <a:t>The historical example on the slide shows the scale. Copying an 80-gigabyte disk over a 10-megabyte-per-second link can take hours. A server that misses one heartbeat may simply be restarting, so immediate reconstruction could waste that copying work.</a:t>
             </a:r>
             <a:endParaRPr lang="en-US" dirty="0"/>
@@ -6717,6 +6756,7 @@
           </a:p>
           <a:p>
             <a:r>
+              <a:rPr dirty="0"/>
               <a:t>Waiting too long creates a different risk. While a chunk has fewer replicas, another disk or machine failure could destroy the remaining copies. The master therefore prioritizes re-replication based on factors such as how far a chunk has fallen below its target and whether it blocks important jobs.</a:t>
             </a:r>
             <a:endParaRPr lang="en-US" dirty="0"/>
@@ -6726,6 +6766,7 @@
           </a:p>
           <a:p>
             <a:r>
+              <a:rPr dirty="0"/>
               <a:t>This is a general failure-detector tradeoff. Fast suspicion improves recovery time, while conservative suspicion avoids unnecessary reconfiguration.</a:t>
             </a:r>
             <a:endParaRPr lang="en-US" dirty="0"/>
@@ -6735,43 +6776,98 @@
           </a:p>
           <a:p>
             <a:r>
+              <a:rPr dirty="0"/>
               <a:t>SOURCE</a:t>
             </a:r>
             <a:endParaRPr lang="en-US" dirty="0"/>
           </a:p>
           <a:p>
             <a:r>
+              <a:rPr dirty="0"/>
               <a:t>MIT 6.824, Spring 2020, Lecture 3 video, 60:46-65:47.</a:t>
             </a:r>
             <a:endParaRPr lang="en-US" dirty="0"/>
           </a:p>
           <a:p>
             <a:r>
-              <a:t>https://www.youtube.com/watch?v=EpIgvowZr00</a:t>
+              <a:rPr dirty="0"/>
+              <a:t>https://</a:t>
+            </a:r>
+            <a:r>
+              <a:rPr dirty="0" err="1"/>
+              <a:t>www.youtube.com</a:t>
+            </a:r>
+            <a:r>
+              <a:rPr dirty="0"/>
+              <a:t>/</a:t>
+            </a:r>
+            <a:r>
+              <a:rPr dirty="0" err="1"/>
+              <a:t>watch?v</a:t>
+            </a:r>
+            <a:r>
+              <a:rPr dirty="0"/>
+              <a:t>=EpIgvowZr00</a:t>
             </a:r>
             <a:endParaRPr lang="en-US" dirty="0"/>
           </a:p>
           <a:p>
             <a:r>
+              <a:rPr dirty="0"/>
               <a:t>MIT 6.5840, GFS lecture notes.</a:t>
             </a:r>
             <a:endParaRPr lang="en-US" dirty="0"/>
           </a:p>
           <a:p>
             <a:r>
-              <a:t>https://pdos.csail.mit.edu/6.824/notes/l-gfs.txt</a:t>
+              <a:rPr dirty="0"/>
+              <a:t>https://</a:t>
+            </a:r>
+            <a:r>
+              <a:rPr dirty="0" err="1"/>
+              <a:t>pdos.csail.mit.edu</a:t>
+            </a:r>
+            <a:r>
+              <a:rPr dirty="0"/>
+              <a:t>/6.824/notes/l-</a:t>
+            </a:r>
+            <a:r>
+              <a:rPr dirty="0" err="1"/>
+              <a:t>gfs.txt</a:t>
             </a:r>
             <a:endParaRPr lang="en-US" dirty="0"/>
           </a:p>
           <a:p>
             <a:r>
-              <a:t>Ghemawat, Gobioff, and Leung, The Google File System, Section 4.3.</a:t>
+              <a:rPr dirty="0"/>
+              <a:t>Ghemawat, </a:t>
+            </a:r>
+            <a:r>
+              <a:rPr dirty="0" err="1"/>
+              <a:t>Gobioff</a:t>
+            </a:r>
+            <a:r>
+              <a:rPr dirty="0"/>
+              <a:t>, and Leung, The Google File System, Section 4.3.</a:t>
             </a:r>
             <a:endParaRPr lang="en-US" dirty="0"/>
           </a:p>
           <a:p>
             <a:r>
-              <a:t>https://pdos.csail.mit.edu/6.824/papers/gfs.pdf</a:t>
+              <a:rPr dirty="0"/>
+              <a:t>https://</a:t>
+            </a:r>
+            <a:r>
+              <a:rPr dirty="0" err="1"/>
+              <a:t>pdos.csail.mit.edu</a:t>
+            </a:r>
+            <a:r>
+              <a:rPr dirty="0"/>
+              <a:t>/6.824/papers/</a:t>
+            </a:r>
+            <a:r>
+              <a:rPr dirty="0" err="1"/>
+              <a:t>gfs.pdf</a:t>
             </a:r>
             <a:endParaRPr lang="en-US" dirty="0"/>
           </a:p>
@@ -6882,6 +6978,7 @@
           <a:lstStyle/>
           <a:p>
             <a:r>
+              <a:rPr dirty="0"/>
               <a:t>The primary for a chunk can fail, but the master cannot instantly know whether it crashed or merely became unreachable from part of the network.</a:t>
             </a:r>
             <a:endParaRPr lang="en-US" dirty="0"/>
@@ -6891,6 +6988,7 @@
           </a:p>
           <a:p>
             <a:r>
+              <a:rPr dirty="0"/>
               <a:t>If the master immediately appoints a replacement while the old primary still serves some clients, both servers may accept writes. The replicas then follow two independent orders. This is split brain.</a:t>
             </a:r>
             <a:endParaRPr lang="en-US" dirty="0"/>
@@ -6900,6 +6998,7 @@
           </a:p>
           <a:p>
             <a:r>
+              <a:rPr dirty="0"/>
               <a:t>Client caching makes the problem harder. A client may hold recently issued information that still names the old primary. Even if the master has changed its answer, an in-flight or cached response can direct that client to the old server.</a:t>
             </a:r>
             <a:endParaRPr lang="en-US" dirty="0"/>
@@ -6909,6 +7008,7 @@
           </a:p>
           <a:p>
             <a:r>
+              <a:rPr dirty="0"/>
               <a:t>GFS needs a rule that limits how long any primary can continue acting without renewed permission.</a:t>
             </a:r>
             <a:endParaRPr lang="en-US" dirty="0"/>
@@ -6918,43 +7018,98 @@
           </a:p>
           <a:p>
             <a:r>
+              <a:rPr dirty="0"/>
               <a:t>SOURCE</a:t>
             </a:r>
             <a:endParaRPr lang="en-US" dirty="0"/>
           </a:p>
           <a:p>
             <a:r>
+              <a:rPr dirty="0"/>
               <a:t>MIT 6.824, Spring 2020, Lecture 3 video, 60:46-70:49.</a:t>
             </a:r>
             <a:endParaRPr lang="en-US" dirty="0"/>
           </a:p>
           <a:p>
             <a:r>
-              <a:t>https://www.youtube.com/watch?v=EpIgvowZr00</a:t>
+              <a:rPr dirty="0"/>
+              <a:t>https://</a:t>
+            </a:r>
+            <a:r>
+              <a:rPr dirty="0" err="1"/>
+              <a:t>www.youtube.com</a:t>
+            </a:r>
+            <a:r>
+              <a:rPr dirty="0"/>
+              <a:t>/</a:t>
+            </a:r>
+            <a:r>
+              <a:rPr dirty="0" err="1"/>
+              <a:t>watch?v</a:t>
+            </a:r>
+            <a:r>
+              <a:rPr dirty="0"/>
+              <a:t>=EpIgvowZr00</a:t>
             </a:r>
             <a:endParaRPr lang="en-US" dirty="0"/>
           </a:p>
           <a:p>
             <a:r>
+              <a:rPr dirty="0"/>
               <a:t>MIT 6.5840, GFS lecture notes.</a:t>
             </a:r>
             <a:endParaRPr lang="en-US" dirty="0"/>
           </a:p>
           <a:p>
             <a:r>
-              <a:t>https://pdos.csail.mit.edu/6.824/notes/l-gfs.txt</a:t>
+              <a:rPr dirty="0"/>
+              <a:t>https://</a:t>
+            </a:r>
+            <a:r>
+              <a:rPr dirty="0" err="1"/>
+              <a:t>pdos.csail.mit.edu</a:t>
+            </a:r>
+            <a:r>
+              <a:rPr dirty="0"/>
+              <a:t>/6.824/notes/l-</a:t>
+            </a:r>
+            <a:r>
+              <a:rPr dirty="0" err="1"/>
+              <a:t>gfs.txt</a:t>
             </a:r>
             <a:endParaRPr lang="en-US" dirty="0"/>
           </a:p>
           <a:p>
             <a:r>
-              <a:t>Ghemawat, Gobioff, and Leung, The Google File System, Sections 3.1 and 4.5.</a:t>
+              <a:rPr dirty="0"/>
+              <a:t>Ghemawat, </a:t>
+            </a:r>
+            <a:r>
+              <a:rPr dirty="0" err="1"/>
+              <a:t>Gobioff</a:t>
+            </a:r>
+            <a:r>
+              <a:rPr dirty="0"/>
+              <a:t>, and Leung, The Google File System, Sections 3.1 and 4.5.</a:t>
             </a:r>
             <a:endParaRPr lang="en-US" dirty="0"/>
           </a:p>
           <a:p>
             <a:r>
-              <a:t>https://pdos.csail.mit.edu/6.824/papers/gfs.pdf</a:t>
+              <a:rPr dirty="0"/>
+              <a:t>https://</a:t>
+            </a:r>
+            <a:r>
+              <a:rPr dirty="0" err="1"/>
+              <a:t>pdos.csail.mit.edu</a:t>
+            </a:r>
+            <a:r>
+              <a:rPr dirty="0"/>
+              <a:t>/6.824/papers/</a:t>
+            </a:r>
+            <a:r>
+              <a:rPr dirty="0" err="1"/>
+              <a:t>gfs.pdf</a:t>
             </a:r>
             <a:endParaRPr lang="en-US" dirty="0"/>
           </a:p>
@@ -12904,7 +13059,7 @@
         </p:spPr>
         <p:txBody>
           <a:bodyPr>
-            <a:normAutofit/>
+            <a:normAutofit fontScale="92500" lnSpcReduction="10000"/>
           </a:bodyPr>
           <a:lstStyle/>
           <a:p>
@@ -13488,7 +13643,7 @@
         </p:spPr>
         <p:txBody>
           <a:bodyPr>
-            <a:normAutofit/>
+            <a:normAutofit fontScale="92500" lnSpcReduction="20000"/>
           </a:bodyPr>
           <a:lstStyle/>
           <a:p>
@@ -13583,7 +13738,7 @@
         </p:spPr>
         <p:txBody>
           <a:bodyPr>
-            <a:normAutofit/>
+            <a:normAutofit fontScale="92500" lnSpcReduction="10000"/>
           </a:bodyPr>
           <a:lstStyle/>
           <a:p>
@@ -16628,7 +16783,7 @@
         </p:spPr>
         <p:txBody>
           <a:bodyPr>
-            <a:normAutofit/>
+            <a:normAutofit fontScale="92500" lnSpcReduction="10000"/>
           </a:bodyPr>
           <a:lstStyle/>
           <a:p>
@@ -17079,7 +17234,7 @@
         </p:spPr>
         <p:txBody>
           <a:bodyPr>
-            <a:normAutofit/>
+            <a:normAutofit fontScale="92500" lnSpcReduction="20000"/>
           </a:bodyPr>
           <a:lstStyle/>
           <a:p>
@@ -17174,7 +17329,7 @@
         </p:spPr>
         <p:txBody>
           <a:bodyPr>
-            <a:normAutofit/>
+            <a:normAutofit fontScale="92500" lnSpcReduction="10000"/>
           </a:bodyPr>
           <a:lstStyle/>
           <a:p>
@@ -18881,831 +19036,6 @@
         <p:cNvPr id="1" name="">
           <a:extLst>
             <a:ext uri="{FF2B5EF4-FFF2-40B4-BE49-F238E27FC236}">
-              <a16:creationId xmlns:a16="http://schemas.microsoft.com/office/drawing/2014/main" id="{872729AB-5EBB-FD20-43DD-D6E0374E6833}"/>
-            </a:ext>
-          </a:extLst>
-        </p:cNvPr>
-        <p:cNvGrpSpPr/>
-        <p:nvPr/>
-      </p:nvGrpSpPr>
-      <p:grpSpPr>
-        <a:xfrm>
-          <a:off x="0" y="0"/>
-          <a:ext cx="0" cy="0"/>
-          <a:chOff x="0" y="0"/>
-          <a:chExt cx="0" cy="0"/>
-        </a:xfrm>
-      </p:grpSpPr>
-      <p:sp>
-        <p:nvSpPr>
-          <p:cNvPr id="7" name="Title 1">
-            <a:extLst>
-              <a:ext uri="{FF2B5EF4-FFF2-40B4-BE49-F238E27FC236}">
-                <a16:creationId xmlns:a16="http://schemas.microsoft.com/office/drawing/2014/main" id="{2ED557C7-2CDD-8C0B-07A1-1DABA8EF652A}"/>
-              </a:ext>
-            </a:extLst>
-          </p:cNvPr>
-          <p:cNvSpPr>
-            <a:spLocks noGrp="1"/>
-          </p:cNvSpPr>
-          <p:nvPr>
-            <p:ph type="title"/>
-          </p:nvPr>
-        </p:nvSpPr>
-        <p:spPr>
-          <a:xfrm>
-            <a:off x="0" y="1"/>
-            <a:ext cx="12191999" cy="914400"/>
-          </a:xfrm>
-        </p:spPr>
-        <p:txBody>
-          <a:bodyPr>
-            <a:normAutofit/>
-          </a:bodyPr>
-          <a:lstStyle/>
-          <a:p>
-            <a:pPr algn="ctr"/>
-            <a:r>
-              <a:rPr lang="en-US" b="1" dirty="0">
-                <a:latin typeface="Helvetica" panose="020B0604020202020204" pitchFamily="34" charset="0"/>
-                <a:cs typeface="Helvetica" panose="020B0604020202020204" pitchFamily="34" charset="0"/>
-              </a:rPr>
-              <a:t>Demo 1: HDFS</a:t>
-            </a:r>
-          </a:p>
-        </p:txBody>
-      </p:sp>
-      <p:sp>
-        <p:nvSpPr>
-          <p:cNvPr id="8" name="Slide Number Placeholder 4">
-            <a:extLst>
-              <a:ext uri="{FF2B5EF4-FFF2-40B4-BE49-F238E27FC236}">
-                <a16:creationId xmlns:a16="http://schemas.microsoft.com/office/drawing/2014/main" id="{25E098EE-1299-32C0-2821-1DB599BAC8E9}"/>
-              </a:ext>
-            </a:extLst>
-          </p:cNvPr>
-          <p:cNvSpPr>
-            <a:spLocks noGrp="1"/>
-          </p:cNvSpPr>
-          <p:nvPr>
-            <p:ph type="sldNum" sz="quarter" idx="12"/>
-          </p:nvPr>
-        </p:nvSpPr>
-        <p:spPr>
-          <a:xfrm>
-            <a:off x="8610600" y="6356350"/>
-            <a:ext cx="2743200" cy="365125"/>
-          </a:xfrm>
-        </p:spPr>
-        <p:txBody>
-          <a:bodyPr/>
-          <a:lstStyle/>
-          <a:p>
-            <a:fld id="{212DA15D-5F50-8B40-811F-34F736B90848}" type="slidenum">
-              <a:rPr lang="en-US" smtClean="0"/>
-              <a:t>19</a:t>
-            </a:fld>
-            <a:endParaRPr lang="en-US"/>
-          </a:p>
-        </p:txBody>
-      </p:sp>
-      <p:sp>
-        <p:nvSpPr>
-          <p:cNvPr id="3" name="TextBox 2">
-            <a:extLst>
-              <a:ext uri="{FF2B5EF4-FFF2-40B4-BE49-F238E27FC236}">
-                <a16:creationId xmlns:a16="http://schemas.microsoft.com/office/drawing/2014/main" id="{857EC8A2-DB9F-8BB1-7445-FE716E76BAC5}"/>
-              </a:ext>
-            </a:extLst>
-          </p:cNvPr>
-          <p:cNvSpPr txBox="1"/>
-          <p:nvPr/>
-        </p:nvSpPr>
-        <p:spPr>
-          <a:xfrm>
-            <a:off x="88134" y="914401"/>
-            <a:ext cx="11872217" cy="4585871"/>
-          </a:xfrm>
-          <a:prstGeom prst="rect">
-            <a:avLst/>
-          </a:prstGeom>
-          <a:noFill/>
-        </p:spPr>
-        <p:txBody>
-          <a:bodyPr wrap="square" rtlCol="0">
-            <a:spAutoFit/>
-          </a:bodyPr>
-          <a:lstStyle/>
-          <a:p>
-            <a:r>
-              <a:rPr lang="en-US" sz="3200" b="1" dirty="0"/>
-              <a:t>HDFS is the open-source clone of GFS</a:t>
-            </a:r>
-          </a:p>
-          <a:p>
-            <a:pPr marL="914400" indent="-457200">
-              <a:buFont typeface="Arial" panose="020B0604020202020204" pitchFamily="34" charset="0"/>
-              <a:buChar char="•"/>
-            </a:pPr>
-            <a:r>
-              <a:rPr lang="en-US" sz="2800" b="0" dirty="0"/>
-              <a:t>One NameNode: the master, names and metadata only</a:t>
-            </a:r>
-          </a:p>
-          <a:p>
-            <a:pPr marL="914400" indent="-457200">
-              <a:buFont typeface="Arial" panose="020B0604020202020204" pitchFamily="34" charset="0"/>
-              <a:buChar char="•"/>
-            </a:pPr>
-            <a:r>
-              <a:rPr lang="en-US" sz="2800" b="0" dirty="0"/>
-              <a:t>Three DataNodes: the chunkservers, data only</a:t>
-            </a:r>
-          </a:p>
-          <a:p>
-            <a:pPr marL="914400" indent="-457200">
-              <a:buFont typeface="Arial" panose="020B0604020202020204" pitchFamily="34" charset="0"/>
-              <a:buChar char="•"/>
-            </a:pPr>
-            <a:endParaRPr lang="en-US" sz="2800" b="0" dirty="0"/>
-          </a:p>
-          <a:p>
-            <a:r>
-              <a:rPr lang="en-US" sz="3200" b="1" dirty="0"/>
-              <a:t>What to watch</a:t>
-            </a:r>
-          </a:p>
-          <a:p>
-            <a:pPr marL="914400" indent="-457200">
-              <a:buFont typeface="Arial" panose="020B0604020202020204" pitchFamily="34" charset="0"/>
-              <a:buChar char="•"/>
-            </a:pPr>
-            <a:r>
-              <a:rPr lang="en-US" sz="2800" b="0" dirty="0"/>
-              <a:t>A 100 MB file becomes 7 blocks, each stored on two servers</a:t>
-            </a:r>
-          </a:p>
-          <a:p>
-            <a:pPr marL="914400" indent="-457200">
-              <a:buFont typeface="Arial" panose="020B0604020202020204" pitchFamily="34" charset="0"/>
-              <a:buChar char="•"/>
-            </a:pPr>
-            <a:r>
-              <a:rPr lang="en-US" sz="2800" b="0" dirty="0"/>
-              <a:t>The master knows block ids and locations, and never touches the data</a:t>
-            </a:r>
-          </a:p>
-          <a:p>
-            <a:pPr marL="914400" indent="-457200">
-              <a:buFont typeface="Arial" panose="020B0604020202020204" pitchFamily="34" charset="0"/>
-              <a:buChar char="•"/>
-            </a:pPr>
-            <a:r>
-              <a:rPr lang="en-US" sz="2800" b="0" dirty="0"/>
-              <a:t>On a DataNode, a block is an ordinary file on local disk</a:t>
-            </a:r>
-          </a:p>
-          <a:p>
-            <a:pPr marL="914400" indent="-457200">
-              <a:buFont typeface="Arial" panose="020B0604020202020204" pitchFamily="34" charset="0"/>
-              <a:buChar char="•"/>
-            </a:pPr>
-            <a:endParaRPr lang="en-US" sz="2800" b="0" dirty="0"/>
-          </a:p>
-          <a:p>
-            <a:r>
-              <a:rPr lang="en-US" sz="3200" b="1" dirty="0"/>
-              <a:t>Then one server dies and the replicas rebuild themselves</a:t>
-            </a:r>
-          </a:p>
-        </p:txBody>
-      </p:sp>
-    </p:spTree>
-    <p:extLst>
-      <p:ext uri="{BB962C8B-B14F-4D97-AF65-F5344CB8AC3E}">
-        <p14:creationId xmlns:p14="http://schemas.microsoft.com/office/powerpoint/2010/main" val="1720670694"/>
-      </p:ext>
-    </p:extLst>
-  </p:cSld>
-  <p:clrMapOvr>
-    <a:masterClrMapping/>
-  </p:clrMapOvr>
-</p:sld>
-</file>
-
-<file path=ppt/slides/slide2.xml><?xml version="1.0" encoding="utf-8"?>
-<p:sld xmlns:a="http://schemas.openxmlformats.org/drawingml/2006/main" xmlns:r="http://schemas.openxmlformats.org/officeDocument/2006/relationships" xmlns:p="http://schemas.openxmlformats.org/presentationml/2006/main">
-  <p:cSld>
-    <p:spTree>
-      <p:nvGrpSpPr>
-        <p:cNvPr id="1" name=""/>
-        <p:cNvGrpSpPr/>
-        <p:nvPr/>
-      </p:nvGrpSpPr>
-      <p:grpSpPr>
-        <a:xfrm>
-          <a:off x="0" y="0"/>
-          <a:ext cx="0" cy="0"/>
-          <a:chOff x="0" y="0"/>
-          <a:chExt cx="0" cy="0"/>
-        </a:xfrm>
-      </p:grpSpPr>
-      <p:sp>
-        <p:nvSpPr>
-          <p:cNvPr id="7" name="Title 1">
-            <a:extLst>
-              <a:ext uri="{FF2B5EF4-FFF2-40B4-BE49-F238E27FC236}">
-                <a16:creationId xmlns:a16="http://schemas.microsoft.com/office/drawing/2014/main" id="{2ED557C7-2CDD-8C0B-07A1-1DABA8EF652A}"/>
-              </a:ext>
-            </a:extLst>
-          </p:cNvPr>
-          <p:cNvSpPr>
-            <a:spLocks noGrp="1"/>
-          </p:cNvSpPr>
-          <p:nvPr>
-            <p:ph type="title"/>
-          </p:nvPr>
-        </p:nvSpPr>
-        <p:spPr>
-          <a:xfrm>
-            <a:off x="0" y="1"/>
-            <a:ext cx="12191999" cy="914400"/>
-          </a:xfrm>
-        </p:spPr>
-        <p:txBody>
-          <a:bodyPr>
-            <a:normAutofit/>
-          </a:bodyPr>
-          <a:lstStyle/>
-          <a:p>
-            <a:pPr algn="ctr">
-              <a:buNone/>
-            </a:pPr>
-            <a:r>
-              <a:rPr b="1">
-                <a:latin typeface="Helvetica"/>
-                <a:ea typeface="Helvetica"/>
-                <a:cs typeface="Helvetica"/>
-              </a:rPr>
-              <a:t>Demo 1: Design Proposal</a:t>
-            </a:r>
-          </a:p>
-        </p:txBody>
-      </p:sp>
-      <p:sp>
-        <p:nvSpPr>
-          <p:cNvPr id="8" name="Slide Number Placeholder 4">
-            <a:extLst>
-              <a:ext uri="{FF2B5EF4-FFF2-40B4-BE49-F238E27FC236}">
-                <a16:creationId xmlns:a16="http://schemas.microsoft.com/office/drawing/2014/main" id="{25E098EE-1299-32C0-2821-1DB599BAC8E9}"/>
-              </a:ext>
-            </a:extLst>
-          </p:cNvPr>
-          <p:cNvSpPr>
-            <a:spLocks noGrp="1"/>
-          </p:cNvSpPr>
-          <p:nvPr>
-            <p:ph type="sldNum" idx="12"/>
-          </p:nvPr>
-        </p:nvSpPr>
-        <p:spPr>
-          <a:xfrm>
-            <a:off x="8610600" y="6356350"/>
-            <a:ext cx="2743200" cy="365125"/>
-          </a:xfrm>
-        </p:spPr>
-        <p:txBody>
-          <a:bodyPr/>
-          <a:lstStyle/>
-          <a:p>
-            <a:fld id="{212DA15D-5F50-8B40-811F-34F736B90848}" type="slidenum">
-              <a:rPr/>
-              <a:t>2</a:t>
-            </a:fld>
-            <a:endParaRPr/>
-          </a:p>
-        </p:txBody>
-      </p:sp>
-      <p:sp>
-        <p:nvSpPr>
-          <p:cNvPr id="9" name="Demo 1 deadline">
-            <a:extLst>
-              <a:ext uri="{FF2B5EF4-FFF2-40B4-BE49-F238E27FC236}">
-                <a16:creationId xmlns:a16="http://schemas.microsoft.com/office/drawing/2014/main" id="{28A03A3E-853D-4FA2-AE8E-9CDFB2A1C51A}"/>
-              </a:ext>
-            </a:extLst>
-          </p:cNvPr>
-          <p:cNvSpPr>
-            <a:spLocks noGrp="1"/>
-          </p:cNvSpPr>
-          <p:nvPr/>
-        </p:nvSpPr>
-        <p:spPr>
-          <a:xfrm>
-            <a:off x="361950" y="933450"/>
-            <a:ext cx="11468100" cy="457200"/>
-          </a:xfrm>
-          <a:prstGeom prst="rect">
-            <a:avLst/>
-          </a:prstGeom>
-          <a:noFill/>
-          <a:ln w="0">
-            <a:noFill/>
-            <a:prstDash val="solid"/>
-          </a:ln>
-        </p:spPr>
-        <p:txBody>
-          <a:bodyPr>
-            <a:normAutofit/>
-          </a:bodyPr>
-          <a:lstStyle/>
-          <a:p>
-            <a:pPr algn="ctr">
-              <a:defRPr sz="2250" b="1">
-                <a:solidFill>
-                  <a:srgbClr val="000000"/>
-                </a:solidFill>
-                <a:latin typeface="Helvetica"/>
-                <a:ea typeface="Helvetica"/>
-                <a:cs typeface="Helvetica"/>
-              </a:defRPr>
-            </a:pPr>
-            <a:r>
-              <a:rPr sz="2250" b="1">
-                <a:solidFill>
-                  <a:srgbClr val="000000"/>
-                </a:solidFill>
-                <a:latin typeface="Helvetica"/>
-                <a:ea typeface="Helvetica"/>
-                <a:cs typeface="Helvetica"/>
-              </a:rPr>
-              <a:t>Wednesday 09/23, due 12:00 noon in branch demo-1</a:t>
-            </a:r>
-          </a:p>
-        </p:txBody>
-      </p:sp>
-      <p:sp>
-        <p:nvSpPr>
-          <p:cNvPr id="10" name="Lab day notice">
-            <a:extLst>
-              <a:ext uri="{FF2B5EF4-FFF2-40B4-BE49-F238E27FC236}">
-                <a16:creationId xmlns:a16="http://schemas.microsoft.com/office/drawing/2014/main" id="{F0C367EF-21EA-42FF-BA10-C1A905D549A5}"/>
-              </a:ext>
-            </a:extLst>
-          </p:cNvPr>
-          <p:cNvSpPr>
-            <a:spLocks noGrp="1"/>
-          </p:cNvSpPr>
-          <p:nvPr/>
-        </p:nvSpPr>
-        <p:spPr>
-          <a:xfrm>
-            <a:off x="361950" y="1352550"/>
-            <a:ext cx="11468100" cy="400050"/>
-          </a:xfrm>
-          <a:prstGeom prst="rect">
-            <a:avLst/>
-          </a:prstGeom>
-          <a:noFill/>
-          <a:ln w="0">
-            <a:noFill/>
-            <a:prstDash val="solid"/>
-          </a:ln>
-        </p:spPr>
-        <p:txBody>
-          <a:bodyPr>
-            <a:normAutofit/>
-          </a:bodyPr>
-          <a:lstStyle/>
-          <a:p>
-            <a:pPr algn="ctr">
-              <a:defRPr sz="1800">
-                <a:solidFill>
-                  <a:srgbClr val="000000"/>
-                </a:solidFill>
-                <a:latin typeface="Helvetica"/>
-                <a:ea typeface="Helvetica"/>
-                <a:cs typeface="Helvetica"/>
-              </a:defRPr>
-            </a:pPr>
-            <a:r>
-              <a:rPr sz="1800">
-                <a:solidFill>
-                  <a:srgbClr val="000000"/>
-                </a:solidFill>
-                <a:latin typeface="Helvetica"/>
-                <a:ea typeface="Helvetica"/>
-                <a:cs typeface="Helvetica"/>
-              </a:rPr>
-              <a:t>Next Monday (09/21) is a lab day. There is no lecture.</a:t>
-            </a:r>
-          </a:p>
-        </p:txBody>
-      </p:sp>
-      <p:graphicFrame>
-        <p:nvGraphicFramePr>
-          <p:cNvPr id="17" name="Table 16"/>
-          <p:cNvGraphicFramePr/>
-          <p:nvPr/>
-        </p:nvGraphicFramePr>
-        <p:xfrm>
-          <a:off x="381000" y="1885950"/>
-          <a:ext cx="11430001" cy="3324225"/>
-        </p:xfrm>
-        <a:graphic>
-          <a:graphicData uri="http://schemas.openxmlformats.org/drawingml/2006/table">
-            <a:tbl>
-              <a:tblPr/>
-              <a:tblGrid>
-                <a:gridCol w="2071688">
-                  <a:extLst>
-                    <a:ext uri="{9D8B030D-6E8A-4147-A177-3AD203B41FA5}">
-                      <a16:colId xmlns:a16="http://schemas.microsoft.com/office/drawing/2014/main" val="20000"/>
-                    </a:ext>
-                  </a:extLst>
-                </a:gridCol>
-                <a:gridCol w="1071563">
-                  <a:extLst>
-                    <a:ext uri="{9D8B030D-6E8A-4147-A177-3AD203B41FA5}">
-                      <a16:colId xmlns:a16="http://schemas.microsoft.com/office/drawing/2014/main" val="20001"/>
-                    </a:ext>
-                  </a:extLst>
-                </a:gridCol>
-                <a:gridCol w="8286750">
-                  <a:extLst>
-                    <a:ext uri="{9D8B030D-6E8A-4147-A177-3AD203B41FA5}">
-                      <a16:colId xmlns:a16="http://schemas.microsoft.com/office/drawing/2014/main" val="20002"/>
-                    </a:ext>
-                  </a:extLst>
-                </a:gridCol>
-              </a:tblGrid>
-              <a:tr h="476250">
-                <a:tc>
-                  <a:txBody>
-                    <a:bodyPr/>
-                    <a:lstStyle/>
-                    <a:p>
-                      <a:r>
-                        <a:rPr sz="1950" b="1">
-                          <a:solidFill>
-                            <a:srgbClr val="000000"/>
-                          </a:solidFill>
-                          <a:latin typeface="Helvetica"/>
-                          <a:ea typeface="Helvetica"/>
-                          <a:cs typeface="Helvetica"/>
-                        </a:rPr>
-                        <a:t>Criterion</a:t>
-                      </a:r>
-                    </a:p>
-                  </a:txBody>
-                  <a:tcPr marL="95250" marR="95250" marT="76200" marB="76200">
-                    <a:solidFill>
-                      <a:srgbClr val="E8E8E8"/>
-                    </a:solidFill>
-                  </a:tcPr>
-                </a:tc>
-                <a:tc>
-                  <a:txBody>
-                    <a:bodyPr/>
-                    <a:lstStyle/>
-                    <a:p>
-                      <a:pPr algn="ctr"/>
-                      <a:r>
-                        <a:rPr sz="1800" b="1">
-                          <a:solidFill>
-                            <a:srgbClr val="000000"/>
-                          </a:solidFill>
-                          <a:latin typeface="Helvetica"/>
-                          <a:ea typeface="Helvetica"/>
-                          <a:cs typeface="Helvetica"/>
-                        </a:rPr>
-                        <a:t>Weight</a:t>
-                      </a:r>
-                    </a:p>
-                  </a:txBody>
-                  <a:tcPr marL="95250" marR="95250" marT="76200" marB="76200">
-                    <a:solidFill>
-                      <a:srgbClr val="E8E8E8"/>
-                    </a:solidFill>
-                  </a:tcPr>
-                </a:tc>
-                <a:tc>
-                  <a:txBody>
-                    <a:bodyPr/>
-                    <a:lstStyle/>
-                    <a:p>
-                      <a:r>
-                        <a:rPr sz="1950" b="1">
-                          <a:solidFill>
-                            <a:srgbClr val="000000"/>
-                          </a:solidFill>
-                          <a:latin typeface="Helvetica"/>
-                          <a:ea typeface="Helvetica"/>
-                          <a:cs typeface="Helvetica"/>
-                        </a:rPr>
-                        <a:t>What we look for</a:t>
-                      </a:r>
-                    </a:p>
-                  </a:txBody>
-                  <a:tcPr marL="95250" marR="95250" marT="76200" marB="76200">
-                    <a:solidFill>
-                      <a:srgbClr val="E8E8E8"/>
-                    </a:solidFill>
-                  </a:tcPr>
-                </a:tc>
-                <a:extLst>
-                  <a:ext uri="{0D108BD9-81ED-4DB2-BD59-A6C34878D82A}">
-                    <a16:rowId xmlns:a16="http://schemas.microsoft.com/office/drawing/2014/main" val="10000"/>
-                  </a:ext>
-                </a:extLst>
-              </a:tr>
-              <a:tr h="1285875">
-                <a:tc>
-                  <a:txBody>
-                    <a:bodyPr/>
-                    <a:lstStyle/>
-                    <a:p>
-                      <a:r>
-                        <a:rPr sz="1725" b="1">
-                          <a:solidFill>
-                            <a:srgbClr val="000000"/>
-                          </a:solidFill>
-                          <a:latin typeface="Helvetica"/>
-                          <a:ea typeface="Helvetica"/>
-                          <a:cs typeface="Helvetica"/>
-                        </a:rPr>
-                        <a:t>Design proposal</a:t>
-                      </a:r>
-                    </a:p>
-                  </a:txBody>
-                  <a:tcPr marL="95250" marR="95250" marT="76200" marB="76200"/>
-                </a:tc>
-                <a:tc>
-                  <a:txBody>
-                    <a:bodyPr/>
-                    <a:lstStyle/>
-                    <a:p>
-                      <a:pPr algn="ctr"/>
-                      <a:r>
-                        <a:rPr sz="1800" b="1">
-                          <a:solidFill>
-                            <a:srgbClr val="000000"/>
-                          </a:solidFill>
-                          <a:latin typeface="Helvetica"/>
-                          <a:ea typeface="Helvetica"/>
-                          <a:cs typeface="Helvetica"/>
-                        </a:rPr>
-                        <a:t>50%</a:t>
-                      </a:r>
-                    </a:p>
-                  </a:txBody>
-                  <a:tcPr marL="95250" marR="95250" marT="76200" marB="76200"/>
-                </a:tc>
-                <a:tc>
-                  <a:txBody>
-                    <a:bodyPr/>
-                    <a:lstStyle/>
-                    <a:p>
-                      <a:r>
-                        <a:rPr sz="1725">
-                          <a:solidFill>
-                            <a:srgbClr val="000000"/>
-                          </a:solidFill>
-                          <a:latin typeface="Helvetica"/>
-                          <a:ea typeface="Helvetica"/>
-                          <a:cs typeface="Helvetica"/>
-                        </a:rPr>
-                        <a:t>Clear problem and proposed design, an architecture diagram, measurable success, and verifiable milestones for Demo 2, Demo 3, and the final. A working system is not required.</a:t>
-                      </a:r>
-                    </a:p>
-                  </a:txBody>
-                  <a:tcPr marL="95250" marR="95250" marT="76200" marB="76200"/>
-                </a:tc>
-                <a:extLst>
-                  <a:ext uri="{0D108BD9-81ED-4DB2-BD59-A6C34878D82A}">
-                    <a16:rowId xmlns:a16="http://schemas.microsoft.com/office/drawing/2014/main" val="10001"/>
-                  </a:ext>
-                </a:extLst>
-              </a:tr>
-              <a:tr h="781050">
-                <a:tc>
-                  <a:txBody>
-                    <a:bodyPr/>
-                    <a:lstStyle/>
-                    <a:p>
-                      <a:r>
-                        <a:rPr sz="1725" b="1">
-                          <a:solidFill>
-                            <a:srgbClr val="000000"/>
-                          </a:solidFill>
-                          <a:latin typeface="Helvetica"/>
-                          <a:ea typeface="Helvetica"/>
-                          <a:cs typeface="Helvetica"/>
-                        </a:rPr>
-                        <a:t>Slides</a:t>
-                      </a:r>
-                    </a:p>
-                  </a:txBody>
-                  <a:tcPr marL="95250" marR="95250" marT="76200" marB="76200"/>
-                </a:tc>
-                <a:tc>
-                  <a:txBody>
-                    <a:bodyPr/>
-                    <a:lstStyle/>
-                    <a:p>
-                      <a:pPr algn="ctr"/>
-                      <a:r>
-                        <a:rPr sz="1800" b="1">
-                          <a:solidFill>
-                            <a:srgbClr val="000000"/>
-                          </a:solidFill>
-                          <a:latin typeface="Helvetica"/>
-                          <a:ea typeface="Helvetica"/>
-                          <a:cs typeface="Helvetica"/>
-                        </a:rPr>
-                        <a:t>25%</a:t>
-                      </a:r>
-                    </a:p>
-                  </a:txBody>
-                  <a:tcPr marL="95250" marR="95250" marT="76200" marB="76200"/>
-                </a:tc>
-                <a:tc>
-                  <a:txBody>
-                    <a:bodyPr/>
-                    <a:lstStyle/>
-                    <a:p>
-                      <a:r>
-                        <a:rPr sz="1725">
-                          <a:solidFill>
-                            <a:srgbClr val="000000"/>
-                          </a:solidFill>
-                          <a:latin typeface="Helvetica"/>
-                          <a:ea typeface="Helvetica"/>
-                          <a:cs typeface="Helvetica"/>
-                        </a:rPr>
-                        <a:t>Problem and motivation, design, evidence, clarity, and finishing within 10 minutes.</a:t>
-                      </a:r>
-                    </a:p>
-                  </a:txBody>
-                  <a:tcPr marL="95250" marR="95250" marT="76200" marB="76200"/>
-                </a:tc>
-                <a:extLst>
-                  <a:ext uri="{0D108BD9-81ED-4DB2-BD59-A6C34878D82A}">
-                    <a16:rowId xmlns:a16="http://schemas.microsoft.com/office/drawing/2014/main" val="10002"/>
-                  </a:ext>
-                </a:extLst>
-              </a:tr>
-              <a:tr h="781050">
-                <a:tc>
-                  <a:txBody>
-                    <a:bodyPr/>
-                    <a:lstStyle/>
-                    <a:p>
-                      <a:r>
-                        <a:rPr sz="1725" b="1">
-                          <a:solidFill>
-                            <a:srgbClr val="000000"/>
-                          </a:solidFill>
-                          <a:latin typeface="Helvetica"/>
-                          <a:ea typeface="Helvetica"/>
-                          <a:cs typeface="Helvetica"/>
-                        </a:rPr>
-                        <a:t>Challenge</a:t>
-                      </a:r>
-                    </a:p>
-                  </a:txBody>
-                  <a:tcPr marL="95250" marR="95250" marT="76200" marB="76200"/>
-                </a:tc>
-                <a:tc>
-                  <a:txBody>
-                    <a:bodyPr/>
-                    <a:lstStyle/>
-                    <a:p>
-                      <a:pPr algn="ctr"/>
-                      <a:r>
-                        <a:rPr sz="1800" b="1">
-                          <a:solidFill>
-                            <a:srgbClr val="000000"/>
-                          </a:solidFill>
-                          <a:latin typeface="Helvetica"/>
-                          <a:ea typeface="Helvetica"/>
-                          <a:cs typeface="Helvetica"/>
-                        </a:rPr>
-                        <a:t>25%</a:t>
-                      </a:r>
-                    </a:p>
-                  </a:txBody>
-                  <a:tcPr marL="95250" marR="95250" marT="76200" marB="76200"/>
-                </a:tc>
-                <a:tc>
-                  <a:txBody>
-                    <a:bodyPr/>
-                    <a:lstStyle/>
-                    <a:p>
-                      <a:r>
-                        <a:rPr sz="1725">
-                          <a:solidFill>
-                            <a:srgbClr val="000000"/>
-                          </a:solidFill>
-                          <a:latin typeface="Helvetica"/>
-                          <a:ea typeface="Helvetica"/>
-                          <a:cs typeface="Helvetica"/>
-                        </a:rPr>
-                        <a:t>The technical difficulty and ambition of the proposed system.</a:t>
-                      </a:r>
-                    </a:p>
-                  </a:txBody>
-                  <a:tcPr marL="95250" marR="95250" marT="76200" marB="76200"/>
-                </a:tc>
-                <a:extLst>
-                  <a:ext uri="{0D108BD9-81ED-4DB2-BD59-A6C34878D82A}">
-                    <a16:rowId xmlns:a16="http://schemas.microsoft.com/office/drawing/2014/main" val="10003"/>
-                  </a:ext>
-                </a:extLst>
-              </a:tr>
-            </a:tbl>
-          </a:graphicData>
-        </a:graphic>
-      </p:graphicFrame>
-      <p:sp>
-        <p:nvSpPr>
-          <p:cNvPr id="12" name="Milestone grading note">
-            <a:extLst>
-              <a:ext uri="{FF2B5EF4-FFF2-40B4-BE49-F238E27FC236}">
-                <a16:creationId xmlns:a16="http://schemas.microsoft.com/office/drawing/2014/main" id="{19113F98-AD09-45E2-9DEF-AC28BD3E4130}"/>
-              </a:ext>
-            </a:extLst>
-          </p:cNvPr>
-          <p:cNvSpPr>
-            <a:spLocks noGrp="1"/>
-          </p:cNvSpPr>
-          <p:nvPr/>
-        </p:nvSpPr>
-        <p:spPr>
-          <a:xfrm>
-            <a:off x="438150" y="5429250"/>
-            <a:ext cx="11315700" cy="438150"/>
-          </a:xfrm>
-          <a:prstGeom prst="rect">
-            <a:avLst/>
-          </a:prstGeom>
-          <a:noFill/>
-          <a:ln w="0">
-            <a:noFill/>
-            <a:prstDash val="solid"/>
-          </a:ln>
-        </p:spPr>
-        <p:txBody>
-          <a:bodyPr>
-            <a:normAutofit/>
-          </a:bodyPr>
-          <a:lstStyle/>
-          <a:p>
-            <a:pPr algn="ctr">
-              <a:defRPr sz="1875" b="1">
-                <a:solidFill>
-                  <a:srgbClr val="000000"/>
-                </a:solidFill>
-                <a:latin typeface="Helvetica"/>
-                <a:ea typeface="Helvetica"/>
-                <a:cs typeface="Helvetica"/>
-              </a:defRPr>
-            </a:pPr>
-            <a:r>
-              <a:rPr sz="1875" b="1">
-                <a:solidFill>
-                  <a:srgbClr val="000000"/>
-                </a:solidFill>
-                <a:latin typeface="Helvetica"/>
-                <a:ea typeface="Helvetica"/>
-                <a:cs typeface="Helvetica"/>
-              </a:rPr>
-              <a:t>Later progress grades use the milestones your team commits to here.</a:t>
-            </a:r>
-          </a:p>
-        </p:txBody>
-      </p:sp>
-    </p:spTree>
-    <p:extLst>
-      <p:ext uri="{BB962C8B-B14F-4D97-AF65-F5344CB8AC3E}">
-        <p14:creationId xmlns:p14="http://schemas.microsoft.com/office/powerpoint/2010/main" val="1720670694"/>
-      </p:ext>
-    </p:extLst>
-  </p:cSld>
-  <p:clrMapOvr>
-    <a:masterClrMapping/>
-  </p:clrMapOvr>
-</p:sld>
-</file>
-
-<file path=ppt/slides/slide20.xml><?xml version="1.0" encoding="utf-8"?>
-<p:sld xmlns:a="http://schemas.openxmlformats.org/drawingml/2006/main" xmlns:r="http://schemas.openxmlformats.org/officeDocument/2006/relationships" xmlns:p="http://schemas.openxmlformats.org/presentationml/2006/main">
-  <p:cSld>
-    <p:spTree>
-      <p:nvGrpSpPr>
-        <p:cNvPr id="1" name="">
-          <a:extLst>
-            <a:ext uri="{FF2B5EF4-FFF2-40B4-BE49-F238E27FC236}">
               <a16:creationId xmlns:a16="http://schemas.microsoft.com/office/drawing/2014/main" id="{8C08E95D-937D-AD36-D9B1-1EF9D542739D}"/>
             </a:ext>
           </a:extLst>
@@ -19788,7 +19118,7 @@
           <a:p>
             <a:fld id="{212DA15D-5F50-8B40-811F-34F736B90848}" type="slidenum">
               <a:rPr lang="en-US" smtClean="0"/>
-              <a:t>20</a:t>
+              <a:t>19</a:t>
             </a:fld>
             <a:endParaRPr lang="en-US"/>
           </a:p>
@@ -20359,7 +19689,612 @@
 </p:sld>
 </file>
 
-<file path=ppt/slides/slide21.xml><?xml version="1.0" encoding="utf-8"?>
+<file path=ppt/slides/slide2.xml><?xml version="1.0" encoding="utf-8"?>
+<p:sld xmlns:a="http://schemas.openxmlformats.org/drawingml/2006/main" xmlns:r="http://schemas.openxmlformats.org/officeDocument/2006/relationships" xmlns:p="http://schemas.openxmlformats.org/presentationml/2006/main">
+  <p:cSld>
+    <p:spTree>
+      <p:nvGrpSpPr>
+        <p:cNvPr id="1" name=""/>
+        <p:cNvGrpSpPr/>
+        <p:nvPr/>
+      </p:nvGrpSpPr>
+      <p:grpSpPr>
+        <a:xfrm>
+          <a:off x="0" y="0"/>
+          <a:ext cx="0" cy="0"/>
+          <a:chOff x="0" y="0"/>
+          <a:chExt cx="0" cy="0"/>
+        </a:xfrm>
+      </p:grpSpPr>
+      <p:sp>
+        <p:nvSpPr>
+          <p:cNvPr id="7" name="Title 1">
+            <a:extLst>
+              <a:ext uri="{FF2B5EF4-FFF2-40B4-BE49-F238E27FC236}">
+                <a16:creationId xmlns:a16="http://schemas.microsoft.com/office/drawing/2014/main" id="{2ED557C7-2CDD-8C0B-07A1-1DABA8EF652A}"/>
+              </a:ext>
+            </a:extLst>
+          </p:cNvPr>
+          <p:cNvSpPr>
+            <a:spLocks noGrp="1"/>
+          </p:cNvSpPr>
+          <p:nvPr>
+            <p:ph type="title"/>
+          </p:nvPr>
+        </p:nvSpPr>
+        <p:spPr>
+          <a:xfrm>
+            <a:off x="0" y="1"/>
+            <a:ext cx="12191999" cy="914400"/>
+          </a:xfrm>
+        </p:spPr>
+        <p:txBody>
+          <a:bodyPr>
+            <a:normAutofit/>
+          </a:bodyPr>
+          <a:lstStyle/>
+          <a:p>
+            <a:pPr algn="ctr">
+              <a:buNone/>
+            </a:pPr>
+            <a:r>
+              <a:rPr b="1">
+                <a:latin typeface="Helvetica"/>
+                <a:ea typeface="Helvetica"/>
+                <a:cs typeface="Helvetica"/>
+              </a:rPr>
+              <a:t>Demo 1: Design Proposal</a:t>
+            </a:r>
+          </a:p>
+        </p:txBody>
+      </p:sp>
+      <p:sp>
+        <p:nvSpPr>
+          <p:cNvPr id="8" name="Slide Number Placeholder 4">
+            <a:extLst>
+              <a:ext uri="{FF2B5EF4-FFF2-40B4-BE49-F238E27FC236}">
+                <a16:creationId xmlns:a16="http://schemas.microsoft.com/office/drawing/2014/main" id="{25E098EE-1299-32C0-2821-1DB599BAC8E9}"/>
+              </a:ext>
+            </a:extLst>
+          </p:cNvPr>
+          <p:cNvSpPr>
+            <a:spLocks noGrp="1"/>
+          </p:cNvSpPr>
+          <p:nvPr>
+            <p:ph type="sldNum" idx="12"/>
+          </p:nvPr>
+        </p:nvSpPr>
+        <p:spPr>
+          <a:xfrm>
+            <a:off x="8610600" y="6356350"/>
+            <a:ext cx="2743200" cy="365125"/>
+          </a:xfrm>
+        </p:spPr>
+        <p:txBody>
+          <a:bodyPr/>
+          <a:lstStyle/>
+          <a:p>
+            <a:fld id="{212DA15D-5F50-8B40-811F-34F736B90848}" type="slidenum">
+              <a:rPr/>
+              <a:t>2</a:t>
+            </a:fld>
+            <a:endParaRPr/>
+          </a:p>
+        </p:txBody>
+      </p:sp>
+      <p:sp>
+        <p:nvSpPr>
+          <p:cNvPr id="9" name="Demo 1 deadline">
+            <a:extLst>
+              <a:ext uri="{FF2B5EF4-FFF2-40B4-BE49-F238E27FC236}">
+                <a16:creationId xmlns:a16="http://schemas.microsoft.com/office/drawing/2014/main" id="{28A03A3E-853D-4FA2-AE8E-9CDFB2A1C51A}"/>
+              </a:ext>
+            </a:extLst>
+          </p:cNvPr>
+          <p:cNvSpPr>
+            <a:spLocks noGrp="1"/>
+          </p:cNvSpPr>
+          <p:nvPr/>
+        </p:nvSpPr>
+        <p:spPr>
+          <a:xfrm>
+            <a:off x="361950" y="933450"/>
+            <a:ext cx="11468100" cy="457200"/>
+          </a:xfrm>
+          <a:prstGeom prst="rect">
+            <a:avLst/>
+          </a:prstGeom>
+          <a:noFill/>
+          <a:ln w="0">
+            <a:noFill/>
+            <a:prstDash val="solid"/>
+          </a:ln>
+        </p:spPr>
+        <p:txBody>
+          <a:bodyPr>
+            <a:normAutofit/>
+          </a:bodyPr>
+          <a:lstStyle/>
+          <a:p>
+            <a:pPr algn="ctr">
+              <a:defRPr sz="2250" b="1">
+                <a:solidFill>
+                  <a:srgbClr val="000000"/>
+                </a:solidFill>
+                <a:latin typeface="Helvetica"/>
+                <a:ea typeface="Helvetica"/>
+                <a:cs typeface="Helvetica"/>
+              </a:defRPr>
+            </a:pPr>
+            <a:r>
+              <a:rPr sz="2250" b="1">
+                <a:solidFill>
+                  <a:srgbClr val="000000"/>
+                </a:solidFill>
+                <a:latin typeface="Helvetica"/>
+                <a:ea typeface="Helvetica"/>
+                <a:cs typeface="Helvetica"/>
+              </a:rPr>
+              <a:t>Wednesday 09/23, due 12:00 noon in branch demo-1</a:t>
+            </a:r>
+          </a:p>
+        </p:txBody>
+      </p:sp>
+      <p:sp>
+        <p:nvSpPr>
+          <p:cNvPr id="10" name="Lab day notice">
+            <a:extLst>
+              <a:ext uri="{FF2B5EF4-FFF2-40B4-BE49-F238E27FC236}">
+                <a16:creationId xmlns:a16="http://schemas.microsoft.com/office/drawing/2014/main" id="{F0C367EF-21EA-42FF-BA10-C1A905D549A5}"/>
+              </a:ext>
+            </a:extLst>
+          </p:cNvPr>
+          <p:cNvSpPr>
+            <a:spLocks noGrp="1"/>
+          </p:cNvSpPr>
+          <p:nvPr/>
+        </p:nvSpPr>
+        <p:spPr>
+          <a:xfrm>
+            <a:off x="361950" y="1352550"/>
+            <a:ext cx="11468100" cy="400050"/>
+          </a:xfrm>
+          <a:prstGeom prst="rect">
+            <a:avLst/>
+          </a:prstGeom>
+          <a:noFill/>
+          <a:ln w="0">
+            <a:noFill/>
+            <a:prstDash val="solid"/>
+          </a:ln>
+        </p:spPr>
+        <p:txBody>
+          <a:bodyPr>
+            <a:normAutofit/>
+          </a:bodyPr>
+          <a:lstStyle/>
+          <a:p>
+            <a:pPr algn="ctr">
+              <a:defRPr sz="1800">
+                <a:solidFill>
+                  <a:srgbClr val="000000"/>
+                </a:solidFill>
+                <a:latin typeface="Helvetica"/>
+                <a:ea typeface="Helvetica"/>
+                <a:cs typeface="Helvetica"/>
+              </a:defRPr>
+            </a:pPr>
+            <a:r>
+              <a:rPr sz="1800">
+                <a:solidFill>
+                  <a:srgbClr val="000000"/>
+                </a:solidFill>
+                <a:latin typeface="Helvetica"/>
+                <a:ea typeface="Helvetica"/>
+                <a:cs typeface="Helvetica"/>
+              </a:rPr>
+              <a:t>Next Monday (09/21) is a lab day. There is no lecture.</a:t>
+            </a:r>
+          </a:p>
+        </p:txBody>
+      </p:sp>
+      <p:graphicFrame>
+        <p:nvGraphicFramePr>
+          <p:cNvPr id="17" name="Table 16"/>
+          <p:cNvGraphicFramePr/>
+          <p:nvPr/>
+        </p:nvGraphicFramePr>
+        <p:xfrm>
+          <a:off x="381000" y="1885950"/>
+          <a:ext cx="11430001" cy="3324225"/>
+        </p:xfrm>
+        <a:graphic>
+          <a:graphicData uri="http://schemas.openxmlformats.org/drawingml/2006/table">
+            <a:tbl>
+              <a:tblPr/>
+              <a:tblGrid>
+                <a:gridCol w="2071688">
+                  <a:extLst>
+                    <a:ext uri="{9D8B030D-6E8A-4147-A177-3AD203B41FA5}">
+                      <a16:colId xmlns:a16="http://schemas.microsoft.com/office/drawing/2014/main" val="20000"/>
+                    </a:ext>
+                  </a:extLst>
+                </a:gridCol>
+                <a:gridCol w="1071563">
+                  <a:extLst>
+                    <a:ext uri="{9D8B030D-6E8A-4147-A177-3AD203B41FA5}">
+                      <a16:colId xmlns:a16="http://schemas.microsoft.com/office/drawing/2014/main" val="20001"/>
+                    </a:ext>
+                  </a:extLst>
+                </a:gridCol>
+                <a:gridCol w="8286750">
+                  <a:extLst>
+                    <a:ext uri="{9D8B030D-6E8A-4147-A177-3AD203B41FA5}">
+                      <a16:colId xmlns:a16="http://schemas.microsoft.com/office/drawing/2014/main" val="20002"/>
+                    </a:ext>
+                  </a:extLst>
+                </a:gridCol>
+              </a:tblGrid>
+              <a:tr h="476250">
+                <a:tc>
+                  <a:txBody>
+                    <a:bodyPr/>
+                    <a:lstStyle/>
+                    <a:p>
+                      <a:r>
+                        <a:rPr sz="1950" b="1">
+                          <a:solidFill>
+                            <a:srgbClr val="000000"/>
+                          </a:solidFill>
+                          <a:latin typeface="Helvetica"/>
+                          <a:ea typeface="Helvetica"/>
+                          <a:cs typeface="Helvetica"/>
+                        </a:rPr>
+                        <a:t>Criterion</a:t>
+                      </a:r>
+                    </a:p>
+                  </a:txBody>
+                  <a:tcPr marL="95250" marR="95250" marT="76200" marB="76200">
+                    <a:solidFill>
+                      <a:srgbClr val="E8E8E8"/>
+                    </a:solidFill>
+                  </a:tcPr>
+                </a:tc>
+                <a:tc>
+                  <a:txBody>
+                    <a:bodyPr/>
+                    <a:lstStyle/>
+                    <a:p>
+                      <a:pPr algn="ctr"/>
+                      <a:r>
+                        <a:rPr sz="1800" b="1">
+                          <a:solidFill>
+                            <a:srgbClr val="000000"/>
+                          </a:solidFill>
+                          <a:latin typeface="Helvetica"/>
+                          <a:ea typeface="Helvetica"/>
+                          <a:cs typeface="Helvetica"/>
+                        </a:rPr>
+                        <a:t>Weight</a:t>
+                      </a:r>
+                    </a:p>
+                  </a:txBody>
+                  <a:tcPr marL="95250" marR="95250" marT="76200" marB="76200">
+                    <a:solidFill>
+                      <a:srgbClr val="E8E8E8"/>
+                    </a:solidFill>
+                  </a:tcPr>
+                </a:tc>
+                <a:tc>
+                  <a:txBody>
+                    <a:bodyPr/>
+                    <a:lstStyle/>
+                    <a:p>
+                      <a:r>
+                        <a:rPr sz="1950" b="1">
+                          <a:solidFill>
+                            <a:srgbClr val="000000"/>
+                          </a:solidFill>
+                          <a:latin typeface="Helvetica"/>
+                          <a:ea typeface="Helvetica"/>
+                          <a:cs typeface="Helvetica"/>
+                        </a:rPr>
+                        <a:t>What we look for</a:t>
+                      </a:r>
+                    </a:p>
+                  </a:txBody>
+                  <a:tcPr marL="95250" marR="95250" marT="76200" marB="76200">
+                    <a:solidFill>
+                      <a:srgbClr val="E8E8E8"/>
+                    </a:solidFill>
+                  </a:tcPr>
+                </a:tc>
+                <a:extLst>
+                  <a:ext uri="{0D108BD9-81ED-4DB2-BD59-A6C34878D82A}">
+                    <a16:rowId xmlns:a16="http://schemas.microsoft.com/office/drawing/2014/main" val="10000"/>
+                  </a:ext>
+                </a:extLst>
+              </a:tr>
+              <a:tr h="1285875">
+                <a:tc>
+                  <a:txBody>
+                    <a:bodyPr/>
+                    <a:lstStyle/>
+                    <a:p>
+                      <a:r>
+                        <a:rPr sz="1725" b="1">
+                          <a:solidFill>
+                            <a:srgbClr val="000000"/>
+                          </a:solidFill>
+                          <a:latin typeface="Helvetica"/>
+                          <a:ea typeface="Helvetica"/>
+                          <a:cs typeface="Helvetica"/>
+                        </a:rPr>
+                        <a:t>Design proposal</a:t>
+                      </a:r>
+                    </a:p>
+                  </a:txBody>
+                  <a:tcPr marL="95250" marR="95250" marT="76200" marB="76200"/>
+                </a:tc>
+                <a:tc>
+                  <a:txBody>
+                    <a:bodyPr/>
+                    <a:lstStyle/>
+                    <a:p>
+                      <a:pPr algn="ctr"/>
+                      <a:r>
+                        <a:rPr sz="1800" b="1">
+                          <a:solidFill>
+                            <a:srgbClr val="000000"/>
+                          </a:solidFill>
+                          <a:latin typeface="Helvetica"/>
+                          <a:ea typeface="Helvetica"/>
+                          <a:cs typeface="Helvetica"/>
+                        </a:rPr>
+                        <a:t>50%</a:t>
+                      </a:r>
+                    </a:p>
+                  </a:txBody>
+                  <a:tcPr marL="95250" marR="95250" marT="76200" marB="76200"/>
+                </a:tc>
+                <a:tc>
+                  <a:txBody>
+                    <a:bodyPr/>
+                    <a:lstStyle/>
+                    <a:p>
+                      <a:r>
+                        <a:rPr sz="1725">
+                          <a:solidFill>
+                            <a:srgbClr val="000000"/>
+                          </a:solidFill>
+                          <a:latin typeface="Helvetica"/>
+                          <a:ea typeface="Helvetica"/>
+                          <a:cs typeface="Helvetica"/>
+                        </a:rPr>
+                        <a:t>Clear problem and proposed design, an architecture diagram, measurable success, and verifiable milestones for Demo 2, Demo 3, and the final. A working system is not required.</a:t>
+                      </a:r>
+                    </a:p>
+                  </a:txBody>
+                  <a:tcPr marL="95250" marR="95250" marT="76200" marB="76200"/>
+                </a:tc>
+                <a:extLst>
+                  <a:ext uri="{0D108BD9-81ED-4DB2-BD59-A6C34878D82A}">
+                    <a16:rowId xmlns:a16="http://schemas.microsoft.com/office/drawing/2014/main" val="10001"/>
+                  </a:ext>
+                </a:extLst>
+              </a:tr>
+              <a:tr h="781050">
+                <a:tc>
+                  <a:txBody>
+                    <a:bodyPr/>
+                    <a:lstStyle/>
+                    <a:p>
+                      <a:r>
+                        <a:rPr sz="1725" b="1">
+                          <a:solidFill>
+                            <a:srgbClr val="000000"/>
+                          </a:solidFill>
+                          <a:latin typeface="Helvetica"/>
+                          <a:ea typeface="Helvetica"/>
+                          <a:cs typeface="Helvetica"/>
+                        </a:rPr>
+                        <a:t>Slides</a:t>
+                      </a:r>
+                    </a:p>
+                  </a:txBody>
+                  <a:tcPr marL="95250" marR="95250" marT="76200" marB="76200"/>
+                </a:tc>
+                <a:tc>
+                  <a:txBody>
+                    <a:bodyPr/>
+                    <a:lstStyle/>
+                    <a:p>
+                      <a:pPr algn="ctr"/>
+                      <a:r>
+                        <a:rPr sz="1800" b="1">
+                          <a:solidFill>
+                            <a:srgbClr val="000000"/>
+                          </a:solidFill>
+                          <a:latin typeface="Helvetica"/>
+                          <a:ea typeface="Helvetica"/>
+                          <a:cs typeface="Helvetica"/>
+                        </a:rPr>
+                        <a:t>25%</a:t>
+                      </a:r>
+                    </a:p>
+                  </a:txBody>
+                  <a:tcPr marL="95250" marR="95250" marT="76200" marB="76200"/>
+                </a:tc>
+                <a:tc>
+                  <a:txBody>
+                    <a:bodyPr/>
+                    <a:lstStyle/>
+                    <a:p>
+                      <a:r>
+                        <a:rPr sz="1725">
+                          <a:solidFill>
+                            <a:srgbClr val="000000"/>
+                          </a:solidFill>
+                          <a:latin typeface="Helvetica"/>
+                          <a:ea typeface="Helvetica"/>
+                          <a:cs typeface="Helvetica"/>
+                        </a:rPr>
+                        <a:t>Problem and motivation, design, evidence, clarity, and finishing within 10 minutes.</a:t>
+                      </a:r>
+                    </a:p>
+                  </a:txBody>
+                  <a:tcPr marL="95250" marR="95250" marT="76200" marB="76200"/>
+                </a:tc>
+                <a:extLst>
+                  <a:ext uri="{0D108BD9-81ED-4DB2-BD59-A6C34878D82A}">
+                    <a16:rowId xmlns:a16="http://schemas.microsoft.com/office/drawing/2014/main" val="10002"/>
+                  </a:ext>
+                </a:extLst>
+              </a:tr>
+              <a:tr h="781050">
+                <a:tc>
+                  <a:txBody>
+                    <a:bodyPr/>
+                    <a:lstStyle/>
+                    <a:p>
+                      <a:r>
+                        <a:rPr sz="1725" b="1">
+                          <a:solidFill>
+                            <a:srgbClr val="000000"/>
+                          </a:solidFill>
+                          <a:latin typeface="Helvetica"/>
+                          <a:ea typeface="Helvetica"/>
+                          <a:cs typeface="Helvetica"/>
+                        </a:rPr>
+                        <a:t>Challenge</a:t>
+                      </a:r>
+                    </a:p>
+                  </a:txBody>
+                  <a:tcPr marL="95250" marR="95250" marT="76200" marB="76200"/>
+                </a:tc>
+                <a:tc>
+                  <a:txBody>
+                    <a:bodyPr/>
+                    <a:lstStyle/>
+                    <a:p>
+                      <a:pPr algn="ctr"/>
+                      <a:r>
+                        <a:rPr sz="1800" b="1">
+                          <a:solidFill>
+                            <a:srgbClr val="000000"/>
+                          </a:solidFill>
+                          <a:latin typeface="Helvetica"/>
+                          <a:ea typeface="Helvetica"/>
+                          <a:cs typeface="Helvetica"/>
+                        </a:rPr>
+                        <a:t>25%</a:t>
+                      </a:r>
+                    </a:p>
+                  </a:txBody>
+                  <a:tcPr marL="95250" marR="95250" marT="76200" marB="76200"/>
+                </a:tc>
+                <a:tc>
+                  <a:txBody>
+                    <a:bodyPr/>
+                    <a:lstStyle/>
+                    <a:p>
+                      <a:r>
+                        <a:rPr sz="1725">
+                          <a:solidFill>
+                            <a:srgbClr val="000000"/>
+                          </a:solidFill>
+                          <a:latin typeface="Helvetica"/>
+                          <a:ea typeface="Helvetica"/>
+                          <a:cs typeface="Helvetica"/>
+                        </a:rPr>
+                        <a:t>The technical difficulty and ambition of the proposed system.</a:t>
+                      </a:r>
+                    </a:p>
+                  </a:txBody>
+                  <a:tcPr marL="95250" marR="95250" marT="76200" marB="76200"/>
+                </a:tc>
+                <a:extLst>
+                  <a:ext uri="{0D108BD9-81ED-4DB2-BD59-A6C34878D82A}">
+                    <a16:rowId xmlns:a16="http://schemas.microsoft.com/office/drawing/2014/main" val="10003"/>
+                  </a:ext>
+                </a:extLst>
+              </a:tr>
+            </a:tbl>
+          </a:graphicData>
+        </a:graphic>
+      </p:graphicFrame>
+      <p:sp>
+        <p:nvSpPr>
+          <p:cNvPr id="12" name="Milestone grading note">
+            <a:extLst>
+              <a:ext uri="{FF2B5EF4-FFF2-40B4-BE49-F238E27FC236}">
+                <a16:creationId xmlns:a16="http://schemas.microsoft.com/office/drawing/2014/main" id="{19113F98-AD09-45E2-9DEF-AC28BD3E4130}"/>
+              </a:ext>
+            </a:extLst>
+          </p:cNvPr>
+          <p:cNvSpPr>
+            <a:spLocks noGrp="1"/>
+          </p:cNvSpPr>
+          <p:nvPr/>
+        </p:nvSpPr>
+        <p:spPr>
+          <a:xfrm>
+            <a:off x="438150" y="5429250"/>
+            <a:ext cx="11315700" cy="438150"/>
+          </a:xfrm>
+          <a:prstGeom prst="rect">
+            <a:avLst/>
+          </a:prstGeom>
+          <a:noFill/>
+          <a:ln w="0">
+            <a:noFill/>
+            <a:prstDash val="solid"/>
+          </a:ln>
+        </p:spPr>
+        <p:txBody>
+          <a:bodyPr>
+            <a:normAutofit/>
+          </a:bodyPr>
+          <a:lstStyle/>
+          <a:p>
+            <a:pPr algn="ctr">
+              <a:defRPr sz="1875" b="1">
+                <a:solidFill>
+                  <a:srgbClr val="000000"/>
+                </a:solidFill>
+                <a:latin typeface="Helvetica"/>
+                <a:ea typeface="Helvetica"/>
+                <a:cs typeface="Helvetica"/>
+              </a:defRPr>
+            </a:pPr>
+            <a:r>
+              <a:rPr sz="1875" b="1">
+                <a:solidFill>
+                  <a:srgbClr val="000000"/>
+                </a:solidFill>
+                <a:latin typeface="Helvetica"/>
+                <a:ea typeface="Helvetica"/>
+                <a:cs typeface="Helvetica"/>
+              </a:rPr>
+              <a:t>Later progress grades use the milestones your team commits to here.</a:t>
+            </a:r>
+          </a:p>
+        </p:txBody>
+      </p:sp>
+    </p:spTree>
+    <p:extLst>
+      <p:ext uri="{BB962C8B-B14F-4D97-AF65-F5344CB8AC3E}">
+        <p14:creationId xmlns:p14="http://schemas.microsoft.com/office/powerpoint/2010/main" val="1720670694"/>
+      </p:ext>
+    </p:extLst>
+  </p:cSld>
+  <p:clrMapOvr>
+    <a:masterClrMapping/>
+  </p:clrMapOvr>
+</p:sld>
+</file>
+
+<file path=ppt/slides/slide20.xml><?xml version="1.0" encoding="utf-8"?>
 <p:sld xmlns:a="http://schemas.openxmlformats.org/drawingml/2006/main" xmlns:r="http://schemas.openxmlformats.org/officeDocument/2006/relationships" xmlns:p="http://schemas.openxmlformats.org/presentationml/2006/main">
   <p:cSld>
     <p:spTree>
@@ -20449,7 +20384,7 @@
           <a:p>
             <a:fld id="{212DA15D-5F50-8B40-811F-34F736B90848}" type="slidenum">
               <a:rPr lang="en-US" smtClean="0"/>
-              <a:t>21</a:t>
+              <a:t>20</a:t>
             </a:fld>
             <a:endParaRPr lang="en-US"/>
           </a:p>
@@ -20748,6 +20683,92 @@
                                   </p:childTnLst>
                                 </p:cTn>
                               </p:par>
+                              <p:par>
+                                <p:cTn id="17" presetID="9" presetClass="entr" presetSubtype="0" fill="hold" nodeType="withEffect">
+                                  <p:stCondLst>
+                                    <p:cond delay="0"/>
+                                  </p:stCondLst>
+                                  <p:childTnLst>
+                                    <p:set>
+                                      <p:cBhvr>
+                                        <p:cTn id="18" dur="1" fill="hold">
+                                          <p:stCondLst>
+                                            <p:cond delay="0"/>
+                                          </p:stCondLst>
+                                        </p:cTn>
+                                        <p:tgtEl>
+                                          <p:spTgt spid="2">
+                                            <p:txEl>
+                                              <p:pRg st="7" end="7"/>
+                                            </p:txEl>
+                                          </p:spTgt>
+                                        </p:tgtEl>
+                                        <p:attrNameLst>
+                                          <p:attrName>style.visibility</p:attrName>
+                                        </p:attrNameLst>
+                                      </p:cBhvr>
+                                      <p:to>
+                                        <p:strVal val="visible"/>
+                                      </p:to>
+                                    </p:set>
+                                    <p:animEffect transition="in" filter="dissolve">
+                                      <p:cBhvr>
+                                        <p:cTn id="19" dur="500"/>
+                                        <p:tgtEl>
+                                          <p:spTgt spid="2">
+                                            <p:txEl>
+                                              <p:pRg st="7" end="7"/>
+                                            </p:txEl>
+                                          </p:spTgt>
+                                        </p:tgtEl>
+                                      </p:cBhvr>
+                                    </p:animEffect>
+                                  </p:childTnLst>
+                                </p:cTn>
+                              </p:par>
+                              <p:par>
+                                <p:cTn id="20" presetID="9" presetClass="entr" presetSubtype="0" fill="hold" nodeType="withEffect">
+                                  <p:stCondLst>
+                                    <p:cond delay="0"/>
+                                  </p:stCondLst>
+                                  <p:childTnLst>
+                                    <p:set>
+                                      <p:cBhvr>
+                                        <p:cTn id="21" dur="1" fill="hold">
+                                          <p:stCondLst>
+                                            <p:cond delay="0"/>
+                                          </p:stCondLst>
+                                        </p:cTn>
+                                        <p:tgtEl>
+                                          <p:spTgt spid="2">
+                                            <p:txEl>
+                                              <p:pRg st="10" end="10"/>
+                                            </p:txEl>
+                                          </p:spTgt>
+                                        </p:tgtEl>
+                                        <p:attrNameLst>
+                                          <p:attrName>style.visibility</p:attrName>
+                                        </p:attrNameLst>
+                                      </p:cBhvr>
+                                      <p:to>
+                                        <p:strVal val="visible"/>
+                                      </p:to>
+                                    </p:set>
+                                    <p:animEffect transition="in" filter="dissolve">
+                                      <p:cBhvr>
+                                        <p:cTn id="22" dur="500"/>
+                                        <p:tgtEl>
+                                          <p:spTgt spid="2">
+                                            <p:txEl>
+                                              <p:pRg st="10" end="10"/>
+                                            </p:txEl>
+                                          </p:spTgt>
+                                        </p:tgtEl>
+                                      </p:cBhvr>
+                                    </p:animEffect>
+                                  </p:childTnLst>
+                                </p:cTn>
+                              </p:par>
                             </p:childTnLst>
                           </p:cTn>
                         </p:par>
@@ -20779,7 +20800,7 @@
 </p:sld>
 </file>
 
-<file path=ppt/slides/slide22.xml><?xml version="1.0" encoding="utf-8"?>
+<file path=ppt/slides/slide21.xml><?xml version="1.0" encoding="utf-8"?>
 <p:sld xmlns:a="http://schemas.openxmlformats.org/drawingml/2006/main" xmlns:r="http://schemas.openxmlformats.org/officeDocument/2006/relationships" xmlns:p="http://schemas.openxmlformats.org/presentationml/2006/main">
   <p:cSld>
     <p:spTree>
@@ -20869,7 +20890,7 @@
           <a:p>
             <a:fld id="{212DA15D-5F50-8B40-811F-34F736B90848}" type="slidenum">
               <a:rPr lang="en-US" smtClean="0"/>
-              <a:t>22</a:t>
+              <a:t>21</a:t>
             </a:fld>
             <a:endParaRPr lang="en-US"/>
           </a:p>
@@ -20916,7 +20937,7 @@
 </p:sld>
 </file>
 
-<file path=ppt/slides/slide23.xml><?xml version="1.0" encoding="utf-8"?>
+<file path=ppt/slides/slide22.xml><?xml version="1.0" encoding="utf-8"?>
 <p:sld xmlns:a="http://schemas.openxmlformats.org/drawingml/2006/main" xmlns:r="http://schemas.openxmlformats.org/officeDocument/2006/relationships" xmlns:p="http://schemas.openxmlformats.org/presentationml/2006/main">
   <p:cSld>
     <p:spTree>
@@ -21006,7 +21027,7 @@
           <a:p>
             <a:fld id="{212DA15D-5F50-8B40-811F-34F736B90848}" type="slidenum">
               <a:rPr lang="en-US" smtClean="0"/>
-              <a:t>23</a:t>
+              <a:t>22</a:t>
             </a:fld>
             <a:endParaRPr lang="en-US"/>
           </a:p>
@@ -21142,7 +21163,7 @@
 </p:sld>
 </file>
 
-<file path=ppt/slides/slide24.xml><?xml version="1.0" encoding="utf-8"?>
+<file path=ppt/slides/slide23.xml><?xml version="1.0" encoding="utf-8"?>
 <p:sld xmlns:a="http://schemas.openxmlformats.org/drawingml/2006/main" xmlns:r="http://schemas.openxmlformats.org/officeDocument/2006/relationships" xmlns:p="http://schemas.openxmlformats.org/presentationml/2006/main">
   <p:cSld>
     <p:spTree>
@@ -21232,7 +21253,7 @@
           <a:p>
             <a:fld id="{212DA15D-5F50-8B40-811F-34F736B90848}" type="slidenum">
               <a:rPr lang="en-US" smtClean="0"/>
-              <a:t>24</a:t>
+              <a:t>23</a:t>
             </a:fld>
             <a:endParaRPr lang="en-US"/>
           </a:p>
@@ -21730,7 +21751,7 @@
 </p:sld>
 </file>
 
-<file path=ppt/slides/slide25.xml><?xml version="1.0" encoding="utf-8"?>
+<file path=ppt/slides/slide24.xml><?xml version="1.0" encoding="utf-8"?>
 <p:sld xmlns:a="http://schemas.openxmlformats.org/drawingml/2006/main" xmlns:r="http://schemas.openxmlformats.org/officeDocument/2006/relationships" xmlns:p="http://schemas.openxmlformats.org/presentationml/2006/main">
   <p:cSld>
     <p:spTree>
@@ -21820,7 +21841,7 @@
           <a:p>
             <a:fld id="{212DA15D-5F50-8B40-811F-34F736B90848}" type="slidenum">
               <a:rPr lang="en-US" smtClean="0"/>
-              <a:t>25</a:t>
+              <a:t>24</a:t>
             </a:fld>
             <a:endParaRPr lang="en-US"/>
           </a:p>
@@ -21840,8 +21861,8 @@
         </p:nvSpPr>
         <p:spPr>
           <a:xfrm>
-            <a:off x="88135" y="914401"/>
-            <a:ext cx="11414752" cy="4031873"/>
+            <a:off x="88134" y="914401"/>
+            <a:ext cx="12419551" cy="5016758"/>
           </a:xfrm>
           <a:prstGeom prst="rect">
             <a:avLst/>
@@ -21860,54 +21881,86 @@
             </a:r>
           </a:p>
           <a:p>
-            <a:pPr marL="457200"/>
+            <a:pPr marL="914400" indent="-457200">
+              <a:buFont typeface="Arial" panose="020B0604020202020204" pitchFamily="34" charset="0"/>
+              <a:buChar char="•"/>
+            </a:pPr>
             <a:r>
               <a:rPr lang="en-US" sz="2800" b="0" dirty="0"/>
               <a:t>file name -&gt; array of chunk handles</a:t>
             </a:r>
           </a:p>
           <a:p>
-            <a:pPr marL="457200"/>
+            <a:pPr marL="914400" indent="-457200">
+              <a:buFont typeface="Arial" panose="020B0604020202020204" pitchFamily="34" charset="0"/>
+              <a:buChar char="•"/>
+            </a:pPr>
             <a:r>
               <a:rPr lang="en-US" sz="2800" b="0" dirty="0"/>
               <a:t>chunk handle -&gt; version number, replica list, primary, lease expiry</a:t>
             </a:r>
           </a:p>
           <a:p>
+            <a:pPr marL="914400" indent="-457200">
+              <a:buFont typeface="Arial" panose="020B0604020202020204" pitchFamily="34" charset="0"/>
+              <a:buChar char="•"/>
+            </a:pPr>
+            <a:endParaRPr lang="en-US" sz="2800" b="0" dirty="0"/>
+          </a:p>
+          <a:p>
             <a:r>
               <a:rPr lang="en-US" sz="3200" b="1" dirty="0"/>
               <a:t>On disk: an operation log plus checkpoints</a:t>
             </a:r>
           </a:p>
           <a:p>
-            <a:pPr marL="457200"/>
+            <a:pPr marL="914400" indent="-457200">
+              <a:buFont typeface="Arial" panose="020B0604020202020204" pitchFamily="34" charset="0"/>
+              <a:buChar char="•"/>
+            </a:pPr>
             <a:r>
               <a:rPr lang="en-US" sz="2800" b="0" dirty="0"/>
               <a:t>Written: the file-to-chunk mapping, and the chunk version numbers</a:t>
             </a:r>
           </a:p>
           <a:p>
-            <a:pPr marL="457200"/>
+            <a:pPr marL="914400" indent="-457200">
+              <a:buFont typeface="Arial" panose="020B0604020202020204" pitchFamily="34" charset="0"/>
+              <a:buChar char="•"/>
+            </a:pPr>
             <a:r>
               <a:rPr lang="en-US" sz="2800" b="0" dirty="0"/>
               <a:t>Not written: replica list, primary, lease expiry - they are rebuilt</a:t>
             </a:r>
           </a:p>
           <a:p>
+            <a:pPr marL="914400" indent="-457200">
+              <a:buFont typeface="Arial" panose="020B0604020202020204" pitchFamily="34" charset="0"/>
+              <a:buChar char="•"/>
+            </a:pPr>
+            <a:endParaRPr lang="en-US" sz="2800" b="0" dirty="0"/>
+          </a:p>
+          <a:p>
             <a:r>
               <a:rPr lang="en-US" sz="3200" b="1" dirty="0"/>
               <a:t>After a reboot</a:t>
             </a:r>
           </a:p>
           <a:p>
-            <a:pPr marL="457200"/>
+            <a:pPr marL="914400" indent="-457200">
+              <a:buFont typeface="Arial" panose="020B0604020202020204" pitchFamily="34" charset="0"/>
+              <a:buChar char="•"/>
+            </a:pPr>
             <a:r>
               <a:rPr lang="en-US" sz="2800" b="0" dirty="0"/>
-              <a:t>Replay the log from the last checkpoint, ask chunkservers what they hold</a:t>
-            </a:r>
-          </a:p>
-          <a:p>
-            <a:pPr marL="457200"/>
+              <a:t>Replay the log from last checkpoint, ask chunkservers what they hold</a:t>
+            </a:r>
+          </a:p>
+          <a:p>
+            <a:pPr marL="914400" indent="-457200">
+              <a:buFont typeface="Arial" panose="020B0604020202020204" pitchFamily="34" charset="0"/>
+              <a:buChar char="•"/>
+            </a:pPr>
             <a:r>
               <a:rPr lang="en-US" sz="2800" b="0" dirty="0"/>
               <a:t>Wait one lease time before naming any new primary</a:t>
@@ -21961,7 +22014,7 @@
                                         <p:tgtEl>
                                           <p:spTgt spid="3">
                                             <p:txEl>
-                                              <p:pRg st="3" end="3"/>
+                                              <p:pRg st="4" end="4"/>
                                             </p:txEl>
                                           </p:spTgt>
                                         </p:tgtEl>
@@ -21979,7 +22032,7 @@
                                         <p:tgtEl>
                                           <p:spTgt spid="3">
                                             <p:txEl>
-                                              <p:pRg st="3" end="3"/>
+                                              <p:pRg st="4" end="4"/>
                                             </p:txEl>
                                           </p:spTgt>
                                         </p:tgtEl>
@@ -22004,7 +22057,7 @@
                                         <p:tgtEl>
                                           <p:spTgt spid="3">
                                             <p:txEl>
-                                              <p:pRg st="4" end="4"/>
+                                              <p:pRg st="5" end="5"/>
                                             </p:txEl>
                                           </p:spTgt>
                                         </p:tgtEl>
@@ -22022,7 +22075,7 @@
                                         <p:tgtEl>
                                           <p:spTgt spid="3">
                                             <p:txEl>
-                                              <p:pRg st="4" end="4"/>
+                                              <p:pRg st="5" end="5"/>
                                             </p:txEl>
                                           </p:spTgt>
                                         </p:tgtEl>
@@ -22047,7 +22100,7 @@
                                         <p:tgtEl>
                                           <p:spTgt spid="3">
                                             <p:txEl>
-                                              <p:pRg st="5" end="5"/>
+                                              <p:pRg st="6" end="6"/>
                                             </p:txEl>
                                           </p:spTgt>
                                         </p:tgtEl>
@@ -22065,7 +22118,7 @@
                                         <p:tgtEl>
                                           <p:spTgt spid="3">
                                             <p:txEl>
-                                              <p:pRg st="5" end="5"/>
+                                              <p:pRg st="6" end="6"/>
                                             </p:txEl>
                                           </p:spTgt>
                                         </p:tgtEl>
@@ -22108,7 +22161,7 @@
                                         <p:tgtEl>
                                           <p:spTgt spid="3">
                                             <p:txEl>
-                                              <p:pRg st="6" end="6"/>
+                                              <p:pRg st="8" end="8"/>
                                             </p:txEl>
                                           </p:spTgt>
                                         </p:tgtEl>
@@ -22126,7 +22179,7 @@
                                         <p:tgtEl>
                                           <p:spTgt spid="3">
                                             <p:txEl>
-                                              <p:pRg st="6" end="6"/>
+                                              <p:pRg st="8" end="8"/>
                                             </p:txEl>
                                           </p:spTgt>
                                         </p:tgtEl>
@@ -22151,7 +22204,7 @@
                                         <p:tgtEl>
                                           <p:spTgt spid="3">
                                             <p:txEl>
-                                              <p:pRg st="7" end="7"/>
+                                              <p:pRg st="9" end="9"/>
                                             </p:txEl>
                                           </p:spTgt>
                                         </p:tgtEl>
@@ -22169,7 +22222,7 @@
                                         <p:tgtEl>
                                           <p:spTgt spid="3">
                                             <p:txEl>
-                                              <p:pRg st="7" end="7"/>
+                                              <p:pRg st="9" end="9"/>
                                             </p:txEl>
                                           </p:spTgt>
                                         </p:tgtEl>
@@ -22194,7 +22247,7 @@
                                         <p:tgtEl>
                                           <p:spTgt spid="3">
                                             <p:txEl>
-                                              <p:pRg st="8" end="8"/>
+                                              <p:pRg st="10" end="10"/>
                                             </p:txEl>
                                           </p:spTgt>
                                         </p:tgtEl>
@@ -22212,7 +22265,7 @@
                                         <p:tgtEl>
                                           <p:spTgt spid="3">
                                             <p:txEl>
-                                              <p:pRg st="8" end="8"/>
+                                              <p:pRg st="10" end="10"/>
                                             </p:txEl>
                                           </p:spTgt>
                                         </p:tgtEl>
@@ -22252,7 +22305,7 @@
 </p:sld>
 </file>
 
-<file path=ppt/slides/slide26.xml><?xml version="1.0" encoding="utf-8"?>
+<file path=ppt/slides/slide25.xml><?xml version="1.0" encoding="utf-8"?>
 <p:sld xmlns:a="http://schemas.openxmlformats.org/drawingml/2006/main" xmlns:r="http://schemas.openxmlformats.org/officeDocument/2006/relationships" xmlns:p="http://schemas.openxmlformats.org/presentationml/2006/main">
   <p:cSld>
     <p:spTree>
@@ -22342,7 +22395,7 @@
           <a:p>
             <a:fld id="{212DA15D-5F50-8B40-811F-34F736B90848}" type="slidenum">
               <a:rPr lang="en-US" smtClean="0"/>
-              <a:t>26</a:t>
+              <a:t>25</a:t>
             </a:fld>
             <a:endParaRPr lang="en-US"/>
           </a:p>
@@ -22363,7 +22416,7 @@
         <p:spPr>
           <a:xfrm>
             <a:off x="84083" y="1137433"/>
-            <a:ext cx="9007365" cy="3170099"/>
+            <a:ext cx="10243258" cy="3662541"/>
           </a:xfrm>
           <a:prstGeom prst="rect">
             <a:avLst/>
@@ -22377,7 +22430,7 @@
           <a:lstStyle/>
           <a:p>
             <a:r>
-              <a:rPr lang="en-US" sz="2800" b="1" dirty="0"/>
+              <a:rPr lang="en-US" sz="3200" b="1" dirty="0"/>
               <a:t>64MB chunks as Linux files </a:t>
             </a:r>
           </a:p>
@@ -22387,7 +22440,7 @@
               <a:buChar char="•"/>
             </a:pPr>
             <a:r>
-              <a:rPr lang="en-US" sz="2400" dirty="0"/>
+              <a:rPr lang="en-US" sz="2800" dirty="0"/>
               <a:t>Reduce size of the master data structures </a:t>
             </a:r>
           </a:p>
@@ -22397,7 +22450,7 @@
               <a:buChar char="•"/>
             </a:pPr>
             <a:r>
-              <a:rPr lang="en-US" sz="2400" dirty="0"/>
+              <a:rPr lang="en-US" sz="2800" dirty="0"/>
               <a:t>Reduce client-master interaction </a:t>
             </a:r>
           </a:p>
@@ -22407,16 +22460,16 @@
               <a:buChar char="•"/>
             </a:pPr>
             <a:r>
-              <a:rPr lang="en-US" sz="2400" dirty="0"/>
+              <a:rPr lang="en-US" sz="2800" dirty="0"/>
               <a:t>Internal fragmentation =&gt; allocate space lazily </a:t>
             </a:r>
           </a:p>
           <a:p>
-            <a:endParaRPr lang="en-US" sz="2400" dirty="0"/>
-          </a:p>
-          <a:p>
-            <a:r>
-              <a:rPr lang="en-US" sz="2800" b="1" dirty="0"/>
+            <a:endParaRPr lang="en-US" sz="2800" dirty="0"/>
+          </a:p>
+          <a:p>
+            <a:r>
+              <a:rPr lang="en-US" sz="3200" b="1" dirty="0"/>
               <a:t>Fault tolerance </a:t>
             </a:r>
           </a:p>
@@ -22426,7 +22479,7 @@
               <a:buChar char="•"/>
             </a:pPr>
             <a:r>
-              <a:rPr lang="en-US" sz="2400" dirty="0"/>
+              <a:rPr lang="en-US" sz="2800" dirty="0"/>
               <a:t>Heart-beat to the master </a:t>
             </a:r>
           </a:p>
@@ -22436,15 +22489,15 @@
               <a:buChar char="•"/>
             </a:pPr>
             <a:r>
-              <a:rPr lang="en-US" sz="2400" dirty="0"/>
+              <a:rPr lang="en-US" sz="2800" dirty="0"/>
               <a:t>Something wrong =&gt; master </a:t>
             </a:r>
             <a:r>
-              <a:rPr lang="en-US" sz="2400" dirty="0" err="1"/>
+              <a:rPr lang="en-US" sz="2800" dirty="0" err="1"/>
               <a:t>inits</a:t>
             </a:r>
             <a:r>
-              <a:rPr lang="en-US" sz="2400" dirty="0"/>
+              <a:rPr lang="en-US" sz="2800" dirty="0"/>
               <a:t> replication </a:t>
             </a:r>
           </a:p>
@@ -22454,6 +22507,226 @@
     <p:extLst>
       <p:ext uri="{BB962C8B-B14F-4D97-AF65-F5344CB8AC3E}">
         <p14:creationId xmlns:p14="http://schemas.microsoft.com/office/powerpoint/2010/main" val="1793889708"/>
+      </p:ext>
+    </p:extLst>
+  </p:cSld>
+  <p:clrMapOvr>
+    <a:masterClrMapping/>
+  </p:clrMapOvr>
+</p:sld>
+</file>
+
+<file path=ppt/slides/slide26.xml><?xml version="1.0" encoding="utf-8"?>
+<p:sld xmlns:a="http://schemas.openxmlformats.org/drawingml/2006/main" xmlns:r="http://schemas.openxmlformats.org/officeDocument/2006/relationships" xmlns:p="http://schemas.openxmlformats.org/presentationml/2006/main">
+  <p:cSld>
+    <p:spTree>
+      <p:nvGrpSpPr>
+        <p:cNvPr id="1" name="">
+          <a:extLst>
+            <a:ext uri="{FF2B5EF4-FFF2-40B4-BE49-F238E27FC236}">
+              <a16:creationId xmlns:a16="http://schemas.microsoft.com/office/drawing/2014/main" id="{872729AB-5EBB-FD20-43DD-D6E0374E6833}"/>
+            </a:ext>
+          </a:extLst>
+        </p:cNvPr>
+        <p:cNvGrpSpPr/>
+        <p:nvPr/>
+      </p:nvGrpSpPr>
+      <p:grpSpPr>
+        <a:xfrm>
+          <a:off x="0" y="0"/>
+          <a:ext cx="0" cy="0"/>
+          <a:chOff x="0" y="0"/>
+          <a:chExt cx="0" cy="0"/>
+        </a:xfrm>
+      </p:grpSpPr>
+      <p:sp>
+        <p:nvSpPr>
+          <p:cNvPr id="7" name="Title 1">
+            <a:extLst>
+              <a:ext uri="{FF2B5EF4-FFF2-40B4-BE49-F238E27FC236}">
+                <a16:creationId xmlns:a16="http://schemas.microsoft.com/office/drawing/2014/main" id="{2ED557C7-2CDD-8C0B-07A1-1DABA8EF652A}"/>
+              </a:ext>
+            </a:extLst>
+          </p:cNvPr>
+          <p:cNvSpPr>
+            <a:spLocks noGrp="1"/>
+          </p:cNvSpPr>
+          <p:nvPr>
+            <p:ph type="title"/>
+          </p:nvPr>
+        </p:nvSpPr>
+        <p:spPr>
+          <a:xfrm>
+            <a:off x="0" y="1"/>
+            <a:ext cx="12191999" cy="914400"/>
+          </a:xfrm>
+        </p:spPr>
+        <p:txBody>
+          <a:bodyPr>
+            <a:normAutofit/>
+          </a:bodyPr>
+          <a:lstStyle/>
+          <a:p>
+            <a:pPr algn="ctr"/>
+            <a:r>
+              <a:rPr lang="en-US" b="1" dirty="0">
+                <a:latin typeface="Helvetica" panose="020B0604020202020204" pitchFamily="34" charset="0"/>
+                <a:cs typeface="Helvetica" panose="020B0604020202020204" pitchFamily="34" charset="0"/>
+              </a:rPr>
+              <a:t>Demo 1: HDFS</a:t>
+            </a:r>
+          </a:p>
+        </p:txBody>
+      </p:sp>
+      <p:sp>
+        <p:nvSpPr>
+          <p:cNvPr id="8" name="Slide Number Placeholder 4">
+            <a:extLst>
+              <a:ext uri="{FF2B5EF4-FFF2-40B4-BE49-F238E27FC236}">
+                <a16:creationId xmlns:a16="http://schemas.microsoft.com/office/drawing/2014/main" id="{25E098EE-1299-32C0-2821-1DB599BAC8E9}"/>
+              </a:ext>
+            </a:extLst>
+          </p:cNvPr>
+          <p:cNvSpPr>
+            <a:spLocks noGrp="1"/>
+          </p:cNvSpPr>
+          <p:nvPr>
+            <p:ph type="sldNum" sz="quarter" idx="12"/>
+          </p:nvPr>
+        </p:nvSpPr>
+        <p:spPr>
+          <a:xfrm>
+            <a:off x="8610600" y="6356350"/>
+            <a:ext cx="2743200" cy="365125"/>
+          </a:xfrm>
+        </p:spPr>
+        <p:txBody>
+          <a:bodyPr/>
+          <a:lstStyle/>
+          <a:p>
+            <a:fld id="{212DA15D-5F50-8B40-811F-34F736B90848}" type="slidenum">
+              <a:rPr lang="en-US" smtClean="0"/>
+              <a:t>26</a:t>
+            </a:fld>
+            <a:endParaRPr lang="en-US"/>
+          </a:p>
+        </p:txBody>
+      </p:sp>
+      <p:sp>
+        <p:nvSpPr>
+          <p:cNvPr id="3" name="TextBox 2">
+            <a:extLst>
+              <a:ext uri="{FF2B5EF4-FFF2-40B4-BE49-F238E27FC236}">
+                <a16:creationId xmlns:a16="http://schemas.microsoft.com/office/drawing/2014/main" id="{857EC8A2-DB9F-8BB1-7445-FE716E76BAC5}"/>
+              </a:ext>
+            </a:extLst>
+          </p:cNvPr>
+          <p:cNvSpPr txBox="1"/>
+          <p:nvPr/>
+        </p:nvSpPr>
+        <p:spPr>
+          <a:xfrm>
+            <a:off x="88134" y="914401"/>
+            <a:ext cx="11872217" cy="4585871"/>
+          </a:xfrm>
+          <a:prstGeom prst="rect">
+            <a:avLst/>
+          </a:prstGeom>
+          <a:noFill/>
+        </p:spPr>
+        <p:txBody>
+          <a:bodyPr wrap="square" rtlCol="0">
+            <a:spAutoFit/>
+          </a:bodyPr>
+          <a:lstStyle/>
+          <a:p>
+            <a:r>
+              <a:rPr lang="en-US" sz="3200" b="1" dirty="0"/>
+              <a:t>HDFS is the open-source clone of GFS</a:t>
+            </a:r>
+          </a:p>
+          <a:p>
+            <a:pPr marL="914400" indent="-457200">
+              <a:buFont typeface="Arial" panose="020B0604020202020204" pitchFamily="34" charset="0"/>
+              <a:buChar char="•"/>
+            </a:pPr>
+            <a:r>
+              <a:rPr lang="en-US" sz="2800" b="0" dirty="0"/>
+              <a:t>One NameNode: the master, names and metadata only</a:t>
+            </a:r>
+          </a:p>
+          <a:p>
+            <a:pPr marL="914400" indent="-457200">
+              <a:buFont typeface="Arial" panose="020B0604020202020204" pitchFamily="34" charset="0"/>
+              <a:buChar char="•"/>
+            </a:pPr>
+            <a:r>
+              <a:rPr lang="en-US" sz="2800" b="0" dirty="0"/>
+              <a:t>Three DataNodes: the chunkservers, data only</a:t>
+            </a:r>
+          </a:p>
+          <a:p>
+            <a:pPr marL="914400" indent="-457200">
+              <a:buFont typeface="Arial" panose="020B0604020202020204" pitchFamily="34" charset="0"/>
+              <a:buChar char="•"/>
+            </a:pPr>
+            <a:endParaRPr lang="en-US" sz="2800" b="0" dirty="0"/>
+          </a:p>
+          <a:p>
+            <a:r>
+              <a:rPr lang="en-US" sz="3200" b="1" dirty="0"/>
+              <a:t>What to watch</a:t>
+            </a:r>
+          </a:p>
+          <a:p>
+            <a:pPr marL="914400" indent="-457200">
+              <a:buFont typeface="Arial" panose="020B0604020202020204" pitchFamily="34" charset="0"/>
+              <a:buChar char="•"/>
+            </a:pPr>
+            <a:r>
+              <a:rPr lang="en-US" sz="2800" b="0" dirty="0"/>
+              <a:t>A 100 MB file becomes 7 blocks, each stored on two servers</a:t>
+            </a:r>
+          </a:p>
+          <a:p>
+            <a:pPr marL="914400" indent="-457200">
+              <a:buFont typeface="Arial" panose="020B0604020202020204" pitchFamily="34" charset="0"/>
+              <a:buChar char="•"/>
+            </a:pPr>
+            <a:r>
+              <a:rPr lang="en-US" sz="2800" b="0" dirty="0"/>
+              <a:t>The master knows block ids and locations, and never touches the data</a:t>
+            </a:r>
+          </a:p>
+          <a:p>
+            <a:pPr marL="914400" indent="-457200">
+              <a:buFont typeface="Arial" panose="020B0604020202020204" pitchFamily="34" charset="0"/>
+              <a:buChar char="•"/>
+            </a:pPr>
+            <a:r>
+              <a:rPr lang="en-US" sz="2800" b="0" dirty="0"/>
+              <a:t>On a DataNode, a block is an ordinary file on local disk</a:t>
+            </a:r>
+          </a:p>
+          <a:p>
+            <a:pPr marL="914400" indent="-457200">
+              <a:buFont typeface="Arial" panose="020B0604020202020204" pitchFamily="34" charset="0"/>
+              <a:buChar char="•"/>
+            </a:pPr>
+            <a:endParaRPr lang="en-US" sz="2800" b="0" dirty="0"/>
+          </a:p>
+          <a:p>
+            <a:r>
+              <a:rPr lang="en-US" sz="3200" b="1" dirty="0"/>
+              <a:t>Then one server dies and the replicas rebuild themselves</a:t>
+            </a:r>
+          </a:p>
+        </p:txBody>
+      </p:sp>
+    </p:spTree>
+    <p:extLst>
+      <p:ext uri="{BB962C8B-B14F-4D97-AF65-F5344CB8AC3E}">
+        <p14:creationId xmlns:p14="http://schemas.microsoft.com/office/powerpoint/2010/main" val="1720670694"/>
       </p:ext>
     </p:extLst>
   </p:cSld>
@@ -23793,153 +24066,6 @@
                       </p:childTnLst>
                     </p:cTn>
                   </p:par>
-                  <p:par>
-                    <p:cTn id="14" fill="hold">
-                      <p:stCondLst>
-                        <p:cond delay="indefinite"/>
-                      </p:stCondLst>
-                      <p:childTnLst>
-                        <p:par>
-                          <p:cTn id="15" fill="hold">
-                            <p:stCondLst>
-                              <p:cond delay="0"/>
-                            </p:stCondLst>
-                            <p:childTnLst>
-                              <p:par>
-                                <p:cTn id="16" presetID="9" presetClass="entr" presetSubtype="0" fill="hold" nodeType="clickEffect">
-                                  <p:stCondLst>
-                                    <p:cond delay="0"/>
-                                  </p:stCondLst>
-                                  <p:childTnLst>
-                                    <p:set>
-                                      <p:cBhvr>
-                                        <p:cTn id="17" dur="1" fill="hold">
-                                          <p:stCondLst>
-                                            <p:cond delay="0"/>
-                                          </p:stCondLst>
-                                        </p:cTn>
-                                        <p:tgtEl>
-                                          <p:spTgt spid="4">
-                                            <p:txEl>
-                                              <p:pRg st="4" end="4"/>
-                                            </p:txEl>
-                                          </p:spTgt>
-                                        </p:tgtEl>
-                                        <p:attrNameLst>
-                                          <p:attrName>style.visibility</p:attrName>
-                                        </p:attrNameLst>
-                                      </p:cBhvr>
-                                      <p:to>
-                                        <p:strVal val="visible"/>
-                                      </p:to>
-                                    </p:set>
-                                    <p:animEffect transition="in" filter="dissolve">
-                                      <p:cBhvr>
-                                        <p:cTn id="18" dur="500"/>
-                                        <p:tgtEl>
-                                          <p:spTgt spid="4">
-                                            <p:txEl>
-                                              <p:pRg st="4" end="4"/>
-                                            </p:txEl>
-                                          </p:spTgt>
-                                        </p:tgtEl>
-                                      </p:cBhvr>
-                                    </p:animEffect>
-                                  </p:childTnLst>
-                                </p:cTn>
-                              </p:par>
-                              <p:par>
-                                <p:cTn id="19" presetID="9" presetClass="entr" presetSubtype="0" fill="hold" nodeType="withEffect">
-                                  <p:stCondLst>
-                                    <p:cond delay="0"/>
-                                  </p:stCondLst>
-                                  <p:childTnLst>
-                                    <p:set>
-                                      <p:cBhvr>
-                                        <p:cTn id="20" dur="1" fill="hold">
-                                          <p:stCondLst>
-                                            <p:cond delay="0"/>
-                                          </p:stCondLst>
-                                        </p:cTn>
-                                        <p:tgtEl>
-                                          <p:spTgt spid="4">
-                                            <p:txEl>
-                                              <p:pRg st="5" end="5"/>
-                                            </p:txEl>
-                                          </p:spTgt>
-                                        </p:tgtEl>
-                                        <p:attrNameLst>
-                                          <p:attrName>style.visibility</p:attrName>
-                                        </p:attrNameLst>
-                                      </p:cBhvr>
-                                      <p:to>
-                                        <p:strVal val="visible"/>
-                                      </p:to>
-                                    </p:set>
-                                    <p:animEffect transition="in" filter="dissolve">
-                                      <p:cBhvr>
-                                        <p:cTn id="21" dur="500"/>
-                                        <p:tgtEl>
-                                          <p:spTgt spid="4">
-                                            <p:txEl>
-                                              <p:pRg st="5" end="5"/>
-                                            </p:txEl>
-                                          </p:spTgt>
-                                        </p:tgtEl>
-                                      </p:cBhvr>
-                                    </p:animEffect>
-                                  </p:childTnLst>
-                                </p:cTn>
-                              </p:par>
-                              <p:par>
-                                <p:cTn id="22" presetID="9" presetClass="entr" presetSubtype="0" fill="hold" nodeType="withEffect">
-                                  <p:stCondLst>
-                                    <p:cond delay="0"/>
-                                  </p:stCondLst>
-                                  <p:childTnLst>
-                                    <p:set>
-                                      <p:cBhvr>
-                                        <p:cTn id="23" dur="1" fill="hold">
-                                          <p:stCondLst>
-                                            <p:cond delay="0"/>
-                                          </p:stCondLst>
-                                        </p:cTn>
-                                        <p:tgtEl>
-                                          <p:spTgt spid="4">
-                                            <p:txEl>
-                                              <p:pRg st="6" end="6"/>
-                                            </p:txEl>
-                                          </p:spTgt>
-                                        </p:tgtEl>
-                                        <p:attrNameLst>
-                                          <p:attrName>style.visibility</p:attrName>
-                                        </p:attrNameLst>
-                                      </p:cBhvr>
-                                      <p:to>
-                                        <p:strVal val="visible"/>
-                                      </p:to>
-                                    </p:set>
-                                    <p:animEffect transition="in" filter="dissolve">
-                                      <p:cBhvr>
-                                        <p:cTn id="24" dur="500"/>
-                                        <p:tgtEl>
-                                          <p:spTgt spid="4">
-                                            <p:txEl>
-                                              <p:pRg st="6" end="6"/>
-                                            </p:txEl>
-                                          </p:spTgt>
-                                        </p:tgtEl>
-                                      </p:cBhvr>
-                                    </p:animEffect>
-                                  </p:childTnLst>
-                                </p:cTn>
-                              </p:par>
-                            </p:childTnLst>
-                          </p:cTn>
-                        </p:par>
-                      </p:childTnLst>
-                    </p:cTn>
-                  </p:par>
                 </p:childTnLst>
               </p:cTn>
               <p:prevCondLst>
@@ -25693,7 +25819,7 @@
         </p:spPr>
         <p:txBody>
           <a:bodyPr>
-            <a:normAutofit/>
+            <a:normAutofit fontScale="90000"/>
           </a:bodyPr>
           <a:lstStyle/>
           <a:p>
@@ -26054,7 +26180,7 @@
               <a:rPr lang="en-US" sz="2400" dirty="0">
                 <a:effectLst/>
               </a:rPr>
-              <a:t>"consistent"</a:t>
+              <a:t>"consistent" but "undefined"</a:t>
             </a:r>
           </a:p>
           <a:p>
@@ -28685,6 +28811,19 @@
               <a:t>Applications that needed order had to arrange it themselves</a:t>
             </a:r>
           </a:p>
+          <a:p>
+            <a:r>
+              <a:rPr lang="en-US" sz="3200" b="1" dirty="0"/>
+              <a:t>This is the point GFS chose on the range</a:t>
+            </a:r>
+          </a:p>
+          <a:p>
+            <a:pPr marL="457200"/>
+            <a:r>
+              <a:rPr lang="en-US" sz="2800" b="0" dirty="0"/>
+              <a:t>The Fix Has a Price promised a cost; these anomalies are it</a:t>
+            </a:r>
+          </a:p>
         </p:txBody>
       </p:sp>
     </p:spTree>
@@ -33513,7 +33652,7 @@
         </p:spPr>
         <p:txBody>
           <a:bodyPr>
-            <a:normAutofit fontScale="76316"/>
+            <a:normAutofit fontScale="76316" lnSpcReduction="10000"/>
           </a:bodyPr>
           <a:lstStyle/>
           <a:p>

</xml_diff>